<commit_message>
Redesign slide 1: key-facts strip, color-coded front headers, one-line items
Co-Authored-By: Claude Opus 5.5 <noreply@anthropic.com>
Claude-Session: https://claude.ai/code/session_01QGTe9h3kfUS6BTZosfrxzF
</commit_message>
<xml_diff>
--- a/resumen-ejecutivo-semanal/Resumen_Ejecutivo_Riesgos_COMEDICA_2_Slides.pptx
+++ b/resumen-ejecutivo-semanal/Resumen_Ejecutivo_Riesgos_COMEDICA_2_Slides.pptx
@@ -1050,7 +1050,7 @@
         </p:nvSpPr>
         <p:spPr>
           <a:xfrm>
-            <a:off x="9537192" y="411480"/>
+            <a:off x="9537192" y="384048"/>
             <a:ext cx="2194560" cy="329184"/>
           </a:xfrm>
           <a:prstGeom prst="roundRect">
@@ -1077,7 +1077,7 @@
         </p:nvSpPr>
         <p:spPr>
           <a:xfrm>
-            <a:off x="9537192" y="411480"/>
+            <a:off x="9537192" y="384048"/>
             <a:ext cx="2194560" cy="329184"/>
           </a:xfrm>
           <a:prstGeom prst="rect">
@@ -1116,15 +1116,503 @@
         </p:nvSpPr>
         <p:spPr>
           <a:xfrm>
-            <a:off x="457200" y="1353312"/>
-            <a:ext cx="5522976" cy="2487168"/>
+            <a:off x="457200" y="1207008"/>
+            <a:ext cx="2708910" cy="566928"/>
           </a:xfrm>
           <a:prstGeom prst="roundRect">
             <a:avLst>
-              <a:gd name="adj" fmla="val 4412"/>
+              <a:gd name="adj" fmla="val 16129"/>
             </a:avLst>
           </a:prstGeom>
           <a:solidFill>
+            <a:srgbClr val="D7F0F2"/>
+          </a:solidFill>
+          <a:ln w="12700">
+            <a:solidFill>
+              <a:srgbClr val="D7F0F2"/>
+            </a:solidFill>
+            <a:prstDash val="solid"/>
+          </a:ln>
+        </p:spPr>
+      </p:sp>
+      <p:sp>
+        <p:nvSpPr>
+          <p:cNvPr id="7" name="Text 5"/>
+          <p:cNvSpPr txBox="1"/>
+          <p:nvPr/>
+        </p:nvSpPr>
+        <p:spPr>
+          <a:xfrm>
+            <a:off x="603504" y="1207008"/>
+            <a:ext cx="868680" cy="566928"/>
+          </a:xfrm>
+          <a:prstGeom prst="rect">
+            <a:avLst/>
+          </a:prstGeom>
+          <a:noFill/>
+          <a:ln/>
+        </p:spPr>
+        <p:txBody>
+          <a:bodyPr wrap="square" lIns="0" tIns="0" rIns="0" bIns="0" rtlCol="0" anchor="ctr"/>
+          <a:lstStyle/>
+          <a:p>
+            <a:pPr indent="0" marL="0">
+              <a:buNone/>
+            </a:pPr>
+            <a:r>
+              <a:rPr lang="en-US" sz="2200" b="1" dirty="0">
+                <a:solidFill>
+                  <a:srgbClr val="0A7480"/>
+                </a:solidFill>
+                <a:latin typeface="Calibri" pitchFamily="34" charset="0"/>
+                <a:ea typeface="Calibri" pitchFamily="34" charset="-122"/>
+                <a:cs typeface="Calibri" pitchFamily="34" charset="-120"/>
+              </a:rPr>
+              <a:t>4</a:t>
+            </a:r>
+            <a:endParaRPr lang="en-US" sz="2200" dirty="0"/>
+          </a:p>
+        </p:txBody>
+      </p:sp>
+      <p:sp>
+        <p:nvSpPr>
+          <p:cNvPr id="8" name="Text 6"/>
+          <p:cNvSpPr txBox="1"/>
+          <p:nvPr/>
+        </p:nvSpPr>
+        <p:spPr>
+          <a:xfrm>
+            <a:off x="1463040" y="1261872"/>
+            <a:ext cx="1611630" cy="457200"/>
+          </a:xfrm>
+          <a:prstGeom prst="rect">
+            <a:avLst/>
+          </a:prstGeom>
+          <a:noFill/>
+          <a:ln/>
+        </p:spPr>
+        <p:txBody>
+          <a:bodyPr wrap="square" lIns="0" tIns="0" rIns="0" bIns="0" rtlCol="0" anchor="ctr"/>
+          <a:lstStyle/>
+          <a:p>
+            <a:pPr indent="0" marL="0">
+              <a:buNone/>
+            </a:pPr>
+            <a:r>
+              <a:rPr lang="en-US" sz="1100" b="1" dirty="0">
+                <a:solidFill>
+                  <a:srgbClr val="0B2545"/>
+                </a:solidFill>
+                <a:latin typeface="Calibri" pitchFamily="34" charset="0"/>
+                <a:ea typeface="Calibri" pitchFamily="34" charset="-122"/>
+                <a:cs typeface="Calibri" pitchFamily="34" charset="-120"/>
+              </a:rPr>
+              <a:t>Requerimientos SSF</a:t>
+            </a:r>
+            <a:endParaRPr lang="en-US" sz="1100" dirty="0"/>
+          </a:p>
+          <a:p>
+            <a:pPr indent="0" marL="0">
+              <a:buNone/>
+            </a:pPr>
+            <a:r>
+              <a:rPr lang="en-US" sz="950" dirty="0">
+                <a:solidFill>
+                  <a:srgbClr val="13507F"/>
+                </a:solidFill>
+                <a:latin typeface="Calibri" pitchFamily="34" charset="0"/>
+                <a:ea typeface="Calibri" pitchFamily="34" charset="-122"/>
+                <a:cs typeface="Calibri" pitchFamily="34" charset="-120"/>
+              </a:rPr>
+              <a:t>22737 · 22741 · 22742 · 23486</a:t>
+            </a:r>
+            <a:endParaRPr lang="en-US" sz="1100" dirty="0"/>
+          </a:p>
+        </p:txBody>
+      </p:sp>
+      <p:sp>
+        <p:nvSpPr>
+          <p:cNvPr id="9" name="Shape 7"/>
+          <p:cNvSpPr/>
+          <p:nvPr/>
+        </p:nvSpPr>
+        <p:spPr>
+          <a:xfrm>
+            <a:off x="3312414" y="1207008"/>
+            <a:ext cx="2708910" cy="566928"/>
+          </a:xfrm>
+          <a:prstGeom prst="roundRect">
+            <a:avLst>
+              <a:gd name="adj" fmla="val 16129"/>
+            </a:avLst>
+          </a:prstGeom>
+          <a:solidFill>
+            <a:srgbClr val="D7F0F2"/>
+          </a:solidFill>
+          <a:ln w="12700">
+            <a:solidFill>
+              <a:srgbClr val="D7F0F2"/>
+            </a:solidFill>
+            <a:prstDash val="solid"/>
+          </a:ln>
+        </p:spPr>
+      </p:sp>
+      <p:sp>
+        <p:nvSpPr>
+          <p:cNvPr id="10" name="Text 8"/>
+          <p:cNvSpPr txBox="1"/>
+          <p:nvPr/>
+        </p:nvSpPr>
+        <p:spPr>
+          <a:xfrm>
+            <a:off x="3458718" y="1207008"/>
+            <a:ext cx="868680" cy="566928"/>
+          </a:xfrm>
+          <a:prstGeom prst="rect">
+            <a:avLst/>
+          </a:prstGeom>
+          <a:noFill/>
+          <a:ln/>
+        </p:spPr>
+        <p:txBody>
+          <a:bodyPr wrap="square" lIns="0" tIns="0" rIns="0" bIns="0" rtlCol="0" anchor="ctr"/>
+          <a:lstStyle/>
+          <a:p>
+            <a:pPr indent="0" marL="0">
+              <a:buNone/>
+            </a:pPr>
+            <a:r>
+              <a:rPr lang="en-US" sz="2200" b="1" dirty="0">
+                <a:solidFill>
+                  <a:srgbClr val="0A7480"/>
+                </a:solidFill>
+                <a:latin typeface="Calibri" pitchFamily="34" charset="0"/>
+                <a:ea typeface="Calibri" pitchFamily="34" charset="-122"/>
+                <a:cs typeface="Calibri" pitchFamily="34" charset="-120"/>
+              </a:rPr>
+              <a:t>90%</a:t>
+            </a:r>
+            <a:endParaRPr lang="en-US" sz="2200" dirty="0"/>
+          </a:p>
+        </p:txBody>
+      </p:sp>
+      <p:sp>
+        <p:nvSpPr>
+          <p:cNvPr id="11" name="Text 9"/>
+          <p:cNvSpPr txBox="1"/>
+          <p:nvPr/>
+        </p:nvSpPr>
+        <p:spPr>
+          <a:xfrm>
+            <a:off x="4318254" y="1261872"/>
+            <a:ext cx="1611630" cy="457200"/>
+          </a:xfrm>
+          <a:prstGeom prst="rect">
+            <a:avLst/>
+          </a:prstGeom>
+          <a:noFill/>
+          <a:ln/>
+        </p:spPr>
+        <p:txBody>
+          <a:bodyPr wrap="square" lIns="0" tIns="0" rIns="0" bIns="0" rtlCol="0" anchor="ctr"/>
+          <a:lstStyle/>
+          <a:p>
+            <a:pPr indent="0" marL="0">
+              <a:buNone/>
+            </a:pPr>
+            <a:r>
+              <a:rPr lang="en-US" sz="1100" b="1" dirty="0">
+                <a:solidFill>
+                  <a:srgbClr val="0B2545"/>
+                </a:solidFill>
+                <a:latin typeface="Calibri" pitchFamily="34" charset="0"/>
+                <a:ea typeface="Calibri" pitchFamily="34" charset="-122"/>
+                <a:cs typeface="Calibri" pitchFamily="34" charset="-120"/>
+              </a:rPr>
+              <a:t>Examen GIR 2026</a:t>
+            </a:r>
+            <a:endParaRPr lang="en-US" sz="1100" dirty="0"/>
+          </a:p>
+          <a:p>
+            <a:pPr indent="0" marL="0">
+              <a:buNone/>
+            </a:pPr>
+            <a:r>
+              <a:rPr lang="en-US" sz="950" dirty="0">
+                <a:solidFill>
+                  <a:srgbClr val="13507F"/>
+                </a:solidFill>
+                <a:latin typeface="Calibri" pitchFamily="34" charset="0"/>
+                <a:ea typeface="Calibri" pitchFamily="34" charset="-122"/>
+                <a:cs typeface="Calibri" pitchFamily="34" charset="-120"/>
+              </a:rPr>
+              <a:t>Avance reportado</a:t>
+            </a:r>
+            <a:endParaRPr lang="en-US" sz="1100" dirty="0"/>
+          </a:p>
+        </p:txBody>
+      </p:sp>
+      <p:sp>
+        <p:nvSpPr>
+          <p:cNvPr id="12" name="Shape 10"/>
+          <p:cNvSpPr/>
+          <p:nvPr/>
+        </p:nvSpPr>
+        <p:spPr>
+          <a:xfrm>
+            <a:off x="6167628" y="1207008"/>
+            <a:ext cx="2708910" cy="566928"/>
+          </a:xfrm>
+          <a:prstGeom prst="roundRect">
+            <a:avLst>
+              <a:gd name="adj" fmla="val 16129"/>
+            </a:avLst>
+          </a:prstGeom>
+          <a:solidFill>
+            <a:srgbClr val="D7F0F2"/>
+          </a:solidFill>
+          <a:ln w="12700">
+            <a:solidFill>
+              <a:srgbClr val="D7F0F2"/>
+            </a:solidFill>
+            <a:prstDash val="solid"/>
+          </a:ln>
+        </p:spPr>
+      </p:sp>
+      <p:sp>
+        <p:nvSpPr>
+          <p:cNvPr id="13" name="Text 11"/>
+          <p:cNvSpPr txBox="1"/>
+          <p:nvPr/>
+        </p:nvSpPr>
+        <p:spPr>
+          <a:xfrm>
+            <a:off x="6313932" y="1207008"/>
+            <a:ext cx="868680" cy="566928"/>
+          </a:xfrm>
+          <a:prstGeom prst="rect">
+            <a:avLst/>
+          </a:prstGeom>
+          <a:noFill/>
+          <a:ln/>
+        </p:spPr>
+        <p:txBody>
+          <a:bodyPr wrap="square" lIns="0" tIns="0" rIns="0" bIns="0" rtlCol="0" anchor="ctr"/>
+          <a:lstStyle/>
+          <a:p>
+            <a:pPr indent="0" marL="0">
+              <a:buNone/>
+            </a:pPr>
+            <a:r>
+              <a:rPr lang="en-US" sz="2200" b="1" dirty="0">
+                <a:solidFill>
+                  <a:srgbClr val="0A7480"/>
+                </a:solidFill>
+                <a:latin typeface="Calibri" pitchFamily="34" charset="0"/>
+                <a:ea typeface="Calibri" pitchFamily="34" charset="-122"/>
+                <a:cs typeface="Calibri" pitchFamily="34" charset="-120"/>
+              </a:rPr>
+              <a:t>60%</a:t>
+            </a:r>
+            <a:endParaRPr lang="en-US" sz="2200" dirty="0"/>
+          </a:p>
+        </p:txBody>
+      </p:sp>
+      <p:sp>
+        <p:nvSpPr>
+          <p:cNvPr id="14" name="Text 12"/>
+          <p:cNvSpPr txBox="1"/>
+          <p:nvPr/>
+        </p:nvSpPr>
+        <p:spPr>
+          <a:xfrm>
+            <a:off x="7173468" y="1261872"/>
+            <a:ext cx="1611630" cy="457200"/>
+          </a:xfrm>
+          <a:prstGeom prst="rect">
+            <a:avLst/>
+          </a:prstGeom>
+          <a:noFill/>
+          <a:ln/>
+        </p:spPr>
+        <p:txBody>
+          <a:bodyPr wrap="square" lIns="0" tIns="0" rIns="0" bIns="0" rtlCol="0" anchor="ctr"/>
+          <a:lstStyle/>
+          <a:p>
+            <a:pPr indent="0" marL="0">
+              <a:buNone/>
+            </a:pPr>
+            <a:r>
+              <a:rPr lang="en-US" sz="1100" b="1" dirty="0">
+                <a:solidFill>
+                  <a:srgbClr val="0B2545"/>
+                </a:solidFill>
+                <a:latin typeface="Calibri" pitchFamily="34" charset="0"/>
+                <a:ea typeface="Calibri" pitchFamily="34" charset="-122"/>
+                <a:cs typeface="Calibri" pitchFamily="34" charset="-120"/>
+              </a:rPr>
+              <a:t>Control de avalúos</a:t>
+            </a:r>
+            <a:endParaRPr lang="en-US" sz="1100" dirty="0"/>
+          </a:p>
+          <a:p>
+            <a:pPr indent="0" marL="0">
+              <a:buNone/>
+            </a:pPr>
+            <a:r>
+              <a:rPr lang="en-US" sz="950" dirty="0">
+                <a:solidFill>
+                  <a:srgbClr val="13507F"/>
+                </a:solidFill>
+                <a:latin typeface="Calibri" pitchFamily="34" charset="0"/>
+                <a:ea typeface="Calibri" pitchFamily="34" charset="-122"/>
+                <a:cs typeface="Calibri" pitchFamily="34" charset="-120"/>
+              </a:rPr>
+              <a:t>Último reporte · por confirmar</a:t>
+            </a:r>
+            <a:endParaRPr lang="en-US" sz="1100" dirty="0"/>
+          </a:p>
+        </p:txBody>
+      </p:sp>
+      <p:sp>
+        <p:nvSpPr>
+          <p:cNvPr id="15" name="Shape 13"/>
+          <p:cNvSpPr/>
+          <p:nvPr/>
+        </p:nvSpPr>
+        <p:spPr>
+          <a:xfrm>
+            <a:off x="9022842" y="1207008"/>
+            <a:ext cx="2708910" cy="566928"/>
+          </a:xfrm>
+          <a:prstGeom prst="roundRect">
+            <a:avLst>
+              <a:gd name="adj" fmla="val 16129"/>
+            </a:avLst>
+          </a:prstGeom>
+          <a:solidFill>
+            <a:srgbClr val="D7F0F2"/>
+          </a:solidFill>
+          <a:ln w="12700">
+            <a:solidFill>
+              <a:srgbClr val="D7F0F2"/>
+            </a:solidFill>
+            <a:prstDash val="solid"/>
+          </a:ln>
+        </p:spPr>
+      </p:sp>
+      <p:sp>
+        <p:nvSpPr>
+          <p:cNvPr id="16" name="Text 14"/>
+          <p:cNvSpPr txBox="1"/>
+          <p:nvPr/>
+        </p:nvSpPr>
+        <p:spPr>
+          <a:xfrm>
+            <a:off x="9169146" y="1207008"/>
+            <a:ext cx="868680" cy="566928"/>
+          </a:xfrm>
+          <a:prstGeom prst="rect">
+            <a:avLst/>
+          </a:prstGeom>
+          <a:noFill/>
+          <a:ln/>
+        </p:spPr>
+        <p:txBody>
+          <a:bodyPr wrap="square" lIns="0" tIns="0" rIns="0" bIns="0" rtlCol="0" anchor="ctr"/>
+          <a:lstStyle/>
+          <a:p>
+            <a:pPr indent="0" marL="0">
+              <a:buNone/>
+            </a:pPr>
+            <a:r>
+              <a:rPr lang="en-US" sz="2200" b="1" dirty="0">
+                <a:solidFill>
+                  <a:srgbClr val="0A7480"/>
+                </a:solidFill>
+                <a:latin typeface="Calibri" pitchFamily="34" charset="0"/>
+                <a:ea typeface="Calibri" pitchFamily="34" charset="-122"/>
+                <a:cs typeface="Calibri" pitchFamily="34" charset="-120"/>
+              </a:rPr>
+              <a:t>01/10</a:t>
+            </a:r>
+            <a:endParaRPr lang="en-US" sz="2200" dirty="0"/>
+          </a:p>
+        </p:txBody>
+      </p:sp>
+      <p:sp>
+        <p:nvSpPr>
+          <p:cNvPr id="17" name="Text 15"/>
+          <p:cNvSpPr txBox="1"/>
+          <p:nvPr/>
+        </p:nvSpPr>
+        <p:spPr>
+          <a:xfrm>
+            <a:off x="10028682" y="1261872"/>
+            <a:ext cx="1611630" cy="457200"/>
+          </a:xfrm>
+          <a:prstGeom prst="rect">
+            <a:avLst/>
+          </a:prstGeom>
+          <a:noFill/>
+          <a:ln/>
+        </p:spPr>
+        <p:txBody>
+          <a:bodyPr wrap="square" lIns="0" tIns="0" rIns="0" bIns="0" rtlCol="0" anchor="ctr"/>
+          <a:lstStyle/>
+          <a:p>
+            <a:pPr indent="0" marL="0">
+              <a:buNone/>
+            </a:pPr>
+            <a:r>
+              <a:rPr lang="en-US" sz="1100" b="1" dirty="0">
+                <a:solidFill>
+                  <a:srgbClr val="0B2545"/>
+                </a:solidFill>
+                <a:latin typeface="Calibri" pitchFamily="34" charset="0"/>
+                <a:ea typeface="Calibri" pitchFamily="34" charset="-122"/>
+                <a:cs typeface="Calibri" pitchFamily="34" charset="-120"/>
+              </a:rPr>
+              <a:t>2.ª prueba de continuidad</a:t>
+            </a:r>
+            <a:endParaRPr lang="en-US" sz="1100" dirty="0"/>
+          </a:p>
+          <a:p>
+            <a:pPr indent="0" marL="0">
+              <a:buNone/>
+            </a:pPr>
+            <a:r>
+              <a:rPr lang="en-US" sz="950" dirty="0">
+                <a:solidFill>
+                  <a:srgbClr val="13507F"/>
+                </a:solidFill>
+                <a:latin typeface="Calibri" pitchFamily="34" charset="0"/>
+                <a:ea typeface="Calibri" pitchFamily="34" charset="-122"/>
+                <a:cs typeface="Calibri" pitchFamily="34" charset="-120"/>
+              </a:rPr>
+              <a:t>Informe de resultados</a:t>
+            </a:r>
+            <a:endParaRPr lang="en-US" sz="1100" dirty="0"/>
+          </a:p>
+        </p:txBody>
+      </p:sp>
+      <p:sp>
+        <p:nvSpPr>
+          <p:cNvPr id="18" name="Shape 16"/>
+          <p:cNvSpPr/>
+          <p:nvPr/>
+        </p:nvSpPr>
+        <p:spPr>
+          <a:xfrm>
+            <a:off x="457200" y="1920240"/>
+            <a:ext cx="5564124" cy="2203704"/>
+          </a:xfrm>
+          <a:prstGeom prst="roundRect">
+            <a:avLst>
+              <a:gd name="adj" fmla="val 4979"/>
+            </a:avLst>
+          </a:prstGeom>
+          <a:solidFill>
             <a:srgbClr val="F1F5F9"/>
           </a:solidFill>
           <a:ln w="12700">
@@ -1137,24 +1625,76 @@
       </p:sp>
       <p:sp>
         <p:nvSpPr>
-          <p:cNvPr id="7" name="Shape 5"/>
-          <p:cNvSpPr/>
-          <p:nvPr/>
-        </p:nvSpPr>
-        <p:spPr>
-          <a:xfrm>
-            <a:off x="658368" y="1536192"/>
-            <a:ext cx="512064" cy="512064"/>
+          <p:cNvPr id="19" name="Shape 17"/>
+          <p:cNvSpPr/>
+          <p:nvPr/>
+        </p:nvSpPr>
+        <p:spPr>
+          <a:xfrm>
+            <a:off x="457200" y="1920240"/>
+            <a:ext cx="5564124" cy="749808"/>
+          </a:xfrm>
+          <a:prstGeom prst="roundRect">
+            <a:avLst>
+              <a:gd name="adj" fmla="val 14634"/>
+            </a:avLst>
+          </a:prstGeom>
+          <a:solidFill>
+            <a:srgbClr val="0B2545"/>
+          </a:solidFill>
+          <a:ln w="12700">
+            <a:solidFill>
+              <a:srgbClr val="0B2545"/>
+            </a:solidFill>
+            <a:prstDash val="solid"/>
+          </a:ln>
+        </p:spPr>
+      </p:sp>
+      <p:sp>
+        <p:nvSpPr>
+          <p:cNvPr id="20" name="Shape 18"/>
+          <p:cNvSpPr/>
+          <p:nvPr/>
+        </p:nvSpPr>
+        <p:spPr>
+          <a:xfrm>
+            <a:off x="457200" y="2560320"/>
+            <a:ext cx="5564124" cy="182880"/>
+          </a:xfrm>
+          <a:prstGeom prst="rect">
+            <a:avLst/>
+          </a:prstGeom>
+          <a:solidFill>
+            <a:srgbClr val="F1F5F9"/>
+          </a:solidFill>
+          <a:ln w="12700">
+            <a:solidFill>
+              <a:srgbClr val="F1F5F9"/>
+            </a:solidFill>
+            <a:prstDash val="solid"/>
+          </a:ln>
+        </p:spPr>
+      </p:sp>
+      <p:sp>
+        <p:nvSpPr>
+          <p:cNvPr id="21" name="Shape 19"/>
+          <p:cNvSpPr/>
+          <p:nvPr/>
+        </p:nvSpPr>
+        <p:spPr>
+          <a:xfrm>
+            <a:off x="640080" y="2020824"/>
+            <a:ext cx="438912" cy="438912"/>
           </a:xfrm>
           <a:prstGeom prst="ellipse">
             <a:avLst/>
           </a:prstGeom>
           <a:solidFill>
-            <a:srgbClr val="0B2545"/>
+            <a:srgbClr val="FFFFFF"/>
           </a:solidFill>
           <a:ln w="12700">
             <a:solidFill>
-              <a:srgbClr val="0B2545"/>
+              <a:srgbClr val="FFFFFF"/>
             </a:solidFill>
             <a:prstDash val="solid"/>
           </a:ln>
@@ -1162,7 +1702,7 @@
       </p:sp>
       <p:pic>
         <p:nvPicPr>
-          <p:cNvPr id="8" name="Image 0" descr="preencoded.png">    </p:cNvPr>
+          <p:cNvPr id="22" name="Image 0" descr="preencoded.png">    </p:cNvPr>
           <p:cNvPicPr>
             <a:picLocks noChangeAspect="1"/>
           </p:cNvPicPr>
@@ -1176,8 +1716,8 @@
         </p:blipFill>
         <p:spPr>
           <a:xfrm>
-            <a:off x="781812" y="1659636"/>
-            <a:ext cx="265176" cy="265176"/>
+            <a:off x="745236" y="2125980"/>
+            <a:ext cx="228600" cy="228600"/>
           </a:xfrm>
           <a:prstGeom prst="rect">
             <a:avLst/>
@@ -1186,14 +1726,14 @@
       </p:pic>
       <p:sp>
         <p:nvSpPr>
-          <p:cNvPr id="9" name="Text 6"/>
-          <p:cNvSpPr txBox="1"/>
-          <p:nvPr/>
-        </p:nvSpPr>
-        <p:spPr>
-          <a:xfrm>
-            <a:off x="1316736" y="1508760"/>
-            <a:ext cx="2935224" cy="310896"/>
+          <p:cNvPr id="23" name="Text 20"/>
+          <p:cNvSpPr txBox="1"/>
+          <p:nvPr/>
+        </p:nvSpPr>
+        <p:spPr>
+          <a:xfrm>
+            <a:off x="1225296" y="1993392"/>
+            <a:ext cx="4649724" cy="292608"/>
           </a:xfrm>
           <a:prstGeom prst="rect">
             <a:avLst/>
@@ -1211,28 +1751,170 @@
             <a:r>
               <a:rPr lang="en-US" sz="1500" b="1" dirty="0">
                 <a:solidFill>
+                  <a:srgbClr val="FFFFFF"/>
+                </a:solidFill>
+                <a:latin typeface="Calibri" pitchFamily="34" charset="0"/>
+                <a:ea typeface="Calibri" pitchFamily="34" charset="-122"/>
+                <a:cs typeface="Calibri" pitchFamily="34" charset="-120"/>
+              </a:rPr>
+              <a:t>Riesgo Operacional y Continuidad</a:t>
+            </a:r>
+            <a:endParaRPr lang="en-US" sz="1500" dirty="0"/>
+          </a:p>
+        </p:txBody>
+      </p:sp>
+      <p:sp>
+        <p:nvSpPr>
+          <p:cNvPr id="24" name="Text 21"/>
+          <p:cNvSpPr txBox="1"/>
+          <p:nvPr/>
+        </p:nvSpPr>
+        <p:spPr>
+          <a:xfrm>
+            <a:off x="1225296" y="2267712"/>
+            <a:ext cx="4649724" cy="219456"/>
+          </a:xfrm>
+          <a:prstGeom prst="rect">
+            <a:avLst/>
+          </a:prstGeom>
+          <a:noFill/>
+          <a:ln/>
+        </p:spPr>
+        <p:txBody>
+          <a:bodyPr wrap="square" lIns="0" tIns="0" rIns="0" bIns="0" rtlCol="0" anchor="ctr"/>
+          <a:lstStyle/>
+          <a:p>
+            <a:pPr indent="0" marL="0">
+              <a:buNone/>
+            </a:pPr>
+            <a:r>
+              <a:rPr lang="en-US" sz="1050" i="1" dirty="0">
+                <a:solidFill>
+                  <a:srgbClr val="DCE8F3"/>
+                </a:solidFill>
+                <a:latin typeface="Calibri" pitchFamily="34" charset="0"/>
+                <a:ea typeface="Calibri" pitchFamily="34" charset="-122"/>
+                <a:cs typeface="Calibri" pitchFamily="34" charset="-120"/>
+              </a:rPr>
+              <a:t>Cultura de riesgos, continuidad del negocio y control de eventos</a:t>
+            </a:r>
+            <a:endParaRPr lang="en-US" sz="1050" dirty="0"/>
+          </a:p>
+        </p:txBody>
+      </p:sp>
+      <p:sp>
+        <p:nvSpPr>
+          <p:cNvPr id="25" name="Shape 22"/>
+          <p:cNvSpPr/>
+          <p:nvPr/>
+        </p:nvSpPr>
+        <p:spPr>
+          <a:xfrm>
+            <a:off x="676656" y="2775204"/>
+            <a:ext cx="64008" cy="64008"/>
+          </a:xfrm>
+          <a:prstGeom prst="rect">
+            <a:avLst/>
+          </a:prstGeom>
+          <a:solidFill>
+            <a:srgbClr val="0B2545"/>
+          </a:solidFill>
+          <a:ln w="12700">
+            <a:solidFill>
+              <a:srgbClr val="0B2545"/>
+            </a:solidFill>
+            <a:prstDash val="solid"/>
+          </a:ln>
+        </p:spPr>
+      </p:sp>
+      <p:sp>
+        <p:nvSpPr>
+          <p:cNvPr id="26" name="Text 23"/>
+          <p:cNvSpPr txBox="1"/>
+          <p:nvPr/>
+        </p:nvSpPr>
+        <p:spPr>
+          <a:xfrm>
+            <a:off x="832104" y="2706624"/>
+            <a:ext cx="5006340" cy="201168"/>
+          </a:xfrm>
+          <a:prstGeom prst="rect">
+            <a:avLst/>
+          </a:prstGeom>
+          <a:noFill/>
+          <a:ln/>
+        </p:spPr>
+        <p:txBody>
+          <a:bodyPr wrap="square" lIns="0" tIns="0" rIns="0" bIns="0" rtlCol="0" anchor="ctr"/>
+          <a:lstStyle/>
+          <a:p>
+            <a:pPr indent="0" marL="0">
+              <a:buNone/>
+            </a:pPr>
+            <a:r>
+              <a:rPr lang="en-US" sz="1100" b="1" dirty="0">
+                <a:solidFill>
                   <a:srgbClr val="0B2545"/>
                 </a:solidFill>
                 <a:latin typeface="Calibri" pitchFamily="34" charset="0"/>
                 <a:ea typeface="Calibri" pitchFamily="34" charset="-122"/>
                 <a:cs typeface="Calibri" pitchFamily="34" charset="-120"/>
               </a:rPr>
-              <a:t>Riesgo Operacional y Continuidad</a:t>
-            </a:r>
-            <a:endParaRPr lang="en-US" sz="1500" dirty="0"/>
-          </a:p>
-        </p:txBody>
-      </p:sp>
-      <p:sp>
-        <p:nvSpPr>
-          <p:cNvPr id="10" name="Text 7"/>
-          <p:cNvSpPr txBox="1"/>
-          <p:nvPr/>
-        </p:nvSpPr>
-        <p:spPr>
-          <a:xfrm>
-            <a:off x="1316736" y="1810512"/>
-            <a:ext cx="4425696" cy="256032"/>
+              <a:t>Capacitación GIR 2026: </a:t>
+            </a:r>
+            <a:pPr indent="0" marL="0">
+              <a:buNone/>
+            </a:pPr>
+            <a:r>
+              <a:rPr lang="en-US" sz="1100" dirty="0">
+                <a:solidFill>
+                  <a:srgbClr val="1B2733"/>
+                </a:solidFill>
+                <a:latin typeface="Calibri" pitchFamily="34" charset="0"/>
+                <a:ea typeface="Calibri" pitchFamily="34" charset="-122"/>
+                <a:cs typeface="Calibri" pitchFamily="34" charset="-120"/>
+              </a:rPr>
+              <a:t>capacitación, examen e informe de seguimiento</a:t>
+            </a:r>
+            <a:endParaRPr lang="en-US" sz="1100" dirty="0"/>
+          </a:p>
+        </p:txBody>
+      </p:sp>
+      <p:sp>
+        <p:nvSpPr>
+          <p:cNvPr id="27" name="Shape 24"/>
+          <p:cNvSpPr/>
+          <p:nvPr/>
+        </p:nvSpPr>
+        <p:spPr>
+          <a:xfrm>
+            <a:off x="676656" y="2999232"/>
+            <a:ext cx="64008" cy="64008"/>
+          </a:xfrm>
+          <a:prstGeom prst="rect">
+            <a:avLst/>
+          </a:prstGeom>
+          <a:solidFill>
+            <a:srgbClr val="0B2545"/>
+          </a:solidFill>
+          <a:ln w="12700">
+            <a:solidFill>
+              <a:srgbClr val="0B2545"/>
+            </a:solidFill>
+            <a:prstDash val="solid"/>
+          </a:ln>
+        </p:spPr>
+      </p:sp>
+      <p:sp>
+        <p:nvSpPr>
+          <p:cNvPr id="28" name="Text 25"/>
+          <p:cNvSpPr txBox="1"/>
+          <p:nvPr/>
+        </p:nvSpPr>
+        <p:spPr>
+          <a:xfrm>
+            <a:off x="832104" y="2930652"/>
+            <a:ext cx="5006340" cy="201168"/>
           </a:xfrm>
           <a:prstGeom prst="rect">
             <a:avLst/>
@@ -1248,15 +1930,29 @@
               <a:buNone/>
             </a:pPr>
             <a:r>
-              <a:rPr lang="en-US" sz="1100" i="1" dirty="0">
-                <a:solidFill>
-                  <a:srgbClr val="13507F"/>
-                </a:solidFill>
-                <a:latin typeface="Calibri" pitchFamily="34" charset="0"/>
-                <a:ea typeface="Calibri" pitchFamily="34" charset="-122"/>
-                <a:cs typeface="Calibri" pitchFamily="34" charset="-120"/>
-              </a:rPr>
-              <a:t>Cultura de riesgos, continuidad del negocio y control de eventos</a:t>
+              <a:rPr lang="en-US" sz="1100" b="1" dirty="0">
+                <a:solidFill>
+                  <a:srgbClr val="0B2545"/>
+                </a:solidFill>
+                <a:latin typeface="Calibri" pitchFamily="34" charset="0"/>
+                <a:ea typeface="Calibri" pitchFamily="34" charset="-122"/>
+                <a:cs typeface="Calibri" pitchFamily="34" charset="-120"/>
+              </a:rPr>
+              <a:t>Continuidad: </a:t>
+            </a:r>
+            <a:pPr indent="0" marL="0">
+              <a:buNone/>
+            </a:pPr>
+            <a:r>
+              <a:rPr lang="en-US" sz="1100" dirty="0">
+                <a:solidFill>
+                  <a:srgbClr val="1B2733"/>
+                </a:solidFill>
+                <a:latin typeface="Calibri" pitchFamily="34" charset="0"/>
+                <a:ea typeface="Calibri" pitchFamily="34" charset="-122"/>
+                <a:cs typeface="Calibri" pitchFamily="34" charset="-120"/>
+              </a:rPr>
+              <a:t>informe de la 2.ª prueba (01/10/2026) y actualización Matriz BIA</a:t>
             </a:r>
             <a:endParaRPr lang="en-US" sz="1100" dirty="0"/>
           </a:p>
@@ -1264,14 +1960,39 @@
       </p:sp>
       <p:sp>
         <p:nvSpPr>
-          <p:cNvPr id="11" name="Text 8"/>
-          <p:cNvSpPr txBox="1"/>
-          <p:nvPr/>
-        </p:nvSpPr>
-        <p:spPr>
-          <a:xfrm>
-            <a:off x="4352544" y="1463040"/>
-            <a:ext cx="1417320" cy="201168"/>
+          <p:cNvPr id="29" name="Shape 26"/>
+          <p:cNvSpPr/>
+          <p:nvPr/>
+        </p:nvSpPr>
+        <p:spPr>
+          <a:xfrm>
+            <a:off x="676656" y="3223260"/>
+            <a:ext cx="64008" cy="64008"/>
+          </a:xfrm>
+          <a:prstGeom prst="rect">
+            <a:avLst/>
+          </a:prstGeom>
+          <a:solidFill>
+            <a:srgbClr val="0B2545"/>
+          </a:solidFill>
+          <a:ln w="12700">
+            <a:solidFill>
+              <a:srgbClr val="0B2545"/>
+            </a:solidFill>
+            <a:prstDash val="solid"/>
+          </a:ln>
+        </p:spPr>
+      </p:sp>
+      <p:sp>
+        <p:nvSpPr>
+          <p:cNvPr id="30" name="Text 27"/>
+          <p:cNvSpPr txBox="1"/>
+          <p:nvPr/>
+        </p:nvSpPr>
+        <p:spPr>
+          <a:xfrm>
+            <a:off x="832104" y="3154680"/>
+            <a:ext cx="5006340" cy="201168"/>
           </a:xfrm>
           <a:prstGeom prst="rect">
             <a:avLst/>
@@ -1283,11 +2004,11 @@
           <a:bodyPr wrap="square" lIns="0" tIns="0" rIns="0" bIns="0" rtlCol="0" anchor="ctr"/>
           <a:lstStyle/>
           <a:p>
-            <a:pPr algn="r" indent="0" marL="0">
-              <a:buNone/>
-            </a:pPr>
-            <a:r>
-              <a:rPr lang="en-US" sz="950" b="1" dirty="0">
+            <a:pPr indent="0" marL="0">
+              <a:buNone/>
+            </a:pPr>
+            <a:r>
+              <a:rPr lang="en-US" sz="1100" b="1" dirty="0">
                 <a:solidFill>
                   <a:srgbClr val="0B2545"/>
                 </a:solidFill>
@@ -1295,352 +2016,327 @@
                 <a:ea typeface="Calibri" pitchFamily="34" charset="-122"/>
                 <a:cs typeface="Calibri" pitchFamily="34" charset="-120"/>
               </a:rPr>
-              <a:t>Examen GIR 2026</a:t>
-            </a:r>
-            <a:endParaRPr lang="en-US" sz="950" dirty="0"/>
-          </a:p>
-        </p:txBody>
-      </p:sp>
-      <p:sp>
-        <p:nvSpPr>
-          <p:cNvPr id="12" name="Shape 9"/>
-          <p:cNvSpPr/>
-          <p:nvPr/>
-        </p:nvSpPr>
-        <p:spPr>
-          <a:xfrm>
-            <a:off x="4352544" y="1728216"/>
-            <a:ext cx="960120" cy="100584"/>
+              <a:t>Matriz de Riesgos Institucional 2026: </a:t>
+            </a:r>
+            <a:pPr indent="0" marL="0">
+              <a:buNone/>
+            </a:pPr>
+            <a:r>
+              <a:rPr lang="en-US" sz="1100" dirty="0">
+                <a:solidFill>
+                  <a:srgbClr val="1B2733"/>
+                </a:solidFill>
+                <a:latin typeface="Calibri" pitchFamily="34" charset="0"/>
+                <a:ea typeface="Calibri" pitchFamily="34" charset="-122"/>
+                <a:cs typeface="Calibri" pitchFamily="34" charset="-120"/>
+              </a:rPr>
+              <a:t>seguimiento de planes de acción</a:t>
+            </a:r>
+            <a:endParaRPr lang="en-US" sz="1100" dirty="0"/>
+          </a:p>
+        </p:txBody>
+      </p:sp>
+      <p:sp>
+        <p:nvSpPr>
+          <p:cNvPr id="31" name="Shape 28"/>
+          <p:cNvSpPr/>
+          <p:nvPr/>
+        </p:nvSpPr>
+        <p:spPr>
+          <a:xfrm>
+            <a:off x="676656" y="3447288"/>
+            <a:ext cx="64008" cy="64008"/>
+          </a:xfrm>
+          <a:prstGeom prst="rect">
+            <a:avLst/>
+          </a:prstGeom>
+          <a:solidFill>
+            <a:srgbClr val="0B2545"/>
+          </a:solidFill>
+          <a:ln w="12700">
+            <a:solidFill>
+              <a:srgbClr val="0B2545"/>
+            </a:solidFill>
+            <a:prstDash val="solid"/>
+          </a:ln>
+        </p:spPr>
+      </p:sp>
+      <p:sp>
+        <p:nvSpPr>
+          <p:cNvPr id="32" name="Text 29"/>
+          <p:cNvSpPr txBox="1"/>
+          <p:nvPr/>
+        </p:nvSpPr>
+        <p:spPr>
+          <a:xfrm>
+            <a:off x="832104" y="3378708"/>
+            <a:ext cx="5006340" cy="201168"/>
+          </a:xfrm>
+          <a:prstGeom prst="rect">
+            <a:avLst/>
+          </a:prstGeom>
+          <a:noFill/>
+          <a:ln/>
+        </p:spPr>
+        <p:txBody>
+          <a:bodyPr wrap="square" lIns="0" tIns="0" rIns="0" bIns="0" rtlCol="0" anchor="ctr"/>
+          <a:lstStyle/>
+          <a:p>
+            <a:pPr indent="0" marL="0">
+              <a:buNone/>
+            </a:pPr>
+            <a:r>
+              <a:rPr lang="en-US" sz="1100" b="1" dirty="0">
+                <a:solidFill>
+                  <a:srgbClr val="0B2545"/>
+                </a:solidFill>
+                <a:latin typeface="Calibri" pitchFamily="34" charset="0"/>
+                <a:ea typeface="Calibri" pitchFamily="34" charset="-122"/>
+                <a:cs typeface="Calibri" pitchFamily="34" charset="-120"/>
+              </a:rPr>
+              <a:t>Eventos: </a:t>
+            </a:r>
+            <a:pPr indent="0" marL="0">
+              <a:buNone/>
+            </a:pPr>
+            <a:r>
+              <a:rPr lang="en-US" sz="1100" dirty="0">
+                <a:solidFill>
+                  <a:srgbClr val="1B2733"/>
+                </a:solidFill>
+                <a:latin typeface="Calibri" pitchFamily="34" charset="0"/>
+                <a:ea typeface="Calibri" pitchFamily="34" charset="-122"/>
+                <a:cs typeface="Calibri" pitchFamily="34" charset="-120"/>
+              </a:rPr>
+              <a:t>caídas de TC (25/09) y Orion (26/09); ventana de mantenimiento</a:t>
+            </a:r>
+            <a:endParaRPr lang="en-US" sz="1100" dirty="0"/>
+          </a:p>
+        </p:txBody>
+      </p:sp>
+      <p:sp>
+        <p:nvSpPr>
+          <p:cNvPr id="33" name="Shape 30"/>
+          <p:cNvSpPr/>
+          <p:nvPr/>
+        </p:nvSpPr>
+        <p:spPr>
+          <a:xfrm>
+            <a:off x="676656" y="3671316"/>
+            <a:ext cx="64008" cy="64008"/>
+          </a:xfrm>
+          <a:prstGeom prst="rect">
+            <a:avLst/>
+          </a:prstGeom>
+          <a:solidFill>
+            <a:srgbClr val="0B2545"/>
+          </a:solidFill>
+          <a:ln w="12700">
+            <a:solidFill>
+              <a:srgbClr val="0B2545"/>
+            </a:solidFill>
+            <a:prstDash val="solid"/>
+          </a:ln>
+        </p:spPr>
+      </p:sp>
+      <p:sp>
+        <p:nvSpPr>
+          <p:cNvPr id="34" name="Text 31"/>
+          <p:cNvSpPr txBox="1"/>
+          <p:nvPr/>
+        </p:nvSpPr>
+        <p:spPr>
+          <a:xfrm>
+            <a:off x="832104" y="3602736"/>
+            <a:ext cx="5006340" cy="201168"/>
+          </a:xfrm>
+          <a:prstGeom prst="rect">
+            <a:avLst/>
+          </a:prstGeom>
+          <a:noFill/>
+          <a:ln/>
+        </p:spPr>
+        <p:txBody>
+          <a:bodyPr wrap="square" lIns="0" tIns="0" rIns="0" bIns="0" rtlCol="0" anchor="ctr"/>
+          <a:lstStyle/>
+          <a:p>
+            <a:pPr indent="0" marL="0">
+              <a:buNone/>
+            </a:pPr>
+            <a:r>
+              <a:rPr lang="en-US" sz="1100" b="1" dirty="0">
+                <a:solidFill>
+                  <a:srgbClr val="0B2545"/>
+                </a:solidFill>
+                <a:latin typeface="Calibri" pitchFamily="34" charset="0"/>
+                <a:ea typeface="Calibri" pitchFamily="34" charset="-122"/>
+                <a:cs typeface="Calibri" pitchFamily="34" charset="-120"/>
+              </a:rPr>
+              <a:t>Opiniones: </a:t>
+            </a:r>
+            <a:pPr indent="0" marL="0">
+              <a:buNone/>
+            </a:pPr>
+            <a:r>
+              <a:rPr lang="en-US" sz="1100" dirty="0">
+                <a:solidFill>
+                  <a:srgbClr val="1B2733"/>
+                </a:solidFill>
+                <a:latin typeface="Calibri" pitchFamily="34" charset="0"/>
+                <a:ea typeface="Calibri" pitchFamily="34" charset="-122"/>
+                <a:cs typeface="Calibri" pitchFamily="34" charset="-120"/>
+              </a:rPr>
+              <a:t>Fábrica de Créditos y caso asociado J. Jacobo Marroquín</a:t>
+            </a:r>
+            <a:endParaRPr lang="en-US" sz="1100" dirty="0"/>
+          </a:p>
+        </p:txBody>
+      </p:sp>
+      <p:sp>
+        <p:nvSpPr>
+          <p:cNvPr id="35" name="Shape 32"/>
+          <p:cNvSpPr/>
+          <p:nvPr/>
+        </p:nvSpPr>
+        <p:spPr>
+          <a:xfrm>
+            <a:off x="676656" y="3895344"/>
+            <a:ext cx="64008" cy="64008"/>
+          </a:xfrm>
+          <a:prstGeom prst="rect">
+            <a:avLst/>
+          </a:prstGeom>
+          <a:solidFill>
+            <a:srgbClr val="0B2545"/>
+          </a:solidFill>
+          <a:ln w="12700">
+            <a:solidFill>
+              <a:srgbClr val="0B2545"/>
+            </a:solidFill>
+            <a:prstDash val="solid"/>
+          </a:ln>
+        </p:spPr>
+      </p:sp>
+      <p:sp>
+        <p:nvSpPr>
+          <p:cNvPr id="36" name="Text 33"/>
+          <p:cNvSpPr txBox="1"/>
+          <p:nvPr/>
+        </p:nvSpPr>
+        <p:spPr>
+          <a:xfrm>
+            <a:off x="832104" y="3826764"/>
+            <a:ext cx="5006340" cy="201168"/>
+          </a:xfrm>
+          <a:prstGeom prst="rect">
+            <a:avLst/>
+          </a:prstGeom>
+          <a:noFill/>
+          <a:ln/>
+        </p:spPr>
+        <p:txBody>
+          <a:bodyPr wrap="square" lIns="0" tIns="0" rIns="0" bIns="0" rtlCol="0" anchor="ctr"/>
+          <a:lstStyle/>
+          <a:p>
+            <a:pPr indent="0" marL="0">
+              <a:buNone/>
+            </a:pPr>
+            <a:r>
+              <a:rPr lang="en-US" sz="1100" b="1" dirty="0">
+                <a:solidFill>
+                  <a:srgbClr val="0B2545"/>
+                </a:solidFill>
+                <a:latin typeface="Calibri" pitchFamily="34" charset="0"/>
+                <a:ea typeface="Calibri" pitchFamily="34" charset="-122"/>
+                <a:cs typeface="Calibri" pitchFamily="34" charset="-120"/>
+              </a:rPr>
+              <a:t>Auditorías: </a:t>
+            </a:r>
+            <a:pPr indent="0" marL="0">
+              <a:buNone/>
+            </a:pPr>
+            <a:r>
+              <a:rPr lang="en-US" sz="1100" dirty="0">
+                <a:solidFill>
+                  <a:srgbClr val="1B2733"/>
+                </a:solidFill>
+                <a:latin typeface="Calibri" pitchFamily="34" charset="0"/>
+                <a:ea typeface="Calibri" pitchFamily="34" charset="-122"/>
+                <a:cs typeface="Calibri" pitchFamily="34" charset="-120"/>
+              </a:rPr>
+              <a:t>información a Auditoría Interna (NRP-24) y Auditoría Externa</a:t>
+            </a:r>
+            <a:endParaRPr lang="en-US" sz="1100" dirty="0"/>
+          </a:p>
+        </p:txBody>
+      </p:sp>
+      <p:sp>
+        <p:nvSpPr>
+          <p:cNvPr id="37" name="Shape 34"/>
+          <p:cNvSpPr/>
+          <p:nvPr/>
+        </p:nvSpPr>
+        <p:spPr>
+          <a:xfrm>
+            <a:off x="6167628" y="1920240"/>
+            <a:ext cx="5564124" cy="2203704"/>
           </a:xfrm>
           <a:prstGeom prst="roundRect">
             <a:avLst>
-              <a:gd name="adj" fmla="val 45455"/>
+              <a:gd name="adj" fmla="val 4979"/>
             </a:avLst>
           </a:prstGeom>
           <a:solidFill>
-            <a:srgbClr val="D5DDE6"/>
+            <a:srgbClr val="F1F5F9"/>
           </a:solidFill>
           <a:ln w="12700">
             <a:solidFill>
-              <a:srgbClr val="D5DDE6"/>
-            </a:solidFill>
-            <a:prstDash val="solid"/>
-          </a:ln>
-        </p:spPr>
-      </p:sp>
-      <p:sp>
-        <p:nvSpPr>
-          <p:cNvPr id="13" name="Shape 10"/>
-          <p:cNvSpPr/>
-          <p:nvPr/>
-        </p:nvSpPr>
-        <p:spPr>
-          <a:xfrm>
-            <a:off x="4352544" y="1728216"/>
-            <a:ext cx="864108" cy="100584"/>
+              <a:srgbClr val="F1F5F9"/>
+            </a:solidFill>
+            <a:prstDash val="solid"/>
+          </a:ln>
+        </p:spPr>
+      </p:sp>
+      <p:sp>
+        <p:nvSpPr>
+          <p:cNvPr id="38" name="Shape 35"/>
+          <p:cNvSpPr/>
+          <p:nvPr/>
+        </p:nvSpPr>
+        <p:spPr>
+          <a:xfrm>
+            <a:off x="6167628" y="1920240"/>
+            <a:ext cx="5564124" cy="749808"/>
           </a:xfrm>
           <a:prstGeom prst="roundRect">
             <a:avLst>
-              <a:gd name="adj" fmla="val 45455"/>
+              <a:gd name="adj" fmla="val 14634"/>
             </a:avLst>
           </a:prstGeom>
           <a:solidFill>
-            <a:srgbClr val="0E9AA7"/>
+            <a:srgbClr val="13507F"/>
           </a:solidFill>
           <a:ln w="12700">
             <a:solidFill>
-              <a:srgbClr val="0E9AA7"/>
-            </a:solidFill>
-            <a:prstDash val="solid"/>
-          </a:ln>
-        </p:spPr>
-      </p:sp>
-      <p:sp>
-        <p:nvSpPr>
-          <p:cNvPr id="14" name="Text 11"/>
-          <p:cNvSpPr txBox="1"/>
-          <p:nvPr/>
-        </p:nvSpPr>
-        <p:spPr>
-          <a:xfrm>
-            <a:off x="5358384" y="1645920"/>
-            <a:ext cx="411480" cy="256032"/>
-          </a:xfrm>
-          <a:prstGeom prst="rect">
-            <a:avLst/>
-          </a:prstGeom>
-          <a:noFill/>
-          <a:ln/>
-        </p:spPr>
-        <p:txBody>
-          <a:bodyPr wrap="square" lIns="0" tIns="0" rIns="0" bIns="0" rtlCol="0" anchor="ctr"/>
-          <a:lstStyle/>
-          <a:p>
-            <a:pPr algn="r" indent="0" marL="0">
-              <a:buNone/>
-            </a:pPr>
-            <a:r>
-              <a:rPr lang="en-US" sz="1200" b="1" dirty="0">
-                <a:solidFill>
-                  <a:srgbClr val="0E9AA7"/>
-                </a:solidFill>
-                <a:latin typeface="Calibri" pitchFamily="34" charset="0"/>
-                <a:ea typeface="Calibri" pitchFamily="34" charset="-122"/>
-                <a:cs typeface="Calibri" pitchFamily="34" charset="-120"/>
-              </a:rPr>
-              <a:t>90%</a:t>
-            </a:r>
-            <a:endParaRPr lang="en-US" sz="1200" dirty="0"/>
-          </a:p>
-        </p:txBody>
-      </p:sp>
-      <p:sp>
-        <p:nvSpPr>
-          <p:cNvPr id="15" name="Text 12"/>
-          <p:cNvSpPr txBox="1"/>
-          <p:nvPr/>
-        </p:nvSpPr>
-        <p:spPr>
-          <a:xfrm>
-            <a:off x="676656" y="2194560"/>
-            <a:ext cx="5102352" cy="1536192"/>
-          </a:xfrm>
-          <a:prstGeom prst="rect">
-            <a:avLst/>
-          </a:prstGeom>
-          <a:noFill/>
-          <a:ln/>
-        </p:spPr>
-        <p:txBody>
-          <a:bodyPr wrap="square" lIns="0" tIns="0" rIns="0" bIns="0" rtlCol="0" anchor="t"/>
-          <a:lstStyle/>
-          <a:p>
-            <a:pPr marL="152400" indent="-152400">
-              <a:spcAft>
-                <a:spcPts val="400"/>
-              </a:spcAft>
-              <a:buSzPct val="100000"/>
-              <a:buChar char="■"/>
-            </a:pPr>
-            <a:r>
-              <a:rPr lang="en-US" sz="1100" b="1" dirty="0">
-                <a:solidFill>
-                  <a:srgbClr val="0B2545"/>
-                </a:solidFill>
-                <a:latin typeface="Calibri" pitchFamily="34" charset="0"/>
-                <a:ea typeface="Calibri" pitchFamily="34" charset="-122"/>
-                <a:cs typeface="Calibri" pitchFamily="34" charset="-120"/>
-              </a:rPr>
-              <a:t>Capacitación GIR 2026:  </a:t>
-            </a:r>
-            <a:pPr indent="0" marL="0">
-              <a:buNone/>
-            </a:pPr>
-            <a:r>
-              <a:rPr lang="en-US" sz="1100" dirty="0">
-                <a:solidFill>
-                  <a:srgbClr val="1B2733"/>
-                </a:solidFill>
-                <a:latin typeface="Calibri" pitchFamily="34" charset="0"/>
-                <a:ea typeface="Calibri" pitchFamily="34" charset="-122"/>
-                <a:cs typeface="Calibri" pitchFamily="34" charset="-120"/>
-              </a:rPr>
-              <a:t>capacitación, examen e informe de seguimiento del examen</a:t>
-            </a:r>
-            <a:endParaRPr lang="en-US" sz="1100" dirty="0"/>
-          </a:p>
-          <a:p>
-            <a:pPr marL="152400" indent="-152400">
-              <a:spcAft>
-                <a:spcPts val="400"/>
-              </a:spcAft>
-              <a:buSzPct val="100000"/>
-              <a:buChar char="■"/>
-            </a:pPr>
-            <a:r>
-              <a:rPr lang="en-US" sz="1100" b="1" dirty="0">
-                <a:solidFill>
-                  <a:srgbClr val="0B2545"/>
-                </a:solidFill>
-                <a:latin typeface="Calibri" pitchFamily="34" charset="0"/>
-                <a:ea typeface="Calibri" pitchFamily="34" charset="-122"/>
-                <a:cs typeface="Calibri" pitchFamily="34" charset="-120"/>
-              </a:rPr>
-              <a:t>Continuidad:  </a:t>
-            </a:r>
-            <a:pPr indent="0" marL="0">
-              <a:buNone/>
-            </a:pPr>
-            <a:r>
-              <a:rPr lang="en-US" sz="1100" dirty="0">
-                <a:solidFill>
-                  <a:srgbClr val="1B2733"/>
-                </a:solidFill>
-                <a:latin typeface="Calibri" pitchFamily="34" charset="0"/>
-                <a:ea typeface="Calibri" pitchFamily="34" charset="-122"/>
-                <a:cs typeface="Calibri" pitchFamily="34" charset="-120"/>
-              </a:rPr>
-              <a:t>informe de la 2.ª prueba (01/10/2026) y actualización de Matriz BIA</a:t>
-            </a:r>
-            <a:endParaRPr lang="en-US" sz="1100" dirty="0"/>
-          </a:p>
-          <a:p>
-            <a:pPr marL="152400" indent="-152400">
-              <a:spcAft>
-                <a:spcPts val="400"/>
-              </a:spcAft>
-              <a:buSzPct val="100000"/>
-              <a:buChar char="■"/>
-            </a:pPr>
-            <a:r>
-              <a:rPr lang="en-US" sz="1100" b="1" dirty="0">
-                <a:solidFill>
-                  <a:srgbClr val="0B2545"/>
-                </a:solidFill>
-                <a:latin typeface="Calibri" pitchFamily="34" charset="0"/>
-                <a:ea typeface="Calibri" pitchFamily="34" charset="-122"/>
-                <a:cs typeface="Calibri" pitchFamily="34" charset="-120"/>
-              </a:rPr>
-              <a:t>Matriz de Riesgos Institucional 2026:  </a:t>
-            </a:r>
-            <a:pPr indent="0" marL="0">
-              <a:buNone/>
-            </a:pPr>
-            <a:r>
-              <a:rPr lang="en-US" sz="1100" dirty="0">
-                <a:solidFill>
-                  <a:srgbClr val="1B2733"/>
-                </a:solidFill>
-                <a:latin typeface="Calibri" pitchFamily="34" charset="0"/>
-                <a:ea typeface="Calibri" pitchFamily="34" charset="-122"/>
-                <a:cs typeface="Calibri" pitchFamily="34" charset="-120"/>
-              </a:rPr>
-              <a:t>seguimiento de planes de acción</a:t>
-            </a:r>
-            <a:endParaRPr lang="en-US" sz="1100" dirty="0"/>
-          </a:p>
-          <a:p>
-            <a:pPr marL="152400" indent="-152400">
-              <a:spcAft>
-                <a:spcPts val="400"/>
-              </a:spcAft>
-              <a:buSzPct val="100000"/>
-              <a:buChar char="■"/>
-            </a:pPr>
-            <a:r>
-              <a:rPr lang="en-US" sz="1100" b="1" dirty="0">
-                <a:solidFill>
-                  <a:srgbClr val="0B2545"/>
-                </a:solidFill>
-                <a:latin typeface="Calibri" pitchFamily="34" charset="0"/>
-                <a:ea typeface="Calibri" pitchFamily="34" charset="-122"/>
-                <a:cs typeface="Calibri" pitchFamily="34" charset="-120"/>
-              </a:rPr>
-              <a:t>Eventos:  </a:t>
-            </a:r>
-            <a:pPr indent="0" marL="0">
-              <a:buNone/>
-            </a:pPr>
-            <a:r>
-              <a:rPr lang="en-US" sz="1100" dirty="0">
-                <a:solidFill>
-                  <a:srgbClr val="1B2733"/>
-                </a:solidFill>
-                <a:latin typeface="Calibri" pitchFamily="34" charset="0"/>
-                <a:ea typeface="Calibri" pitchFamily="34" charset="-122"/>
-                <a:cs typeface="Calibri" pitchFamily="34" charset="-120"/>
-              </a:rPr>
-              <a:t>caídas de TC (25/09) y Orion (26/09); ventana de mantenimiento</a:t>
-            </a:r>
-            <a:endParaRPr lang="en-US" sz="1100" dirty="0"/>
-          </a:p>
-          <a:p>
-            <a:pPr marL="152400" indent="-152400">
-              <a:spcAft>
-                <a:spcPts val="400"/>
-              </a:spcAft>
-              <a:buSzPct val="100000"/>
-              <a:buChar char="■"/>
-            </a:pPr>
-            <a:r>
-              <a:rPr lang="en-US" sz="1100" b="1" dirty="0">
-                <a:solidFill>
-                  <a:srgbClr val="0B2545"/>
-                </a:solidFill>
-                <a:latin typeface="Calibri" pitchFamily="34" charset="0"/>
-                <a:ea typeface="Calibri" pitchFamily="34" charset="-122"/>
-                <a:cs typeface="Calibri" pitchFamily="34" charset="-120"/>
-              </a:rPr>
-              <a:t>Opiniones e informes:  </a:t>
-            </a:r>
-            <a:pPr indent="0" marL="0">
-              <a:buNone/>
-            </a:pPr>
-            <a:r>
-              <a:rPr lang="en-US" sz="1100" dirty="0">
-                <a:solidFill>
-                  <a:srgbClr val="1B2733"/>
-                </a:solidFill>
-                <a:latin typeface="Calibri" pitchFamily="34" charset="0"/>
-                <a:ea typeface="Calibri" pitchFamily="34" charset="-122"/>
-                <a:cs typeface="Calibri" pitchFamily="34" charset="-120"/>
-              </a:rPr>
-              <a:t>Fábrica de Créditos; caso asociado J. Jacobo Marroquín; Acuerdos Semestrales del Comité de Riesgos (Junta de Vigilancia)</a:t>
-            </a:r>
-            <a:endParaRPr lang="en-US" sz="1100" dirty="0"/>
-          </a:p>
-          <a:p>
-            <a:pPr marL="152400" indent="-152400">
-              <a:spcAft>
-                <a:spcPts val="400"/>
-              </a:spcAft>
-              <a:buSzPct val="100000"/>
-              <a:buChar char="■"/>
-            </a:pPr>
-            <a:r>
-              <a:rPr lang="en-US" sz="1100" b="1" dirty="0">
-                <a:solidFill>
-                  <a:srgbClr val="0B2545"/>
-                </a:solidFill>
-                <a:latin typeface="Calibri" pitchFamily="34" charset="0"/>
-                <a:ea typeface="Calibri" pitchFamily="34" charset="-122"/>
-                <a:cs typeface="Calibri" pitchFamily="34" charset="-120"/>
-              </a:rPr>
-              <a:t>Auditorías:  </a:t>
-            </a:r>
-            <a:pPr indent="0" marL="0">
-              <a:buNone/>
-            </a:pPr>
-            <a:r>
-              <a:rPr lang="en-US" sz="1100" dirty="0">
-                <a:solidFill>
-                  <a:srgbClr val="1B2733"/>
-                </a:solidFill>
-                <a:latin typeface="Calibri" pitchFamily="34" charset="0"/>
-                <a:ea typeface="Calibri" pitchFamily="34" charset="-122"/>
-                <a:cs typeface="Calibri" pitchFamily="34" charset="-120"/>
-              </a:rPr>
-              <a:t>información a Auditoría Interna (NRP-24) y Auditoría Externa</a:t>
-            </a:r>
-            <a:endParaRPr lang="en-US" sz="1100" dirty="0"/>
-          </a:p>
-        </p:txBody>
-      </p:sp>
-      <p:sp>
-        <p:nvSpPr>
-          <p:cNvPr id="16" name="Shape 13"/>
-          <p:cNvSpPr/>
-          <p:nvPr/>
-        </p:nvSpPr>
-        <p:spPr>
-          <a:xfrm>
-            <a:off x="6208776" y="1353312"/>
-            <a:ext cx="5522976" cy="2487168"/>
-          </a:xfrm>
-          <a:prstGeom prst="roundRect">
-            <a:avLst>
-              <a:gd name="adj" fmla="val 4412"/>
-            </a:avLst>
+              <a:srgbClr val="13507F"/>
+            </a:solidFill>
+            <a:prstDash val="solid"/>
+          </a:ln>
+        </p:spPr>
+      </p:sp>
+      <p:sp>
+        <p:nvSpPr>
+          <p:cNvPr id="39" name="Shape 36"/>
+          <p:cNvSpPr/>
+          <p:nvPr/>
+        </p:nvSpPr>
+        <p:spPr>
+          <a:xfrm>
+            <a:off x="6167628" y="2560320"/>
+            <a:ext cx="5564124" cy="182880"/>
+          </a:xfrm>
+          <a:prstGeom prst="rect">
+            <a:avLst/>
           </a:prstGeom>
           <a:solidFill>
             <a:srgbClr val="F1F5F9"/>
@@ -1655,24 +2351,24 @@
       </p:sp>
       <p:sp>
         <p:nvSpPr>
-          <p:cNvPr id="17" name="Shape 14"/>
-          <p:cNvSpPr/>
-          <p:nvPr/>
-        </p:nvSpPr>
-        <p:spPr>
-          <a:xfrm>
-            <a:off x="6409944" y="1536192"/>
-            <a:ext cx="512064" cy="512064"/>
+          <p:cNvPr id="40" name="Shape 37"/>
+          <p:cNvSpPr/>
+          <p:nvPr/>
+        </p:nvSpPr>
+        <p:spPr>
+          <a:xfrm>
+            <a:off x="6350508" y="2020824"/>
+            <a:ext cx="438912" cy="438912"/>
           </a:xfrm>
           <a:prstGeom prst="ellipse">
             <a:avLst/>
           </a:prstGeom>
           <a:solidFill>
-            <a:srgbClr val="0B2545"/>
+            <a:srgbClr val="FFFFFF"/>
           </a:solidFill>
           <a:ln w="12700">
             <a:solidFill>
-              <a:srgbClr val="0B2545"/>
+              <a:srgbClr val="FFFFFF"/>
             </a:solidFill>
             <a:prstDash val="solid"/>
           </a:ln>
@@ -1680,7 +2376,7 @@
       </p:sp>
       <p:pic>
         <p:nvPicPr>
-          <p:cNvPr id="18" name="Image 1" descr="preencoded.png">    </p:cNvPr>
+          <p:cNvPr id="41" name="Image 1" descr="preencoded.png">    </p:cNvPr>
           <p:cNvPicPr>
             <a:picLocks noChangeAspect="1"/>
           </p:cNvPicPr>
@@ -1694,8 +2390,8 @@
         </p:blipFill>
         <p:spPr>
           <a:xfrm>
-            <a:off x="6533388" y="1659636"/>
-            <a:ext cx="265176" cy="265176"/>
+            <a:off x="6455664" y="2125980"/>
+            <a:ext cx="228600" cy="228600"/>
           </a:xfrm>
           <a:prstGeom prst="rect">
             <a:avLst/>
@@ -1704,14 +2400,14 @@
       </p:pic>
       <p:sp>
         <p:nvSpPr>
-          <p:cNvPr id="19" name="Text 15"/>
-          <p:cNvSpPr txBox="1"/>
-          <p:nvPr/>
-        </p:nvSpPr>
-        <p:spPr>
-          <a:xfrm>
-            <a:off x="7068312" y="1508760"/>
-            <a:ext cx="2935224" cy="310896"/>
+          <p:cNvPr id="42" name="Text 38"/>
+          <p:cNvSpPr txBox="1"/>
+          <p:nvPr/>
+        </p:nvSpPr>
+        <p:spPr>
+          <a:xfrm>
+            <a:off x="6935724" y="1993392"/>
+            <a:ext cx="4649724" cy="292608"/>
           </a:xfrm>
           <a:prstGeom prst="rect">
             <a:avLst/>
@@ -1729,28 +2425,170 @@
             <a:r>
               <a:rPr lang="en-US" sz="1500" b="1" dirty="0">
                 <a:solidFill>
+                  <a:srgbClr val="FFFFFF"/>
+                </a:solidFill>
+                <a:latin typeface="Calibri" pitchFamily="34" charset="0"/>
+                <a:ea typeface="Calibri" pitchFamily="34" charset="-122"/>
+                <a:cs typeface="Calibri" pitchFamily="34" charset="-120"/>
+              </a:rPr>
+              <a:t>Riesgo Normativo y Requerimientos SSF</a:t>
+            </a:r>
+            <a:endParaRPr lang="en-US" sz="1500" dirty="0"/>
+          </a:p>
+        </p:txBody>
+      </p:sp>
+      <p:sp>
+        <p:nvSpPr>
+          <p:cNvPr id="43" name="Text 39"/>
+          <p:cNvSpPr txBox="1"/>
+          <p:nvPr/>
+        </p:nvSpPr>
+        <p:spPr>
+          <a:xfrm>
+            <a:off x="6935724" y="2267712"/>
+            <a:ext cx="4649724" cy="219456"/>
+          </a:xfrm>
+          <a:prstGeom prst="rect">
+            <a:avLst/>
+          </a:prstGeom>
+          <a:noFill/>
+          <a:ln/>
+        </p:spPr>
+        <p:txBody>
+          <a:bodyPr wrap="square" lIns="0" tIns="0" rIns="0" bIns="0" rtlCol="0" anchor="ctr"/>
+          <a:lstStyle/>
+          <a:p>
+            <a:pPr indent="0" marL="0">
+              <a:buNone/>
+            </a:pPr>
+            <a:r>
+              <a:rPr lang="en-US" sz="1050" i="1" dirty="0">
+                <a:solidFill>
+                  <a:srgbClr val="DCE8F3"/>
+                </a:solidFill>
+                <a:latin typeface="Calibri" pitchFamily="34" charset="0"/>
+                <a:ea typeface="Calibri" pitchFamily="34" charset="-122"/>
+                <a:cs typeface="Calibri" pitchFamily="34" charset="-120"/>
+              </a:rPr>
+              <a:t>Requerimientos coordinados con las áreas y pruebas de descargo</a:t>
+            </a:r>
+            <a:endParaRPr lang="en-US" sz="1050" dirty="0"/>
+          </a:p>
+        </p:txBody>
+      </p:sp>
+      <p:sp>
+        <p:nvSpPr>
+          <p:cNvPr id="44" name="Shape 40"/>
+          <p:cNvSpPr/>
+          <p:nvPr/>
+        </p:nvSpPr>
+        <p:spPr>
+          <a:xfrm>
+            <a:off x="6387084" y="2775204"/>
+            <a:ext cx="64008" cy="64008"/>
+          </a:xfrm>
+          <a:prstGeom prst="rect">
+            <a:avLst/>
+          </a:prstGeom>
+          <a:solidFill>
+            <a:srgbClr val="13507F"/>
+          </a:solidFill>
+          <a:ln w="12700">
+            <a:solidFill>
+              <a:srgbClr val="13507F"/>
+            </a:solidFill>
+            <a:prstDash val="solid"/>
+          </a:ln>
+        </p:spPr>
+      </p:sp>
+      <p:sp>
+        <p:nvSpPr>
+          <p:cNvPr id="45" name="Text 41"/>
+          <p:cNvSpPr txBox="1"/>
+          <p:nvPr/>
+        </p:nvSpPr>
+        <p:spPr>
+          <a:xfrm>
+            <a:off x="6542532" y="2706624"/>
+            <a:ext cx="5006340" cy="201168"/>
+          </a:xfrm>
+          <a:prstGeom prst="rect">
+            <a:avLst/>
+          </a:prstGeom>
+          <a:noFill/>
+          <a:ln/>
+        </p:spPr>
+        <p:txBody>
+          <a:bodyPr wrap="square" lIns="0" tIns="0" rIns="0" bIns="0" rtlCol="0" anchor="ctr"/>
+          <a:lstStyle/>
+          <a:p>
+            <a:pPr indent="0" marL="0">
+              <a:buNone/>
+            </a:pPr>
+            <a:r>
+              <a:rPr lang="en-US" sz="1100" b="1" dirty="0">
+                <a:solidFill>
                   <a:srgbClr val="0B2545"/>
                 </a:solidFill>
                 <a:latin typeface="Calibri" pitchFamily="34" charset="0"/>
                 <a:ea typeface="Calibri" pitchFamily="34" charset="-122"/>
                 <a:cs typeface="Calibri" pitchFamily="34" charset="-120"/>
               </a:rPr>
-              <a:t>Riesgo Normativo y SSF</a:t>
-            </a:r>
-            <a:endParaRPr lang="en-US" sz="1500" dirty="0"/>
-          </a:p>
-        </p:txBody>
-      </p:sp>
-      <p:sp>
-        <p:nvSpPr>
-          <p:cNvPr id="20" name="Text 16"/>
-          <p:cNvSpPr txBox="1"/>
-          <p:nvPr/>
-        </p:nvSpPr>
-        <p:spPr>
-          <a:xfrm>
-            <a:off x="7068312" y="1810512"/>
-            <a:ext cx="4425696" cy="256032"/>
+              <a:t>Gob. Corporativo · 22741: </a:t>
+            </a:r>
+            <a:pPr indent="0" marL="0">
+              <a:buNone/>
+            </a:pPr>
+            <a:r>
+              <a:rPr lang="en-US" sz="1100" dirty="0">
+                <a:solidFill>
+                  <a:srgbClr val="1B2733"/>
+                </a:solidFill>
+                <a:latin typeface="Calibri" pitchFamily="34" charset="0"/>
+                <a:ea typeface="Calibri" pitchFamily="34" charset="-122"/>
+                <a:cs typeface="Calibri" pitchFamily="34" charset="-120"/>
+              </a:rPr>
+              <a:t>requerimiento a áreas y descargos (visita 18432)</a:t>
+            </a:r>
+            <a:endParaRPr lang="en-US" sz="1100" dirty="0"/>
+          </a:p>
+        </p:txBody>
+      </p:sp>
+      <p:sp>
+        <p:nvSpPr>
+          <p:cNvPr id="46" name="Shape 42"/>
+          <p:cNvSpPr/>
+          <p:nvPr/>
+        </p:nvSpPr>
+        <p:spPr>
+          <a:xfrm>
+            <a:off x="6387084" y="2999232"/>
+            <a:ext cx="64008" cy="64008"/>
+          </a:xfrm>
+          <a:prstGeom prst="rect">
+            <a:avLst/>
+          </a:prstGeom>
+          <a:solidFill>
+            <a:srgbClr val="13507F"/>
+          </a:solidFill>
+          <a:ln w="12700">
+            <a:solidFill>
+              <a:srgbClr val="13507F"/>
+            </a:solidFill>
+            <a:prstDash val="solid"/>
+          </a:ln>
+        </p:spPr>
+      </p:sp>
+      <p:sp>
+        <p:nvSpPr>
+          <p:cNvPr id="47" name="Text 43"/>
+          <p:cNvSpPr txBox="1"/>
+          <p:nvPr/>
+        </p:nvSpPr>
+        <p:spPr>
+          <a:xfrm>
+            <a:off x="6542532" y="2930652"/>
+            <a:ext cx="5006340" cy="201168"/>
           </a:xfrm>
           <a:prstGeom prst="rect">
             <a:avLst/>
@@ -1766,15 +2604,29 @@
               <a:buNone/>
             </a:pPr>
             <a:r>
-              <a:rPr lang="en-US" sz="1100" i="1" dirty="0">
-                <a:solidFill>
-                  <a:srgbClr val="13507F"/>
-                </a:solidFill>
-                <a:latin typeface="Calibri" pitchFamily="34" charset="0"/>
-                <a:ea typeface="Calibri" pitchFamily="34" charset="-122"/>
-                <a:cs typeface="Calibri" pitchFamily="34" charset="-120"/>
-              </a:rPr>
-              <a:t>Requerimientos SSF coordinados con las áreas y pruebas de descargo</a:t>
+              <a:rPr lang="en-US" sz="1100" b="1" dirty="0">
+                <a:solidFill>
+                  <a:srgbClr val="0B2545"/>
+                </a:solidFill>
+                <a:latin typeface="Calibri" pitchFamily="34" charset="0"/>
+                <a:ea typeface="Calibri" pitchFamily="34" charset="-122"/>
+                <a:cs typeface="Calibri" pitchFamily="34" charset="-120"/>
+              </a:rPr>
+              <a:t>PLD/FT · 23486: </a:t>
+            </a:r>
+            <a:pPr indent="0" marL="0">
+              <a:buNone/>
+            </a:pPr>
+            <a:r>
+              <a:rPr lang="en-US" sz="1100" dirty="0">
+                <a:solidFill>
+                  <a:srgbClr val="1B2733"/>
+                </a:solidFill>
+                <a:latin typeface="Calibri" pitchFamily="34" charset="0"/>
+                <a:ea typeface="Calibri" pitchFamily="34" charset="-122"/>
+                <a:cs typeface="Calibri" pitchFamily="34" charset="-120"/>
+              </a:rPr>
+              <a:t>seguimiento al envío de pruebas de descargo</a:t>
             </a:r>
             <a:endParaRPr lang="en-US" sz="1100" dirty="0"/>
           </a:p>
@@ -1782,14 +2634,39 @@
       </p:sp>
       <p:sp>
         <p:nvSpPr>
-          <p:cNvPr id="21" name="Text 17"/>
-          <p:cNvSpPr txBox="1"/>
-          <p:nvPr/>
-        </p:nvSpPr>
-        <p:spPr>
-          <a:xfrm>
-            <a:off x="10104120" y="1463040"/>
-            <a:ext cx="1417320" cy="201168"/>
+          <p:cNvPr id="48" name="Shape 44"/>
+          <p:cNvSpPr/>
+          <p:nvPr/>
+        </p:nvSpPr>
+        <p:spPr>
+          <a:xfrm>
+            <a:off x="6387084" y="3223260"/>
+            <a:ext cx="64008" cy="64008"/>
+          </a:xfrm>
+          <a:prstGeom prst="rect">
+            <a:avLst/>
+          </a:prstGeom>
+          <a:solidFill>
+            <a:srgbClr val="13507F"/>
+          </a:solidFill>
+          <a:ln w="12700">
+            <a:solidFill>
+              <a:srgbClr val="13507F"/>
+            </a:solidFill>
+            <a:prstDash val="solid"/>
+          </a:ln>
+        </p:spPr>
+      </p:sp>
+      <p:sp>
+        <p:nvSpPr>
+          <p:cNvPr id="49" name="Text 45"/>
+          <p:cNvSpPr txBox="1"/>
+          <p:nvPr/>
+        </p:nvSpPr>
+        <p:spPr>
+          <a:xfrm>
+            <a:off x="6542532" y="3154680"/>
+            <a:ext cx="5006340" cy="201168"/>
           </a:xfrm>
           <a:prstGeom prst="rect">
             <a:avLst/>
@@ -1801,11 +2678,11 @@
           <a:bodyPr wrap="square" lIns="0" tIns="0" rIns="0" bIns="0" rtlCol="0" anchor="ctr"/>
           <a:lstStyle/>
           <a:p>
-            <a:pPr algn="r" indent="0" marL="0">
-              <a:buNone/>
-            </a:pPr>
-            <a:r>
-              <a:rPr lang="en-US" sz="950" b="1" dirty="0">
+            <a:pPr indent="0" marL="0">
+              <a:buNone/>
+            </a:pPr>
+            <a:r>
+              <a:rPr lang="en-US" sz="1100" b="1" dirty="0">
                 <a:solidFill>
                   <a:srgbClr val="0B2545"/>
                 </a:solidFill>
@@ -1813,352 +2690,327 @@
                 <a:ea typeface="Calibri" pitchFamily="34" charset="-122"/>
                 <a:cs typeface="Calibri" pitchFamily="34" charset="-120"/>
               </a:rPr>
-              <a:t>Avalúos (último reporte)</a:t>
-            </a:r>
-            <a:endParaRPr lang="en-US" sz="950" dirty="0"/>
-          </a:p>
-        </p:txBody>
-      </p:sp>
-      <p:sp>
-        <p:nvSpPr>
-          <p:cNvPr id="22" name="Shape 18"/>
-          <p:cNvSpPr/>
-          <p:nvPr/>
-        </p:nvSpPr>
-        <p:spPr>
-          <a:xfrm>
-            <a:off x="10104120" y="1728216"/>
-            <a:ext cx="960120" cy="100584"/>
+              <a:t>Riesgo Específico · 22742: </a:t>
+            </a:r>
+            <a:pPr indent="0" marL="0">
+              <a:buNone/>
+            </a:pPr>
+            <a:r>
+              <a:rPr lang="en-US" sz="1100" dirty="0">
+                <a:solidFill>
+                  <a:srgbClr val="1B2733"/>
+                </a:solidFill>
+                <a:latin typeface="Calibri" pitchFamily="34" charset="0"/>
+                <a:ea typeface="Calibri" pitchFamily="34" charset="-122"/>
+                <a:cs typeface="Calibri" pitchFamily="34" charset="-120"/>
+              </a:rPr>
+              <a:t>presentación de resultados preliminares</a:t>
+            </a:r>
+            <a:endParaRPr lang="en-US" sz="1100" dirty="0"/>
+          </a:p>
+        </p:txBody>
+      </p:sp>
+      <p:sp>
+        <p:nvSpPr>
+          <p:cNvPr id="50" name="Shape 46"/>
+          <p:cNvSpPr/>
+          <p:nvPr/>
+        </p:nvSpPr>
+        <p:spPr>
+          <a:xfrm>
+            <a:off x="6387084" y="3447288"/>
+            <a:ext cx="64008" cy="64008"/>
+          </a:xfrm>
+          <a:prstGeom prst="rect">
+            <a:avLst/>
+          </a:prstGeom>
+          <a:solidFill>
+            <a:srgbClr val="13507F"/>
+          </a:solidFill>
+          <a:ln w="12700">
+            <a:solidFill>
+              <a:srgbClr val="13507F"/>
+            </a:solidFill>
+            <a:prstDash val="solid"/>
+          </a:ln>
+        </p:spPr>
+      </p:sp>
+      <p:sp>
+        <p:nvSpPr>
+          <p:cNvPr id="51" name="Text 47"/>
+          <p:cNvSpPr txBox="1"/>
+          <p:nvPr/>
+        </p:nvSpPr>
+        <p:spPr>
+          <a:xfrm>
+            <a:off x="6542532" y="3378708"/>
+            <a:ext cx="5006340" cy="201168"/>
+          </a:xfrm>
+          <a:prstGeom prst="rect">
+            <a:avLst/>
+          </a:prstGeom>
+          <a:noFill/>
+          <a:ln/>
+        </p:spPr>
+        <p:txBody>
+          <a:bodyPr wrap="square" lIns="0" tIns="0" rIns="0" bIns="0" rtlCol="0" anchor="ctr"/>
+          <a:lstStyle/>
+          <a:p>
+            <a:pPr indent="0" marL="0">
+              <a:buNone/>
+            </a:pPr>
+            <a:r>
+              <a:rPr lang="en-US" sz="1100" b="1" dirty="0">
+                <a:solidFill>
+                  <a:srgbClr val="0B2545"/>
+                </a:solidFill>
+                <a:latin typeface="Calibri" pitchFamily="34" charset="0"/>
+                <a:ea typeface="Calibri" pitchFamily="34" charset="-122"/>
+                <a:cs typeface="Calibri" pitchFamily="34" charset="-120"/>
+              </a:rPr>
+              <a:t>Plan de Recuperación · 22737: </a:t>
+            </a:r>
+            <a:pPr indent="0" marL="0">
+              <a:buNone/>
+            </a:pPr>
+            <a:r>
+              <a:rPr lang="en-US" sz="1100" dirty="0">
+                <a:solidFill>
+                  <a:srgbClr val="1B2733"/>
+                </a:solidFill>
+                <a:latin typeface="Calibri" pitchFamily="34" charset="0"/>
+                <a:ea typeface="Calibri" pitchFamily="34" charset="-122"/>
+                <a:cs typeface="Calibri" pitchFamily="34" charset="-120"/>
+              </a:rPr>
+              <a:t>indicadores de Gob. Corporativo y Reputacional</a:t>
+            </a:r>
+            <a:endParaRPr lang="en-US" sz="1100" dirty="0"/>
+          </a:p>
+        </p:txBody>
+      </p:sp>
+      <p:sp>
+        <p:nvSpPr>
+          <p:cNvPr id="52" name="Shape 48"/>
+          <p:cNvSpPr/>
+          <p:nvPr/>
+        </p:nvSpPr>
+        <p:spPr>
+          <a:xfrm>
+            <a:off x="6387084" y="3671316"/>
+            <a:ext cx="64008" cy="64008"/>
+          </a:xfrm>
+          <a:prstGeom prst="rect">
+            <a:avLst/>
+          </a:prstGeom>
+          <a:solidFill>
+            <a:srgbClr val="13507F"/>
+          </a:solidFill>
+          <a:ln w="12700">
+            <a:solidFill>
+              <a:srgbClr val="13507F"/>
+            </a:solidFill>
+            <a:prstDash val="solid"/>
+          </a:ln>
+        </p:spPr>
+      </p:sp>
+      <p:sp>
+        <p:nvSpPr>
+          <p:cNvPr id="53" name="Text 49"/>
+          <p:cNvSpPr txBox="1"/>
+          <p:nvPr/>
+        </p:nvSpPr>
+        <p:spPr>
+          <a:xfrm>
+            <a:off x="6542532" y="3602736"/>
+            <a:ext cx="5006340" cy="201168"/>
+          </a:xfrm>
+          <a:prstGeom prst="rect">
+            <a:avLst/>
+          </a:prstGeom>
+          <a:noFill/>
+          <a:ln/>
+        </p:spPr>
+        <p:txBody>
+          <a:bodyPr wrap="square" lIns="0" tIns="0" rIns="0" bIns="0" rtlCol="0" anchor="ctr"/>
+          <a:lstStyle/>
+          <a:p>
+            <a:pPr indent="0" marL="0">
+              <a:buNone/>
+            </a:pPr>
+            <a:r>
+              <a:rPr lang="en-US" sz="1100" b="1" dirty="0">
+                <a:solidFill>
+                  <a:srgbClr val="0B2545"/>
+                </a:solidFill>
+                <a:latin typeface="Calibri" pitchFamily="34" charset="0"/>
+                <a:ea typeface="Calibri" pitchFamily="34" charset="-122"/>
+                <a:cs typeface="Calibri" pitchFamily="34" charset="-120"/>
+              </a:rPr>
+              <a:t>Avalúos: </a:t>
+            </a:r>
+            <a:pPr indent="0" marL="0">
+              <a:buNone/>
+            </a:pPr>
+            <a:r>
+              <a:rPr lang="en-US" sz="1100" dirty="0">
+                <a:solidFill>
+                  <a:srgbClr val="1B2733"/>
+                </a:solidFill>
+                <a:latin typeface="Calibri" pitchFamily="34" charset="0"/>
+                <a:ea typeface="Calibri" pitchFamily="34" charset="-122"/>
+                <a:cs typeface="Calibri" pitchFamily="34" charset="-120"/>
+              </a:rPr>
+              <a:t>política, procedimientos, perfil de revisor, peritos y avisos</a:t>
+            </a:r>
+            <a:endParaRPr lang="en-US" sz="1100" dirty="0"/>
+          </a:p>
+        </p:txBody>
+      </p:sp>
+      <p:sp>
+        <p:nvSpPr>
+          <p:cNvPr id="54" name="Shape 50"/>
+          <p:cNvSpPr/>
+          <p:nvPr/>
+        </p:nvSpPr>
+        <p:spPr>
+          <a:xfrm>
+            <a:off x="6387084" y="3895344"/>
+            <a:ext cx="64008" cy="64008"/>
+          </a:xfrm>
+          <a:prstGeom prst="rect">
+            <a:avLst/>
+          </a:prstGeom>
+          <a:solidFill>
+            <a:srgbClr val="13507F"/>
+          </a:solidFill>
+          <a:ln w="12700">
+            <a:solidFill>
+              <a:srgbClr val="13507F"/>
+            </a:solidFill>
+            <a:prstDash val="solid"/>
+          </a:ln>
+        </p:spPr>
+      </p:sp>
+      <p:sp>
+        <p:nvSpPr>
+          <p:cNvPr id="55" name="Text 51"/>
+          <p:cNvSpPr txBox="1"/>
+          <p:nvPr/>
+        </p:nvSpPr>
+        <p:spPr>
+          <a:xfrm>
+            <a:off x="6542532" y="3826764"/>
+            <a:ext cx="5006340" cy="201168"/>
+          </a:xfrm>
+          <a:prstGeom prst="rect">
+            <a:avLst/>
+          </a:prstGeom>
+          <a:noFill/>
+          <a:ln/>
+        </p:spPr>
+        <p:txBody>
+          <a:bodyPr wrap="square" lIns="0" tIns="0" rIns="0" bIns="0" rtlCol="0" anchor="ctr"/>
+          <a:lstStyle/>
+          <a:p>
+            <a:pPr indent="0" marL="0">
+              <a:buNone/>
+            </a:pPr>
+            <a:r>
+              <a:rPr lang="en-US" sz="1100" b="1" dirty="0">
+                <a:solidFill>
+                  <a:srgbClr val="0B2545"/>
+                </a:solidFill>
+                <a:latin typeface="Calibri" pitchFamily="34" charset="0"/>
+                <a:ea typeface="Calibri" pitchFamily="34" charset="-122"/>
+                <a:cs typeface="Calibri" pitchFamily="34" charset="-120"/>
+              </a:rPr>
+              <a:t>Comité y envíos: </a:t>
+            </a:r>
+            <a:pPr indent="0" marL="0">
+              <a:buNone/>
+            </a:pPr>
+            <a:r>
+              <a:rPr lang="en-US" sz="1100" dirty="0">
+                <a:solidFill>
+                  <a:srgbClr val="1B2733"/>
+                </a:solidFill>
+                <a:latin typeface="Calibri" pitchFamily="34" charset="0"/>
+                <a:ea typeface="Calibri" pitchFamily="34" charset="-122"/>
+                <a:cs typeface="Calibri" pitchFamily="34" charset="-120"/>
+              </a:rPr>
+              <a:t>Acuerdos Semestrales (J. Vigilancia), acta 29/08/2026, DAR</a:t>
+            </a:r>
+            <a:endParaRPr lang="en-US" sz="1100" dirty="0"/>
+          </a:p>
+        </p:txBody>
+      </p:sp>
+      <p:sp>
+        <p:nvSpPr>
+          <p:cNvPr id="56" name="Shape 52"/>
+          <p:cNvSpPr/>
+          <p:nvPr/>
+        </p:nvSpPr>
+        <p:spPr>
+          <a:xfrm>
+            <a:off x="457200" y="4270248"/>
+            <a:ext cx="5564124" cy="2203704"/>
           </a:xfrm>
           <a:prstGeom prst="roundRect">
             <a:avLst>
-              <a:gd name="adj" fmla="val 45455"/>
+              <a:gd name="adj" fmla="val 4979"/>
             </a:avLst>
           </a:prstGeom>
           <a:solidFill>
-            <a:srgbClr val="D5DDE6"/>
+            <a:srgbClr val="F1F5F9"/>
           </a:solidFill>
           <a:ln w="12700">
             <a:solidFill>
-              <a:srgbClr val="D5DDE6"/>
-            </a:solidFill>
-            <a:prstDash val="solid"/>
-          </a:ln>
-        </p:spPr>
-      </p:sp>
-      <p:sp>
-        <p:nvSpPr>
-          <p:cNvPr id="23" name="Shape 19"/>
-          <p:cNvSpPr/>
-          <p:nvPr/>
-        </p:nvSpPr>
-        <p:spPr>
-          <a:xfrm>
-            <a:off x="10104120" y="1728216"/>
-            <a:ext cx="576072" cy="100584"/>
+              <a:srgbClr val="F1F5F9"/>
+            </a:solidFill>
+            <a:prstDash val="solid"/>
+          </a:ln>
+        </p:spPr>
+      </p:sp>
+      <p:sp>
+        <p:nvSpPr>
+          <p:cNvPr id="57" name="Shape 53"/>
+          <p:cNvSpPr/>
+          <p:nvPr/>
+        </p:nvSpPr>
+        <p:spPr>
+          <a:xfrm>
+            <a:off x="457200" y="4270248"/>
+            <a:ext cx="5564124" cy="749808"/>
           </a:xfrm>
           <a:prstGeom prst="roundRect">
             <a:avLst>
-              <a:gd name="adj" fmla="val 45455"/>
+              <a:gd name="adj" fmla="val 14634"/>
             </a:avLst>
           </a:prstGeom>
           <a:solidFill>
-            <a:srgbClr val="0E9AA7"/>
+            <a:srgbClr val="0A7480"/>
           </a:solidFill>
           <a:ln w="12700">
             <a:solidFill>
-              <a:srgbClr val="0E9AA7"/>
-            </a:solidFill>
-            <a:prstDash val="solid"/>
-          </a:ln>
-        </p:spPr>
-      </p:sp>
-      <p:sp>
-        <p:nvSpPr>
-          <p:cNvPr id="24" name="Text 20"/>
-          <p:cNvSpPr txBox="1"/>
-          <p:nvPr/>
-        </p:nvSpPr>
-        <p:spPr>
-          <a:xfrm>
-            <a:off x="11109960" y="1645920"/>
-            <a:ext cx="411480" cy="256032"/>
-          </a:xfrm>
-          <a:prstGeom prst="rect">
-            <a:avLst/>
-          </a:prstGeom>
-          <a:noFill/>
-          <a:ln/>
-        </p:spPr>
-        <p:txBody>
-          <a:bodyPr wrap="square" lIns="0" tIns="0" rIns="0" bIns="0" rtlCol="0" anchor="ctr"/>
-          <a:lstStyle/>
-          <a:p>
-            <a:pPr algn="r" indent="0" marL="0">
-              <a:buNone/>
-            </a:pPr>
-            <a:r>
-              <a:rPr lang="en-US" sz="1200" b="1" dirty="0">
-                <a:solidFill>
-                  <a:srgbClr val="0E9AA7"/>
-                </a:solidFill>
-                <a:latin typeface="Calibri" pitchFamily="34" charset="0"/>
-                <a:ea typeface="Calibri" pitchFamily="34" charset="-122"/>
-                <a:cs typeface="Calibri" pitchFamily="34" charset="-120"/>
-              </a:rPr>
-              <a:t>60%</a:t>
-            </a:r>
-            <a:endParaRPr lang="en-US" sz="1200" dirty="0"/>
-          </a:p>
-        </p:txBody>
-      </p:sp>
-      <p:sp>
-        <p:nvSpPr>
-          <p:cNvPr id="25" name="Text 21"/>
-          <p:cNvSpPr txBox="1"/>
-          <p:nvPr/>
-        </p:nvSpPr>
-        <p:spPr>
-          <a:xfrm>
-            <a:off x="6428232" y="2194560"/>
-            <a:ext cx="5102352" cy="1536192"/>
-          </a:xfrm>
-          <a:prstGeom prst="rect">
-            <a:avLst/>
-          </a:prstGeom>
-          <a:noFill/>
-          <a:ln/>
-        </p:spPr>
-        <p:txBody>
-          <a:bodyPr wrap="square" lIns="0" tIns="0" rIns="0" bIns="0" rtlCol="0" anchor="t"/>
-          <a:lstStyle/>
-          <a:p>
-            <a:pPr marL="152400" indent="-152400">
-              <a:spcAft>
-                <a:spcPts val="400"/>
-              </a:spcAft>
-              <a:buSzPct val="100000"/>
-              <a:buChar char="■"/>
-            </a:pPr>
-            <a:r>
-              <a:rPr lang="en-US" sz="1100" b="1" dirty="0">
-                <a:solidFill>
-                  <a:srgbClr val="0B2545"/>
-                </a:solidFill>
-                <a:latin typeface="Calibri" pitchFamily="34" charset="0"/>
-                <a:ea typeface="Calibri" pitchFamily="34" charset="-122"/>
-                <a:cs typeface="Calibri" pitchFamily="34" charset="-120"/>
-              </a:rPr>
-              <a:t>Gobierno Corporativo · 22741:  </a:t>
-            </a:r>
-            <a:pPr indent="0" marL="0">
-              <a:buNone/>
-            </a:pPr>
-            <a:r>
-              <a:rPr lang="en-US" sz="1100" dirty="0">
-                <a:solidFill>
-                  <a:srgbClr val="1B2733"/>
-                </a:solidFill>
-                <a:latin typeface="Calibri" pitchFamily="34" charset="0"/>
-                <a:ea typeface="Calibri" pitchFamily="34" charset="-122"/>
-                <a:cs typeface="Calibri" pitchFamily="34" charset="-120"/>
-              </a:rPr>
-              <a:t>matriz de requerimiento, solicitudes a áreas y seguimiento de descargos (visita 18432)</a:t>
-            </a:r>
-            <a:endParaRPr lang="en-US" sz="1100" dirty="0"/>
-          </a:p>
-          <a:p>
-            <a:pPr marL="152400" indent="-152400">
-              <a:spcAft>
-                <a:spcPts val="400"/>
-              </a:spcAft>
-              <a:buSzPct val="100000"/>
-              <a:buChar char="■"/>
-            </a:pPr>
-            <a:r>
-              <a:rPr lang="en-US" sz="1100" b="1" dirty="0">
-                <a:solidFill>
-                  <a:srgbClr val="0B2545"/>
-                </a:solidFill>
-                <a:latin typeface="Calibri" pitchFamily="34" charset="0"/>
-                <a:ea typeface="Calibri" pitchFamily="34" charset="-122"/>
-                <a:cs typeface="Calibri" pitchFamily="34" charset="-120"/>
-              </a:rPr>
-              <a:t>PLD/FT · 23486:  </a:t>
-            </a:r>
-            <a:pPr indent="0" marL="0">
-              <a:buNone/>
-            </a:pPr>
-            <a:r>
-              <a:rPr lang="en-US" sz="1100" dirty="0">
-                <a:solidFill>
-                  <a:srgbClr val="1B2733"/>
-                </a:solidFill>
-                <a:latin typeface="Calibri" pitchFamily="34" charset="0"/>
-                <a:ea typeface="Calibri" pitchFamily="34" charset="-122"/>
-                <a:cs typeface="Calibri" pitchFamily="34" charset="-120"/>
-              </a:rPr>
-              <a:t>seguimiento al envío de pruebas de descargo</a:t>
-            </a:r>
-            <a:endParaRPr lang="en-US" sz="1100" dirty="0"/>
-          </a:p>
-          <a:p>
-            <a:pPr marL="152400" indent="-152400">
-              <a:spcAft>
-                <a:spcPts val="400"/>
-              </a:spcAft>
-              <a:buSzPct val="100000"/>
-              <a:buChar char="■"/>
-            </a:pPr>
-            <a:r>
-              <a:rPr lang="en-US" sz="1100" b="1" dirty="0">
-                <a:solidFill>
-                  <a:srgbClr val="0B2545"/>
-                </a:solidFill>
-                <a:latin typeface="Calibri" pitchFamily="34" charset="0"/>
-                <a:ea typeface="Calibri" pitchFamily="34" charset="-122"/>
-                <a:cs typeface="Calibri" pitchFamily="34" charset="-120"/>
-              </a:rPr>
-              <a:t>Riesgo Específico · 22742:  </a:t>
-            </a:r>
-            <a:pPr indent="0" marL="0">
-              <a:buNone/>
-            </a:pPr>
-            <a:r>
-              <a:rPr lang="en-US" sz="1100" dirty="0">
-                <a:solidFill>
-                  <a:srgbClr val="1B2733"/>
-                </a:solidFill>
-                <a:latin typeface="Calibri" pitchFamily="34" charset="0"/>
-                <a:ea typeface="Calibri" pitchFamily="34" charset="-122"/>
-                <a:cs typeface="Calibri" pitchFamily="34" charset="-120"/>
-              </a:rPr>
-              <a:t>presentación de resultados preliminares</a:t>
-            </a:r>
-            <a:endParaRPr lang="en-US" sz="1100" dirty="0"/>
-          </a:p>
-          <a:p>
-            <a:pPr marL="152400" indent="-152400">
-              <a:spcAft>
-                <a:spcPts val="400"/>
-              </a:spcAft>
-              <a:buSzPct val="100000"/>
-              <a:buChar char="■"/>
-            </a:pPr>
-            <a:r>
-              <a:rPr lang="en-US" sz="1100" b="1" dirty="0">
-                <a:solidFill>
-                  <a:srgbClr val="0B2545"/>
-                </a:solidFill>
-                <a:latin typeface="Calibri" pitchFamily="34" charset="0"/>
-                <a:ea typeface="Calibri" pitchFamily="34" charset="-122"/>
-                <a:cs typeface="Calibri" pitchFamily="34" charset="-120"/>
-              </a:rPr>
-              <a:t>Plan de Recuperación · 22737:  </a:t>
-            </a:r>
-            <a:pPr indent="0" marL="0">
-              <a:buNone/>
-            </a:pPr>
-            <a:r>
-              <a:rPr lang="en-US" sz="1100" dirty="0">
-                <a:solidFill>
-                  <a:srgbClr val="1B2733"/>
-                </a:solidFill>
-                <a:latin typeface="Calibri" pitchFamily="34" charset="0"/>
-                <a:ea typeface="Calibri" pitchFamily="34" charset="-122"/>
-                <a:cs typeface="Calibri" pitchFamily="34" charset="-120"/>
-              </a:rPr>
-              <a:t>indicadores de Gobierno Corporativo y Reputacional</a:t>
-            </a:r>
-            <a:endParaRPr lang="en-US" sz="1100" dirty="0"/>
-          </a:p>
-          <a:p>
-            <a:pPr marL="152400" indent="-152400">
-              <a:spcAft>
-                <a:spcPts val="400"/>
-              </a:spcAft>
-              <a:buSzPct val="100000"/>
-              <a:buChar char="■"/>
-            </a:pPr>
-            <a:r>
-              <a:rPr lang="en-US" sz="1100" b="1" dirty="0">
-                <a:solidFill>
-                  <a:srgbClr val="0B2545"/>
-                </a:solidFill>
-                <a:latin typeface="Calibri" pitchFamily="34" charset="0"/>
-                <a:ea typeface="Calibri" pitchFamily="34" charset="-122"/>
-                <a:cs typeface="Calibri" pitchFamily="34" charset="-120"/>
-              </a:rPr>
-              <a:t>Avalúos:  </a:t>
-            </a:r>
-            <a:pPr indent="0" marL="0">
-              <a:buNone/>
-            </a:pPr>
-            <a:r>
-              <a:rPr lang="en-US" sz="1100" dirty="0">
-                <a:solidFill>
-                  <a:srgbClr val="1B2733"/>
-                </a:solidFill>
-                <a:latin typeface="Calibri" pitchFamily="34" charset="0"/>
-                <a:ea typeface="Calibri" pitchFamily="34" charset="-122"/>
-                <a:cs typeface="Calibri" pitchFamily="34" charset="-120"/>
-              </a:rPr>
-              <a:t>política, procedimientos y perfil de revisor; asignación a perito, gestión electrónica y aviso a asociados</a:t>
-            </a:r>
-            <a:endParaRPr lang="en-US" sz="1100" dirty="0"/>
-          </a:p>
-          <a:p>
-            <a:pPr marL="152400" indent="-152400">
-              <a:spcAft>
-                <a:spcPts val="400"/>
-              </a:spcAft>
-              <a:buSzPct val="100000"/>
-              <a:buChar char="■"/>
-            </a:pPr>
-            <a:r>
-              <a:rPr lang="en-US" sz="1100" b="1" dirty="0">
-                <a:solidFill>
-                  <a:srgbClr val="0B2545"/>
-                </a:solidFill>
-                <a:latin typeface="Calibri" pitchFamily="34" charset="0"/>
-                <a:ea typeface="Calibri" pitchFamily="34" charset="-122"/>
-                <a:cs typeface="Calibri" pitchFamily="34" charset="-120"/>
-              </a:rPr>
-              <a:t>Otros:  </a:t>
-            </a:r>
-            <a:pPr indent="0" marL="0">
-              <a:buNone/>
-            </a:pPr>
-            <a:r>
-              <a:rPr lang="en-US" sz="1100" dirty="0">
-                <a:solidFill>
-                  <a:srgbClr val="1B2733"/>
-                </a:solidFill>
-                <a:latin typeface="Calibri" pitchFamily="34" charset="0"/>
-                <a:ea typeface="Calibri" pitchFamily="34" charset="-122"/>
-                <a:cs typeface="Calibri" pitchFamily="34" charset="-120"/>
-              </a:rPr>
-              <a:t>envíos regulatorios (DAR); acta de sesión del 29/08/2026</a:t>
-            </a:r>
-            <a:endParaRPr lang="en-US" sz="1100" dirty="0"/>
-          </a:p>
-        </p:txBody>
-      </p:sp>
-      <p:sp>
-        <p:nvSpPr>
-          <p:cNvPr id="26" name="Shape 22"/>
-          <p:cNvSpPr/>
-          <p:nvPr/>
-        </p:nvSpPr>
-        <p:spPr>
-          <a:xfrm>
-            <a:off x="457200" y="3986784"/>
-            <a:ext cx="5522976" cy="2487168"/>
-          </a:xfrm>
-          <a:prstGeom prst="roundRect">
-            <a:avLst>
-              <a:gd name="adj" fmla="val 4412"/>
-            </a:avLst>
+              <a:srgbClr val="0A7480"/>
+            </a:solidFill>
+            <a:prstDash val="solid"/>
+          </a:ln>
+        </p:spPr>
+      </p:sp>
+      <p:sp>
+        <p:nvSpPr>
+          <p:cNvPr id="58" name="Shape 54"/>
+          <p:cNvSpPr/>
+          <p:nvPr/>
+        </p:nvSpPr>
+        <p:spPr>
+          <a:xfrm>
+            <a:off x="457200" y="4910328"/>
+            <a:ext cx="5564124" cy="182880"/>
+          </a:xfrm>
+          <a:prstGeom prst="rect">
+            <a:avLst/>
           </a:prstGeom>
           <a:solidFill>
             <a:srgbClr val="F1F5F9"/>
@@ -2173,24 +3025,24 @@
       </p:sp>
       <p:sp>
         <p:nvSpPr>
-          <p:cNvPr id="27" name="Shape 23"/>
-          <p:cNvSpPr/>
-          <p:nvPr/>
-        </p:nvSpPr>
-        <p:spPr>
-          <a:xfrm>
-            <a:off x="658368" y="4169664"/>
-            <a:ext cx="512064" cy="512064"/>
+          <p:cNvPr id="59" name="Shape 55"/>
+          <p:cNvSpPr/>
+          <p:nvPr/>
+        </p:nvSpPr>
+        <p:spPr>
+          <a:xfrm>
+            <a:off x="640080" y="4370832"/>
+            <a:ext cx="438912" cy="438912"/>
           </a:xfrm>
           <a:prstGeom prst="ellipse">
             <a:avLst/>
           </a:prstGeom>
           <a:solidFill>
-            <a:srgbClr val="0B2545"/>
+            <a:srgbClr val="FFFFFF"/>
           </a:solidFill>
           <a:ln w="12700">
             <a:solidFill>
-              <a:srgbClr val="0B2545"/>
+              <a:srgbClr val="FFFFFF"/>
             </a:solidFill>
             <a:prstDash val="solid"/>
           </a:ln>
@@ -2198,7 +3050,7 @@
       </p:sp>
       <p:pic>
         <p:nvPicPr>
-          <p:cNvPr id="28" name="Image 2" descr="preencoded.png">    </p:cNvPr>
+          <p:cNvPr id="60" name="Image 2" descr="preencoded.png">    </p:cNvPr>
           <p:cNvPicPr>
             <a:picLocks noChangeAspect="1"/>
           </p:cNvPicPr>
@@ -2212,8 +3064,8 @@
         </p:blipFill>
         <p:spPr>
           <a:xfrm>
-            <a:off x="781812" y="4293108"/>
-            <a:ext cx="265176" cy="265176"/>
+            <a:off x="745236" y="4475988"/>
+            <a:ext cx="228600" cy="228600"/>
           </a:xfrm>
           <a:prstGeom prst="rect">
             <a:avLst/>
@@ -2222,14 +3074,14 @@
       </p:pic>
       <p:sp>
         <p:nvSpPr>
-          <p:cNvPr id="29" name="Text 24"/>
-          <p:cNvSpPr txBox="1"/>
-          <p:nvPr/>
-        </p:nvSpPr>
-        <p:spPr>
-          <a:xfrm>
-            <a:off x="1316736" y="4142232"/>
-            <a:ext cx="4425696" cy="310896"/>
+          <p:cNvPr id="61" name="Text 56"/>
+          <p:cNvSpPr txBox="1"/>
+          <p:nvPr/>
+        </p:nvSpPr>
+        <p:spPr>
+          <a:xfrm>
+            <a:off x="1225296" y="4343400"/>
+            <a:ext cx="4649724" cy="292608"/>
           </a:xfrm>
           <a:prstGeom prst="rect">
             <a:avLst/>
@@ -2247,28 +3099,170 @@
             <a:r>
               <a:rPr lang="en-US" sz="1500" b="1" dirty="0">
                 <a:solidFill>
+                  <a:srgbClr val="FFFFFF"/>
+                </a:solidFill>
+                <a:latin typeface="Calibri" pitchFamily="34" charset="0"/>
+                <a:ea typeface="Calibri" pitchFamily="34" charset="-122"/>
+                <a:cs typeface="Calibri" pitchFamily="34" charset="-120"/>
+              </a:rPr>
+              <a:t>Riesgo Financiero y Crediticio</a:t>
+            </a:r>
+            <a:endParaRPr lang="en-US" sz="1500" dirty="0"/>
+          </a:p>
+        </p:txBody>
+      </p:sp>
+      <p:sp>
+        <p:nvSpPr>
+          <p:cNvPr id="62" name="Text 57"/>
+          <p:cNvSpPr txBox="1"/>
+          <p:nvPr/>
+        </p:nvSpPr>
+        <p:spPr>
+          <a:xfrm>
+            <a:off x="1225296" y="4617720"/>
+            <a:ext cx="4649724" cy="219456"/>
+          </a:xfrm>
+          <a:prstGeom prst="rect">
+            <a:avLst/>
+          </a:prstGeom>
+          <a:noFill/>
+          <a:ln/>
+        </p:spPr>
+        <p:txBody>
+          <a:bodyPr wrap="square" lIns="0" tIns="0" rIns="0" bIns="0" rtlCol="0" anchor="ctr"/>
+          <a:lstStyle/>
+          <a:p>
+            <a:pPr indent="0" marL="0">
+              <a:buNone/>
+            </a:pPr>
+            <a:r>
+              <a:rPr lang="en-US" sz="1050" i="1" dirty="0">
+                <a:solidFill>
+                  <a:srgbClr val="DCE8F3"/>
+                </a:solidFill>
+                <a:latin typeface="Calibri" pitchFamily="34" charset="0"/>
+                <a:ea typeface="Calibri" pitchFamily="34" charset="-122"/>
+                <a:cs typeface="Calibri" pitchFamily="34" charset="-120"/>
+              </a:rPr>
+              <a:t>Medición, reportes regulatorios y control de cartera y reservas</a:t>
+            </a:r>
+            <a:endParaRPr lang="en-US" sz="1050" dirty="0"/>
+          </a:p>
+        </p:txBody>
+      </p:sp>
+      <p:sp>
+        <p:nvSpPr>
+          <p:cNvPr id="63" name="Shape 58"/>
+          <p:cNvSpPr/>
+          <p:nvPr/>
+        </p:nvSpPr>
+        <p:spPr>
+          <a:xfrm>
+            <a:off x="676656" y="5125212"/>
+            <a:ext cx="64008" cy="64008"/>
+          </a:xfrm>
+          <a:prstGeom prst="rect">
+            <a:avLst/>
+          </a:prstGeom>
+          <a:solidFill>
+            <a:srgbClr val="0A7480"/>
+          </a:solidFill>
+          <a:ln w="12700">
+            <a:solidFill>
+              <a:srgbClr val="0A7480"/>
+            </a:solidFill>
+            <a:prstDash val="solid"/>
+          </a:ln>
+        </p:spPr>
+      </p:sp>
+      <p:sp>
+        <p:nvSpPr>
+          <p:cNvPr id="64" name="Text 59"/>
+          <p:cNvSpPr txBox="1"/>
+          <p:nvPr/>
+        </p:nvSpPr>
+        <p:spPr>
+          <a:xfrm>
+            <a:off x="832104" y="5056632"/>
+            <a:ext cx="5006340" cy="201168"/>
+          </a:xfrm>
+          <a:prstGeom prst="rect">
+            <a:avLst/>
+          </a:prstGeom>
+          <a:noFill/>
+          <a:ln/>
+        </p:spPr>
+        <p:txBody>
+          <a:bodyPr wrap="square" lIns="0" tIns="0" rIns="0" bIns="0" rtlCol="0" anchor="ctr"/>
+          <a:lstStyle/>
+          <a:p>
+            <a:pPr indent="0" marL="0">
+              <a:buNone/>
+            </a:pPr>
+            <a:r>
+              <a:rPr lang="en-US" sz="1100" b="1" dirty="0">
+                <a:solidFill>
                   <a:srgbClr val="0B2545"/>
                 </a:solidFill>
                 <a:latin typeface="Calibri" pitchFamily="34" charset="0"/>
                 <a:ea typeface="Calibri" pitchFamily="34" charset="-122"/>
                 <a:cs typeface="Calibri" pitchFamily="34" charset="-120"/>
               </a:rPr>
-              <a:t>Riesgo Financiero y Crediticio</a:t>
-            </a:r>
-            <a:endParaRPr lang="en-US" sz="1500" dirty="0"/>
-          </a:p>
-        </p:txBody>
-      </p:sp>
-      <p:sp>
-        <p:nvSpPr>
-          <p:cNvPr id="30" name="Text 25"/>
-          <p:cNvSpPr txBox="1"/>
-          <p:nvPr/>
-        </p:nvSpPr>
-        <p:spPr>
-          <a:xfrm>
-            <a:off x="1316736" y="4443984"/>
-            <a:ext cx="4425696" cy="256032"/>
+              <a:t>Crédito: </a:t>
+            </a:r>
+            <a:pPr indent="0" marL="0">
+              <a:buNone/>
+            </a:pPr>
+            <a:r>
+              <a:rPr lang="en-US" sz="1100" dirty="0">
+                <a:solidFill>
+                  <a:srgbClr val="1B2733"/>
+                </a:solidFill>
+                <a:latin typeface="Calibri" pitchFamily="34" charset="0"/>
+                <a:ea typeface="Calibri" pitchFamily="34" charset="-122"/>
+                <a:cs typeface="Calibri" pitchFamily="34" charset="-120"/>
+              </a:rPr>
+              <a:t>pérdidas esperadas, matrices de transición y cosechas (Comité)</a:t>
+            </a:r>
+            <a:endParaRPr lang="en-US" sz="1100" dirty="0"/>
+          </a:p>
+        </p:txBody>
+      </p:sp>
+      <p:sp>
+        <p:nvSpPr>
+          <p:cNvPr id="65" name="Shape 60"/>
+          <p:cNvSpPr/>
+          <p:nvPr/>
+        </p:nvSpPr>
+        <p:spPr>
+          <a:xfrm>
+            <a:off x="676656" y="5349240"/>
+            <a:ext cx="64008" cy="64008"/>
+          </a:xfrm>
+          <a:prstGeom prst="rect">
+            <a:avLst/>
+          </a:prstGeom>
+          <a:solidFill>
+            <a:srgbClr val="0A7480"/>
+          </a:solidFill>
+          <a:ln w="12700">
+            <a:solidFill>
+              <a:srgbClr val="0A7480"/>
+            </a:solidFill>
+            <a:prstDash val="solid"/>
+          </a:ln>
+        </p:spPr>
+      </p:sp>
+      <p:sp>
+        <p:nvSpPr>
+          <p:cNvPr id="66" name="Text 61"/>
+          <p:cNvSpPr txBox="1"/>
+          <p:nvPr/>
+        </p:nvSpPr>
+        <p:spPr>
+          <a:xfrm>
+            <a:off x="832104" y="5280660"/>
+            <a:ext cx="5006340" cy="201168"/>
           </a:xfrm>
           <a:prstGeom prst="rect">
             <a:avLst/>
@@ -2284,15 +3278,29 @@
               <a:buNone/>
             </a:pPr>
             <a:r>
-              <a:rPr lang="en-US" sz="1100" i="1" dirty="0">
-                <a:solidFill>
-                  <a:srgbClr val="13507F"/>
-                </a:solidFill>
-                <a:latin typeface="Calibri" pitchFamily="34" charset="0"/>
-                <a:ea typeface="Calibri" pitchFamily="34" charset="-122"/>
-                <a:cs typeface="Calibri" pitchFamily="34" charset="-120"/>
-              </a:rPr>
-              <a:t>Medición, reportes regulatorios y control de cartera y reservas</a:t>
+              <a:rPr lang="en-US" sz="1100" b="1" dirty="0">
+                <a:solidFill>
+                  <a:srgbClr val="0B2545"/>
+                </a:solidFill>
+                <a:latin typeface="Calibri" pitchFamily="34" charset="0"/>
+                <a:ea typeface="Calibri" pitchFamily="34" charset="-122"/>
+                <a:cs typeface="Calibri" pitchFamily="34" charset="-120"/>
+              </a:rPr>
+              <a:t>Liquidez y mercado: </a:t>
+            </a:r>
+            <a:pPr indent="0" marL="0">
+              <a:buNone/>
+            </a:pPr>
+            <a:r>
+              <a:rPr lang="en-US" sz="1100" dirty="0">
+                <a:solidFill>
+                  <a:srgbClr val="1B2733"/>
+                </a:solidFill>
+                <a:latin typeface="Calibri" pitchFamily="34" charset="0"/>
+                <a:ea typeface="Calibri" pitchFamily="34" charset="-122"/>
+                <a:cs typeface="Calibri" pitchFamily="34" charset="-120"/>
+              </a:rPr>
+              <a:t>informe al Comité, escenarios y anexo 03 NRP-05</a:t>
             </a:r>
             <a:endParaRPr lang="en-US" sz="1100" dirty="0"/>
           </a:p>
@@ -2300,31 +3308,52 @@
       </p:sp>
       <p:sp>
         <p:nvSpPr>
-          <p:cNvPr id="31" name="Text 26"/>
-          <p:cNvSpPr txBox="1"/>
-          <p:nvPr/>
-        </p:nvSpPr>
-        <p:spPr>
-          <a:xfrm>
-            <a:off x="676656" y="4828032"/>
-            <a:ext cx="5102352" cy="1536192"/>
-          </a:xfrm>
-          <a:prstGeom prst="rect">
-            <a:avLst/>
-          </a:prstGeom>
-          <a:noFill/>
-          <a:ln/>
-        </p:spPr>
-        <p:txBody>
-          <a:bodyPr wrap="square" lIns="0" tIns="0" rIns="0" bIns="0" rtlCol="0" anchor="t"/>
-          <a:lstStyle/>
-          <a:p>
-            <a:pPr marL="152400" indent="-152400">
-              <a:spcAft>
-                <a:spcPts val="400"/>
-              </a:spcAft>
-              <a:buSzPct val="100000"/>
-              <a:buChar char="■"/>
+          <p:cNvPr id="67" name="Shape 62"/>
+          <p:cNvSpPr/>
+          <p:nvPr/>
+        </p:nvSpPr>
+        <p:spPr>
+          <a:xfrm>
+            <a:off x="676656" y="5573268"/>
+            <a:ext cx="64008" cy="64008"/>
+          </a:xfrm>
+          <a:prstGeom prst="rect">
+            <a:avLst/>
+          </a:prstGeom>
+          <a:solidFill>
+            <a:srgbClr val="0A7480"/>
+          </a:solidFill>
+          <a:ln w="12700">
+            <a:solidFill>
+              <a:srgbClr val="0A7480"/>
+            </a:solidFill>
+            <a:prstDash val="solid"/>
+          </a:ln>
+        </p:spPr>
+      </p:sp>
+      <p:sp>
+        <p:nvSpPr>
+          <p:cNvPr id="68" name="Text 63"/>
+          <p:cNvSpPr txBox="1"/>
+          <p:nvPr/>
+        </p:nvSpPr>
+        <p:spPr>
+          <a:xfrm>
+            <a:off x="832104" y="5504688"/>
+            <a:ext cx="5006340" cy="201168"/>
+          </a:xfrm>
+          <a:prstGeom prst="rect">
+            <a:avLst/>
+          </a:prstGeom>
+          <a:noFill/>
+          <a:ln/>
+        </p:spPr>
+        <p:txBody>
+          <a:bodyPr wrap="square" lIns="0" tIns="0" rIns="0" bIns="0" rtlCol="0" anchor="ctr"/>
+          <a:lstStyle/>
+          <a:p>
+            <a:pPr indent="0" marL="0">
+              <a:buNone/>
             </a:pPr>
             <a:r>
               <a:rPr lang="en-US" sz="1100" b="1" dirty="0">
@@ -2335,7 +3364,7 @@
                 <a:ea typeface="Calibri" pitchFamily="34" charset="-122"/>
                 <a:cs typeface="Calibri" pitchFamily="34" charset="-120"/>
               </a:rPr>
-              <a:t>Crédito:  </a:t>
+              <a:t>Activos de riesgo: </a:t>
             </a:r>
             <a:pPr indent="0" marL="0">
               <a:buNone/>
@@ -2349,17 +3378,60 @@
                 <a:ea typeface="Calibri" pitchFamily="34" charset="-122"/>
                 <a:cs typeface="Calibri" pitchFamily="34" charset="-120"/>
               </a:rPr>
-              <a:t>informe al Comité – pérdidas esperadas, matrices de transición, cosechas</a:t>
+              <a:t>NCB-022, Central de Riesgo, CTRI-RECR, relacionados</a:t>
             </a:r>
             <a:endParaRPr lang="en-US" sz="1100" dirty="0"/>
           </a:p>
-          <a:p>
-            <a:pPr marL="152400" indent="-152400">
-              <a:spcAft>
-                <a:spcPts val="400"/>
-              </a:spcAft>
-              <a:buSzPct val="100000"/>
-              <a:buChar char="■"/>
+        </p:txBody>
+      </p:sp>
+      <p:sp>
+        <p:nvSpPr>
+          <p:cNvPr id="69" name="Shape 64"/>
+          <p:cNvSpPr/>
+          <p:nvPr/>
+        </p:nvSpPr>
+        <p:spPr>
+          <a:xfrm>
+            <a:off x="676656" y="5797296"/>
+            <a:ext cx="64008" cy="64008"/>
+          </a:xfrm>
+          <a:prstGeom prst="rect">
+            <a:avLst/>
+          </a:prstGeom>
+          <a:solidFill>
+            <a:srgbClr val="0A7480"/>
+          </a:solidFill>
+          <a:ln w="12700">
+            <a:solidFill>
+              <a:srgbClr val="0A7480"/>
+            </a:solidFill>
+            <a:prstDash val="solid"/>
+          </a:ln>
+        </p:spPr>
+      </p:sp>
+      <p:sp>
+        <p:nvSpPr>
+          <p:cNvPr id="70" name="Text 65"/>
+          <p:cNvSpPr txBox="1"/>
+          <p:nvPr/>
+        </p:nvSpPr>
+        <p:spPr>
+          <a:xfrm>
+            <a:off x="832104" y="5728716"/>
+            <a:ext cx="5006340" cy="201168"/>
+          </a:xfrm>
+          <a:prstGeom prst="rect">
+            <a:avLst/>
+          </a:prstGeom>
+          <a:noFill/>
+          <a:ln/>
+        </p:spPr>
+        <p:txBody>
+          <a:bodyPr wrap="square" lIns="0" tIns="0" rIns="0" bIns="0" rtlCol="0" anchor="ctr"/>
+          <a:lstStyle/>
+          <a:p>
+            <a:pPr indent="0" marL="0">
+              <a:buNone/>
             </a:pPr>
             <a:r>
               <a:rPr lang="en-US" sz="1100" b="1" dirty="0">
@@ -2370,7 +3442,7 @@
                 <a:ea typeface="Calibri" pitchFamily="34" charset="-122"/>
                 <a:cs typeface="Calibri" pitchFamily="34" charset="-120"/>
               </a:rPr>
-              <a:t>Liquidez y mercado:  </a:t>
+              <a:t>Tarjeta de crédito: </a:t>
             </a:r>
             <a:pPr indent="0" marL="0">
               <a:buNone/>
@@ -2384,17 +3456,60 @@
                 <a:ea typeface="Calibri" pitchFamily="34" charset="-122"/>
                 <a:cs typeface="Calibri" pitchFamily="34" charset="-120"/>
               </a:rPr>
-              <a:t>informe al Comité, escenarios regulatorios y anexo 03 NRP-05</a:t>
+              <a:t>análisis de cartera, simulación de vencida, cuadratura</a:t>
             </a:r>
             <a:endParaRPr lang="en-US" sz="1100" dirty="0"/>
           </a:p>
-          <a:p>
-            <a:pPr marL="152400" indent="-152400">
-              <a:spcAft>
-                <a:spcPts val="400"/>
-              </a:spcAft>
-              <a:buSzPct val="100000"/>
-              <a:buChar char="■"/>
+        </p:txBody>
+      </p:sp>
+      <p:sp>
+        <p:nvSpPr>
+          <p:cNvPr id="71" name="Shape 66"/>
+          <p:cNvSpPr/>
+          <p:nvPr/>
+        </p:nvSpPr>
+        <p:spPr>
+          <a:xfrm>
+            <a:off x="676656" y="6021324"/>
+            <a:ext cx="64008" cy="64008"/>
+          </a:xfrm>
+          <a:prstGeom prst="rect">
+            <a:avLst/>
+          </a:prstGeom>
+          <a:solidFill>
+            <a:srgbClr val="0A7480"/>
+          </a:solidFill>
+          <a:ln w="12700">
+            <a:solidFill>
+              <a:srgbClr val="0A7480"/>
+            </a:solidFill>
+            <a:prstDash val="solid"/>
+          </a:ln>
+        </p:spPr>
+      </p:sp>
+      <p:sp>
+        <p:nvSpPr>
+          <p:cNvPr id="72" name="Text 67"/>
+          <p:cNvSpPr txBox="1"/>
+          <p:nvPr/>
+        </p:nvSpPr>
+        <p:spPr>
+          <a:xfrm>
+            <a:off x="832104" y="5952744"/>
+            <a:ext cx="5006340" cy="201168"/>
+          </a:xfrm>
+          <a:prstGeom prst="rect">
+            <a:avLst/>
+          </a:prstGeom>
+          <a:noFill/>
+          <a:ln/>
+        </p:spPr>
+        <p:txBody>
+          <a:bodyPr wrap="square" lIns="0" tIns="0" rIns="0" bIns="0" rtlCol="0" anchor="ctr"/>
+          <a:lstStyle/>
+          <a:p>
+            <a:pPr indent="0" marL="0">
+              <a:buNone/>
             </a:pPr>
             <a:r>
               <a:rPr lang="en-US" sz="1100" b="1" dirty="0">
@@ -2405,7 +3520,7 @@
                 <a:ea typeface="Calibri" pitchFamily="34" charset="-122"/>
                 <a:cs typeface="Calibri" pitchFamily="34" charset="-120"/>
               </a:rPr>
-              <a:t>Activos de riesgo:  </a:t>
+              <a:t>Reservas y deuda: </a:t>
             </a:r>
             <a:pPr indent="0" marL="0">
               <a:buNone/>
@@ -2419,17 +3534,60 @@
                 <a:ea typeface="Calibri" pitchFamily="34" charset="-122"/>
                 <a:cs typeface="Calibri" pitchFamily="34" charset="-120"/>
               </a:rPr>
-              <a:t>NCB-022, Central de Riesgo (NRP-41), CTRI-RECR y créditos relacionados</a:t>
+              <a:t>reserva de saneamiento y registro de traslados de deuda</a:t>
             </a:r>
             <a:endParaRPr lang="en-US" sz="1100" dirty="0"/>
           </a:p>
-          <a:p>
-            <a:pPr marL="152400" indent="-152400">
-              <a:spcAft>
-                <a:spcPts val="400"/>
-              </a:spcAft>
-              <a:buSzPct val="100000"/>
-              <a:buChar char="■"/>
+        </p:txBody>
+      </p:sp>
+      <p:sp>
+        <p:nvSpPr>
+          <p:cNvPr id="73" name="Shape 68"/>
+          <p:cNvSpPr/>
+          <p:nvPr/>
+        </p:nvSpPr>
+        <p:spPr>
+          <a:xfrm>
+            <a:off x="676656" y="6245352"/>
+            <a:ext cx="64008" cy="64008"/>
+          </a:xfrm>
+          <a:prstGeom prst="rect">
+            <a:avLst/>
+          </a:prstGeom>
+          <a:solidFill>
+            <a:srgbClr val="0A7480"/>
+          </a:solidFill>
+          <a:ln w="12700">
+            <a:solidFill>
+              <a:srgbClr val="0A7480"/>
+            </a:solidFill>
+            <a:prstDash val="solid"/>
+          </a:ln>
+        </p:spPr>
+      </p:sp>
+      <p:sp>
+        <p:nvSpPr>
+          <p:cNvPr id="74" name="Text 69"/>
+          <p:cNvSpPr txBox="1"/>
+          <p:nvPr/>
+        </p:nvSpPr>
+        <p:spPr>
+          <a:xfrm>
+            <a:off x="832104" y="6176772"/>
+            <a:ext cx="5006340" cy="201168"/>
+          </a:xfrm>
+          <a:prstGeom prst="rect">
+            <a:avLst/>
+          </a:prstGeom>
+          <a:noFill/>
+          <a:ln/>
+        </p:spPr>
+        <p:txBody>
+          <a:bodyPr wrap="square" lIns="0" tIns="0" rIns="0" bIns="0" rtlCol="0" anchor="ctr"/>
+          <a:lstStyle/>
+          <a:p>
+            <a:pPr indent="0" marL="0">
+              <a:buNone/>
             </a:pPr>
             <a:r>
               <a:rPr lang="en-US" sz="1100" b="1" dirty="0">
@@ -2440,7 +3598,7 @@
                 <a:ea typeface="Calibri" pitchFamily="34" charset="-122"/>
                 <a:cs typeface="Calibri" pitchFamily="34" charset="-120"/>
               </a:rPr>
-              <a:t>Tarjeta y reservas:  </a:t>
+              <a:t>Largo plazo: </a:t>
             </a:r>
             <a:pPr indent="0" marL="0">
               <a:buNone/>
@@ -2454,96 +3612,26 @@
                 <a:ea typeface="Calibri" pitchFamily="34" charset="-122"/>
                 <a:cs typeface="Calibri" pitchFamily="34" charset="-120"/>
               </a:rPr>
-              <a:t>análisis de cartera TC, simulación de vencida; reserva de saneamiento</a:t>
+              <a:t>Política de TC, sistema de créditos NRP-41, TC de alto riesgo</a:t>
             </a:r>
             <a:endParaRPr lang="en-US" sz="1100" dirty="0"/>
           </a:p>
-          <a:p>
-            <a:pPr marL="152400" indent="-152400">
-              <a:spcAft>
-                <a:spcPts val="400"/>
-              </a:spcAft>
-              <a:buSzPct val="100000"/>
-              <a:buChar char="■"/>
-            </a:pPr>
-            <a:r>
-              <a:rPr lang="en-US" sz="1100" b="1" dirty="0">
-                <a:solidFill>
-                  <a:srgbClr val="0B2545"/>
-                </a:solidFill>
-                <a:latin typeface="Calibri" pitchFamily="34" charset="0"/>
-                <a:ea typeface="Calibri" pitchFamily="34" charset="-122"/>
-                <a:cs typeface="Calibri" pitchFamily="34" charset="-120"/>
-              </a:rPr>
-              <a:t>Seguimiento:  </a:t>
-            </a:r>
-            <a:pPr indent="0" marL="0">
-              <a:buNone/>
-            </a:pPr>
-            <a:r>
-              <a:rPr lang="en-US" sz="1100" dirty="0">
-                <a:solidFill>
-                  <a:srgbClr val="1B2733"/>
-                </a:solidFill>
-                <a:latin typeface="Calibri" pitchFamily="34" charset="0"/>
-                <a:ea typeface="Calibri" pitchFamily="34" charset="-122"/>
-                <a:cs typeface="Calibri" pitchFamily="34" charset="-120"/>
-              </a:rPr>
-              <a:t>traslados de deuda, segmentación de productos, consultas de aspirantes</a:t>
-            </a:r>
-            <a:endParaRPr lang="en-US" sz="1100" dirty="0"/>
-          </a:p>
-          <a:p>
-            <a:pPr marL="152400" indent="-152400">
-              <a:spcAft>
-                <a:spcPts val="400"/>
-              </a:spcAft>
-              <a:buSzPct val="100000"/>
-              <a:buChar char="■"/>
-            </a:pPr>
-            <a:r>
-              <a:rPr lang="en-US" sz="1100" b="1" dirty="0">
-                <a:solidFill>
-                  <a:srgbClr val="0B2545"/>
-                </a:solidFill>
-                <a:latin typeface="Calibri" pitchFamily="34" charset="0"/>
-                <a:ea typeface="Calibri" pitchFamily="34" charset="-122"/>
-                <a:cs typeface="Calibri" pitchFamily="34" charset="-120"/>
-              </a:rPr>
-              <a:t>Largo plazo:  </a:t>
-            </a:r>
-            <a:pPr indent="0" marL="0">
-              <a:buNone/>
-            </a:pPr>
-            <a:r>
-              <a:rPr lang="en-US" sz="1100" dirty="0">
-                <a:solidFill>
-                  <a:srgbClr val="1B2733"/>
-                </a:solidFill>
-                <a:latin typeface="Calibri" pitchFamily="34" charset="0"/>
-                <a:ea typeface="Calibri" pitchFamily="34" charset="-122"/>
-                <a:cs typeface="Calibri" pitchFamily="34" charset="-120"/>
-              </a:rPr>
-              <a:t>Política de TC, sistema de créditos (NRP-41), expedientes TC de alto riesgo</a:t>
-            </a:r>
-            <a:endParaRPr lang="en-US" sz="1100" dirty="0"/>
-          </a:p>
-        </p:txBody>
-      </p:sp>
-      <p:sp>
-        <p:nvSpPr>
-          <p:cNvPr id="32" name="Shape 27"/>
-          <p:cNvSpPr/>
-          <p:nvPr/>
-        </p:nvSpPr>
-        <p:spPr>
-          <a:xfrm>
-            <a:off x="6208776" y="3986784"/>
-            <a:ext cx="5522976" cy="2487168"/>
+        </p:txBody>
+      </p:sp>
+      <p:sp>
+        <p:nvSpPr>
+          <p:cNvPr id="75" name="Shape 70"/>
+          <p:cNvSpPr/>
+          <p:nvPr/>
+        </p:nvSpPr>
+        <p:spPr>
+          <a:xfrm>
+            <a:off x="6167628" y="4270248"/>
+            <a:ext cx="5564124" cy="2203704"/>
           </a:xfrm>
           <a:prstGeom prst="roundRect">
             <a:avLst>
-              <a:gd name="adj" fmla="val 4412"/>
+              <a:gd name="adj" fmla="val 4979"/>
             </a:avLst>
           </a:prstGeom>
           <a:solidFill>
@@ -2559,24 +3647,76 @@
       </p:sp>
       <p:sp>
         <p:nvSpPr>
-          <p:cNvPr id="33" name="Shape 28"/>
-          <p:cNvSpPr/>
-          <p:nvPr/>
-        </p:nvSpPr>
-        <p:spPr>
-          <a:xfrm>
-            <a:off x="6409944" y="4169664"/>
-            <a:ext cx="512064" cy="512064"/>
+          <p:cNvPr id="76" name="Shape 71"/>
+          <p:cNvSpPr/>
+          <p:nvPr/>
+        </p:nvSpPr>
+        <p:spPr>
+          <a:xfrm>
+            <a:off x="6167628" y="4270248"/>
+            <a:ext cx="5564124" cy="749808"/>
+          </a:xfrm>
+          <a:prstGeom prst="roundRect">
+            <a:avLst>
+              <a:gd name="adj" fmla="val 14634"/>
+            </a:avLst>
+          </a:prstGeom>
+          <a:solidFill>
+            <a:srgbClr val="2E4A73"/>
+          </a:solidFill>
+          <a:ln w="12700">
+            <a:solidFill>
+              <a:srgbClr val="2E4A73"/>
+            </a:solidFill>
+            <a:prstDash val="solid"/>
+          </a:ln>
+        </p:spPr>
+      </p:sp>
+      <p:sp>
+        <p:nvSpPr>
+          <p:cNvPr id="77" name="Shape 72"/>
+          <p:cNvSpPr/>
+          <p:nvPr/>
+        </p:nvSpPr>
+        <p:spPr>
+          <a:xfrm>
+            <a:off x="6167628" y="4910328"/>
+            <a:ext cx="5564124" cy="182880"/>
+          </a:xfrm>
+          <a:prstGeom prst="rect">
+            <a:avLst/>
+          </a:prstGeom>
+          <a:solidFill>
+            <a:srgbClr val="F1F5F9"/>
+          </a:solidFill>
+          <a:ln w="12700">
+            <a:solidFill>
+              <a:srgbClr val="F1F5F9"/>
+            </a:solidFill>
+            <a:prstDash val="solid"/>
+          </a:ln>
+        </p:spPr>
+      </p:sp>
+      <p:sp>
+        <p:nvSpPr>
+          <p:cNvPr id="78" name="Shape 73"/>
+          <p:cNvSpPr/>
+          <p:nvPr/>
+        </p:nvSpPr>
+        <p:spPr>
+          <a:xfrm>
+            <a:off x="6350508" y="4370832"/>
+            <a:ext cx="438912" cy="438912"/>
           </a:xfrm>
           <a:prstGeom prst="ellipse">
             <a:avLst/>
           </a:prstGeom>
           <a:solidFill>
-            <a:srgbClr val="0B2545"/>
+            <a:srgbClr val="FFFFFF"/>
           </a:solidFill>
           <a:ln w="12700">
             <a:solidFill>
-              <a:srgbClr val="0B2545"/>
+              <a:srgbClr val="FFFFFF"/>
             </a:solidFill>
             <a:prstDash val="solid"/>
           </a:ln>
@@ -2584,7 +3724,7 @@
       </p:sp>
       <p:pic>
         <p:nvPicPr>
-          <p:cNvPr id="34" name="Image 3" descr="preencoded.png">    </p:cNvPr>
+          <p:cNvPr id="79" name="Image 3" descr="preencoded.png">    </p:cNvPr>
           <p:cNvPicPr>
             <a:picLocks noChangeAspect="1"/>
           </p:cNvPicPr>
@@ -2598,8 +3738,8 @@
         </p:blipFill>
         <p:spPr>
           <a:xfrm>
-            <a:off x="6533388" y="4293108"/>
-            <a:ext cx="265176" cy="265176"/>
+            <a:off x="6455664" y="4475988"/>
+            <a:ext cx="228600" cy="228600"/>
           </a:xfrm>
           <a:prstGeom prst="rect">
             <a:avLst/>
@@ -2608,14 +3748,14 @@
       </p:pic>
       <p:sp>
         <p:nvSpPr>
-          <p:cNvPr id="35" name="Text 29"/>
-          <p:cNvSpPr txBox="1"/>
-          <p:nvPr/>
-        </p:nvSpPr>
-        <p:spPr>
-          <a:xfrm>
-            <a:off x="7068312" y="4142232"/>
-            <a:ext cx="4425696" cy="310896"/>
+          <p:cNvPr id="80" name="Text 74"/>
+          <p:cNvSpPr txBox="1"/>
+          <p:nvPr/>
+        </p:nvSpPr>
+        <p:spPr>
+          <a:xfrm>
+            <a:off x="6935724" y="4343400"/>
+            <a:ext cx="4649724" cy="292608"/>
           </a:xfrm>
           <a:prstGeom prst="rect">
             <a:avLst/>
@@ -2633,28 +3773,170 @@
             <a:r>
               <a:rPr lang="en-US" sz="1500" b="1" dirty="0">
                 <a:solidFill>
+                  <a:srgbClr val="FFFFFF"/>
+                </a:solidFill>
+                <a:latin typeface="Calibri" pitchFamily="34" charset="0"/>
+                <a:ea typeface="Calibri" pitchFamily="34" charset="-122"/>
+                <a:cs typeface="Calibri" pitchFamily="34" charset="-120"/>
+              </a:rPr>
+              <a:t>Proyectos Transversales</a:t>
+            </a:r>
+            <a:endParaRPr lang="en-US" sz="1500" dirty="0"/>
+          </a:p>
+        </p:txBody>
+      </p:sp>
+      <p:sp>
+        <p:nvSpPr>
+          <p:cNvPr id="81" name="Text 75"/>
+          <p:cNvSpPr txBox="1"/>
+          <p:nvPr/>
+        </p:nvSpPr>
+        <p:spPr>
+          <a:xfrm>
+            <a:off x="6935724" y="4617720"/>
+            <a:ext cx="4649724" cy="219456"/>
+          </a:xfrm>
+          <a:prstGeom prst="rect">
+            <a:avLst/>
+          </a:prstGeom>
+          <a:noFill/>
+          <a:ln/>
+        </p:spPr>
+        <p:txBody>
+          <a:bodyPr wrap="square" lIns="0" tIns="0" rIns="0" bIns="0" rtlCol="0" anchor="ctr"/>
+          <a:lstStyle/>
+          <a:p>
+            <a:pPr indent="0" marL="0">
+              <a:buNone/>
+            </a:pPr>
+            <a:r>
+              <a:rPr lang="en-US" sz="1050" i="1" dirty="0">
+                <a:solidFill>
+                  <a:srgbClr val="DCE8F3"/>
+                </a:solidFill>
+                <a:latin typeface="Calibri" pitchFamily="34" charset="0"/>
+                <a:ea typeface="Calibri" pitchFamily="34" charset="-122"/>
+                <a:cs typeface="Calibri" pitchFamily="34" charset="-120"/>
+              </a:rPr>
+              <a:t>Mejora institucional en coordinación con otras áreas</a:t>
+            </a:r>
+            <a:endParaRPr lang="en-US" sz="1050" dirty="0"/>
+          </a:p>
+        </p:txBody>
+      </p:sp>
+      <p:sp>
+        <p:nvSpPr>
+          <p:cNvPr id="82" name="Shape 76"/>
+          <p:cNvSpPr/>
+          <p:nvPr/>
+        </p:nvSpPr>
+        <p:spPr>
+          <a:xfrm>
+            <a:off x="6387084" y="5125212"/>
+            <a:ext cx="64008" cy="64008"/>
+          </a:xfrm>
+          <a:prstGeom prst="rect">
+            <a:avLst/>
+          </a:prstGeom>
+          <a:solidFill>
+            <a:srgbClr val="2E4A73"/>
+          </a:solidFill>
+          <a:ln w="12700">
+            <a:solidFill>
+              <a:srgbClr val="2E4A73"/>
+            </a:solidFill>
+            <a:prstDash val="solid"/>
+          </a:ln>
+        </p:spPr>
+      </p:sp>
+      <p:sp>
+        <p:nvSpPr>
+          <p:cNvPr id="83" name="Text 77"/>
+          <p:cNvSpPr txBox="1"/>
+          <p:nvPr/>
+        </p:nvSpPr>
+        <p:spPr>
+          <a:xfrm>
+            <a:off x="6542532" y="5056632"/>
+            <a:ext cx="5006340" cy="201168"/>
+          </a:xfrm>
+          <a:prstGeom prst="rect">
+            <a:avLst/>
+          </a:prstGeom>
+          <a:noFill/>
+          <a:ln/>
+        </p:spPr>
+        <p:txBody>
+          <a:bodyPr wrap="square" lIns="0" tIns="0" rIns="0" bIns="0" rtlCol="0" anchor="ctr"/>
+          <a:lstStyle/>
+          <a:p>
+            <a:pPr indent="0" marL="0">
+              <a:buNone/>
+            </a:pPr>
+            <a:r>
+              <a:rPr lang="en-US" sz="1100" b="1" dirty="0">
+                <a:solidFill>
                   <a:srgbClr val="0B2545"/>
                 </a:solidFill>
                 <a:latin typeface="Calibri" pitchFamily="34" charset="0"/>
                 <a:ea typeface="Calibri" pitchFamily="34" charset="-122"/>
                 <a:cs typeface="Calibri" pitchFamily="34" charset="-120"/>
               </a:rPr>
-              <a:t>Proyectos Transversales</a:t>
-            </a:r>
-            <a:endParaRPr lang="en-US" sz="1500" dirty="0"/>
-          </a:p>
-        </p:txBody>
-      </p:sp>
-      <p:sp>
-        <p:nvSpPr>
-          <p:cNvPr id="36" name="Text 30"/>
-          <p:cNvSpPr txBox="1"/>
-          <p:nvPr/>
-        </p:nvSpPr>
-        <p:spPr>
-          <a:xfrm>
-            <a:off x="7068312" y="4443984"/>
-            <a:ext cx="4425696" cy="256032"/>
+              <a:t>BIA: </a:t>
+            </a:r>
+            <a:pPr indent="0" marL="0">
+              <a:buNone/>
+            </a:pPr>
+            <a:r>
+              <a:rPr lang="en-US" sz="1100" dirty="0">
+                <a:solidFill>
+                  <a:srgbClr val="1B2733"/>
+                </a:solidFill>
+                <a:latin typeface="Calibri" pitchFamily="34" charset="0"/>
+                <a:ea typeface="Calibri" pitchFamily="34" charset="-122"/>
+                <a:cs typeface="Calibri" pitchFamily="34" charset="-120"/>
+              </a:rPr>
+              <a:t>cuestionario para las entrevistas</a:t>
+            </a:r>
+            <a:endParaRPr lang="en-US" sz="1100" dirty="0"/>
+          </a:p>
+        </p:txBody>
+      </p:sp>
+      <p:sp>
+        <p:nvSpPr>
+          <p:cNvPr id="84" name="Shape 78"/>
+          <p:cNvSpPr/>
+          <p:nvPr/>
+        </p:nvSpPr>
+        <p:spPr>
+          <a:xfrm>
+            <a:off x="6387084" y="5349240"/>
+            <a:ext cx="64008" cy="64008"/>
+          </a:xfrm>
+          <a:prstGeom prst="rect">
+            <a:avLst/>
+          </a:prstGeom>
+          <a:solidFill>
+            <a:srgbClr val="2E4A73"/>
+          </a:solidFill>
+          <a:ln w="12700">
+            <a:solidFill>
+              <a:srgbClr val="2E4A73"/>
+            </a:solidFill>
+            <a:prstDash val="solid"/>
+          </a:ln>
+        </p:spPr>
+      </p:sp>
+      <p:sp>
+        <p:nvSpPr>
+          <p:cNvPr id="85" name="Text 79"/>
+          <p:cNvSpPr txBox="1"/>
+          <p:nvPr/>
+        </p:nvSpPr>
+        <p:spPr>
+          <a:xfrm>
+            <a:off x="6542532" y="5280660"/>
+            <a:ext cx="5006340" cy="201168"/>
           </a:xfrm>
           <a:prstGeom prst="rect">
             <a:avLst/>
@@ -2670,15 +3952,29 @@
               <a:buNone/>
             </a:pPr>
             <a:r>
-              <a:rPr lang="en-US" sz="1100" i="1" dirty="0">
-                <a:solidFill>
-                  <a:srgbClr val="13507F"/>
-                </a:solidFill>
-                <a:latin typeface="Calibri" pitchFamily="34" charset="0"/>
-                <a:ea typeface="Calibri" pitchFamily="34" charset="-122"/>
-                <a:cs typeface="Calibri" pitchFamily="34" charset="-120"/>
-              </a:rPr>
-              <a:t>Mejora institucional en coordinación con otras áreas</a:t>
+              <a:rPr lang="en-US" sz="1100" b="1" dirty="0">
+                <a:solidFill>
+                  <a:srgbClr val="0B2545"/>
+                </a:solidFill>
+                <a:latin typeface="Calibri" pitchFamily="34" charset="0"/>
+                <a:ea typeface="Calibri" pitchFamily="34" charset="-122"/>
+                <a:cs typeface="Calibri" pitchFamily="34" charset="-120"/>
+              </a:rPr>
+              <a:t>Formularios: </a:t>
+            </a:r>
+            <a:pPr indent="0" marL="0">
+              <a:buNone/>
+            </a:pPr>
+            <a:r>
+              <a:rPr lang="en-US" sz="1100" dirty="0">
+                <a:solidFill>
+                  <a:srgbClr val="1B2733"/>
+                </a:solidFill>
+                <a:latin typeface="Calibri" pitchFamily="34" charset="0"/>
+                <a:ea typeface="Calibri" pitchFamily="34" charset="-122"/>
+                <a:cs typeface="Calibri" pitchFamily="34" charset="-120"/>
+              </a:rPr>
+              <a:t>unificación de Actualización de Datos y Conozca a tu Cliente</a:t>
             </a:r>
             <a:endParaRPr lang="en-US" sz="1100" dirty="0"/>
           </a:p>
@@ -2686,31 +3982,52 @@
       </p:sp>
       <p:sp>
         <p:nvSpPr>
-          <p:cNvPr id="37" name="Text 31"/>
-          <p:cNvSpPr txBox="1"/>
-          <p:nvPr/>
-        </p:nvSpPr>
-        <p:spPr>
-          <a:xfrm>
-            <a:off x="6428232" y="4828032"/>
-            <a:ext cx="5102352" cy="1536192"/>
-          </a:xfrm>
-          <a:prstGeom prst="rect">
-            <a:avLst/>
-          </a:prstGeom>
-          <a:noFill/>
-          <a:ln/>
-        </p:spPr>
-        <p:txBody>
-          <a:bodyPr wrap="square" lIns="0" tIns="0" rIns="0" bIns="0" rtlCol="0" anchor="t"/>
-          <a:lstStyle/>
-          <a:p>
-            <a:pPr marL="152400" indent="-152400">
-              <a:spcAft>
-                <a:spcPts val="400"/>
-              </a:spcAft>
-              <a:buSzPct val="100000"/>
-              <a:buChar char="■"/>
+          <p:cNvPr id="86" name="Shape 80"/>
+          <p:cNvSpPr/>
+          <p:nvPr/>
+        </p:nvSpPr>
+        <p:spPr>
+          <a:xfrm>
+            <a:off x="6387084" y="5573268"/>
+            <a:ext cx="64008" cy="64008"/>
+          </a:xfrm>
+          <a:prstGeom prst="rect">
+            <a:avLst/>
+          </a:prstGeom>
+          <a:solidFill>
+            <a:srgbClr val="2E4A73"/>
+          </a:solidFill>
+          <a:ln w="12700">
+            <a:solidFill>
+              <a:srgbClr val="2E4A73"/>
+            </a:solidFill>
+            <a:prstDash val="solid"/>
+          </a:ln>
+        </p:spPr>
+      </p:sp>
+      <p:sp>
+        <p:nvSpPr>
+          <p:cNvPr id="87" name="Text 81"/>
+          <p:cNvSpPr txBox="1"/>
+          <p:nvPr/>
+        </p:nvSpPr>
+        <p:spPr>
+          <a:xfrm>
+            <a:off x="6542532" y="5504688"/>
+            <a:ext cx="5006340" cy="201168"/>
+          </a:xfrm>
+          <a:prstGeom prst="rect">
+            <a:avLst/>
+          </a:prstGeom>
+          <a:noFill/>
+          <a:ln/>
+        </p:spPr>
+        <p:txBody>
+          <a:bodyPr wrap="square" lIns="0" tIns="0" rIns="0" bIns="0" rtlCol="0" anchor="ctr"/>
+          <a:lstStyle/>
+          <a:p>
+            <a:pPr indent="0" marL="0">
+              <a:buNone/>
             </a:pPr>
             <a:r>
               <a:rPr lang="en-US" sz="1100" b="1" dirty="0">
@@ -2721,7 +4038,7 @@
                 <a:ea typeface="Calibri" pitchFamily="34" charset="-122"/>
                 <a:cs typeface="Calibri" pitchFamily="34" charset="-120"/>
               </a:rPr>
-              <a:t>BIA:  </a:t>
+              <a:t>Comparativos de políticas: </a:t>
             </a:r>
             <a:pPr indent="0" marL="0">
               <a:buNone/>
@@ -2735,17 +4052,60 @@
                 <a:ea typeface="Calibri" pitchFamily="34" charset="-122"/>
                 <a:cs typeface="Calibri" pitchFamily="34" charset="-120"/>
               </a:rPr>
-              <a:t>elaboración del cuestionario para entrevistas</a:t>
+              <a:t>servicios tercerizados y gobierno corporativo</a:t>
             </a:r>
             <a:endParaRPr lang="en-US" sz="1100" dirty="0"/>
           </a:p>
-          <a:p>
-            <a:pPr marL="152400" indent="-152400">
-              <a:spcAft>
-                <a:spcPts val="400"/>
-              </a:spcAft>
-              <a:buSzPct val="100000"/>
-              <a:buChar char="■"/>
+        </p:txBody>
+      </p:sp>
+      <p:sp>
+        <p:nvSpPr>
+          <p:cNvPr id="88" name="Shape 82"/>
+          <p:cNvSpPr/>
+          <p:nvPr/>
+        </p:nvSpPr>
+        <p:spPr>
+          <a:xfrm>
+            <a:off x="6387084" y="5797296"/>
+            <a:ext cx="64008" cy="64008"/>
+          </a:xfrm>
+          <a:prstGeom prst="rect">
+            <a:avLst/>
+          </a:prstGeom>
+          <a:solidFill>
+            <a:srgbClr val="2E4A73"/>
+          </a:solidFill>
+          <a:ln w="12700">
+            <a:solidFill>
+              <a:srgbClr val="2E4A73"/>
+            </a:solidFill>
+            <a:prstDash val="solid"/>
+          </a:ln>
+        </p:spPr>
+      </p:sp>
+      <p:sp>
+        <p:nvSpPr>
+          <p:cNvPr id="89" name="Text 83"/>
+          <p:cNvSpPr txBox="1"/>
+          <p:nvPr/>
+        </p:nvSpPr>
+        <p:spPr>
+          <a:xfrm>
+            <a:off x="6542532" y="5728716"/>
+            <a:ext cx="5006340" cy="201168"/>
+          </a:xfrm>
+          <a:prstGeom prst="rect">
+            <a:avLst/>
+          </a:prstGeom>
+          <a:noFill/>
+          <a:ln/>
+        </p:spPr>
+        <p:txBody>
+          <a:bodyPr wrap="square" lIns="0" tIns="0" rIns="0" bIns="0" rtlCol="0" anchor="ctr"/>
+          <a:lstStyle/>
+          <a:p>
+            <a:pPr indent="0" marL="0">
+              <a:buNone/>
             </a:pPr>
             <a:r>
               <a:rPr lang="en-US" sz="1100" b="1" dirty="0">
@@ -2756,7 +4116,7 @@
                 <a:ea typeface="Calibri" pitchFamily="34" charset="-122"/>
                 <a:cs typeface="Calibri" pitchFamily="34" charset="-120"/>
               </a:rPr>
-              <a:t>Formularios:  </a:t>
+              <a:t>Procesos: </a:t>
             </a:r>
             <a:pPr indent="0" marL="0">
               <a:buNone/>
@@ -2770,17 +4130,60 @@
                 <a:ea typeface="Calibri" pitchFamily="34" charset="-122"/>
                 <a:cs typeface="Calibri" pitchFamily="34" charset="-120"/>
               </a:rPr>
-              <a:t>unificación de Actualización de Datos (Atención al Asociado) y Conozca a tu Cliente (Oficialía de Cumplimiento)</a:t>
+              <a:t>Matriz de Sistemas Informáticos y cambio de estructura del Depto.</a:t>
             </a:r>
             <a:endParaRPr lang="en-US" sz="1100" dirty="0"/>
           </a:p>
-          <a:p>
-            <a:pPr marL="152400" indent="-152400">
-              <a:spcAft>
-                <a:spcPts val="400"/>
-              </a:spcAft>
-              <a:buSzPct val="100000"/>
-              <a:buChar char="■"/>
+        </p:txBody>
+      </p:sp>
+      <p:sp>
+        <p:nvSpPr>
+          <p:cNvPr id="90" name="Shape 84"/>
+          <p:cNvSpPr/>
+          <p:nvPr/>
+        </p:nvSpPr>
+        <p:spPr>
+          <a:xfrm>
+            <a:off x="6387084" y="6021324"/>
+            <a:ext cx="64008" cy="64008"/>
+          </a:xfrm>
+          <a:prstGeom prst="rect">
+            <a:avLst/>
+          </a:prstGeom>
+          <a:solidFill>
+            <a:srgbClr val="2E4A73"/>
+          </a:solidFill>
+          <a:ln w="12700">
+            <a:solidFill>
+              <a:srgbClr val="2E4A73"/>
+            </a:solidFill>
+            <a:prstDash val="solid"/>
+          </a:ln>
+        </p:spPr>
+      </p:sp>
+      <p:sp>
+        <p:nvSpPr>
+          <p:cNvPr id="91" name="Text 85"/>
+          <p:cNvSpPr txBox="1"/>
+          <p:nvPr/>
+        </p:nvSpPr>
+        <p:spPr>
+          <a:xfrm>
+            <a:off x="6542532" y="5952744"/>
+            <a:ext cx="5006340" cy="201168"/>
+          </a:xfrm>
+          <a:prstGeom prst="rect">
+            <a:avLst/>
+          </a:prstGeom>
+          <a:noFill/>
+          <a:ln/>
+        </p:spPr>
+        <p:txBody>
+          <a:bodyPr wrap="square" lIns="0" tIns="0" rIns="0" bIns="0" rtlCol="0" anchor="ctr"/>
+          <a:lstStyle/>
+          <a:p>
+            <a:pPr indent="0" marL="0">
+              <a:buNone/>
             </a:pPr>
             <a:r>
               <a:rPr lang="en-US" sz="1100" b="1" dirty="0">
@@ -2791,7 +4194,7 @@
                 <a:ea typeface="Calibri" pitchFamily="34" charset="-122"/>
                 <a:cs typeface="Calibri" pitchFamily="34" charset="-120"/>
               </a:rPr>
-              <a:t>Comparativos de políticas:  </a:t>
+              <a:t>Atención al Asociado: </a:t>
             </a:r>
             <a:pPr indent="0" marL="0">
               <a:buNone/>
@@ -2805,17 +4208,60 @@
                 <a:ea typeface="Calibri" pitchFamily="34" charset="-122"/>
                 <a:cs typeface="Calibri" pitchFamily="34" charset="-120"/>
               </a:rPr>
-              <a:t>servicios tercerizados y gobierno corporativo</a:t>
+              <a:t>actualización de página web</a:t>
             </a:r>
             <a:endParaRPr lang="en-US" sz="1100" dirty="0"/>
           </a:p>
-          <a:p>
-            <a:pPr marL="152400" indent="-152400">
-              <a:spcAft>
-                <a:spcPts val="400"/>
-              </a:spcAft>
-              <a:buSzPct val="100000"/>
-              <a:buChar char="■"/>
+        </p:txBody>
+      </p:sp>
+      <p:sp>
+        <p:nvSpPr>
+          <p:cNvPr id="92" name="Shape 86"/>
+          <p:cNvSpPr/>
+          <p:nvPr/>
+        </p:nvSpPr>
+        <p:spPr>
+          <a:xfrm>
+            <a:off x="6387084" y="6245352"/>
+            <a:ext cx="64008" cy="64008"/>
+          </a:xfrm>
+          <a:prstGeom prst="rect">
+            <a:avLst/>
+          </a:prstGeom>
+          <a:solidFill>
+            <a:srgbClr val="2E4A73"/>
+          </a:solidFill>
+          <a:ln w="12700">
+            <a:solidFill>
+              <a:srgbClr val="2E4A73"/>
+            </a:solidFill>
+            <a:prstDash val="solid"/>
+          </a:ln>
+        </p:spPr>
+      </p:sp>
+      <p:sp>
+        <p:nvSpPr>
+          <p:cNvPr id="93" name="Text 87"/>
+          <p:cNvSpPr txBox="1"/>
+          <p:nvPr/>
+        </p:nvSpPr>
+        <p:spPr>
+          <a:xfrm>
+            <a:off x="6542532" y="6176772"/>
+            <a:ext cx="5006340" cy="201168"/>
+          </a:xfrm>
+          <a:prstGeom prst="rect">
+            <a:avLst/>
+          </a:prstGeom>
+          <a:noFill/>
+          <a:ln/>
+        </p:spPr>
+        <p:txBody>
+          <a:bodyPr wrap="square" lIns="0" tIns="0" rIns="0" bIns="0" rtlCol="0" anchor="ctr"/>
+          <a:lstStyle/>
+          <a:p>
+            <a:pPr indent="0" marL="0">
+              <a:buNone/>
             </a:pPr>
             <a:r>
               <a:rPr lang="en-US" sz="1100" b="1" dirty="0">
@@ -2826,7 +4272,7 @@
                 <a:ea typeface="Calibri" pitchFamily="34" charset="-122"/>
                 <a:cs typeface="Calibri" pitchFamily="34" charset="-120"/>
               </a:rPr>
-              <a:t>Procesos:  </a:t>
+              <a:t>Segmentación: </a:t>
             </a:r>
             <a:pPr indent="0" marL="0">
               <a:buNone/>
@@ -2840,50 +4286,15 @@
                 <a:ea typeface="Calibri" pitchFamily="34" charset="-122"/>
                 <a:cs typeface="Calibri" pitchFamily="34" charset="-120"/>
               </a:rPr>
-              <a:t>Matriz de Administración de Sistemas Informáticos y solicitud de cambio de estructura del Departamento</a:t>
+              <a:t>informe de segmentación de productos de COMEDICA</a:t>
             </a:r>
             <a:endParaRPr lang="en-US" sz="1100" dirty="0"/>
           </a:p>
-          <a:p>
-            <a:pPr marL="152400" indent="-152400">
-              <a:spcAft>
-                <a:spcPts val="400"/>
-              </a:spcAft>
-              <a:buSzPct val="100000"/>
-              <a:buChar char="■"/>
-            </a:pPr>
-            <a:r>
-              <a:rPr lang="en-US" sz="1100" b="1" dirty="0">
-                <a:solidFill>
-                  <a:srgbClr val="0B2545"/>
-                </a:solidFill>
-                <a:latin typeface="Calibri" pitchFamily="34" charset="0"/>
-                <a:ea typeface="Calibri" pitchFamily="34" charset="-122"/>
-                <a:cs typeface="Calibri" pitchFamily="34" charset="-120"/>
-              </a:rPr>
-              <a:t>Atención al Asociado:  </a:t>
-            </a:r>
-            <a:pPr indent="0" marL="0">
-              <a:buNone/>
-            </a:pPr>
-            <a:r>
-              <a:rPr lang="en-US" sz="1100" dirty="0">
-                <a:solidFill>
-                  <a:srgbClr val="1B2733"/>
-                </a:solidFill>
-                <a:latin typeface="Calibri" pitchFamily="34" charset="0"/>
-                <a:ea typeface="Calibri" pitchFamily="34" charset="-122"/>
-                <a:cs typeface="Calibri" pitchFamily="34" charset="-120"/>
-              </a:rPr>
-              <a:t>actualización de página web</a:t>
-            </a:r>
-            <a:endParaRPr lang="en-US" sz="1100" dirty="0"/>
-          </a:p>
-        </p:txBody>
-      </p:sp>
-      <p:sp>
-        <p:nvSpPr>
-          <p:cNvPr id="38" name="Text 32"/>
+        </p:txBody>
+      </p:sp>
+      <p:sp>
+        <p:nvSpPr>
+          <p:cNvPr id="94" name="Text 88"/>
           <p:cNvSpPr txBox="1"/>
           <p:nvPr/>
         </p:nvSpPr>

</xml_diff>

<commit_message>
Simplify slide 1: weekly activities only, single GIR exam indicator, larger text
Co-Authored-By: Claude Opus 5.5 <noreply@anthropic.com>
Claude-Session: https://claude.ai/code/session_01QGTe9h3kfUS6BTZosfrxzF
</commit_message>
<xml_diff>
--- a/resumen-ejecutivo-semanal/Resumen_Ejecutivo_Riesgos_COMEDICA_2_Slides.pptx
+++ b/resumen-ejecutivo-semanal/Resumen_Ejecutivo_Riesgos_COMEDICA_2_Slides.pptx
@@ -503,7 +503,7 @@
           <a:p>
             <a:r>
               <a:rPr lang="en-US" dirty="0"/>
-              <a:t>Resumen de los cuatro frentes de gestión, integrando las actividades de S1 y S2. Examen GIR 2026: avance 90% (reportado). Avalúos: 60% según la presentación anterior, por confirmar. Los demás frentes se presentan sin estado porque los documentos no lo indican.</a:t>
+              <a:t>Resumen de los cuatro frentes de gestión, integrando las actividades de S1 y S2. Examen GIR 2026: avance 90% (reportado). Los demás frentes se presentan sin estado porque los documentos no lo indican.</a:t>
             </a:r>
             <a:endParaRPr lang="en-US" dirty="0"/>
           </a:p>
@@ -973,7 +973,7 @@
         <p:spPr>
           <a:xfrm>
             <a:off x="457200" y="292608"/>
-            <a:ext cx="8778240" cy="548640"/>
+            <a:ext cx="8046720" cy="548640"/>
           </a:xfrm>
           <a:prstGeom prst="rect">
             <a:avLst/>
@@ -1036,7 +1036,7 @@
                 <a:ea typeface="Calibri" pitchFamily="34" charset="-122"/>
                 <a:cs typeface="Calibri" pitchFamily="34" charset="-120"/>
               </a:rPr>
-              <a:t>Departamento de Administración de Riesgos · COMÉDICA de R.L.</a:t>
+              <a:t>Departamento de Administración de Riesgos · COMÉDICA de R.L. · Seguimiento semanal</a:t>
             </a:r>
             <a:endParaRPr lang="en-US" sz="1300" dirty="0"/>
           </a:p>
@@ -1050,8 +1050,91 @@
         </p:nvSpPr>
         <p:spPr>
           <a:xfrm>
-            <a:off x="9537192" y="384048"/>
-            <a:ext cx="2194560" cy="329184"/>
+            <a:off x="8622792" y="310896"/>
+            <a:ext cx="3108960" cy="713232"/>
+          </a:xfrm>
+          <a:prstGeom prst="roundRect">
+            <a:avLst>
+              <a:gd name="adj" fmla="val 15385"/>
+            </a:avLst>
+          </a:prstGeom>
+          <a:solidFill>
+            <a:srgbClr val="D7F0F2"/>
+          </a:solidFill>
+          <a:ln w="12700">
+            <a:solidFill>
+              <a:srgbClr val="D7F0F2"/>
+            </a:solidFill>
+            <a:prstDash val="solid"/>
+          </a:ln>
+        </p:spPr>
+      </p:sp>
+      <p:sp>
+        <p:nvSpPr>
+          <p:cNvPr id="5" name="Text 3"/>
+          <p:cNvSpPr txBox="1"/>
+          <p:nvPr/>
+        </p:nvSpPr>
+        <p:spPr>
+          <a:xfrm>
+            <a:off x="8823960" y="384048"/>
+            <a:ext cx="1554480" cy="438912"/>
+          </a:xfrm>
+          <a:prstGeom prst="rect">
+            <a:avLst/>
+          </a:prstGeom>
+          <a:noFill/>
+          <a:ln/>
+        </p:spPr>
+        <p:txBody>
+          <a:bodyPr wrap="square" lIns="0" tIns="0" rIns="0" bIns="0" rtlCol="0" anchor="ctr"/>
+          <a:lstStyle/>
+          <a:p>
+            <a:pPr indent="0" marL="0">
+              <a:buNone/>
+            </a:pPr>
+            <a:r>
+              <a:rPr lang="en-US" sz="1300" b="1" dirty="0">
+                <a:solidFill>
+                  <a:srgbClr val="0B2545"/>
+                </a:solidFill>
+                <a:latin typeface="Calibri" pitchFamily="34" charset="0"/>
+                <a:ea typeface="Calibri" pitchFamily="34" charset="-122"/>
+                <a:cs typeface="Calibri" pitchFamily="34" charset="-120"/>
+              </a:rPr>
+              <a:t>Examen GIR 2026</a:t>
+            </a:r>
+            <a:endParaRPr lang="en-US" sz="1300" dirty="0"/>
+          </a:p>
+          <a:p>
+            <a:pPr indent="0" marL="0">
+              <a:buNone/>
+            </a:pPr>
+            <a:r>
+              <a:rPr lang="en-US" sz="1050" dirty="0">
+                <a:solidFill>
+                  <a:srgbClr val="13507F"/>
+                </a:solidFill>
+                <a:latin typeface="Calibri" pitchFamily="34" charset="0"/>
+                <a:ea typeface="Calibri" pitchFamily="34" charset="-122"/>
+                <a:cs typeface="Calibri" pitchFamily="34" charset="-120"/>
+              </a:rPr>
+              <a:t>Avance reportado</a:t>
+            </a:r>
+            <a:endParaRPr lang="en-US" sz="1300" dirty="0"/>
+          </a:p>
+        </p:txBody>
+      </p:sp>
+      <p:sp>
+        <p:nvSpPr>
+          <p:cNvPr id="6" name="Shape 4"/>
+          <p:cNvSpPr/>
+          <p:nvPr/>
+        </p:nvSpPr>
+        <p:spPr>
+          <a:xfrm>
+            <a:off x="8823960" y="859536"/>
+            <a:ext cx="1737360" cy="82296"/>
           </a:xfrm>
           <a:prstGeom prst="roundRect">
             <a:avLst>
@@ -1059,120 +1142,42 @@
             </a:avLst>
           </a:prstGeom>
           <a:solidFill>
-            <a:srgbClr val="0B2545"/>
-          </a:solidFill>
-          <a:ln w="12700">
-            <a:solidFill>
-              <a:srgbClr val="0B2545"/>
-            </a:solidFill>
-            <a:prstDash val="solid"/>
-          </a:ln>
-        </p:spPr>
-      </p:sp>
-      <p:sp>
-        <p:nvSpPr>
-          <p:cNvPr id="5" name="Text 3"/>
-          <p:cNvSpPr txBox="1"/>
-          <p:nvPr/>
-        </p:nvSpPr>
-        <p:spPr>
-          <a:xfrm>
-            <a:off x="9537192" y="384048"/>
-            <a:ext cx="2194560" cy="329184"/>
-          </a:xfrm>
-          <a:prstGeom prst="rect">
-            <a:avLst/>
-          </a:prstGeom>
-          <a:noFill/>
-          <a:ln/>
-        </p:spPr>
-        <p:txBody>
-          <a:bodyPr wrap="square" lIns="0" tIns="0" rIns="0" bIns="0" rtlCol="0" anchor="ctr"/>
-          <a:lstStyle/>
-          <a:p>
-            <a:pPr algn="ctr" indent="0" marL="0">
-              <a:buNone/>
-            </a:pPr>
-            <a:r>
-              <a:rPr lang="en-US" sz="1100" b="1" dirty="0">
-                <a:solidFill>
-                  <a:srgbClr val="FFFFFF"/>
-                </a:solidFill>
-                <a:latin typeface="Calibri" pitchFamily="34" charset="0"/>
-                <a:ea typeface="Calibri" pitchFamily="34" charset="-122"/>
-                <a:cs typeface="Calibri" pitchFamily="34" charset="-120"/>
-              </a:rPr>
-              <a:t>Seguimiento semanal · S1 – S2</a:t>
-            </a:r>
-            <a:endParaRPr lang="en-US" sz="1100" dirty="0"/>
-          </a:p>
-        </p:txBody>
-      </p:sp>
-      <p:sp>
-        <p:nvSpPr>
-          <p:cNvPr id="6" name="Shape 4"/>
-          <p:cNvSpPr/>
-          <p:nvPr/>
-        </p:nvSpPr>
-        <p:spPr>
-          <a:xfrm>
-            <a:off x="457200" y="1207008"/>
-            <a:ext cx="2708910" cy="566928"/>
+            <a:srgbClr val="B9DDE1"/>
+          </a:solidFill>
+          <a:ln w="12700">
+            <a:solidFill>
+              <a:srgbClr val="B9DDE1"/>
+            </a:solidFill>
+            <a:prstDash val="solid"/>
+          </a:ln>
+        </p:spPr>
+      </p:sp>
+      <p:sp>
+        <p:nvSpPr>
+          <p:cNvPr id="7" name="Shape 5"/>
+          <p:cNvSpPr/>
+          <p:nvPr/>
+        </p:nvSpPr>
+        <p:spPr>
+          <a:xfrm>
+            <a:off x="8823960" y="859536"/>
+            <a:ext cx="1563624" cy="82296"/>
           </a:xfrm>
           <a:prstGeom prst="roundRect">
             <a:avLst>
-              <a:gd name="adj" fmla="val 16129"/>
+              <a:gd name="adj" fmla="val 50000"/>
             </a:avLst>
           </a:prstGeom>
           <a:solidFill>
-            <a:srgbClr val="D7F0F2"/>
-          </a:solidFill>
-          <a:ln w="12700">
-            <a:solidFill>
-              <a:srgbClr val="D7F0F2"/>
-            </a:solidFill>
-            <a:prstDash val="solid"/>
-          </a:ln>
-        </p:spPr>
-      </p:sp>
-      <p:sp>
-        <p:nvSpPr>
-          <p:cNvPr id="7" name="Text 5"/>
-          <p:cNvSpPr txBox="1"/>
-          <p:nvPr/>
-        </p:nvSpPr>
-        <p:spPr>
-          <a:xfrm>
-            <a:off x="603504" y="1207008"/>
-            <a:ext cx="868680" cy="566928"/>
-          </a:xfrm>
-          <a:prstGeom prst="rect">
-            <a:avLst/>
-          </a:prstGeom>
-          <a:noFill/>
-          <a:ln/>
-        </p:spPr>
-        <p:txBody>
-          <a:bodyPr wrap="square" lIns="0" tIns="0" rIns="0" bIns="0" rtlCol="0" anchor="ctr"/>
-          <a:lstStyle/>
-          <a:p>
-            <a:pPr indent="0" marL="0">
-              <a:buNone/>
-            </a:pPr>
-            <a:r>
-              <a:rPr lang="en-US" sz="2200" b="1" dirty="0">
-                <a:solidFill>
-                  <a:srgbClr val="0A7480"/>
-                </a:solidFill>
-                <a:latin typeface="Calibri" pitchFamily="34" charset="0"/>
-                <a:ea typeface="Calibri" pitchFamily="34" charset="-122"/>
-                <a:cs typeface="Calibri" pitchFamily="34" charset="-120"/>
-              </a:rPr>
-              <a:t>4</a:t>
-            </a:r>
-            <a:endParaRPr lang="en-US" sz="2200" dirty="0"/>
-          </a:p>
-        </p:txBody>
+            <a:srgbClr val="0A7480"/>
+          </a:solidFill>
+          <a:ln w="12700">
+            <a:solidFill>
+              <a:srgbClr val="0A7480"/>
+            </a:solidFill>
+            <a:prstDash val="solid"/>
+          </a:ln>
+        </p:spPr>
       </p:sp>
       <p:sp>
         <p:nvSpPr>
@@ -1182,8 +1187,8 @@
         </p:nvSpPr>
         <p:spPr>
           <a:xfrm>
-            <a:off x="1463040" y="1261872"/>
-            <a:ext cx="1611630" cy="457200"/>
+            <a:off x="10634472" y="310896"/>
+            <a:ext cx="914400" cy="713232"/>
           </a:xfrm>
           <a:prstGeom prst="rect">
             <a:avLst/>
@@ -1195,38 +1200,21 @@
           <a:bodyPr wrap="square" lIns="0" tIns="0" rIns="0" bIns="0" rtlCol="0" anchor="ctr"/>
           <a:lstStyle/>
           <a:p>
-            <a:pPr indent="0" marL="0">
-              <a:buNone/>
-            </a:pPr>
-            <a:r>
-              <a:rPr lang="en-US" sz="1100" b="1" dirty="0">
-                <a:solidFill>
-                  <a:srgbClr val="0B2545"/>
-                </a:solidFill>
-                <a:latin typeface="Calibri" pitchFamily="34" charset="0"/>
-                <a:ea typeface="Calibri" pitchFamily="34" charset="-122"/>
-                <a:cs typeface="Calibri" pitchFamily="34" charset="-120"/>
-              </a:rPr>
-              <a:t>Requerimientos SSF</a:t>
-            </a:r>
-            <a:endParaRPr lang="en-US" sz="1100" dirty="0"/>
-          </a:p>
-          <a:p>
-            <a:pPr indent="0" marL="0">
-              <a:buNone/>
-            </a:pPr>
-            <a:r>
-              <a:rPr lang="en-US" sz="950" dirty="0">
-                <a:solidFill>
-                  <a:srgbClr val="13507F"/>
-                </a:solidFill>
-                <a:latin typeface="Calibri" pitchFamily="34" charset="0"/>
-                <a:ea typeface="Calibri" pitchFamily="34" charset="-122"/>
-                <a:cs typeface="Calibri" pitchFamily="34" charset="-120"/>
-              </a:rPr>
-              <a:t>22737 · 22741 · 22742 · 23486</a:t>
-            </a:r>
-            <a:endParaRPr lang="en-US" sz="1100" dirty="0"/>
+            <a:pPr algn="r" indent="0" marL="0">
+              <a:buNone/>
+            </a:pPr>
+            <a:r>
+              <a:rPr lang="en-US" sz="3000" b="1" dirty="0">
+                <a:solidFill>
+                  <a:srgbClr val="0A7480"/>
+                </a:solidFill>
+                <a:latin typeface="Calibri" pitchFamily="34" charset="0"/>
+                <a:ea typeface="Calibri" pitchFamily="34" charset="-122"/>
+                <a:cs typeface="Calibri" pitchFamily="34" charset="-120"/>
+              </a:rPr>
+              <a:t>90%</a:t>
+            </a:r>
+            <a:endParaRPr lang="en-US" sz="3000" dirty="0"/>
           </a:p>
         </p:txBody>
       </p:sp>
@@ -1238,379 +1226,65 @@
         </p:nvSpPr>
         <p:spPr>
           <a:xfrm>
-            <a:off x="3312414" y="1207008"/>
-            <a:ext cx="2708910" cy="566928"/>
+            <a:off x="457200" y="1371600"/>
+            <a:ext cx="5564124" cy="2432304"/>
           </a:xfrm>
           <a:prstGeom prst="roundRect">
             <a:avLst>
-              <a:gd name="adj" fmla="val 16129"/>
+              <a:gd name="adj" fmla="val 4511"/>
             </a:avLst>
           </a:prstGeom>
           <a:solidFill>
-            <a:srgbClr val="D7F0F2"/>
-          </a:solidFill>
-          <a:ln w="12700">
-            <a:solidFill>
-              <a:srgbClr val="D7F0F2"/>
-            </a:solidFill>
-            <a:prstDash val="solid"/>
-          </a:ln>
-        </p:spPr>
-      </p:sp>
-      <p:sp>
-        <p:nvSpPr>
-          <p:cNvPr id="10" name="Text 8"/>
-          <p:cNvSpPr txBox="1"/>
-          <p:nvPr/>
-        </p:nvSpPr>
-        <p:spPr>
-          <a:xfrm>
-            <a:off x="3458718" y="1207008"/>
-            <a:ext cx="868680" cy="566928"/>
-          </a:xfrm>
-          <a:prstGeom prst="rect">
-            <a:avLst/>
-          </a:prstGeom>
-          <a:noFill/>
-          <a:ln/>
-        </p:spPr>
-        <p:txBody>
-          <a:bodyPr wrap="square" lIns="0" tIns="0" rIns="0" bIns="0" rtlCol="0" anchor="ctr"/>
-          <a:lstStyle/>
-          <a:p>
-            <a:pPr indent="0" marL="0">
-              <a:buNone/>
-            </a:pPr>
-            <a:r>
-              <a:rPr lang="en-US" sz="2200" b="1" dirty="0">
-                <a:solidFill>
-                  <a:srgbClr val="0A7480"/>
-                </a:solidFill>
-                <a:latin typeface="Calibri" pitchFamily="34" charset="0"/>
-                <a:ea typeface="Calibri" pitchFamily="34" charset="-122"/>
-                <a:cs typeface="Calibri" pitchFamily="34" charset="-120"/>
-              </a:rPr>
-              <a:t>90%</a:t>
-            </a:r>
-            <a:endParaRPr lang="en-US" sz="2200" dirty="0"/>
-          </a:p>
-        </p:txBody>
-      </p:sp>
-      <p:sp>
-        <p:nvSpPr>
-          <p:cNvPr id="11" name="Text 9"/>
-          <p:cNvSpPr txBox="1"/>
-          <p:nvPr/>
-        </p:nvSpPr>
-        <p:spPr>
-          <a:xfrm>
-            <a:off x="4318254" y="1261872"/>
-            <a:ext cx="1611630" cy="457200"/>
-          </a:xfrm>
-          <a:prstGeom prst="rect">
-            <a:avLst/>
-          </a:prstGeom>
-          <a:noFill/>
-          <a:ln/>
-        </p:spPr>
-        <p:txBody>
-          <a:bodyPr wrap="square" lIns="0" tIns="0" rIns="0" bIns="0" rtlCol="0" anchor="ctr"/>
-          <a:lstStyle/>
-          <a:p>
-            <a:pPr indent="0" marL="0">
-              <a:buNone/>
-            </a:pPr>
-            <a:r>
-              <a:rPr lang="en-US" sz="1100" b="1" dirty="0">
-                <a:solidFill>
-                  <a:srgbClr val="0B2545"/>
-                </a:solidFill>
-                <a:latin typeface="Calibri" pitchFamily="34" charset="0"/>
-                <a:ea typeface="Calibri" pitchFamily="34" charset="-122"/>
-                <a:cs typeface="Calibri" pitchFamily="34" charset="-120"/>
-              </a:rPr>
-              <a:t>Examen GIR 2026</a:t>
-            </a:r>
-            <a:endParaRPr lang="en-US" sz="1100" dirty="0"/>
-          </a:p>
-          <a:p>
-            <a:pPr indent="0" marL="0">
-              <a:buNone/>
-            </a:pPr>
-            <a:r>
-              <a:rPr lang="en-US" sz="950" dirty="0">
-                <a:solidFill>
-                  <a:srgbClr val="13507F"/>
-                </a:solidFill>
-                <a:latin typeface="Calibri" pitchFamily="34" charset="0"/>
-                <a:ea typeface="Calibri" pitchFamily="34" charset="-122"/>
-                <a:cs typeface="Calibri" pitchFamily="34" charset="-120"/>
-              </a:rPr>
-              <a:t>Avance reportado</a:t>
-            </a:r>
-            <a:endParaRPr lang="en-US" sz="1100" dirty="0"/>
-          </a:p>
-        </p:txBody>
-      </p:sp>
-      <p:sp>
-        <p:nvSpPr>
-          <p:cNvPr id="12" name="Shape 10"/>
-          <p:cNvSpPr/>
-          <p:nvPr/>
-        </p:nvSpPr>
-        <p:spPr>
-          <a:xfrm>
-            <a:off x="6167628" y="1207008"/>
-            <a:ext cx="2708910" cy="566928"/>
+            <a:srgbClr val="F1F5F9"/>
+          </a:solidFill>
+          <a:ln w="12700">
+            <a:solidFill>
+              <a:srgbClr val="F1F5F9"/>
+            </a:solidFill>
+            <a:prstDash val="solid"/>
+          </a:ln>
+        </p:spPr>
+      </p:sp>
+      <p:sp>
+        <p:nvSpPr>
+          <p:cNvPr id="10" name="Shape 8"/>
+          <p:cNvSpPr/>
+          <p:nvPr/>
+        </p:nvSpPr>
+        <p:spPr>
+          <a:xfrm>
+            <a:off x="457200" y="1371600"/>
+            <a:ext cx="5564124" cy="676656"/>
           </a:xfrm>
           <a:prstGeom prst="roundRect">
             <a:avLst>
-              <a:gd name="adj" fmla="val 16129"/>
+              <a:gd name="adj" fmla="val 16216"/>
             </a:avLst>
           </a:prstGeom>
           <a:solidFill>
-            <a:srgbClr val="D7F0F2"/>
-          </a:solidFill>
-          <a:ln w="12700">
-            <a:solidFill>
-              <a:srgbClr val="D7F0F2"/>
-            </a:solidFill>
-            <a:prstDash val="solid"/>
-          </a:ln>
-        </p:spPr>
-      </p:sp>
-      <p:sp>
-        <p:nvSpPr>
-          <p:cNvPr id="13" name="Text 11"/>
-          <p:cNvSpPr txBox="1"/>
-          <p:nvPr/>
-        </p:nvSpPr>
-        <p:spPr>
-          <a:xfrm>
-            <a:off x="6313932" y="1207008"/>
-            <a:ext cx="868680" cy="566928"/>
-          </a:xfrm>
-          <a:prstGeom prst="rect">
-            <a:avLst/>
-          </a:prstGeom>
-          <a:noFill/>
-          <a:ln/>
-        </p:spPr>
-        <p:txBody>
-          <a:bodyPr wrap="square" lIns="0" tIns="0" rIns="0" bIns="0" rtlCol="0" anchor="ctr"/>
-          <a:lstStyle/>
-          <a:p>
-            <a:pPr indent="0" marL="0">
-              <a:buNone/>
-            </a:pPr>
-            <a:r>
-              <a:rPr lang="en-US" sz="2200" b="1" dirty="0">
-                <a:solidFill>
-                  <a:srgbClr val="0A7480"/>
-                </a:solidFill>
-                <a:latin typeface="Calibri" pitchFamily="34" charset="0"/>
-                <a:ea typeface="Calibri" pitchFamily="34" charset="-122"/>
-                <a:cs typeface="Calibri" pitchFamily="34" charset="-120"/>
-              </a:rPr>
-              <a:t>60%</a:t>
-            </a:r>
-            <a:endParaRPr lang="en-US" sz="2200" dirty="0"/>
-          </a:p>
-        </p:txBody>
-      </p:sp>
-      <p:sp>
-        <p:nvSpPr>
-          <p:cNvPr id="14" name="Text 12"/>
-          <p:cNvSpPr txBox="1"/>
-          <p:nvPr/>
-        </p:nvSpPr>
-        <p:spPr>
-          <a:xfrm>
-            <a:off x="7173468" y="1261872"/>
-            <a:ext cx="1611630" cy="457200"/>
-          </a:xfrm>
-          <a:prstGeom prst="rect">
-            <a:avLst/>
-          </a:prstGeom>
-          <a:noFill/>
-          <a:ln/>
-        </p:spPr>
-        <p:txBody>
-          <a:bodyPr wrap="square" lIns="0" tIns="0" rIns="0" bIns="0" rtlCol="0" anchor="ctr"/>
-          <a:lstStyle/>
-          <a:p>
-            <a:pPr indent="0" marL="0">
-              <a:buNone/>
-            </a:pPr>
-            <a:r>
-              <a:rPr lang="en-US" sz="1100" b="1" dirty="0">
-                <a:solidFill>
-                  <a:srgbClr val="0B2545"/>
-                </a:solidFill>
-                <a:latin typeface="Calibri" pitchFamily="34" charset="0"/>
-                <a:ea typeface="Calibri" pitchFamily="34" charset="-122"/>
-                <a:cs typeface="Calibri" pitchFamily="34" charset="-120"/>
-              </a:rPr>
-              <a:t>Control de avalúos</a:t>
-            </a:r>
-            <a:endParaRPr lang="en-US" sz="1100" dirty="0"/>
-          </a:p>
-          <a:p>
-            <a:pPr indent="0" marL="0">
-              <a:buNone/>
-            </a:pPr>
-            <a:r>
-              <a:rPr lang="en-US" sz="950" dirty="0">
-                <a:solidFill>
-                  <a:srgbClr val="13507F"/>
-                </a:solidFill>
-                <a:latin typeface="Calibri" pitchFamily="34" charset="0"/>
-                <a:ea typeface="Calibri" pitchFamily="34" charset="-122"/>
-                <a:cs typeface="Calibri" pitchFamily="34" charset="-120"/>
-              </a:rPr>
-              <a:t>Último reporte · por confirmar</a:t>
-            </a:r>
-            <a:endParaRPr lang="en-US" sz="1100" dirty="0"/>
-          </a:p>
-        </p:txBody>
-      </p:sp>
-      <p:sp>
-        <p:nvSpPr>
-          <p:cNvPr id="15" name="Shape 13"/>
-          <p:cNvSpPr/>
-          <p:nvPr/>
-        </p:nvSpPr>
-        <p:spPr>
-          <a:xfrm>
-            <a:off x="9022842" y="1207008"/>
-            <a:ext cx="2708910" cy="566928"/>
-          </a:xfrm>
-          <a:prstGeom prst="roundRect">
-            <a:avLst>
-              <a:gd name="adj" fmla="val 16129"/>
-            </a:avLst>
-          </a:prstGeom>
-          <a:solidFill>
-            <a:srgbClr val="D7F0F2"/>
-          </a:solidFill>
-          <a:ln w="12700">
-            <a:solidFill>
-              <a:srgbClr val="D7F0F2"/>
-            </a:solidFill>
-            <a:prstDash val="solid"/>
-          </a:ln>
-        </p:spPr>
-      </p:sp>
-      <p:sp>
-        <p:nvSpPr>
-          <p:cNvPr id="16" name="Text 14"/>
-          <p:cNvSpPr txBox="1"/>
-          <p:nvPr/>
-        </p:nvSpPr>
-        <p:spPr>
-          <a:xfrm>
-            <a:off x="9169146" y="1207008"/>
-            <a:ext cx="868680" cy="566928"/>
-          </a:xfrm>
-          <a:prstGeom prst="rect">
-            <a:avLst/>
-          </a:prstGeom>
-          <a:noFill/>
-          <a:ln/>
-        </p:spPr>
-        <p:txBody>
-          <a:bodyPr wrap="square" lIns="0" tIns="0" rIns="0" bIns="0" rtlCol="0" anchor="ctr"/>
-          <a:lstStyle/>
-          <a:p>
-            <a:pPr indent="0" marL="0">
-              <a:buNone/>
-            </a:pPr>
-            <a:r>
-              <a:rPr lang="en-US" sz="2200" b="1" dirty="0">
-                <a:solidFill>
-                  <a:srgbClr val="0A7480"/>
-                </a:solidFill>
-                <a:latin typeface="Calibri" pitchFamily="34" charset="0"/>
-                <a:ea typeface="Calibri" pitchFamily="34" charset="-122"/>
-                <a:cs typeface="Calibri" pitchFamily="34" charset="-120"/>
-              </a:rPr>
-              <a:t>01/10</a:t>
-            </a:r>
-            <a:endParaRPr lang="en-US" sz="2200" dirty="0"/>
-          </a:p>
-        </p:txBody>
-      </p:sp>
-      <p:sp>
-        <p:nvSpPr>
-          <p:cNvPr id="17" name="Text 15"/>
-          <p:cNvSpPr txBox="1"/>
-          <p:nvPr/>
-        </p:nvSpPr>
-        <p:spPr>
-          <a:xfrm>
-            <a:off x="10028682" y="1261872"/>
-            <a:ext cx="1611630" cy="457200"/>
-          </a:xfrm>
-          <a:prstGeom prst="rect">
-            <a:avLst/>
-          </a:prstGeom>
-          <a:noFill/>
-          <a:ln/>
-        </p:spPr>
-        <p:txBody>
-          <a:bodyPr wrap="square" lIns="0" tIns="0" rIns="0" bIns="0" rtlCol="0" anchor="ctr"/>
-          <a:lstStyle/>
-          <a:p>
-            <a:pPr indent="0" marL="0">
-              <a:buNone/>
-            </a:pPr>
-            <a:r>
-              <a:rPr lang="en-US" sz="1100" b="1" dirty="0">
-                <a:solidFill>
-                  <a:srgbClr val="0B2545"/>
-                </a:solidFill>
-                <a:latin typeface="Calibri" pitchFamily="34" charset="0"/>
-                <a:ea typeface="Calibri" pitchFamily="34" charset="-122"/>
-                <a:cs typeface="Calibri" pitchFamily="34" charset="-120"/>
-              </a:rPr>
-              <a:t>2.ª prueba de continuidad</a:t>
-            </a:r>
-            <a:endParaRPr lang="en-US" sz="1100" dirty="0"/>
-          </a:p>
-          <a:p>
-            <a:pPr indent="0" marL="0">
-              <a:buNone/>
-            </a:pPr>
-            <a:r>
-              <a:rPr lang="en-US" sz="950" dirty="0">
-                <a:solidFill>
-                  <a:srgbClr val="13507F"/>
-                </a:solidFill>
-                <a:latin typeface="Calibri" pitchFamily="34" charset="0"/>
-                <a:ea typeface="Calibri" pitchFamily="34" charset="-122"/>
-                <a:cs typeface="Calibri" pitchFamily="34" charset="-120"/>
-              </a:rPr>
-              <a:t>Informe de resultados</a:t>
-            </a:r>
-            <a:endParaRPr lang="en-US" sz="1100" dirty="0"/>
-          </a:p>
-        </p:txBody>
-      </p:sp>
-      <p:sp>
-        <p:nvSpPr>
-          <p:cNvPr id="18" name="Shape 16"/>
-          <p:cNvSpPr/>
-          <p:nvPr/>
-        </p:nvSpPr>
-        <p:spPr>
-          <a:xfrm>
-            <a:off x="457200" y="1920240"/>
-            <a:ext cx="5564124" cy="2203704"/>
-          </a:xfrm>
-          <a:prstGeom prst="roundRect">
-            <a:avLst>
-              <a:gd name="adj" fmla="val 4979"/>
-            </a:avLst>
+            <a:srgbClr val="0B2545"/>
+          </a:solidFill>
+          <a:ln w="12700">
+            <a:solidFill>
+              <a:srgbClr val="0B2545"/>
+            </a:solidFill>
+            <a:prstDash val="solid"/>
+          </a:ln>
+        </p:spPr>
+      </p:sp>
+      <p:sp>
+        <p:nvSpPr>
+          <p:cNvPr id="11" name="Shape 9"/>
+          <p:cNvSpPr/>
+          <p:nvPr/>
+        </p:nvSpPr>
+        <p:spPr>
+          <a:xfrm>
+            <a:off x="457200" y="1938528"/>
+            <a:ext cx="5564124" cy="182880"/>
+          </a:xfrm>
+          <a:prstGeom prst="rect">
+            <a:avLst/>
           </a:prstGeom>
           <a:solidFill>
             <a:srgbClr val="F1F5F9"/>
@@ -1625,66 +1299,14 @@
       </p:sp>
       <p:sp>
         <p:nvSpPr>
-          <p:cNvPr id="19" name="Shape 17"/>
-          <p:cNvSpPr/>
-          <p:nvPr/>
-        </p:nvSpPr>
-        <p:spPr>
-          <a:xfrm>
-            <a:off x="457200" y="1920240"/>
-            <a:ext cx="5564124" cy="749808"/>
-          </a:xfrm>
-          <a:prstGeom prst="roundRect">
-            <a:avLst>
-              <a:gd name="adj" fmla="val 14634"/>
-            </a:avLst>
-          </a:prstGeom>
-          <a:solidFill>
-            <a:srgbClr val="0B2545"/>
-          </a:solidFill>
-          <a:ln w="12700">
-            <a:solidFill>
-              <a:srgbClr val="0B2545"/>
-            </a:solidFill>
-            <a:prstDash val="solid"/>
-          </a:ln>
-        </p:spPr>
-      </p:sp>
-      <p:sp>
-        <p:nvSpPr>
-          <p:cNvPr id="20" name="Shape 18"/>
-          <p:cNvSpPr/>
-          <p:nvPr/>
-        </p:nvSpPr>
-        <p:spPr>
-          <a:xfrm>
-            <a:off x="457200" y="2560320"/>
-            <a:ext cx="5564124" cy="182880"/>
-          </a:xfrm>
-          <a:prstGeom prst="rect">
-            <a:avLst/>
-          </a:prstGeom>
-          <a:solidFill>
-            <a:srgbClr val="F1F5F9"/>
-          </a:solidFill>
-          <a:ln w="12700">
-            <a:solidFill>
-              <a:srgbClr val="F1F5F9"/>
-            </a:solidFill>
-            <a:prstDash val="solid"/>
-          </a:ln>
-        </p:spPr>
-      </p:sp>
-      <p:sp>
-        <p:nvSpPr>
-          <p:cNvPr id="21" name="Shape 19"/>
-          <p:cNvSpPr/>
-          <p:nvPr/>
-        </p:nvSpPr>
-        <p:spPr>
-          <a:xfrm>
-            <a:off x="640080" y="2020824"/>
-            <a:ext cx="438912" cy="438912"/>
+          <p:cNvPr id="12" name="Shape 10"/>
+          <p:cNvSpPr/>
+          <p:nvPr/>
+        </p:nvSpPr>
+        <p:spPr>
+          <a:xfrm>
+            <a:off x="640080" y="1463040"/>
+            <a:ext cx="384048" cy="384048"/>
           </a:xfrm>
           <a:prstGeom prst="ellipse">
             <a:avLst/>
@@ -1702,7 +1324,7 @@
       </p:sp>
       <p:pic>
         <p:nvPicPr>
-          <p:cNvPr id="22" name="Image 0" descr="preencoded.png">    </p:cNvPr>
+          <p:cNvPr id="13" name="Image 0" descr="preencoded.png">    </p:cNvPr>
           <p:cNvPicPr>
             <a:picLocks noChangeAspect="1"/>
           </p:cNvPicPr>
@@ -1716,8 +1338,8 @@
         </p:blipFill>
         <p:spPr>
           <a:xfrm>
-            <a:off x="745236" y="2125980"/>
-            <a:ext cx="228600" cy="228600"/>
+            <a:off x="731520" y="1554480"/>
+            <a:ext cx="201168" cy="201168"/>
           </a:xfrm>
           <a:prstGeom prst="rect">
             <a:avLst/>
@@ -1726,14 +1348,14 @@
       </p:pic>
       <p:sp>
         <p:nvSpPr>
-          <p:cNvPr id="23" name="Text 20"/>
+          <p:cNvPr id="14" name="Text 11"/>
           <p:cNvSpPr txBox="1"/>
           <p:nvPr/>
         </p:nvSpPr>
         <p:spPr>
           <a:xfrm>
-            <a:off x="1225296" y="1993392"/>
-            <a:ext cx="4649724" cy="292608"/>
+            <a:off x="1170432" y="1463040"/>
+            <a:ext cx="4695444" cy="384048"/>
           </a:xfrm>
           <a:prstGeom prst="rect">
             <a:avLst/>
@@ -1749,7 +1371,7 @@
               <a:buNone/>
             </a:pPr>
             <a:r>
-              <a:rPr lang="en-US" sz="1500" b="1" dirty="0">
+              <a:rPr lang="en-US" sz="1600" b="1" dirty="0">
                 <a:solidFill>
                   <a:srgbClr val="FFFFFF"/>
                 </a:solidFill>
@@ -1759,9 +1381,290 @@
               </a:rPr>
               <a:t>Riesgo Operacional y Continuidad</a:t>
             </a:r>
-            <a:endParaRPr lang="en-US" sz="1500" dirty="0"/>
-          </a:p>
-        </p:txBody>
+            <a:endParaRPr lang="en-US" sz="1600" dirty="0"/>
+          </a:p>
+        </p:txBody>
+      </p:sp>
+      <p:sp>
+        <p:nvSpPr>
+          <p:cNvPr id="15" name="Shape 12"/>
+          <p:cNvSpPr/>
+          <p:nvPr/>
+        </p:nvSpPr>
+        <p:spPr>
+          <a:xfrm>
+            <a:off x="713232" y="2235708"/>
+            <a:ext cx="73152" cy="73152"/>
+          </a:xfrm>
+          <a:prstGeom prst="rect">
+            <a:avLst/>
+          </a:prstGeom>
+          <a:solidFill>
+            <a:srgbClr val="0B2545"/>
+          </a:solidFill>
+          <a:ln w="12700">
+            <a:solidFill>
+              <a:srgbClr val="0B2545"/>
+            </a:solidFill>
+            <a:prstDash val="solid"/>
+          </a:ln>
+        </p:spPr>
+      </p:sp>
+      <p:sp>
+        <p:nvSpPr>
+          <p:cNvPr id="16" name="Text 13"/>
+          <p:cNvSpPr txBox="1"/>
+          <p:nvPr/>
+        </p:nvSpPr>
+        <p:spPr>
+          <a:xfrm>
+            <a:off x="896112" y="2139696"/>
+            <a:ext cx="4924044" cy="265176"/>
+          </a:xfrm>
+          <a:prstGeom prst="rect">
+            <a:avLst/>
+          </a:prstGeom>
+          <a:noFill/>
+          <a:ln/>
+        </p:spPr>
+        <p:txBody>
+          <a:bodyPr wrap="square" lIns="0" tIns="0" rIns="0" bIns="0" rtlCol="0" anchor="ctr"/>
+          <a:lstStyle/>
+          <a:p>
+            <a:pPr indent="0" marL="0">
+              <a:buNone/>
+            </a:pPr>
+            <a:r>
+              <a:rPr lang="en-US" sz="1300" dirty="0">
+                <a:solidFill>
+                  <a:srgbClr val="1B2733"/>
+                </a:solidFill>
+                <a:latin typeface="Calibri" pitchFamily="34" charset="0"/>
+                <a:ea typeface="Calibri" pitchFamily="34" charset="-122"/>
+                <a:cs typeface="Calibri" pitchFamily="34" charset="-120"/>
+              </a:rPr>
+              <a:t>Capacitación GIR 2026 e informe de seguimiento del examen</a:t>
+            </a:r>
+            <a:endParaRPr lang="en-US" sz="1300" dirty="0"/>
+          </a:p>
+        </p:txBody>
+      </p:sp>
+      <p:sp>
+        <p:nvSpPr>
+          <p:cNvPr id="17" name="Shape 14"/>
+          <p:cNvSpPr/>
+          <p:nvPr/>
+        </p:nvSpPr>
+        <p:spPr>
+          <a:xfrm>
+            <a:off x="713232" y="2546604"/>
+            <a:ext cx="73152" cy="73152"/>
+          </a:xfrm>
+          <a:prstGeom prst="rect">
+            <a:avLst/>
+          </a:prstGeom>
+          <a:solidFill>
+            <a:srgbClr val="0B2545"/>
+          </a:solidFill>
+          <a:ln w="12700">
+            <a:solidFill>
+              <a:srgbClr val="0B2545"/>
+            </a:solidFill>
+            <a:prstDash val="solid"/>
+          </a:ln>
+        </p:spPr>
+      </p:sp>
+      <p:sp>
+        <p:nvSpPr>
+          <p:cNvPr id="18" name="Text 15"/>
+          <p:cNvSpPr txBox="1"/>
+          <p:nvPr/>
+        </p:nvSpPr>
+        <p:spPr>
+          <a:xfrm>
+            <a:off x="896112" y="2450592"/>
+            <a:ext cx="4924044" cy="265176"/>
+          </a:xfrm>
+          <a:prstGeom prst="rect">
+            <a:avLst/>
+          </a:prstGeom>
+          <a:noFill/>
+          <a:ln/>
+        </p:spPr>
+        <p:txBody>
+          <a:bodyPr wrap="square" lIns="0" tIns="0" rIns="0" bIns="0" rtlCol="0" anchor="ctr"/>
+          <a:lstStyle/>
+          <a:p>
+            <a:pPr indent="0" marL="0">
+              <a:buNone/>
+            </a:pPr>
+            <a:r>
+              <a:rPr lang="en-US" sz="1300" dirty="0">
+                <a:solidFill>
+                  <a:srgbClr val="1B2733"/>
+                </a:solidFill>
+                <a:latin typeface="Calibri" pitchFamily="34" charset="0"/>
+                <a:ea typeface="Calibri" pitchFamily="34" charset="-122"/>
+                <a:cs typeface="Calibri" pitchFamily="34" charset="-120"/>
+              </a:rPr>
+              <a:t>Informe de la 2.ª prueba de Continuidad del Negocio (01/10/2026)</a:t>
+            </a:r>
+            <a:endParaRPr lang="en-US" sz="1300" dirty="0"/>
+          </a:p>
+        </p:txBody>
+      </p:sp>
+      <p:sp>
+        <p:nvSpPr>
+          <p:cNvPr id="19" name="Shape 16"/>
+          <p:cNvSpPr/>
+          <p:nvPr/>
+        </p:nvSpPr>
+        <p:spPr>
+          <a:xfrm>
+            <a:off x="713232" y="2857500"/>
+            <a:ext cx="73152" cy="73152"/>
+          </a:xfrm>
+          <a:prstGeom prst="rect">
+            <a:avLst/>
+          </a:prstGeom>
+          <a:solidFill>
+            <a:srgbClr val="0B2545"/>
+          </a:solidFill>
+          <a:ln w="12700">
+            <a:solidFill>
+              <a:srgbClr val="0B2545"/>
+            </a:solidFill>
+            <a:prstDash val="solid"/>
+          </a:ln>
+        </p:spPr>
+      </p:sp>
+      <p:sp>
+        <p:nvSpPr>
+          <p:cNvPr id="20" name="Text 17"/>
+          <p:cNvSpPr txBox="1"/>
+          <p:nvPr/>
+        </p:nvSpPr>
+        <p:spPr>
+          <a:xfrm>
+            <a:off x="896112" y="2761488"/>
+            <a:ext cx="4924044" cy="265176"/>
+          </a:xfrm>
+          <a:prstGeom prst="rect">
+            <a:avLst/>
+          </a:prstGeom>
+          <a:noFill/>
+          <a:ln/>
+        </p:spPr>
+        <p:txBody>
+          <a:bodyPr wrap="square" lIns="0" tIns="0" rIns="0" bIns="0" rtlCol="0" anchor="ctr"/>
+          <a:lstStyle/>
+          <a:p>
+            <a:pPr indent="0" marL="0">
+              <a:buNone/>
+            </a:pPr>
+            <a:r>
+              <a:rPr lang="en-US" sz="1300" dirty="0">
+                <a:solidFill>
+                  <a:srgbClr val="1B2733"/>
+                </a:solidFill>
+                <a:latin typeface="Calibri" pitchFamily="34" charset="0"/>
+                <a:ea typeface="Calibri" pitchFamily="34" charset="-122"/>
+                <a:cs typeface="Calibri" pitchFamily="34" charset="-120"/>
+              </a:rPr>
+              <a:t>Seguimiento de planes de acción – Matriz de Riesgos 2026</a:t>
+            </a:r>
+            <a:endParaRPr lang="en-US" sz="1300" dirty="0"/>
+          </a:p>
+        </p:txBody>
+      </p:sp>
+      <p:sp>
+        <p:nvSpPr>
+          <p:cNvPr id="21" name="Shape 18"/>
+          <p:cNvSpPr/>
+          <p:nvPr/>
+        </p:nvSpPr>
+        <p:spPr>
+          <a:xfrm>
+            <a:off x="713232" y="3168396"/>
+            <a:ext cx="73152" cy="73152"/>
+          </a:xfrm>
+          <a:prstGeom prst="rect">
+            <a:avLst/>
+          </a:prstGeom>
+          <a:solidFill>
+            <a:srgbClr val="0B2545"/>
+          </a:solidFill>
+          <a:ln w="12700">
+            <a:solidFill>
+              <a:srgbClr val="0B2545"/>
+            </a:solidFill>
+            <a:prstDash val="solid"/>
+          </a:ln>
+        </p:spPr>
+      </p:sp>
+      <p:sp>
+        <p:nvSpPr>
+          <p:cNvPr id="22" name="Text 19"/>
+          <p:cNvSpPr txBox="1"/>
+          <p:nvPr/>
+        </p:nvSpPr>
+        <p:spPr>
+          <a:xfrm>
+            <a:off x="896112" y="3072384"/>
+            <a:ext cx="4924044" cy="265176"/>
+          </a:xfrm>
+          <a:prstGeom prst="rect">
+            <a:avLst/>
+          </a:prstGeom>
+          <a:noFill/>
+          <a:ln/>
+        </p:spPr>
+        <p:txBody>
+          <a:bodyPr wrap="square" lIns="0" tIns="0" rIns="0" bIns="0" rtlCol="0" anchor="ctr"/>
+          <a:lstStyle/>
+          <a:p>
+            <a:pPr indent="0" marL="0">
+              <a:buNone/>
+            </a:pPr>
+            <a:r>
+              <a:rPr lang="en-US" sz="1300" dirty="0">
+                <a:solidFill>
+                  <a:srgbClr val="1B2733"/>
+                </a:solidFill>
+                <a:latin typeface="Calibri" pitchFamily="34" charset="0"/>
+                <a:ea typeface="Calibri" pitchFamily="34" charset="-122"/>
+                <a:cs typeface="Calibri" pitchFamily="34" charset="-120"/>
+              </a:rPr>
+              <a:t>Eventos de riesgo: caídas de TC (25/09) y Orion (26/09)</a:t>
+            </a:r>
+            <a:endParaRPr lang="en-US" sz="1300" dirty="0"/>
+          </a:p>
+        </p:txBody>
+      </p:sp>
+      <p:sp>
+        <p:nvSpPr>
+          <p:cNvPr id="23" name="Shape 20"/>
+          <p:cNvSpPr/>
+          <p:nvPr/>
+        </p:nvSpPr>
+        <p:spPr>
+          <a:xfrm>
+            <a:off x="713232" y="3479292"/>
+            <a:ext cx="73152" cy="73152"/>
+          </a:xfrm>
+          <a:prstGeom prst="rect">
+            <a:avLst/>
+          </a:prstGeom>
+          <a:solidFill>
+            <a:srgbClr val="0B2545"/>
+          </a:solidFill>
+          <a:ln w="12700">
+            <a:solidFill>
+              <a:srgbClr val="0B2545"/>
+            </a:solidFill>
+            <a:prstDash val="solid"/>
+          </a:ln>
+        </p:spPr>
       </p:sp>
       <p:sp>
         <p:nvSpPr>
@@ -1771,8 +1674,8 @@
         </p:nvSpPr>
         <p:spPr>
           <a:xfrm>
-            <a:off x="1225296" y="2267712"/>
-            <a:ext cx="4649724" cy="219456"/>
+            <a:off x="896112" y="3383280"/>
+            <a:ext cx="4924044" cy="265176"/>
           </a:xfrm>
           <a:prstGeom prst="rect">
             <a:avLst/>
@@ -1788,17 +1691,17 @@
               <a:buNone/>
             </a:pPr>
             <a:r>
-              <a:rPr lang="en-US" sz="1050" i="1" dirty="0">
-                <a:solidFill>
-                  <a:srgbClr val="DCE8F3"/>
-                </a:solidFill>
-                <a:latin typeface="Calibri" pitchFamily="34" charset="0"/>
-                <a:ea typeface="Calibri" pitchFamily="34" charset="-122"/>
-                <a:cs typeface="Calibri" pitchFamily="34" charset="-120"/>
-              </a:rPr>
-              <a:t>Cultura de riesgos, continuidad del negocio y control de eventos</a:t>
-            </a:r>
-            <a:endParaRPr lang="en-US" sz="1050" dirty="0"/>
+              <a:rPr lang="en-US" sz="1300" dirty="0">
+                <a:solidFill>
+                  <a:srgbClr val="1B2733"/>
+                </a:solidFill>
+                <a:latin typeface="Calibri" pitchFamily="34" charset="0"/>
+                <a:ea typeface="Calibri" pitchFamily="34" charset="-122"/>
+                <a:cs typeface="Calibri" pitchFamily="34" charset="-120"/>
+              </a:rPr>
+              <a:t>Opiniones: Fábrica de Créditos y caso de asociado</a:t>
+            </a:r>
+            <a:endParaRPr lang="en-US" sz="1300" dirty="0"/>
           </a:p>
         </p:txBody>
       </p:sp>
@@ -1810,480 +1713,12 @@
         </p:nvSpPr>
         <p:spPr>
           <a:xfrm>
-            <a:off x="676656" y="2775204"/>
-            <a:ext cx="64008" cy="64008"/>
-          </a:xfrm>
-          <a:prstGeom prst="rect">
-            <a:avLst/>
-          </a:prstGeom>
-          <a:solidFill>
-            <a:srgbClr val="0B2545"/>
-          </a:solidFill>
-          <a:ln w="12700">
-            <a:solidFill>
-              <a:srgbClr val="0B2545"/>
-            </a:solidFill>
-            <a:prstDash val="solid"/>
-          </a:ln>
-        </p:spPr>
-      </p:sp>
-      <p:sp>
-        <p:nvSpPr>
-          <p:cNvPr id="26" name="Text 23"/>
-          <p:cNvSpPr txBox="1"/>
-          <p:nvPr/>
-        </p:nvSpPr>
-        <p:spPr>
-          <a:xfrm>
-            <a:off x="832104" y="2706624"/>
-            <a:ext cx="5006340" cy="201168"/>
-          </a:xfrm>
-          <a:prstGeom prst="rect">
-            <a:avLst/>
-          </a:prstGeom>
-          <a:noFill/>
-          <a:ln/>
-        </p:spPr>
-        <p:txBody>
-          <a:bodyPr wrap="square" lIns="0" tIns="0" rIns="0" bIns="0" rtlCol="0" anchor="ctr"/>
-          <a:lstStyle/>
-          <a:p>
-            <a:pPr indent="0" marL="0">
-              <a:buNone/>
-            </a:pPr>
-            <a:r>
-              <a:rPr lang="en-US" sz="1100" b="1" dirty="0">
-                <a:solidFill>
-                  <a:srgbClr val="0B2545"/>
-                </a:solidFill>
-                <a:latin typeface="Calibri" pitchFamily="34" charset="0"/>
-                <a:ea typeface="Calibri" pitchFamily="34" charset="-122"/>
-                <a:cs typeface="Calibri" pitchFamily="34" charset="-120"/>
-              </a:rPr>
-              <a:t>Capacitación GIR 2026: </a:t>
-            </a:r>
-            <a:pPr indent="0" marL="0">
-              <a:buNone/>
-            </a:pPr>
-            <a:r>
-              <a:rPr lang="en-US" sz="1100" dirty="0">
-                <a:solidFill>
-                  <a:srgbClr val="1B2733"/>
-                </a:solidFill>
-                <a:latin typeface="Calibri" pitchFamily="34" charset="0"/>
-                <a:ea typeface="Calibri" pitchFamily="34" charset="-122"/>
-                <a:cs typeface="Calibri" pitchFamily="34" charset="-120"/>
-              </a:rPr>
-              <a:t>capacitación, examen e informe de seguimiento</a:t>
-            </a:r>
-            <a:endParaRPr lang="en-US" sz="1100" dirty="0"/>
-          </a:p>
-        </p:txBody>
-      </p:sp>
-      <p:sp>
-        <p:nvSpPr>
-          <p:cNvPr id="27" name="Shape 24"/>
-          <p:cNvSpPr/>
-          <p:nvPr/>
-        </p:nvSpPr>
-        <p:spPr>
-          <a:xfrm>
-            <a:off x="676656" y="2999232"/>
-            <a:ext cx="64008" cy="64008"/>
-          </a:xfrm>
-          <a:prstGeom prst="rect">
-            <a:avLst/>
-          </a:prstGeom>
-          <a:solidFill>
-            <a:srgbClr val="0B2545"/>
-          </a:solidFill>
-          <a:ln w="12700">
-            <a:solidFill>
-              <a:srgbClr val="0B2545"/>
-            </a:solidFill>
-            <a:prstDash val="solid"/>
-          </a:ln>
-        </p:spPr>
-      </p:sp>
-      <p:sp>
-        <p:nvSpPr>
-          <p:cNvPr id="28" name="Text 25"/>
-          <p:cNvSpPr txBox="1"/>
-          <p:nvPr/>
-        </p:nvSpPr>
-        <p:spPr>
-          <a:xfrm>
-            <a:off x="832104" y="2930652"/>
-            <a:ext cx="5006340" cy="201168"/>
-          </a:xfrm>
-          <a:prstGeom prst="rect">
-            <a:avLst/>
-          </a:prstGeom>
-          <a:noFill/>
-          <a:ln/>
-        </p:spPr>
-        <p:txBody>
-          <a:bodyPr wrap="square" lIns="0" tIns="0" rIns="0" bIns="0" rtlCol="0" anchor="ctr"/>
-          <a:lstStyle/>
-          <a:p>
-            <a:pPr indent="0" marL="0">
-              <a:buNone/>
-            </a:pPr>
-            <a:r>
-              <a:rPr lang="en-US" sz="1100" b="1" dirty="0">
-                <a:solidFill>
-                  <a:srgbClr val="0B2545"/>
-                </a:solidFill>
-                <a:latin typeface="Calibri" pitchFamily="34" charset="0"/>
-                <a:ea typeface="Calibri" pitchFamily="34" charset="-122"/>
-                <a:cs typeface="Calibri" pitchFamily="34" charset="-120"/>
-              </a:rPr>
-              <a:t>Continuidad: </a:t>
-            </a:r>
-            <a:pPr indent="0" marL="0">
-              <a:buNone/>
-            </a:pPr>
-            <a:r>
-              <a:rPr lang="en-US" sz="1100" dirty="0">
-                <a:solidFill>
-                  <a:srgbClr val="1B2733"/>
-                </a:solidFill>
-                <a:latin typeface="Calibri" pitchFamily="34" charset="0"/>
-                <a:ea typeface="Calibri" pitchFamily="34" charset="-122"/>
-                <a:cs typeface="Calibri" pitchFamily="34" charset="-120"/>
-              </a:rPr>
-              <a:t>informe de la 2.ª prueba (01/10/2026) y actualización Matriz BIA</a:t>
-            </a:r>
-            <a:endParaRPr lang="en-US" sz="1100" dirty="0"/>
-          </a:p>
-        </p:txBody>
-      </p:sp>
-      <p:sp>
-        <p:nvSpPr>
-          <p:cNvPr id="29" name="Shape 26"/>
-          <p:cNvSpPr/>
-          <p:nvPr/>
-        </p:nvSpPr>
-        <p:spPr>
-          <a:xfrm>
-            <a:off x="676656" y="3223260"/>
-            <a:ext cx="64008" cy="64008"/>
-          </a:xfrm>
-          <a:prstGeom prst="rect">
-            <a:avLst/>
-          </a:prstGeom>
-          <a:solidFill>
-            <a:srgbClr val="0B2545"/>
-          </a:solidFill>
-          <a:ln w="12700">
-            <a:solidFill>
-              <a:srgbClr val="0B2545"/>
-            </a:solidFill>
-            <a:prstDash val="solid"/>
-          </a:ln>
-        </p:spPr>
-      </p:sp>
-      <p:sp>
-        <p:nvSpPr>
-          <p:cNvPr id="30" name="Text 27"/>
-          <p:cNvSpPr txBox="1"/>
-          <p:nvPr/>
-        </p:nvSpPr>
-        <p:spPr>
-          <a:xfrm>
-            <a:off x="832104" y="3154680"/>
-            <a:ext cx="5006340" cy="201168"/>
-          </a:xfrm>
-          <a:prstGeom prst="rect">
-            <a:avLst/>
-          </a:prstGeom>
-          <a:noFill/>
-          <a:ln/>
-        </p:spPr>
-        <p:txBody>
-          <a:bodyPr wrap="square" lIns="0" tIns="0" rIns="0" bIns="0" rtlCol="0" anchor="ctr"/>
-          <a:lstStyle/>
-          <a:p>
-            <a:pPr indent="0" marL="0">
-              <a:buNone/>
-            </a:pPr>
-            <a:r>
-              <a:rPr lang="en-US" sz="1100" b="1" dirty="0">
-                <a:solidFill>
-                  <a:srgbClr val="0B2545"/>
-                </a:solidFill>
-                <a:latin typeface="Calibri" pitchFamily="34" charset="0"/>
-                <a:ea typeface="Calibri" pitchFamily="34" charset="-122"/>
-                <a:cs typeface="Calibri" pitchFamily="34" charset="-120"/>
-              </a:rPr>
-              <a:t>Matriz de Riesgos Institucional 2026: </a:t>
-            </a:r>
-            <a:pPr indent="0" marL="0">
-              <a:buNone/>
-            </a:pPr>
-            <a:r>
-              <a:rPr lang="en-US" sz="1100" dirty="0">
-                <a:solidFill>
-                  <a:srgbClr val="1B2733"/>
-                </a:solidFill>
-                <a:latin typeface="Calibri" pitchFamily="34" charset="0"/>
-                <a:ea typeface="Calibri" pitchFamily="34" charset="-122"/>
-                <a:cs typeface="Calibri" pitchFamily="34" charset="-120"/>
-              </a:rPr>
-              <a:t>seguimiento de planes de acción</a:t>
-            </a:r>
-            <a:endParaRPr lang="en-US" sz="1100" dirty="0"/>
-          </a:p>
-        </p:txBody>
-      </p:sp>
-      <p:sp>
-        <p:nvSpPr>
-          <p:cNvPr id="31" name="Shape 28"/>
-          <p:cNvSpPr/>
-          <p:nvPr/>
-        </p:nvSpPr>
-        <p:spPr>
-          <a:xfrm>
-            <a:off x="676656" y="3447288"/>
-            <a:ext cx="64008" cy="64008"/>
-          </a:xfrm>
-          <a:prstGeom prst="rect">
-            <a:avLst/>
-          </a:prstGeom>
-          <a:solidFill>
-            <a:srgbClr val="0B2545"/>
-          </a:solidFill>
-          <a:ln w="12700">
-            <a:solidFill>
-              <a:srgbClr val="0B2545"/>
-            </a:solidFill>
-            <a:prstDash val="solid"/>
-          </a:ln>
-        </p:spPr>
-      </p:sp>
-      <p:sp>
-        <p:nvSpPr>
-          <p:cNvPr id="32" name="Text 29"/>
-          <p:cNvSpPr txBox="1"/>
-          <p:nvPr/>
-        </p:nvSpPr>
-        <p:spPr>
-          <a:xfrm>
-            <a:off x="832104" y="3378708"/>
-            <a:ext cx="5006340" cy="201168"/>
-          </a:xfrm>
-          <a:prstGeom prst="rect">
-            <a:avLst/>
-          </a:prstGeom>
-          <a:noFill/>
-          <a:ln/>
-        </p:spPr>
-        <p:txBody>
-          <a:bodyPr wrap="square" lIns="0" tIns="0" rIns="0" bIns="0" rtlCol="0" anchor="ctr"/>
-          <a:lstStyle/>
-          <a:p>
-            <a:pPr indent="0" marL="0">
-              <a:buNone/>
-            </a:pPr>
-            <a:r>
-              <a:rPr lang="en-US" sz="1100" b="1" dirty="0">
-                <a:solidFill>
-                  <a:srgbClr val="0B2545"/>
-                </a:solidFill>
-                <a:latin typeface="Calibri" pitchFamily="34" charset="0"/>
-                <a:ea typeface="Calibri" pitchFamily="34" charset="-122"/>
-                <a:cs typeface="Calibri" pitchFamily="34" charset="-120"/>
-              </a:rPr>
-              <a:t>Eventos: </a:t>
-            </a:r>
-            <a:pPr indent="0" marL="0">
-              <a:buNone/>
-            </a:pPr>
-            <a:r>
-              <a:rPr lang="en-US" sz="1100" dirty="0">
-                <a:solidFill>
-                  <a:srgbClr val="1B2733"/>
-                </a:solidFill>
-                <a:latin typeface="Calibri" pitchFamily="34" charset="0"/>
-                <a:ea typeface="Calibri" pitchFamily="34" charset="-122"/>
-                <a:cs typeface="Calibri" pitchFamily="34" charset="-120"/>
-              </a:rPr>
-              <a:t>caídas de TC (25/09) y Orion (26/09); ventana de mantenimiento</a:t>
-            </a:r>
-            <a:endParaRPr lang="en-US" sz="1100" dirty="0"/>
-          </a:p>
-        </p:txBody>
-      </p:sp>
-      <p:sp>
-        <p:nvSpPr>
-          <p:cNvPr id="33" name="Shape 30"/>
-          <p:cNvSpPr/>
-          <p:nvPr/>
-        </p:nvSpPr>
-        <p:spPr>
-          <a:xfrm>
-            <a:off x="676656" y="3671316"/>
-            <a:ext cx="64008" cy="64008"/>
-          </a:xfrm>
-          <a:prstGeom prst="rect">
-            <a:avLst/>
-          </a:prstGeom>
-          <a:solidFill>
-            <a:srgbClr val="0B2545"/>
-          </a:solidFill>
-          <a:ln w="12700">
-            <a:solidFill>
-              <a:srgbClr val="0B2545"/>
-            </a:solidFill>
-            <a:prstDash val="solid"/>
-          </a:ln>
-        </p:spPr>
-      </p:sp>
-      <p:sp>
-        <p:nvSpPr>
-          <p:cNvPr id="34" name="Text 31"/>
-          <p:cNvSpPr txBox="1"/>
-          <p:nvPr/>
-        </p:nvSpPr>
-        <p:spPr>
-          <a:xfrm>
-            <a:off x="832104" y="3602736"/>
-            <a:ext cx="5006340" cy="201168"/>
-          </a:xfrm>
-          <a:prstGeom prst="rect">
-            <a:avLst/>
-          </a:prstGeom>
-          <a:noFill/>
-          <a:ln/>
-        </p:spPr>
-        <p:txBody>
-          <a:bodyPr wrap="square" lIns="0" tIns="0" rIns="0" bIns="0" rtlCol="0" anchor="ctr"/>
-          <a:lstStyle/>
-          <a:p>
-            <a:pPr indent="0" marL="0">
-              <a:buNone/>
-            </a:pPr>
-            <a:r>
-              <a:rPr lang="en-US" sz="1100" b="1" dirty="0">
-                <a:solidFill>
-                  <a:srgbClr val="0B2545"/>
-                </a:solidFill>
-                <a:latin typeface="Calibri" pitchFamily="34" charset="0"/>
-                <a:ea typeface="Calibri" pitchFamily="34" charset="-122"/>
-                <a:cs typeface="Calibri" pitchFamily="34" charset="-120"/>
-              </a:rPr>
-              <a:t>Opiniones: </a:t>
-            </a:r>
-            <a:pPr indent="0" marL="0">
-              <a:buNone/>
-            </a:pPr>
-            <a:r>
-              <a:rPr lang="en-US" sz="1100" dirty="0">
-                <a:solidFill>
-                  <a:srgbClr val="1B2733"/>
-                </a:solidFill>
-                <a:latin typeface="Calibri" pitchFamily="34" charset="0"/>
-                <a:ea typeface="Calibri" pitchFamily="34" charset="-122"/>
-                <a:cs typeface="Calibri" pitchFamily="34" charset="-120"/>
-              </a:rPr>
-              <a:t>Fábrica de Créditos y caso asociado J. Jacobo Marroquín</a:t>
-            </a:r>
-            <a:endParaRPr lang="en-US" sz="1100" dirty="0"/>
-          </a:p>
-        </p:txBody>
-      </p:sp>
-      <p:sp>
-        <p:nvSpPr>
-          <p:cNvPr id="35" name="Shape 32"/>
-          <p:cNvSpPr/>
-          <p:nvPr/>
-        </p:nvSpPr>
-        <p:spPr>
-          <a:xfrm>
-            <a:off x="676656" y="3895344"/>
-            <a:ext cx="64008" cy="64008"/>
-          </a:xfrm>
-          <a:prstGeom prst="rect">
-            <a:avLst/>
-          </a:prstGeom>
-          <a:solidFill>
-            <a:srgbClr val="0B2545"/>
-          </a:solidFill>
-          <a:ln w="12700">
-            <a:solidFill>
-              <a:srgbClr val="0B2545"/>
-            </a:solidFill>
-            <a:prstDash val="solid"/>
-          </a:ln>
-        </p:spPr>
-      </p:sp>
-      <p:sp>
-        <p:nvSpPr>
-          <p:cNvPr id="36" name="Text 33"/>
-          <p:cNvSpPr txBox="1"/>
-          <p:nvPr/>
-        </p:nvSpPr>
-        <p:spPr>
-          <a:xfrm>
-            <a:off x="832104" y="3826764"/>
-            <a:ext cx="5006340" cy="201168"/>
-          </a:xfrm>
-          <a:prstGeom prst="rect">
-            <a:avLst/>
-          </a:prstGeom>
-          <a:noFill/>
-          <a:ln/>
-        </p:spPr>
-        <p:txBody>
-          <a:bodyPr wrap="square" lIns="0" tIns="0" rIns="0" bIns="0" rtlCol="0" anchor="ctr"/>
-          <a:lstStyle/>
-          <a:p>
-            <a:pPr indent="0" marL="0">
-              <a:buNone/>
-            </a:pPr>
-            <a:r>
-              <a:rPr lang="en-US" sz="1100" b="1" dirty="0">
-                <a:solidFill>
-                  <a:srgbClr val="0B2545"/>
-                </a:solidFill>
-                <a:latin typeface="Calibri" pitchFamily="34" charset="0"/>
-                <a:ea typeface="Calibri" pitchFamily="34" charset="-122"/>
-                <a:cs typeface="Calibri" pitchFamily="34" charset="-120"/>
-              </a:rPr>
-              <a:t>Auditorías: </a:t>
-            </a:r>
-            <a:pPr indent="0" marL="0">
-              <a:buNone/>
-            </a:pPr>
-            <a:r>
-              <a:rPr lang="en-US" sz="1100" dirty="0">
-                <a:solidFill>
-                  <a:srgbClr val="1B2733"/>
-                </a:solidFill>
-                <a:latin typeface="Calibri" pitchFamily="34" charset="0"/>
-                <a:ea typeface="Calibri" pitchFamily="34" charset="-122"/>
-                <a:cs typeface="Calibri" pitchFamily="34" charset="-120"/>
-              </a:rPr>
-              <a:t>información a Auditoría Interna (NRP-24) y Auditoría Externa</a:t>
-            </a:r>
-            <a:endParaRPr lang="en-US" sz="1100" dirty="0"/>
-          </a:p>
-        </p:txBody>
-      </p:sp>
-      <p:sp>
-        <p:nvSpPr>
-          <p:cNvPr id="37" name="Shape 34"/>
-          <p:cNvSpPr/>
-          <p:nvPr/>
-        </p:nvSpPr>
-        <p:spPr>
-          <a:xfrm>
-            <a:off x="6167628" y="1920240"/>
-            <a:ext cx="5564124" cy="2203704"/>
+            <a:off x="6167628" y="1371600"/>
+            <a:ext cx="5564124" cy="2432304"/>
           </a:xfrm>
           <a:prstGeom prst="roundRect">
             <a:avLst>
-              <a:gd name="adj" fmla="val 4979"/>
+              <a:gd name="adj" fmla="val 4511"/>
             </a:avLst>
           </a:prstGeom>
           <a:solidFill>
@@ -2299,18 +1734,18 @@
       </p:sp>
       <p:sp>
         <p:nvSpPr>
-          <p:cNvPr id="38" name="Shape 35"/>
-          <p:cNvSpPr/>
-          <p:nvPr/>
-        </p:nvSpPr>
-        <p:spPr>
-          <a:xfrm>
-            <a:off x="6167628" y="1920240"/>
-            <a:ext cx="5564124" cy="749808"/>
+          <p:cNvPr id="26" name="Shape 23"/>
+          <p:cNvSpPr/>
+          <p:nvPr/>
+        </p:nvSpPr>
+        <p:spPr>
+          <a:xfrm>
+            <a:off x="6167628" y="1371600"/>
+            <a:ext cx="5564124" cy="676656"/>
           </a:xfrm>
           <a:prstGeom prst="roundRect">
             <a:avLst>
-              <a:gd name="adj" fmla="val 14634"/>
+              <a:gd name="adj" fmla="val 16216"/>
             </a:avLst>
           </a:prstGeom>
           <a:solidFill>
@@ -2326,13 +1761,13 @@
       </p:sp>
       <p:sp>
         <p:nvSpPr>
-          <p:cNvPr id="39" name="Shape 36"/>
-          <p:cNvSpPr/>
-          <p:nvPr/>
-        </p:nvSpPr>
-        <p:spPr>
-          <a:xfrm>
-            <a:off x="6167628" y="2560320"/>
+          <p:cNvPr id="27" name="Shape 24"/>
+          <p:cNvSpPr/>
+          <p:nvPr/>
+        </p:nvSpPr>
+        <p:spPr>
+          <a:xfrm>
+            <a:off x="6167628" y="1938528"/>
             <a:ext cx="5564124" cy="182880"/>
           </a:xfrm>
           <a:prstGeom prst="rect">
@@ -2351,14 +1786,14 @@
       </p:sp>
       <p:sp>
         <p:nvSpPr>
-          <p:cNvPr id="40" name="Shape 37"/>
-          <p:cNvSpPr/>
-          <p:nvPr/>
-        </p:nvSpPr>
-        <p:spPr>
-          <a:xfrm>
-            <a:off x="6350508" y="2020824"/>
-            <a:ext cx="438912" cy="438912"/>
+          <p:cNvPr id="28" name="Shape 25"/>
+          <p:cNvSpPr/>
+          <p:nvPr/>
+        </p:nvSpPr>
+        <p:spPr>
+          <a:xfrm>
+            <a:off x="6350508" y="1463040"/>
+            <a:ext cx="384048" cy="384048"/>
           </a:xfrm>
           <a:prstGeom prst="ellipse">
             <a:avLst/>
@@ -2376,7 +1811,7 @@
       </p:sp>
       <p:pic>
         <p:nvPicPr>
-          <p:cNvPr id="41" name="Image 1" descr="preencoded.png">    </p:cNvPr>
+          <p:cNvPr id="29" name="Image 1" descr="preencoded.png">    </p:cNvPr>
           <p:cNvPicPr>
             <a:picLocks noChangeAspect="1"/>
           </p:cNvPicPr>
@@ -2390,8 +1825,8 @@
         </p:blipFill>
         <p:spPr>
           <a:xfrm>
-            <a:off x="6455664" y="2125980"/>
-            <a:ext cx="228600" cy="228600"/>
+            <a:off x="6441948" y="1554480"/>
+            <a:ext cx="201168" cy="201168"/>
           </a:xfrm>
           <a:prstGeom prst="rect">
             <a:avLst/>
@@ -2400,14 +1835,14 @@
       </p:pic>
       <p:sp>
         <p:nvSpPr>
-          <p:cNvPr id="42" name="Text 38"/>
+          <p:cNvPr id="30" name="Text 26"/>
           <p:cNvSpPr txBox="1"/>
           <p:nvPr/>
         </p:nvSpPr>
         <p:spPr>
           <a:xfrm>
-            <a:off x="6935724" y="1993392"/>
-            <a:ext cx="4649724" cy="292608"/>
+            <a:off x="6880860" y="1463040"/>
+            <a:ext cx="4695444" cy="384048"/>
           </a:xfrm>
           <a:prstGeom prst="rect">
             <a:avLst/>
@@ -2423,7 +1858,7 @@
               <a:buNone/>
             </a:pPr>
             <a:r>
-              <a:rPr lang="en-US" sz="1500" b="1" dirty="0">
+              <a:rPr lang="en-US" sz="1600" b="1" dirty="0">
                 <a:solidFill>
                   <a:srgbClr val="FFFFFF"/>
                 </a:solidFill>
@@ -2431,22 +1866,47 @@
                 <a:ea typeface="Calibri" pitchFamily="34" charset="-122"/>
                 <a:cs typeface="Calibri" pitchFamily="34" charset="-120"/>
               </a:rPr>
-              <a:t>Riesgo Normativo y Requerimientos SSF</a:t>
-            </a:r>
-            <a:endParaRPr lang="en-US" sz="1500" dirty="0"/>
-          </a:p>
-        </p:txBody>
-      </p:sp>
-      <p:sp>
-        <p:nvSpPr>
-          <p:cNvPr id="43" name="Text 39"/>
+              <a:t>Riesgo Normativo</a:t>
+            </a:r>
+            <a:endParaRPr lang="en-US" sz="1600" dirty="0"/>
+          </a:p>
+        </p:txBody>
+      </p:sp>
+      <p:sp>
+        <p:nvSpPr>
+          <p:cNvPr id="31" name="Shape 27"/>
+          <p:cNvSpPr/>
+          <p:nvPr/>
+        </p:nvSpPr>
+        <p:spPr>
+          <a:xfrm>
+            <a:off x="6423660" y="2235708"/>
+            <a:ext cx="73152" cy="73152"/>
+          </a:xfrm>
+          <a:prstGeom prst="rect">
+            <a:avLst/>
+          </a:prstGeom>
+          <a:solidFill>
+            <a:srgbClr val="13507F"/>
+          </a:solidFill>
+          <a:ln w="12700">
+            <a:solidFill>
+              <a:srgbClr val="13507F"/>
+            </a:solidFill>
+            <a:prstDash val="solid"/>
+          </a:ln>
+        </p:spPr>
+      </p:sp>
+      <p:sp>
+        <p:nvSpPr>
+          <p:cNvPr id="32" name="Text 28"/>
           <p:cNvSpPr txBox="1"/>
           <p:nvPr/>
         </p:nvSpPr>
         <p:spPr>
           <a:xfrm>
-            <a:off x="6935724" y="2267712"/>
-            <a:ext cx="4649724" cy="219456"/>
+            <a:off x="6606540" y="2139696"/>
+            <a:ext cx="4924044" cy="265176"/>
           </a:xfrm>
           <a:prstGeom prst="rect">
             <a:avLst/>
@@ -2462,30 +1922,30 @@
               <a:buNone/>
             </a:pPr>
             <a:r>
-              <a:rPr lang="en-US" sz="1050" i="1" dirty="0">
-                <a:solidFill>
-                  <a:srgbClr val="DCE8F3"/>
-                </a:solidFill>
-                <a:latin typeface="Calibri" pitchFamily="34" charset="0"/>
-                <a:ea typeface="Calibri" pitchFamily="34" charset="-122"/>
-                <a:cs typeface="Calibri" pitchFamily="34" charset="-120"/>
-              </a:rPr>
-              <a:t>Requerimientos coordinados con las áreas y pruebas de descargo</a:t>
-            </a:r>
-            <a:endParaRPr lang="en-US" sz="1050" dirty="0"/>
-          </a:p>
-        </p:txBody>
-      </p:sp>
-      <p:sp>
-        <p:nvSpPr>
-          <p:cNvPr id="44" name="Shape 40"/>
-          <p:cNvSpPr/>
-          <p:nvPr/>
-        </p:nvSpPr>
-        <p:spPr>
-          <a:xfrm>
-            <a:off x="6387084" y="2775204"/>
-            <a:ext cx="64008" cy="64008"/>
+              <a:rPr lang="en-US" sz="1300" dirty="0">
+                <a:solidFill>
+                  <a:srgbClr val="1B2733"/>
+                </a:solidFill>
+                <a:latin typeface="Calibri" pitchFamily="34" charset="0"/>
+                <a:ea typeface="Calibri" pitchFamily="34" charset="-122"/>
+                <a:cs typeface="Calibri" pitchFamily="34" charset="-120"/>
+              </a:rPr>
+              <a:t>Gobierno Corporativo (nota 22741): matriz y requerimiento a áreas</a:t>
+            </a:r>
+            <a:endParaRPr lang="en-US" sz="1300" dirty="0"/>
+          </a:p>
+        </p:txBody>
+      </p:sp>
+      <p:sp>
+        <p:nvSpPr>
+          <p:cNvPr id="33" name="Shape 29"/>
+          <p:cNvSpPr/>
+          <p:nvPr/>
+        </p:nvSpPr>
+        <p:spPr>
+          <a:xfrm>
+            <a:off x="6423660" y="2546604"/>
+            <a:ext cx="73152" cy="73152"/>
           </a:xfrm>
           <a:prstGeom prst="rect">
             <a:avLst/>
@@ -2503,14 +1963,14 @@
       </p:sp>
       <p:sp>
         <p:nvSpPr>
-          <p:cNvPr id="45" name="Text 41"/>
+          <p:cNvPr id="34" name="Text 30"/>
           <p:cNvSpPr txBox="1"/>
           <p:nvPr/>
         </p:nvSpPr>
         <p:spPr>
           <a:xfrm>
-            <a:off x="6542532" y="2706624"/>
-            <a:ext cx="5006340" cy="201168"/>
+            <a:off x="6606540" y="2450592"/>
+            <a:ext cx="4924044" cy="265176"/>
           </a:xfrm>
           <a:prstGeom prst="rect">
             <a:avLst/>
@@ -2526,21 +1986,7 @@
               <a:buNone/>
             </a:pPr>
             <a:r>
-              <a:rPr lang="en-US" sz="1100" b="1" dirty="0">
-                <a:solidFill>
-                  <a:srgbClr val="0B2545"/>
-                </a:solidFill>
-                <a:latin typeface="Calibri" pitchFamily="34" charset="0"/>
-                <a:ea typeface="Calibri" pitchFamily="34" charset="-122"/>
-                <a:cs typeface="Calibri" pitchFamily="34" charset="-120"/>
-              </a:rPr>
-              <a:t>Gob. Corporativo · 22741: </a:t>
-            </a:r>
-            <a:pPr indent="0" marL="0">
-              <a:buNone/>
-            </a:pPr>
-            <a:r>
-              <a:rPr lang="en-US" sz="1100" dirty="0">
+              <a:rPr lang="en-US" sz="1300" dirty="0">
                 <a:solidFill>
                   <a:srgbClr val="1B2733"/>
                 </a:solidFill>
@@ -2548,22 +1994,22 @@
                 <a:ea typeface="Calibri" pitchFamily="34" charset="-122"/>
                 <a:cs typeface="Calibri" pitchFamily="34" charset="-120"/>
               </a:rPr>
-              <a:t>requerimiento a áreas y descargos (visita 18432)</a:t>
-            </a:r>
-            <a:endParaRPr lang="en-US" sz="1100" dirty="0"/>
-          </a:p>
-        </p:txBody>
-      </p:sp>
-      <p:sp>
-        <p:nvSpPr>
-          <p:cNvPr id="46" name="Shape 42"/>
-          <p:cNvSpPr/>
-          <p:nvPr/>
-        </p:nvSpPr>
-        <p:spPr>
-          <a:xfrm>
-            <a:off x="6387084" y="2999232"/>
-            <a:ext cx="64008" cy="64008"/>
+              <a:t>Seguimiento de pruebas de descargo – notas 22741 y 23486</a:t>
+            </a:r>
+            <a:endParaRPr lang="en-US" sz="1300" dirty="0"/>
+          </a:p>
+        </p:txBody>
+      </p:sp>
+      <p:sp>
+        <p:nvSpPr>
+          <p:cNvPr id="35" name="Shape 31"/>
+          <p:cNvSpPr/>
+          <p:nvPr/>
+        </p:nvSpPr>
+        <p:spPr>
+          <a:xfrm>
+            <a:off x="6423660" y="2857500"/>
+            <a:ext cx="73152" cy="73152"/>
           </a:xfrm>
           <a:prstGeom prst="rect">
             <a:avLst/>
@@ -2581,14 +2027,14 @@
       </p:sp>
       <p:sp>
         <p:nvSpPr>
-          <p:cNvPr id="47" name="Text 43"/>
+          <p:cNvPr id="36" name="Text 32"/>
           <p:cNvSpPr txBox="1"/>
           <p:nvPr/>
         </p:nvSpPr>
         <p:spPr>
           <a:xfrm>
-            <a:off x="6542532" y="2930652"/>
-            <a:ext cx="5006340" cy="201168"/>
+            <a:off x="6606540" y="2761488"/>
+            <a:ext cx="4924044" cy="265176"/>
           </a:xfrm>
           <a:prstGeom prst="rect">
             <a:avLst/>
@@ -2604,21 +2050,7 @@
               <a:buNone/>
             </a:pPr>
             <a:r>
-              <a:rPr lang="en-US" sz="1100" b="1" dirty="0">
-                <a:solidFill>
-                  <a:srgbClr val="0B2545"/>
-                </a:solidFill>
-                <a:latin typeface="Calibri" pitchFamily="34" charset="0"/>
-                <a:ea typeface="Calibri" pitchFamily="34" charset="-122"/>
-                <a:cs typeface="Calibri" pitchFamily="34" charset="-120"/>
-              </a:rPr>
-              <a:t>PLD/FT · 23486: </a:t>
-            </a:r>
-            <a:pPr indent="0" marL="0">
-              <a:buNone/>
-            </a:pPr>
-            <a:r>
-              <a:rPr lang="en-US" sz="1100" dirty="0">
+              <a:rPr lang="en-US" sz="1300" dirty="0">
                 <a:solidFill>
                   <a:srgbClr val="1B2733"/>
                 </a:solidFill>
@@ -2626,22 +2058,22 @@
                 <a:ea typeface="Calibri" pitchFamily="34" charset="-122"/>
                 <a:cs typeface="Calibri" pitchFamily="34" charset="-120"/>
               </a:rPr>
-              <a:t>seguimiento al envío de pruebas de descargo</a:t>
-            </a:r>
-            <a:endParaRPr lang="en-US" sz="1100" dirty="0"/>
-          </a:p>
-        </p:txBody>
-      </p:sp>
-      <p:sp>
-        <p:nvSpPr>
-          <p:cNvPr id="48" name="Shape 44"/>
-          <p:cNvSpPr/>
-          <p:nvPr/>
-        </p:nvSpPr>
-        <p:spPr>
-          <a:xfrm>
-            <a:off x="6387084" y="3223260"/>
-            <a:ext cx="64008" cy="64008"/>
+              <a:t>Presentación de resultados preliminares de Riesgo Específico</a:t>
+            </a:r>
+            <a:endParaRPr lang="en-US" sz="1300" dirty="0"/>
+          </a:p>
+        </p:txBody>
+      </p:sp>
+      <p:sp>
+        <p:nvSpPr>
+          <p:cNvPr id="37" name="Shape 33"/>
+          <p:cNvSpPr/>
+          <p:nvPr/>
+        </p:nvSpPr>
+        <p:spPr>
+          <a:xfrm>
+            <a:off x="6423660" y="3168396"/>
+            <a:ext cx="73152" cy="73152"/>
           </a:xfrm>
           <a:prstGeom prst="rect">
             <a:avLst/>
@@ -2659,14 +2091,14 @@
       </p:sp>
       <p:sp>
         <p:nvSpPr>
-          <p:cNvPr id="49" name="Text 45"/>
+          <p:cNvPr id="38" name="Text 34"/>
           <p:cNvSpPr txBox="1"/>
           <p:nvPr/>
         </p:nvSpPr>
         <p:spPr>
           <a:xfrm>
-            <a:off x="6542532" y="3154680"/>
-            <a:ext cx="5006340" cy="201168"/>
+            <a:off x="6606540" y="3072384"/>
+            <a:ext cx="4924044" cy="265176"/>
           </a:xfrm>
           <a:prstGeom prst="rect">
             <a:avLst/>
@@ -2682,21 +2114,7 @@
               <a:buNone/>
             </a:pPr>
             <a:r>
-              <a:rPr lang="en-US" sz="1100" b="1" dirty="0">
-                <a:solidFill>
-                  <a:srgbClr val="0B2545"/>
-                </a:solidFill>
-                <a:latin typeface="Calibri" pitchFamily="34" charset="0"/>
-                <a:ea typeface="Calibri" pitchFamily="34" charset="-122"/>
-                <a:cs typeface="Calibri" pitchFamily="34" charset="-120"/>
-              </a:rPr>
-              <a:t>Riesgo Específico · 22742: </a:t>
-            </a:r>
-            <a:pPr indent="0" marL="0">
-              <a:buNone/>
-            </a:pPr>
-            <a:r>
-              <a:rPr lang="en-US" sz="1100" dirty="0">
+              <a:rPr lang="en-US" sz="1300" dirty="0">
                 <a:solidFill>
                   <a:srgbClr val="1B2733"/>
                 </a:solidFill>
@@ -2704,22 +2122,22 @@
                 <a:ea typeface="Calibri" pitchFamily="34" charset="-122"/>
                 <a:cs typeface="Calibri" pitchFamily="34" charset="-120"/>
               </a:rPr>
-              <a:t>presentación de resultados preliminares</a:t>
-            </a:r>
-            <a:endParaRPr lang="en-US" sz="1100" dirty="0"/>
-          </a:p>
-        </p:txBody>
-      </p:sp>
-      <p:sp>
-        <p:nvSpPr>
-          <p:cNvPr id="50" name="Shape 46"/>
-          <p:cNvSpPr/>
-          <p:nvPr/>
-        </p:nvSpPr>
-        <p:spPr>
-          <a:xfrm>
-            <a:off x="6387084" y="3447288"/>
-            <a:ext cx="64008" cy="64008"/>
+              <a:t>Control de avalúos: asignación a perito y aviso a asociados</a:t>
+            </a:r>
+            <a:endParaRPr lang="en-US" sz="1300" dirty="0"/>
+          </a:p>
+        </p:txBody>
+      </p:sp>
+      <p:sp>
+        <p:nvSpPr>
+          <p:cNvPr id="39" name="Shape 35"/>
+          <p:cNvSpPr/>
+          <p:nvPr/>
+        </p:nvSpPr>
+        <p:spPr>
+          <a:xfrm>
+            <a:off x="6423660" y="3479292"/>
+            <a:ext cx="73152" cy="73152"/>
           </a:xfrm>
           <a:prstGeom prst="rect">
             <a:avLst/>
@@ -2737,14 +2155,14 @@
       </p:sp>
       <p:sp>
         <p:nvSpPr>
-          <p:cNvPr id="51" name="Text 47"/>
+          <p:cNvPr id="40" name="Text 36"/>
           <p:cNvSpPr txBox="1"/>
           <p:nvPr/>
         </p:nvSpPr>
         <p:spPr>
           <a:xfrm>
-            <a:off x="6542532" y="3378708"/>
-            <a:ext cx="5006340" cy="201168"/>
+            <a:off x="6606540" y="3383280"/>
+            <a:ext cx="4924044" cy="265176"/>
           </a:xfrm>
           <a:prstGeom prst="rect">
             <a:avLst/>
@@ -2760,21 +2178,7 @@
               <a:buNone/>
             </a:pPr>
             <a:r>
-              <a:rPr lang="en-US" sz="1100" b="1" dirty="0">
-                <a:solidFill>
-                  <a:srgbClr val="0B2545"/>
-                </a:solidFill>
-                <a:latin typeface="Calibri" pitchFamily="34" charset="0"/>
-                <a:ea typeface="Calibri" pitchFamily="34" charset="-122"/>
-                <a:cs typeface="Calibri" pitchFamily="34" charset="-120"/>
-              </a:rPr>
-              <a:t>Plan de Recuperación · 22737: </a:t>
-            </a:r>
-            <a:pPr indent="0" marL="0">
-              <a:buNone/>
-            </a:pPr>
-            <a:r>
-              <a:rPr lang="en-US" sz="1100" dirty="0">
+              <a:rPr lang="en-US" sz="1300" dirty="0">
                 <a:solidFill>
                   <a:srgbClr val="1B2733"/>
                 </a:solidFill>
@@ -2782,182 +2186,26 @@
                 <a:ea typeface="Calibri" pitchFamily="34" charset="-122"/>
                 <a:cs typeface="Calibri" pitchFamily="34" charset="-120"/>
               </a:rPr>
-              <a:t>indicadores de Gob. Corporativo y Reputacional</a:t>
-            </a:r>
-            <a:endParaRPr lang="en-US" sz="1100" dirty="0"/>
-          </a:p>
-        </p:txBody>
-      </p:sp>
-      <p:sp>
-        <p:nvSpPr>
-          <p:cNvPr id="52" name="Shape 48"/>
-          <p:cNvSpPr/>
-          <p:nvPr/>
-        </p:nvSpPr>
-        <p:spPr>
-          <a:xfrm>
-            <a:off x="6387084" y="3671316"/>
-            <a:ext cx="64008" cy="64008"/>
-          </a:xfrm>
-          <a:prstGeom prst="rect">
-            <a:avLst/>
-          </a:prstGeom>
-          <a:solidFill>
-            <a:srgbClr val="13507F"/>
-          </a:solidFill>
-          <a:ln w="12700">
-            <a:solidFill>
-              <a:srgbClr val="13507F"/>
-            </a:solidFill>
-            <a:prstDash val="solid"/>
-          </a:ln>
-        </p:spPr>
-      </p:sp>
-      <p:sp>
-        <p:nvSpPr>
-          <p:cNvPr id="53" name="Text 49"/>
-          <p:cNvSpPr txBox="1"/>
-          <p:nvPr/>
-        </p:nvSpPr>
-        <p:spPr>
-          <a:xfrm>
-            <a:off x="6542532" y="3602736"/>
-            <a:ext cx="5006340" cy="201168"/>
-          </a:xfrm>
-          <a:prstGeom prst="rect">
-            <a:avLst/>
-          </a:prstGeom>
-          <a:noFill/>
-          <a:ln/>
-        </p:spPr>
-        <p:txBody>
-          <a:bodyPr wrap="square" lIns="0" tIns="0" rIns="0" bIns="0" rtlCol="0" anchor="ctr"/>
-          <a:lstStyle/>
-          <a:p>
-            <a:pPr indent="0" marL="0">
-              <a:buNone/>
-            </a:pPr>
-            <a:r>
-              <a:rPr lang="en-US" sz="1100" b="1" dirty="0">
-                <a:solidFill>
-                  <a:srgbClr val="0B2545"/>
-                </a:solidFill>
-                <a:latin typeface="Calibri" pitchFamily="34" charset="0"/>
-                <a:ea typeface="Calibri" pitchFamily="34" charset="-122"/>
-                <a:cs typeface="Calibri" pitchFamily="34" charset="-120"/>
-              </a:rPr>
-              <a:t>Avalúos: </a:t>
-            </a:r>
-            <a:pPr indent="0" marL="0">
-              <a:buNone/>
-            </a:pPr>
-            <a:r>
-              <a:rPr lang="en-US" sz="1100" dirty="0">
-                <a:solidFill>
-                  <a:srgbClr val="1B2733"/>
-                </a:solidFill>
-                <a:latin typeface="Calibri" pitchFamily="34" charset="0"/>
-                <a:ea typeface="Calibri" pitchFamily="34" charset="-122"/>
-                <a:cs typeface="Calibri" pitchFamily="34" charset="-120"/>
-              </a:rPr>
-              <a:t>política, procedimientos, perfil de revisor, peritos y avisos</a:t>
-            </a:r>
-            <a:endParaRPr lang="en-US" sz="1100" dirty="0"/>
-          </a:p>
-        </p:txBody>
-      </p:sp>
-      <p:sp>
-        <p:nvSpPr>
-          <p:cNvPr id="54" name="Shape 50"/>
-          <p:cNvSpPr/>
-          <p:nvPr/>
-        </p:nvSpPr>
-        <p:spPr>
-          <a:xfrm>
-            <a:off x="6387084" y="3895344"/>
-            <a:ext cx="64008" cy="64008"/>
-          </a:xfrm>
-          <a:prstGeom prst="rect">
-            <a:avLst/>
-          </a:prstGeom>
-          <a:solidFill>
-            <a:srgbClr val="13507F"/>
-          </a:solidFill>
-          <a:ln w="12700">
-            <a:solidFill>
-              <a:srgbClr val="13507F"/>
-            </a:solidFill>
-            <a:prstDash val="solid"/>
-          </a:ln>
-        </p:spPr>
-      </p:sp>
-      <p:sp>
-        <p:nvSpPr>
-          <p:cNvPr id="55" name="Text 51"/>
-          <p:cNvSpPr txBox="1"/>
-          <p:nvPr/>
-        </p:nvSpPr>
-        <p:spPr>
-          <a:xfrm>
-            <a:off x="6542532" y="3826764"/>
-            <a:ext cx="5006340" cy="201168"/>
-          </a:xfrm>
-          <a:prstGeom prst="rect">
-            <a:avLst/>
-          </a:prstGeom>
-          <a:noFill/>
-          <a:ln/>
-        </p:spPr>
-        <p:txBody>
-          <a:bodyPr wrap="square" lIns="0" tIns="0" rIns="0" bIns="0" rtlCol="0" anchor="ctr"/>
-          <a:lstStyle/>
-          <a:p>
-            <a:pPr indent="0" marL="0">
-              <a:buNone/>
-            </a:pPr>
-            <a:r>
-              <a:rPr lang="en-US" sz="1100" b="1" dirty="0">
-                <a:solidFill>
-                  <a:srgbClr val="0B2545"/>
-                </a:solidFill>
-                <a:latin typeface="Calibri" pitchFamily="34" charset="0"/>
-                <a:ea typeface="Calibri" pitchFamily="34" charset="-122"/>
-                <a:cs typeface="Calibri" pitchFamily="34" charset="-120"/>
-              </a:rPr>
-              <a:t>Comité y envíos: </a:t>
-            </a:r>
-            <a:pPr indent="0" marL="0">
-              <a:buNone/>
-            </a:pPr>
-            <a:r>
-              <a:rPr lang="en-US" sz="1100" dirty="0">
-                <a:solidFill>
-                  <a:srgbClr val="1B2733"/>
-                </a:solidFill>
-                <a:latin typeface="Calibri" pitchFamily="34" charset="0"/>
-                <a:ea typeface="Calibri" pitchFamily="34" charset="-122"/>
-                <a:cs typeface="Calibri" pitchFamily="34" charset="-120"/>
-              </a:rPr>
-              <a:t>Acuerdos Semestrales (J. Vigilancia), acta 29/08/2026, DAR</a:t>
-            </a:r>
-            <a:endParaRPr lang="en-US" sz="1100" dirty="0"/>
-          </a:p>
-        </p:txBody>
-      </p:sp>
-      <p:sp>
-        <p:nvSpPr>
-          <p:cNvPr id="56" name="Shape 52"/>
-          <p:cNvSpPr/>
-          <p:nvPr/>
-        </p:nvSpPr>
-        <p:spPr>
-          <a:xfrm>
-            <a:off x="457200" y="4270248"/>
-            <a:ext cx="5564124" cy="2203704"/>
+              <a:t>Acuerdos Semestrales del Comité de Riesgos y acta del 29/08</a:t>
+            </a:r>
+            <a:endParaRPr lang="en-US" sz="1300" dirty="0"/>
+          </a:p>
+        </p:txBody>
+      </p:sp>
+      <p:sp>
+        <p:nvSpPr>
+          <p:cNvPr id="41" name="Shape 37"/>
+          <p:cNvSpPr/>
+          <p:nvPr/>
+        </p:nvSpPr>
+        <p:spPr>
+          <a:xfrm>
+            <a:off x="457200" y="3968496"/>
+            <a:ext cx="5564124" cy="2432304"/>
           </a:xfrm>
           <a:prstGeom prst="roundRect">
             <a:avLst>
-              <a:gd name="adj" fmla="val 4979"/>
+              <a:gd name="adj" fmla="val 4511"/>
             </a:avLst>
           </a:prstGeom>
           <a:solidFill>
@@ -2973,18 +2221,18 @@
       </p:sp>
       <p:sp>
         <p:nvSpPr>
-          <p:cNvPr id="57" name="Shape 53"/>
-          <p:cNvSpPr/>
-          <p:nvPr/>
-        </p:nvSpPr>
-        <p:spPr>
-          <a:xfrm>
-            <a:off x="457200" y="4270248"/>
-            <a:ext cx="5564124" cy="749808"/>
+          <p:cNvPr id="42" name="Shape 38"/>
+          <p:cNvSpPr/>
+          <p:nvPr/>
+        </p:nvSpPr>
+        <p:spPr>
+          <a:xfrm>
+            <a:off x="457200" y="3968496"/>
+            <a:ext cx="5564124" cy="676656"/>
           </a:xfrm>
           <a:prstGeom prst="roundRect">
             <a:avLst>
-              <a:gd name="adj" fmla="val 14634"/>
+              <a:gd name="adj" fmla="val 16216"/>
             </a:avLst>
           </a:prstGeom>
           <a:solidFill>
@@ -3000,13 +2248,13 @@
       </p:sp>
       <p:sp>
         <p:nvSpPr>
-          <p:cNvPr id="58" name="Shape 54"/>
-          <p:cNvSpPr/>
-          <p:nvPr/>
-        </p:nvSpPr>
-        <p:spPr>
-          <a:xfrm>
-            <a:off x="457200" y="4910328"/>
+          <p:cNvPr id="43" name="Shape 39"/>
+          <p:cNvSpPr/>
+          <p:nvPr/>
+        </p:nvSpPr>
+        <p:spPr>
+          <a:xfrm>
+            <a:off x="457200" y="4535424"/>
             <a:ext cx="5564124" cy="182880"/>
           </a:xfrm>
           <a:prstGeom prst="rect">
@@ -3025,14 +2273,14 @@
       </p:sp>
       <p:sp>
         <p:nvSpPr>
-          <p:cNvPr id="59" name="Shape 55"/>
-          <p:cNvSpPr/>
-          <p:nvPr/>
-        </p:nvSpPr>
-        <p:spPr>
-          <a:xfrm>
-            <a:off x="640080" y="4370832"/>
-            <a:ext cx="438912" cy="438912"/>
+          <p:cNvPr id="44" name="Shape 40"/>
+          <p:cNvSpPr/>
+          <p:nvPr/>
+        </p:nvSpPr>
+        <p:spPr>
+          <a:xfrm>
+            <a:off x="640080" y="4059936"/>
+            <a:ext cx="384048" cy="384048"/>
           </a:xfrm>
           <a:prstGeom prst="ellipse">
             <a:avLst/>
@@ -3050,7 +2298,7 @@
       </p:sp>
       <p:pic>
         <p:nvPicPr>
-          <p:cNvPr id="60" name="Image 2" descr="preencoded.png">    </p:cNvPr>
+          <p:cNvPr id="45" name="Image 2" descr="preencoded.png">    </p:cNvPr>
           <p:cNvPicPr>
             <a:picLocks noChangeAspect="1"/>
           </p:cNvPicPr>
@@ -3064,8 +2312,8 @@
         </p:blipFill>
         <p:spPr>
           <a:xfrm>
-            <a:off x="745236" y="4475988"/>
-            <a:ext cx="228600" cy="228600"/>
+            <a:off x="731520" y="4151376"/>
+            <a:ext cx="201168" cy="201168"/>
           </a:xfrm>
           <a:prstGeom prst="rect">
             <a:avLst/>
@@ -3074,14 +2322,14 @@
       </p:pic>
       <p:sp>
         <p:nvSpPr>
-          <p:cNvPr id="61" name="Text 56"/>
+          <p:cNvPr id="46" name="Text 41"/>
           <p:cNvSpPr txBox="1"/>
           <p:nvPr/>
         </p:nvSpPr>
         <p:spPr>
           <a:xfrm>
-            <a:off x="1225296" y="4343400"/>
-            <a:ext cx="4649724" cy="292608"/>
+            <a:off x="1170432" y="4059936"/>
+            <a:ext cx="4695444" cy="384048"/>
           </a:xfrm>
           <a:prstGeom prst="rect">
             <a:avLst/>
@@ -3097,7 +2345,7 @@
               <a:buNone/>
             </a:pPr>
             <a:r>
-              <a:rPr lang="en-US" sz="1500" b="1" dirty="0">
+              <a:rPr lang="en-US" sz="1600" b="1" dirty="0">
                 <a:solidFill>
                   <a:srgbClr val="FFFFFF"/>
                 </a:solidFill>
@@ -3107,20 +2355,45 @@
               </a:rPr>
               <a:t>Riesgo Financiero y Crediticio</a:t>
             </a:r>
-            <a:endParaRPr lang="en-US" sz="1500" dirty="0"/>
-          </a:p>
-        </p:txBody>
-      </p:sp>
-      <p:sp>
-        <p:nvSpPr>
-          <p:cNvPr id="62" name="Text 57"/>
+            <a:endParaRPr lang="en-US" sz="1600" dirty="0"/>
+          </a:p>
+        </p:txBody>
+      </p:sp>
+      <p:sp>
+        <p:nvSpPr>
+          <p:cNvPr id="47" name="Shape 42"/>
+          <p:cNvSpPr/>
+          <p:nvPr/>
+        </p:nvSpPr>
+        <p:spPr>
+          <a:xfrm>
+            <a:off x="713232" y="4832604"/>
+            <a:ext cx="73152" cy="73152"/>
+          </a:xfrm>
+          <a:prstGeom prst="rect">
+            <a:avLst/>
+          </a:prstGeom>
+          <a:solidFill>
+            <a:srgbClr val="0A7480"/>
+          </a:solidFill>
+          <a:ln w="12700">
+            <a:solidFill>
+              <a:srgbClr val="0A7480"/>
+            </a:solidFill>
+            <a:prstDash val="solid"/>
+          </a:ln>
+        </p:spPr>
+      </p:sp>
+      <p:sp>
+        <p:nvSpPr>
+          <p:cNvPr id="48" name="Text 43"/>
           <p:cNvSpPr txBox="1"/>
           <p:nvPr/>
         </p:nvSpPr>
         <p:spPr>
           <a:xfrm>
-            <a:off x="1225296" y="4617720"/>
-            <a:ext cx="4649724" cy="219456"/>
+            <a:off x="896112" y="4736592"/>
+            <a:ext cx="4924044" cy="265176"/>
           </a:xfrm>
           <a:prstGeom prst="rect">
             <a:avLst/>
@@ -3136,30 +2409,30 @@
               <a:buNone/>
             </a:pPr>
             <a:r>
-              <a:rPr lang="en-US" sz="1050" i="1" dirty="0">
-                <a:solidFill>
-                  <a:srgbClr val="DCE8F3"/>
-                </a:solidFill>
-                <a:latin typeface="Calibri" pitchFamily="34" charset="0"/>
-                <a:ea typeface="Calibri" pitchFamily="34" charset="-122"/>
-                <a:cs typeface="Calibri" pitchFamily="34" charset="-120"/>
-              </a:rPr>
-              <a:t>Medición, reportes regulatorios y control de cartera y reservas</a:t>
-            </a:r>
-            <a:endParaRPr lang="en-US" sz="1050" dirty="0"/>
-          </a:p>
-        </p:txBody>
-      </p:sp>
-      <p:sp>
-        <p:nvSpPr>
-          <p:cNvPr id="63" name="Shape 58"/>
-          <p:cNvSpPr/>
-          <p:nvPr/>
-        </p:nvSpPr>
-        <p:spPr>
-          <a:xfrm>
-            <a:off x="676656" y="5125212"/>
-            <a:ext cx="64008" cy="64008"/>
+              <a:rPr lang="en-US" sz="1300" dirty="0">
+                <a:solidFill>
+                  <a:srgbClr val="1B2733"/>
+                </a:solidFill>
+                <a:latin typeface="Calibri" pitchFamily="34" charset="0"/>
+                <a:ea typeface="Calibri" pitchFamily="34" charset="-122"/>
+                <a:cs typeface="Calibri" pitchFamily="34" charset="-120"/>
+              </a:rPr>
+              <a:t>Informes al Comité: riesgo de crédito, liquidez y mercado</a:t>
+            </a:r>
+            <a:endParaRPr lang="en-US" sz="1300" dirty="0"/>
+          </a:p>
+        </p:txBody>
+      </p:sp>
+      <p:sp>
+        <p:nvSpPr>
+          <p:cNvPr id="49" name="Shape 44"/>
+          <p:cNvSpPr/>
+          <p:nvPr/>
+        </p:nvSpPr>
+        <p:spPr>
+          <a:xfrm>
+            <a:off x="713232" y="5143500"/>
+            <a:ext cx="73152" cy="73152"/>
           </a:xfrm>
           <a:prstGeom prst="rect">
             <a:avLst/>
@@ -3177,14 +2450,14 @@
       </p:sp>
       <p:sp>
         <p:nvSpPr>
-          <p:cNvPr id="64" name="Text 59"/>
+          <p:cNvPr id="50" name="Text 45"/>
           <p:cNvSpPr txBox="1"/>
           <p:nvPr/>
         </p:nvSpPr>
         <p:spPr>
           <a:xfrm>
-            <a:off x="832104" y="5056632"/>
-            <a:ext cx="5006340" cy="201168"/>
+            <a:off x="896112" y="5047488"/>
+            <a:ext cx="4924044" cy="265176"/>
           </a:xfrm>
           <a:prstGeom prst="rect">
             <a:avLst/>
@@ -3200,21 +2473,7 @@
               <a:buNone/>
             </a:pPr>
             <a:r>
-              <a:rPr lang="en-US" sz="1100" b="1" dirty="0">
-                <a:solidFill>
-                  <a:srgbClr val="0B2545"/>
-                </a:solidFill>
-                <a:latin typeface="Calibri" pitchFamily="34" charset="0"/>
-                <a:ea typeface="Calibri" pitchFamily="34" charset="-122"/>
-                <a:cs typeface="Calibri" pitchFamily="34" charset="-120"/>
-              </a:rPr>
-              <a:t>Crédito: </a:t>
-            </a:r>
-            <a:pPr indent="0" marL="0">
-              <a:buNone/>
-            </a:pPr>
-            <a:r>
-              <a:rPr lang="en-US" sz="1100" dirty="0">
+              <a:rPr lang="en-US" sz="1300" dirty="0">
                 <a:solidFill>
                   <a:srgbClr val="1B2733"/>
                 </a:solidFill>
@@ -3222,22 +2481,22 @@
                 <a:ea typeface="Calibri" pitchFamily="34" charset="-122"/>
                 <a:cs typeface="Calibri" pitchFamily="34" charset="-120"/>
               </a:rPr>
-              <a:t>pérdidas esperadas, matrices de transición y cosechas (Comité)</a:t>
-            </a:r>
-            <a:endParaRPr lang="en-US" sz="1100" dirty="0"/>
-          </a:p>
-        </p:txBody>
-      </p:sp>
-      <p:sp>
-        <p:nvSpPr>
-          <p:cNvPr id="65" name="Shape 60"/>
-          <p:cNvSpPr/>
-          <p:nvPr/>
-        </p:nvSpPr>
-        <p:spPr>
-          <a:xfrm>
-            <a:off x="676656" y="5349240"/>
-            <a:ext cx="64008" cy="64008"/>
+              <a:t>Envíos SSF: NRP-05, NCB-022, Central de Riesgo, CTRI-RECR</a:t>
+            </a:r>
+            <a:endParaRPr lang="en-US" sz="1300" dirty="0"/>
+          </a:p>
+        </p:txBody>
+      </p:sp>
+      <p:sp>
+        <p:nvSpPr>
+          <p:cNvPr id="51" name="Shape 46"/>
+          <p:cNvSpPr/>
+          <p:nvPr/>
+        </p:nvSpPr>
+        <p:spPr>
+          <a:xfrm>
+            <a:off x="713232" y="5454396"/>
+            <a:ext cx="73152" cy="73152"/>
           </a:xfrm>
           <a:prstGeom prst="rect">
             <a:avLst/>
@@ -3255,14 +2514,14 @@
       </p:sp>
       <p:sp>
         <p:nvSpPr>
-          <p:cNvPr id="66" name="Text 61"/>
+          <p:cNvPr id="52" name="Text 47"/>
           <p:cNvSpPr txBox="1"/>
           <p:nvPr/>
         </p:nvSpPr>
         <p:spPr>
           <a:xfrm>
-            <a:off x="832104" y="5280660"/>
-            <a:ext cx="5006340" cy="201168"/>
+            <a:off x="896112" y="5358384"/>
+            <a:ext cx="4924044" cy="265176"/>
           </a:xfrm>
           <a:prstGeom prst="rect">
             <a:avLst/>
@@ -3278,21 +2537,7 @@
               <a:buNone/>
             </a:pPr>
             <a:r>
-              <a:rPr lang="en-US" sz="1100" b="1" dirty="0">
-                <a:solidFill>
-                  <a:srgbClr val="0B2545"/>
-                </a:solidFill>
-                <a:latin typeface="Calibri" pitchFamily="34" charset="0"/>
-                <a:ea typeface="Calibri" pitchFamily="34" charset="-122"/>
-                <a:cs typeface="Calibri" pitchFamily="34" charset="-120"/>
-              </a:rPr>
-              <a:t>Liquidez y mercado: </a:t>
-            </a:r>
-            <a:pPr indent="0" marL="0">
-              <a:buNone/>
-            </a:pPr>
-            <a:r>
-              <a:rPr lang="en-US" sz="1100" dirty="0">
+              <a:rPr lang="en-US" sz="1300" dirty="0">
                 <a:solidFill>
                   <a:srgbClr val="1B2733"/>
                 </a:solidFill>
@@ -3300,22 +2545,22 @@
                 <a:ea typeface="Calibri" pitchFamily="34" charset="-122"/>
                 <a:cs typeface="Calibri" pitchFamily="34" charset="-120"/>
               </a:rPr>
-              <a:t>informe al Comité, escenarios y anexo 03 NRP-05</a:t>
-            </a:r>
-            <a:endParaRPr lang="en-US" sz="1100" dirty="0"/>
-          </a:p>
-        </p:txBody>
-      </p:sp>
-      <p:sp>
-        <p:nvSpPr>
-          <p:cNvPr id="67" name="Shape 62"/>
-          <p:cNvSpPr/>
-          <p:nvPr/>
-        </p:nvSpPr>
-        <p:spPr>
-          <a:xfrm>
-            <a:off x="676656" y="5573268"/>
-            <a:ext cx="64008" cy="64008"/>
+              <a:t>Cartera de tarjeta de crédito y reserva de saneamiento</a:t>
+            </a:r>
+            <a:endParaRPr lang="en-US" sz="1300" dirty="0"/>
+          </a:p>
+        </p:txBody>
+      </p:sp>
+      <p:sp>
+        <p:nvSpPr>
+          <p:cNvPr id="53" name="Shape 48"/>
+          <p:cNvSpPr/>
+          <p:nvPr/>
+        </p:nvSpPr>
+        <p:spPr>
+          <a:xfrm>
+            <a:off x="713232" y="5765292"/>
+            <a:ext cx="73152" cy="73152"/>
           </a:xfrm>
           <a:prstGeom prst="rect">
             <a:avLst/>
@@ -3333,14 +2578,14 @@
       </p:sp>
       <p:sp>
         <p:nvSpPr>
-          <p:cNvPr id="68" name="Text 63"/>
+          <p:cNvPr id="54" name="Text 49"/>
           <p:cNvSpPr txBox="1"/>
           <p:nvPr/>
         </p:nvSpPr>
         <p:spPr>
           <a:xfrm>
-            <a:off x="832104" y="5504688"/>
-            <a:ext cx="5006340" cy="201168"/>
+            <a:off x="896112" y="5669280"/>
+            <a:ext cx="4924044" cy="265176"/>
           </a:xfrm>
           <a:prstGeom prst="rect">
             <a:avLst/>
@@ -3356,21 +2601,7 @@
               <a:buNone/>
             </a:pPr>
             <a:r>
-              <a:rPr lang="en-US" sz="1100" b="1" dirty="0">
-                <a:solidFill>
-                  <a:srgbClr val="0B2545"/>
-                </a:solidFill>
-                <a:latin typeface="Calibri" pitchFamily="34" charset="0"/>
-                <a:ea typeface="Calibri" pitchFamily="34" charset="-122"/>
-                <a:cs typeface="Calibri" pitchFamily="34" charset="-120"/>
-              </a:rPr>
-              <a:t>Activos de riesgo: </a:t>
-            </a:r>
-            <a:pPr indent="0" marL="0">
-              <a:buNone/>
-            </a:pPr>
-            <a:r>
-              <a:rPr lang="en-US" sz="1100" dirty="0">
+              <a:rPr lang="en-US" sz="1300" dirty="0">
                 <a:solidFill>
                   <a:srgbClr val="1B2733"/>
                 </a:solidFill>
@@ -3378,22 +2609,22 @@
                 <a:ea typeface="Calibri" pitchFamily="34" charset="-122"/>
                 <a:cs typeface="Calibri" pitchFamily="34" charset="-120"/>
               </a:rPr>
-              <a:t>NCB-022, Central de Riesgo, CTRI-RECR, relacionados</a:t>
-            </a:r>
-            <a:endParaRPr lang="en-US" sz="1100" dirty="0"/>
-          </a:p>
-        </p:txBody>
-      </p:sp>
-      <p:sp>
-        <p:nvSpPr>
-          <p:cNvPr id="69" name="Shape 64"/>
-          <p:cNvSpPr/>
-          <p:nvPr/>
-        </p:nvSpPr>
-        <p:spPr>
-          <a:xfrm>
-            <a:off x="676656" y="5797296"/>
-            <a:ext cx="64008" cy="64008"/>
+              <a:t>Traslados de deuda y segmentación de productos</a:t>
+            </a:r>
+            <a:endParaRPr lang="en-US" sz="1300" dirty="0"/>
+          </a:p>
+        </p:txBody>
+      </p:sp>
+      <p:sp>
+        <p:nvSpPr>
+          <p:cNvPr id="55" name="Shape 50"/>
+          <p:cNvSpPr/>
+          <p:nvPr/>
+        </p:nvSpPr>
+        <p:spPr>
+          <a:xfrm>
+            <a:off x="713232" y="6076188"/>
+            <a:ext cx="73152" cy="73152"/>
           </a:xfrm>
           <a:prstGeom prst="rect">
             <a:avLst/>
@@ -3411,14 +2642,14 @@
       </p:sp>
       <p:sp>
         <p:nvSpPr>
-          <p:cNvPr id="70" name="Text 65"/>
+          <p:cNvPr id="56" name="Text 51"/>
           <p:cNvSpPr txBox="1"/>
           <p:nvPr/>
         </p:nvSpPr>
         <p:spPr>
           <a:xfrm>
-            <a:off x="832104" y="5728716"/>
-            <a:ext cx="5006340" cy="201168"/>
+            <a:off x="896112" y="5980176"/>
+            <a:ext cx="4924044" cy="265176"/>
           </a:xfrm>
           <a:prstGeom prst="rect">
             <a:avLst/>
@@ -3434,21 +2665,7 @@
               <a:buNone/>
             </a:pPr>
             <a:r>
-              <a:rPr lang="en-US" sz="1100" b="1" dirty="0">
-                <a:solidFill>
-                  <a:srgbClr val="0B2545"/>
-                </a:solidFill>
-                <a:latin typeface="Calibri" pitchFamily="34" charset="0"/>
-                <a:ea typeface="Calibri" pitchFamily="34" charset="-122"/>
-                <a:cs typeface="Calibri" pitchFamily="34" charset="-120"/>
-              </a:rPr>
-              <a:t>Tarjeta de crédito: </a:t>
-            </a:r>
-            <a:pPr indent="0" marL="0">
-              <a:buNone/>
-            </a:pPr>
-            <a:r>
-              <a:rPr lang="en-US" sz="1100" dirty="0">
+              <a:rPr lang="en-US" sz="1300" dirty="0">
                 <a:solidFill>
                   <a:srgbClr val="1B2733"/>
                 </a:solidFill>
@@ -3456,182 +2673,26 @@
                 <a:ea typeface="Calibri" pitchFamily="34" charset="-122"/>
                 <a:cs typeface="Calibri" pitchFamily="34" charset="-120"/>
               </a:rPr>
-              <a:t>análisis de cartera, simulación de vencida, cuadratura</a:t>
-            </a:r>
-            <a:endParaRPr lang="en-US" sz="1100" dirty="0"/>
-          </a:p>
-        </p:txBody>
-      </p:sp>
-      <p:sp>
-        <p:nvSpPr>
-          <p:cNvPr id="71" name="Shape 66"/>
-          <p:cNvSpPr/>
-          <p:nvPr/>
-        </p:nvSpPr>
-        <p:spPr>
-          <a:xfrm>
-            <a:off x="676656" y="6021324"/>
-            <a:ext cx="64008" cy="64008"/>
-          </a:xfrm>
-          <a:prstGeom prst="rect">
-            <a:avLst/>
-          </a:prstGeom>
-          <a:solidFill>
-            <a:srgbClr val="0A7480"/>
-          </a:solidFill>
-          <a:ln w="12700">
-            <a:solidFill>
-              <a:srgbClr val="0A7480"/>
-            </a:solidFill>
-            <a:prstDash val="solid"/>
-          </a:ln>
-        </p:spPr>
-      </p:sp>
-      <p:sp>
-        <p:nvSpPr>
-          <p:cNvPr id="72" name="Text 67"/>
-          <p:cNvSpPr txBox="1"/>
-          <p:nvPr/>
-        </p:nvSpPr>
-        <p:spPr>
-          <a:xfrm>
-            <a:off x="832104" y="5952744"/>
-            <a:ext cx="5006340" cy="201168"/>
-          </a:xfrm>
-          <a:prstGeom prst="rect">
-            <a:avLst/>
-          </a:prstGeom>
-          <a:noFill/>
-          <a:ln/>
-        </p:spPr>
-        <p:txBody>
-          <a:bodyPr wrap="square" lIns="0" tIns="0" rIns="0" bIns="0" rtlCol="0" anchor="ctr"/>
-          <a:lstStyle/>
-          <a:p>
-            <a:pPr indent="0" marL="0">
-              <a:buNone/>
-            </a:pPr>
-            <a:r>
-              <a:rPr lang="en-US" sz="1100" b="1" dirty="0">
-                <a:solidFill>
-                  <a:srgbClr val="0B2545"/>
-                </a:solidFill>
-                <a:latin typeface="Calibri" pitchFamily="34" charset="0"/>
-                <a:ea typeface="Calibri" pitchFamily="34" charset="-122"/>
-                <a:cs typeface="Calibri" pitchFamily="34" charset="-120"/>
-              </a:rPr>
-              <a:t>Reservas y deuda: </a:t>
-            </a:r>
-            <a:pPr indent="0" marL="0">
-              <a:buNone/>
-            </a:pPr>
-            <a:r>
-              <a:rPr lang="en-US" sz="1100" dirty="0">
-                <a:solidFill>
-                  <a:srgbClr val="1B2733"/>
-                </a:solidFill>
-                <a:latin typeface="Calibri" pitchFamily="34" charset="0"/>
-                <a:ea typeface="Calibri" pitchFamily="34" charset="-122"/>
-                <a:cs typeface="Calibri" pitchFamily="34" charset="-120"/>
-              </a:rPr>
-              <a:t>reserva de saneamiento y registro de traslados de deuda</a:t>
-            </a:r>
-            <a:endParaRPr lang="en-US" sz="1100" dirty="0"/>
-          </a:p>
-        </p:txBody>
-      </p:sp>
-      <p:sp>
-        <p:nvSpPr>
-          <p:cNvPr id="73" name="Shape 68"/>
-          <p:cNvSpPr/>
-          <p:nvPr/>
-        </p:nvSpPr>
-        <p:spPr>
-          <a:xfrm>
-            <a:off x="676656" y="6245352"/>
-            <a:ext cx="64008" cy="64008"/>
-          </a:xfrm>
-          <a:prstGeom prst="rect">
-            <a:avLst/>
-          </a:prstGeom>
-          <a:solidFill>
-            <a:srgbClr val="0A7480"/>
-          </a:solidFill>
-          <a:ln w="12700">
-            <a:solidFill>
-              <a:srgbClr val="0A7480"/>
-            </a:solidFill>
-            <a:prstDash val="solid"/>
-          </a:ln>
-        </p:spPr>
-      </p:sp>
-      <p:sp>
-        <p:nvSpPr>
-          <p:cNvPr id="74" name="Text 69"/>
-          <p:cNvSpPr txBox="1"/>
-          <p:nvPr/>
-        </p:nvSpPr>
-        <p:spPr>
-          <a:xfrm>
-            <a:off x="832104" y="6176772"/>
-            <a:ext cx="5006340" cy="201168"/>
-          </a:xfrm>
-          <a:prstGeom prst="rect">
-            <a:avLst/>
-          </a:prstGeom>
-          <a:noFill/>
-          <a:ln/>
-        </p:spPr>
-        <p:txBody>
-          <a:bodyPr wrap="square" lIns="0" tIns="0" rIns="0" bIns="0" rtlCol="0" anchor="ctr"/>
-          <a:lstStyle/>
-          <a:p>
-            <a:pPr indent="0" marL="0">
-              <a:buNone/>
-            </a:pPr>
-            <a:r>
-              <a:rPr lang="en-US" sz="1100" b="1" dirty="0">
-                <a:solidFill>
-                  <a:srgbClr val="0B2545"/>
-                </a:solidFill>
-                <a:latin typeface="Calibri" pitchFamily="34" charset="0"/>
-                <a:ea typeface="Calibri" pitchFamily="34" charset="-122"/>
-                <a:cs typeface="Calibri" pitchFamily="34" charset="-120"/>
-              </a:rPr>
-              <a:t>Largo plazo: </a:t>
-            </a:r>
-            <a:pPr indent="0" marL="0">
-              <a:buNone/>
-            </a:pPr>
-            <a:r>
-              <a:rPr lang="en-US" sz="1100" dirty="0">
-                <a:solidFill>
-                  <a:srgbClr val="1B2733"/>
-                </a:solidFill>
-                <a:latin typeface="Calibri" pitchFamily="34" charset="0"/>
-                <a:ea typeface="Calibri" pitchFamily="34" charset="-122"/>
-                <a:cs typeface="Calibri" pitchFamily="34" charset="-120"/>
-              </a:rPr>
-              <a:t>Política de TC, sistema de créditos NRP-41, TC de alto riesgo</a:t>
-            </a:r>
-            <a:endParaRPr lang="en-US" sz="1100" dirty="0"/>
-          </a:p>
-        </p:txBody>
-      </p:sp>
-      <p:sp>
-        <p:nvSpPr>
-          <p:cNvPr id="75" name="Shape 70"/>
-          <p:cNvSpPr/>
-          <p:nvPr/>
-        </p:nvSpPr>
-        <p:spPr>
-          <a:xfrm>
-            <a:off x="6167628" y="4270248"/>
-            <a:ext cx="5564124" cy="2203704"/>
+              <a:t>Largo plazo: Política de TC y sistema de créditos NRP-41</a:t>
+            </a:r>
+            <a:endParaRPr lang="en-US" sz="1300" dirty="0"/>
+          </a:p>
+        </p:txBody>
+      </p:sp>
+      <p:sp>
+        <p:nvSpPr>
+          <p:cNvPr id="57" name="Shape 52"/>
+          <p:cNvSpPr/>
+          <p:nvPr/>
+        </p:nvSpPr>
+        <p:spPr>
+          <a:xfrm>
+            <a:off x="6167628" y="3968496"/>
+            <a:ext cx="5564124" cy="2432304"/>
           </a:xfrm>
           <a:prstGeom prst="roundRect">
             <a:avLst>
-              <a:gd name="adj" fmla="val 4979"/>
+              <a:gd name="adj" fmla="val 4511"/>
             </a:avLst>
           </a:prstGeom>
           <a:solidFill>
@@ -3647,18 +2708,18 @@
       </p:sp>
       <p:sp>
         <p:nvSpPr>
-          <p:cNvPr id="76" name="Shape 71"/>
-          <p:cNvSpPr/>
-          <p:nvPr/>
-        </p:nvSpPr>
-        <p:spPr>
-          <a:xfrm>
-            <a:off x="6167628" y="4270248"/>
-            <a:ext cx="5564124" cy="749808"/>
+          <p:cNvPr id="58" name="Shape 53"/>
+          <p:cNvSpPr/>
+          <p:nvPr/>
+        </p:nvSpPr>
+        <p:spPr>
+          <a:xfrm>
+            <a:off x="6167628" y="3968496"/>
+            <a:ext cx="5564124" cy="676656"/>
           </a:xfrm>
           <a:prstGeom prst="roundRect">
             <a:avLst>
-              <a:gd name="adj" fmla="val 14634"/>
+              <a:gd name="adj" fmla="val 16216"/>
             </a:avLst>
           </a:prstGeom>
           <a:solidFill>
@@ -3674,13 +2735,13 @@
       </p:sp>
       <p:sp>
         <p:nvSpPr>
-          <p:cNvPr id="77" name="Shape 72"/>
-          <p:cNvSpPr/>
-          <p:nvPr/>
-        </p:nvSpPr>
-        <p:spPr>
-          <a:xfrm>
-            <a:off x="6167628" y="4910328"/>
+          <p:cNvPr id="59" name="Shape 54"/>
+          <p:cNvSpPr/>
+          <p:nvPr/>
+        </p:nvSpPr>
+        <p:spPr>
+          <a:xfrm>
+            <a:off x="6167628" y="4535424"/>
             <a:ext cx="5564124" cy="182880"/>
           </a:xfrm>
           <a:prstGeom prst="rect">
@@ -3699,14 +2760,14 @@
       </p:sp>
       <p:sp>
         <p:nvSpPr>
-          <p:cNvPr id="78" name="Shape 73"/>
-          <p:cNvSpPr/>
-          <p:nvPr/>
-        </p:nvSpPr>
-        <p:spPr>
-          <a:xfrm>
-            <a:off x="6350508" y="4370832"/>
-            <a:ext cx="438912" cy="438912"/>
+          <p:cNvPr id="60" name="Shape 55"/>
+          <p:cNvSpPr/>
+          <p:nvPr/>
+        </p:nvSpPr>
+        <p:spPr>
+          <a:xfrm>
+            <a:off x="6350508" y="4059936"/>
+            <a:ext cx="384048" cy="384048"/>
           </a:xfrm>
           <a:prstGeom prst="ellipse">
             <a:avLst/>
@@ -3724,7 +2785,7 @@
       </p:sp>
       <p:pic>
         <p:nvPicPr>
-          <p:cNvPr id="79" name="Image 3" descr="preencoded.png">    </p:cNvPr>
+          <p:cNvPr id="61" name="Image 3" descr="preencoded.png">    </p:cNvPr>
           <p:cNvPicPr>
             <a:picLocks noChangeAspect="1"/>
           </p:cNvPicPr>
@@ -3738,8 +2799,8 @@
         </p:blipFill>
         <p:spPr>
           <a:xfrm>
-            <a:off x="6455664" y="4475988"/>
-            <a:ext cx="228600" cy="228600"/>
+            <a:off x="6441948" y="4151376"/>
+            <a:ext cx="201168" cy="201168"/>
           </a:xfrm>
           <a:prstGeom prst="rect">
             <a:avLst/>
@@ -3748,14 +2809,14 @@
       </p:pic>
       <p:sp>
         <p:nvSpPr>
-          <p:cNvPr id="80" name="Text 74"/>
+          <p:cNvPr id="62" name="Text 56"/>
           <p:cNvSpPr txBox="1"/>
           <p:nvPr/>
         </p:nvSpPr>
         <p:spPr>
           <a:xfrm>
-            <a:off x="6935724" y="4343400"/>
-            <a:ext cx="4649724" cy="292608"/>
+            <a:off x="6880860" y="4059936"/>
+            <a:ext cx="4695444" cy="384048"/>
           </a:xfrm>
           <a:prstGeom prst="rect">
             <a:avLst/>
@@ -3771,7 +2832,7 @@
               <a:buNone/>
             </a:pPr>
             <a:r>
-              <a:rPr lang="en-US" sz="1500" b="1" dirty="0">
+              <a:rPr lang="en-US" sz="1600" b="1" dirty="0">
                 <a:solidFill>
                   <a:srgbClr val="FFFFFF"/>
                 </a:solidFill>
@@ -3779,22 +2840,47 @@
                 <a:ea typeface="Calibri" pitchFamily="34" charset="-122"/>
                 <a:cs typeface="Calibri" pitchFamily="34" charset="-120"/>
               </a:rPr>
-              <a:t>Proyectos Transversales</a:t>
-            </a:r>
-            <a:endParaRPr lang="en-US" sz="1500" dirty="0"/>
-          </a:p>
-        </p:txBody>
-      </p:sp>
-      <p:sp>
-        <p:nvSpPr>
-          <p:cNvPr id="81" name="Text 75"/>
+              <a:t>Proyectos y Coordinación</a:t>
+            </a:r>
+            <a:endParaRPr lang="en-US" sz="1600" dirty="0"/>
+          </a:p>
+        </p:txBody>
+      </p:sp>
+      <p:sp>
+        <p:nvSpPr>
+          <p:cNvPr id="63" name="Shape 57"/>
+          <p:cNvSpPr/>
+          <p:nvPr/>
+        </p:nvSpPr>
+        <p:spPr>
+          <a:xfrm>
+            <a:off x="6423660" y="4832604"/>
+            <a:ext cx="73152" cy="73152"/>
+          </a:xfrm>
+          <a:prstGeom prst="rect">
+            <a:avLst/>
+          </a:prstGeom>
+          <a:solidFill>
+            <a:srgbClr val="2E4A73"/>
+          </a:solidFill>
+          <a:ln w="12700">
+            <a:solidFill>
+              <a:srgbClr val="2E4A73"/>
+            </a:solidFill>
+            <a:prstDash val="solid"/>
+          </a:ln>
+        </p:spPr>
+      </p:sp>
+      <p:sp>
+        <p:nvSpPr>
+          <p:cNvPr id="64" name="Text 58"/>
           <p:cNvSpPr txBox="1"/>
           <p:nvPr/>
         </p:nvSpPr>
         <p:spPr>
           <a:xfrm>
-            <a:off x="6935724" y="4617720"/>
-            <a:ext cx="4649724" cy="219456"/>
+            <a:off x="6606540" y="4736592"/>
+            <a:ext cx="4924044" cy="265176"/>
           </a:xfrm>
           <a:prstGeom prst="rect">
             <a:avLst/>
@@ -3810,30 +2896,30 @@
               <a:buNone/>
             </a:pPr>
             <a:r>
-              <a:rPr lang="en-US" sz="1050" i="1" dirty="0">
-                <a:solidFill>
-                  <a:srgbClr val="DCE8F3"/>
-                </a:solidFill>
-                <a:latin typeface="Calibri" pitchFamily="34" charset="0"/>
-                <a:ea typeface="Calibri" pitchFamily="34" charset="-122"/>
-                <a:cs typeface="Calibri" pitchFamily="34" charset="-120"/>
-              </a:rPr>
-              <a:t>Mejora institucional en coordinación con otras áreas</a:t>
-            </a:r>
-            <a:endParaRPr lang="en-US" sz="1050" dirty="0"/>
-          </a:p>
-        </p:txBody>
-      </p:sp>
-      <p:sp>
-        <p:nvSpPr>
-          <p:cNvPr id="82" name="Shape 76"/>
-          <p:cNvSpPr/>
-          <p:nvPr/>
-        </p:nvSpPr>
-        <p:spPr>
-          <a:xfrm>
-            <a:off x="6387084" y="5125212"/>
-            <a:ext cx="64008" cy="64008"/>
+              <a:rPr lang="en-US" sz="1300" dirty="0">
+                <a:solidFill>
+                  <a:srgbClr val="1B2733"/>
+                </a:solidFill>
+                <a:latin typeface="Calibri" pitchFamily="34" charset="0"/>
+                <a:ea typeface="Calibri" pitchFamily="34" charset="-122"/>
+                <a:cs typeface="Calibri" pitchFamily="34" charset="-120"/>
+              </a:rPr>
+              <a:t>Unificación de formularios Actualización de Datos y Conozca tu Cliente</a:t>
+            </a:r>
+            <a:endParaRPr lang="en-US" sz="1300" dirty="0"/>
+          </a:p>
+        </p:txBody>
+      </p:sp>
+      <p:sp>
+        <p:nvSpPr>
+          <p:cNvPr id="65" name="Shape 59"/>
+          <p:cNvSpPr/>
+          <p:nvPr/>
+        </p:nvSpPr>
+        <p:spPr>
+          <a:xfrm>
+            <a:off x="6423660" y="5143500"/>
+            <a:ext cx="73152" cy="73152"/>
           </a:xfrm>
           <a:prstGeom prst="rect">
             <a:avLst/>
@@ -3851,14 +2937,14 @@
       </p:sp>
       <p:sp>
         <p:nvSpPr>
-          <p:cNvPr id="83" name="Text 77"/>
+          <p:cNvPr id="66" name="Text 60"/>
           <p:cNvSpPr txBox="1"/>
           <p:nvPr/>
         </p:nvSpPr>
         <p:spPr>
           <a:xfrm>
-            <a:off x="6542532" y="5056632"/>
-            <a:ext cx="5006340" cy="201168"/>
+            <a:off x="6606540" y="5047488"/>
+            <a:ext cx="4924044" cy="265176"/>
           </a:xfrm>
           <a:prstGeom prst="rect">
             <a:avLst/>
@@ -3874,21 +2960,7 @@
               <a:buNone/>
             </a:pPr>
             <a:r>
-              <a:rPr lang="en-US" sz="1100" b="1" dirty="0">
-                <a:solidFill>
-                  <a:srgbClr val="0B2545"/>
-                </a:solidFill>
-                <a:latin typeface="Calibri" pitchFamily="34" charset="0"/>
-                <a:ea typeface="Calibri" pitchFamily="34" charset="-122"/>
-                <a:cs typeface="Calibri" pitchFamily="34" charset="-120"/>
-              </a:rPr>
-              <a:t>BIA: </a:t>
-            </a:r>
-            <a:pPr indent="0" marL="0">
-              <a:buNone/>
-            </a:pPr>
-            <a:r>
-              <a:rPr lang="en-US" sz="1100" dirty="0">
+              <a:rPr lang="en-US" sz="1300" dirty="0">
                 <a:solidFill>
                   <a:srgbClr val="1B2733"/>
                 </a:solidFill>
@@ -3896,22 +2968,22 @@
                 <a:ea typeface="Calibri" pitchFamily="34" charset="-122"/>
                 <a:cs typeface="Calibri" pitchFamily="34" charset="-120"/>
               </a:rPr>
-              <a:t>cuestionario para las entrevistas</a:t>
-            </a:r>
-            <a:endParaRPr lang="en-US" sz="1100" dirty="0"/>
-          </a:p>
-        </p:txBody>
-      </p:sp>
-      <p:sp>
-        <p:nvSpPr>
-          <p:cNvPr id="84" name="Shape 78"/>
-          <p:cNvSpPr/>
-          <p:nvPr/>
-        </p:nvSpPr>
-        <p:spPr>
-          <a:xfrm>
-            <a:off x="6387084" y="5349240"/>
-            <a:ext cx="64008" cy="64008"/>
+              <a:t>Cuestionario para entrevistas BIA</a:t>
+            </a:r>
+            <a:endParaRPr lang="en-US" sz="1300" dirty="0"/>
+          </a:p>
+        </p:txBody>
+      </p:sp>
+      <p:sp>
+        <p:nvSpPr>
+          <p:cNvPr id="67" name="Shape 61"/>
+          <p:cNvSpPr/>
+          <p:nvPr/>
+        </p:nvSpPr>
+        <p:spPr>
+          <a:xfrm>
+            <a:off x="6423660" y="5454396"/>
+            <a:ext cx="73152" cy="73152"/>
           </a:xfrm>
           <a:prstGeom prst="rect">
             <a:avLst/>
@@ -3929,14 +3001,14 @@
       </p:sp>
       <p:sp>
         <p:nvSpPr>
-          <p:cNvPr id="85" name="Text 79"/>
+          <p:cNvPr id="68" name="Text 62"/>
           <p:cNvSpPr txBox="1"/>
           <p:nvPr/>
         </p:nvSpPr>
         <p:spPr>
           <a:xfrm>
-            <a:off x="6542532" y="5280660"/>
-            <a:ext cx="5006340" cy="201168"/>
+            <a:off x="6606540" y="5358384"/>
+            <a:ext cx="4924044" cy="265176"/>
           </a:xfrm>
           <a:prstGeom prst="rect">
             <a:avLst/>
@@ -3952,21 +3024,7 @@
               <a:buNone/>
             </a:pPr>
             <a:r>
-              <a:rPr lang="en-US" sz="1100" b="1" dirty="0">
-                <a:solidFill>
-                  <a:srgbClr val="0B2545"/>
-                </a:solidFill>
-                <a:latin typeface="Calibri" pitchFamily="34" charset="0"/>
-                <a:ea typeface="Calibri" pitchFamily="34" charset="-122"/>
-                <a:cs typeface="Calibri" pitchFamily="34" charset="-120"/>
-              </a:rPr>
-              <a:t>Formularios: </a:t>
-            </a:r>
-            <a:pPr indent="0" marL="0">
-              <a:buNone/>
-            </a:pPr>
-            <a:r>
-              <a:rPr lang="en-US" sz="1100" dirty="0">
+              <a:rPr lang="en-US" sz="1300" dirty="0">
                 <a:solidFill>
                   <a:srgbClr val="1B2733"/>
                 </a:solidFill>
@@ -3974,22 +3032,22 @@
                 <a:ea typeface="Calibri" pitchFamily="34" charset="-122"/>
                 <a:cs typeface="Calibri" pitchFamily="34" charset="-120"/>
               </a:rPr>
-              <a:t>unificación de Actualización de Datos y Conozca a tu Cliente</a:t>
-            </a:r>
-            <a:endParaRPr lang="en-US" sz="1100" dirty="0"/>
-          </a:p>
-        </p:txBody>
-      </p:sp>
-      <p:sp>
-        <p:nvSpPr>
-          <p:cNvPr id="86" name="Shape 80"/>
-          <p:cNvSpPr/>
-          <p:nvPr/>
-        </p:nvSpPr>
-        <p:spPr>
-          <a:xfrm>
-            <a:off x="6387084" y="5573268"/>
-            <a:ext cx="64008" cy="64008"/>
+              <a:t>Comparativos de políticas: tercerizados y gobierno corporativo</a:t>
+            </a:r>
+            <a:endParaRPr lang="en-US" sz="1300" dirty="0"/>
+          </a:p>
+        </p:txBody>
+      </p:sp>
+      <p:sp>
+        <p:nvSpPr>
+          <p:cNvPr id="69" name="Shape 63"/>
+          <p:cNvSpPr/>
+          <p:nvPr/>
+        </p:nvSpPr>
+        <p:spPr>
+          <a:xfrm>
+            <a:off x="6423660" y="5765292"/>
+            <a:ext cx="73152" cy="73152"/>
           </a:xfrm>
           <a:prstGeom prst="rect">
             <a:avLst/>
@@ -4007,14 +3065,14 @@
       </p:sp>
       <p:sp>
         <p:nvSpPr>
-          <p:cNvPr id="87" name="Text 81"/>
+          <p:cNvPr id="70" name="Text 64"/>
           <p:cNvSpPr txBox="1"/>
           <p:nvPr/>
         </p:nvSpPr>
         <p:spPr>
           <a:xfrm>
-            <a:off x="6542532" y="5504688"/>
-            <a:ext cx="5006340" cy="201168"/>
+            <a:off x="6606540" y="5669280"/>
+            <a:ext cx="4924044" cy="265176"/>
           </a:xfrm>
           <a:prstGeom prst="rect">
             <a:avLst/>
@@ -4030,21 +3088,7 @@
               <a:buNone/>
             </a:pPr>
             <a:r>
-              <a:rPr lang="en-US" sz="1100" b="1" dirty="0">
-                <a:solidFill>
-                  <a:srgbClr val="0B2545"/>
-                </a:solidFill>
-                <a:latin typeface="Calibri" pitchFamily="34" charset="0"/>
-                <a:ea typeface="Calibri" pitchFamily="34" charset="-122"/>
-                <a:cs typeface="Calibri" pitchFamily="34" charset="-120"/>
-              </a:rPr>
-              <a:t>Comparativos de políticas: </a:t>
-            </a:r>
-            <a:pPr indent="0" marL="0">
-              <a:buNone/>
-            </a:pPr>
-            <a:r>
-              <a:rPr lang="en-US" sz="1100" dirty="0">
+              <a:rPr lang="en-US" sz="1300" dirty="0">
                 <a:solidFill>
                   <a:srgbClr val="1B2733"/>
                 </a:solidFill>
@@ -4052,22 +3096,22 @@
                 <a:ea typeface="Calibri" pitchFamily="34" charset="-122"/>
                 <a:cs typeface="Calibri" pitchFamily="34" charset="-120"/>
               </a:rPr>
-              <a:t>servicios tercerizados y gobierno corporativo</a:t>
-            </a:r>
-            <a:endParaRPr lang="en-US" sz="1100" dirty="0"/>
-          </a:p>
-        </p:txBody>
-      </p:sp>
-      <p:sp>
-        <p:nvSpPr>
-          <p:cNvPr id="88" name="Shape 82"/>
-          <p:cNvSpPr/>
-          <p:nvPr/>
-        </p:nvSpPr>
-        <p:spPr>
-          <a:xfrm>
-            <a:off x="6387084" y="5797296"/>
-            <a:ext cx="64008" cy="64008"/>
+              <a:t>Procesos: Matriz de Sistemas Informáticos y estructura del Depto.</a:t>
+            </a:r>
+            <a:endParaRPr lang="en-US" sz="1300" dirty="0"/>
+          </a:p>
+        </p:txBody>
+      </p:sp>
+      <p:sp>
+        <p:nvSpPr>
+          <p:cNvPr id="71" name="Shape 65"/>
+          <p:cNvSpPr/>
+          <p:nvPr/>
+        </p:nvSpPr>
+        <p:spPr>
+          <a:xfrm>
+            <a:off x="6423660" y="6076188"/>
+            <a:ext cx="73152" cy="73152"/>
           </a:xfrm>
           <a:prstGeom prst="rect">
             <a:avLst/>
@@ -4085,14 +3129,14 @@
       </p:sp>
       <p:sp>
         <p:nvSpPr>
-          <p:cNvPr id="89" name="Text 83"/>
+          <p:cNvPr id="72" name="Text 66"/>
           <p:cNvSpPr txBox="1"/>
           <p:nvPr/>
         </p:nvSpPr>
         <p:spPr>
           <a:xfrm>
-            <a:off x="6542532" y="5728716"/>
-            <a:ext cx="5006340" cy="201168"/>
+            <a:off x="6606540" y="5980176"/>
+            <a:ext cx="4924044" cy="265176"/>
           </a:xfrm>
           <a:prstGeom prst="rect">
             <a:avLst/>
@@ -4108,21 +3152,7 @@
               <a:buNone/>
             </a:pPr>
             <a:r>
-              <a:rPr lang="en-US" sz="1100" b="1" dirty="0">
-                <a:solidFill>
-                  <a:srgbClr val="0B2545"/>
-                </a:solidFill>
-                <a:latin typeface="Calibri" pitchFamily="34" charset="0"/>
-                <a:ea typeface="Calibri" pitchFamily="34" charset="-122"/>
-                <a:cs typeface="Calibri" pitchFamily="34" charset="-120"/>
-              </a:rPr>
-              <a:t>Procesos: </a:t>
-            </a:r>
-            <a:pPr indent="0" marL="0">
-              <a:buNone/>
-            </a:pPr>
-            <a:r>
-              <a:rPr lang="en-US" sz="1100" dirty="0">
+              <a:rPr lang="en-US" sz="1300" dirty="0">
                 <a:solidFill>
                   <a:srgbClr val="1B2733"/>
                 </a:solidFill>
@@ -4130,171 +3160,15 @@
                 <a:ea typeface="Calibri" pitchFamily="34" charset="-122"/>
                 <a:cs typeface="Calibri" pitchFamily="34" charset="-120"/>
               </a:rPr>
-              <a:t>Matriz de Sistemas Informáticos y cambio de estructura del Depto.</a:t>
-            </a:r>
-            <a:endParaRPr lang="en-US" sz="1100" dirty="0"/>
-          </a:p>
-        </p:txBody>
-      </p:sp>
-      <p:sp>
-        <p:nvSpPr>
-          <p:cNvPr id="90" name="Shape 84"/>
-          <p:cNvSpPr/>
-          <p:nvPr/>
-        </p:nvSpPr>
-        <p:spPr>
-          <a:xfrm>
-            <a:off x="6387084" y="6021324"/>
-            <a:ext cx="64008" cy="64008"/>
-          </a:xfrm>
-          <a:prstGeom prst="rect">
-            <a:avLst/>
-          </a:prstGeom>
-          <a:solidFill>
-            <a:srgbClr val="2E4A73"/>
-          </a:solidFill>
-          <a:ln w="12700">
-            <a:solidFill>
-              <a:srgbClr val="2E4A73"/>
-            </a:solidFill>
-            <a:prstDash val="solid"/>
-          </a:ln>
-        </p:spPr>
-      </p:sp>
-      <p:sp>
-        <p:nvSpPr>
-          <p:cNvPr id="91" name="Text 85"/>
-          <p:cNvSpPr txBox="1"/>
-          <p:nvPr/>
-        </p:nvSpPr>
-        <p:spPr>
-          <a:xfrm>
-            <a:off x="6542532" y="5952744"/>
-            <a:ext cx="5006340" cy="201168"/>
-          </a:xfrm>
-          <a:prstGeom prst="rect">
-            <a:avLst/>
-          </a:prstGeom>
-          <a:noFill/>
-          <a:ln/>
-        </p:spPr>
-        <p:txBody>
-          <a:bodyPr wrap="square" lIns="0" tIns="0" rIns="0" bIns="0" rtlCol="0" anchor="ctr"/>
-          <a:lstStyle/>
-          <a:p>
-            <a:pPr indent="0" marL="0">
-              <a:buNone/>
-            </a:pPr>
-            <a:r>
-              <a:rPr lang="en-US" sz="1100" b="1" dirty="0">
-                <a:solidFill>
-                  <a:srgbClr val="0B2545"/>
-                </a:solidFill>
-                <a:latin typeface="Calibri" pitchFamily="34" charset="0"/>
-                <a:ea typeface="Calibri" pitchFamily="34" charset="-122"/>
-                <a:cs typeface="Calibri" pitchFamily="34" charset="-120"/>
-              </a:rPr>
-              <a:t>Atención al Asociado: </a:t>
-            </a:r>
-            <a:pPr indent="0" marL="0">
-              <a:buNone/>
-            </a:pPr>
-            <a:r>
-              <a:rPr lang="en-US" sz="1100" dirty="0">
-                <a:solidFill>
-                  <a:srgbClr val="1B2733"/>
-                </a:solidFill>
-                <a:latin typeface="Calibri" pitchFamily="34" charset="0"/>
-                <a:ea typeface="Calibri" pitchFamily="34" charset="-122"/>
-                <a:cs typeface="Calibri" pitchFamily="34" charset="-120"/>
-              </a:rPr>
-              <a:t>actualización de página web</a:t>
-            </a:r>
-            <a:endParaRPr lang="en-US" sz="1100" dirty="0"/>
-          </a:p>
-        </p:txBody>
-      </p:sp>
-      <p:sp>
-        <p:nvSpPr>
-          <p:cNvPr id="92" name="Shape 86"/>
-          <p:cNvSpPr/>
-          <p:nvPr/>
-        </p:nvSpPr>
-        <p:spPr>
-          <a:xfrm>
-            <a:off x="6387084" y="6245352"/>
-            <a:ext cx="64008" cy="64008"/>
-          </a:xfrm>
-          <a:prstGeom prst="rect">
-            <a:avLst/>
-          </a:prstGeom>
-          <a:solidFill>
-            <a:srgbClr val="2E4A73"/>
-          </a:solidFill>
-          <a:ln w="12700">
-            <a:solidFill>
-              <a:srgbClr val="2E4A73"/>
-            </a:solidFill>
-            <a:prstDash val="solid"/>
-          </a:ln>
-        </p:spPr>
-      </p:sp>
-      <p:sp>
-        <p:nvSpPr>
-          <p:cNvPr id="93" name="Text 87"/>
-          <p:cNvSpPr txBox="1"/>
-          <p:nvPr/>
-        </p:nvSpPr>
-        <p:spPr>
-          <a:xfrm>
-            <a:off x="6542532" y="6176772"/>
-            <a:ext cx="5006340" cy="201168"/>
-          </a:xfrm>
-          <a:prstGeom prst="rect">
-            <a:avLst/>
-          </a:prstGeom>
-          <a:noFill/>
-          <a:ln/>
-        </p:spPr>
-        <p:txBody>
-          <a:bodyPr wrap="square" lIns="0" tIns="0" rIns="0" bIns="0" rtlCol="0" anchor="ctr"/>
-          <a:lstStyle/>
-          <a:p>
-            <a:pPr indent="0" marL="0">
-              <a:buNone/>
-            </a:pPr>
-            <a:r>
-              <a:rPr lang="en-US" sz="1100" b="1" dirty="0">
-                <a:solidFill>
-                  <a:srgbClr val="0B2545"/>
-                </a:solidFill>
-                <a:latin typeface="Calibri" pitchFamily="34" charset="0"/>
-                <a:ea typeface="Calibri" pitchFamily="34" charset="-122"/>
-                <a:cs typeface="Calibri" pitchFamily="34" charset="-120"/>
-              </a:rPr>
-              <a:t>Segmentación: </a:t>
-            </a:r>
-            <a:pPr indent="0" marL="0">
-              <a:buNone/>
-            </a:pPr>
-            <a:r>
-              <a:rPr lang="en-US" sz="1100" dirty="0">
-                <a:solidFill>
-                  <a:srgbClr val="1B2733"/>
-                </a:solidFill>
-                <a:latin typeface="Calibri" pitchFamily="34" charset="0"/>
-                <a:ea typeface="Calibri" pitchFamily="34" charset="-122"/>
-                <a:cs typeface="Calibri" pitchFamily="34" charset="-120"/>
-              </a:rPr>
-              <a:t>informe de segmentación de productos de COMEDICA</a:t>
-            </a:r>
-            <a:endParaRPr lang="en-US" sz="1100" dirty="0"/>
-          </a:p>
-        </p:txBody>
-      </p:sp>
-      <p:sp>
-        <p:nvSpPr>
-          <p:cNvPr id="94" name="Text 88"/>
+              <a:t>Información para Auditoría Interna (NRP-24) y Auditoría Externa</a:t>
+            </a:r>
+            <a:endParaRPr lang="en-US" sz="1300" dirty="0"/>
+          </a:p>
+        </p:txBody>
+      </p:sp>
+      <p:sp>
+        <p:nvSpPr>
+          <p:cNvPr id="73" name="Text 67"/>
           <p:cNvSpPr txBox="1"/>
           <p:nvPr/>
         </p:nvSpPr>
@@ -4325,7 +3199,7 @@
                 <a:ea typeface="Calibri" pitchFamily="34" charset="-122"/>
                 <a:cs typeface="Calibri" pitchFamily="34" charset="-120"/>
               </a:rPr>
-              <a:t>Fuentes: presentación base «Resumen Ejecutivo Riesgos» y documento de actividades semanales. Sin estado documentado: se presenta solo la actividad.</a:t>
+              <a:t>Fuente: documento de actividades semanales.</a:t>
             </a:r>
             <a:endParaRPr lang="en-US" sz="900" dirty="0"/>
           </a:p>
@@ -4372,7 +3246,7 @@
         <p:spPr>
           <a:xfrm>
             <a:off x="457200" y="292608"/>
-            <a:ext cx="8778240" cy="548640"/>
+            <a:ext cx="8046720" cy="548640"/>
           </a:xfrm>
           <a:prstGeom prst="rect">
             <a:avLst/>

</xml_diff>

<commit_message>
Slide 1: matrix layout matching the original deck (fronts x follow-up/this week), GIR exam 90%
Co-Authored-By: Claude Opus 5.5 <noreply@anthropic.com>
Claude-Session: https://claude.ai/code/session_01QGTe9h3kfUS6BTZosfrxzF
</commit_message>
<xml_diff>
--- a/resumen-ejecutivo-semanal/Resumen_Ejecutivo_Riesgos_COMEDICA_2_Slides.pptx
+++ b/resumen-ejecutivo-semanal/Resumen_Ejecutivo_Riesgos_COMEDICA_2_Slides.pptx
@@ -503,7 +503,7 @@
           <a:p>
             <a:r>
               <a:rPr lang="en-US" dirty="0"/>
-              <a:t>Resumen de los cuatro frentes de gestión, integrando las actividades de S1 y S2. Examen GIR 2026: avance 90% (reportado). Los demás frentes se presentan sin estado porque los documentos no lo indican.</a:t>
+              <a:t>Matriz por frente. Columna izquierda: asuntos del informe anterior que siguen vigentes (plazos SSF). Columna derecha: actividades de la semana según el documento de actividades. Examen GIR 2026: avance 90%.</a:t>
             </a:r>
             <a:endParaRPr lang="en-US" dirty="0"/>
           </a:p>
@@ -997,7 +997,7 @@
                 <a:ea typeface="Calibri" pitchFamily="34" charset="-122"/>
                 <a:cs typeface="Calibri" pitchFamily="34" charset="-120"/>
               </a:rPr>
-              <a:t>Gestión Integral de Riesgos | Resumen Ejecutivo Semanal</a:t>
+              <a:t>Departamento de Administración de Riesgos</a:t>
             </a:r>
             <a:endParaRPr lang="en-US" sz="2600" dirty="0"/>
           </a:p>
@@ -1036,7 +1036,7 @@
                 <a:ea typeface="Calibri" pitchFamily="34" charset="-122"/>
                 <a:cs typeface="Calibri" pitchFamily="34" charset="-120"/>
               </a:rPr>
-              <a:t>Departamento de Administración de Riesgos · COMÉDICA de R.L. · Seguimiento semanal</a:t>
+              <a:t>Informe semanal · Resumen ejecutivo</a:t>
             </a:r>
             <a:endParaRPr lang="en-US" sz="1300" dirty="0"/>
           </a:p>
@@ -1050,215 +1050,12 @@
         </p:nvSpPr>
         <p:spPr>
           <a:xfrm>
-            <a:off x="8622792" y="310896"/>
-            <a:ext cx="3108960" cy="713232"/>
-          </a:xfrm>
-          <a:prstGeom prst="roundRect">
-            <a:avLst>
-              <a:gd name="adj" fmla="val 15385"/>
-            </a:avLst>
-          </a:prstGeom>
-          <a:solidFill>
-            <a:srgbClr val="D7F0F2"/>
-          </a:solidFill>
-          <a:ln w="12700">
-            <a:solidFill>
-              <a:srgbClr val="D7F0F2"/>
-            </a:solidFill>
-            <a:prstDash val="solid"/>
-          </a:ln>
-        </p:spPr>
-      </p:sp>
-      <p:sp>
-        <p:nvSpPr>
-          <p:cNvPr id="5" name="Text 3"/>
-          <p:cNvSpPr txBox="1"/>
-          <p:nvPr/>
-        </p:nvSpPr>
-        <p:spPr>
-          <a:xfrm>
-            <a:off x="8823960" y="384048"/>
-            <a:ext cx="1554480" cy="438912"/>
-          </a:xfrm>
-          <a:prstGeom prst="rect">
-            <a:avLst/>
-          </a:prstGeom>
-          <a:noFill/>
-          <a:ln/>
-        </p:spPr>
-        <p:txBody>
-          <a:bodyPr wrap="square" lIns="0" tIns="0" rIns="0" bIns="0" rtlCol="0" anchor="ctr"/>
-          <a:lstStyle/>
-          <a:p>
-            <a:pPr indent="0" marL="0">
-              <a:buNone/>
-            </a:pPr>
-            <a:r>
-              <a:rPr lang="en-US" sz="1300" b="1" dirty="0">
-                <a:solidFill>
-                  <a:srgbClr val="0B2545"/>
-                </a:solidFill>
-                <a:latin typeface="Calibri" pitchFamily="34" charset="0"/>
-                <a:ea typeface="Calibri" pitchFamily="34" charset="-122"/>
-                <a:cs typeface="Calibri" pitchFamily="34" charset="-120"/>
-              </a:rPr>
-              <a:t>Examen GIR 2026</a:t>
-            </a:r>
-            <a:endParaRPr lang="en-US" sz="1300" dirty="0"/>
-          </a:p>
-          <a:p>
-            <a:pPr indent="0" marL="0">
-              <a:buNone/>
-            </a:pPr>
-            <a:r>
-              <a:rPr lang="en-US" sz="1050" dirty="0">
-                <a:solidFill>
-                  <a:srgbClr val="13507F"/>
-                </a:solidFill>
-                <a:latin typeface="Calibri" pitchFamily="34" charset="0"/>
-                <a:ea typeface="Calibri" pitchFamily="34" charset="-122"/>
-                <a:cs typeface="Calibri" pitchFamily="34" charset="-120"/>
-              </a:rPr>
-              <a:t>Avance reportado</a:t>
-            </a:r>
-            <a:endParaRPr lang="en-US" sz="1300" dirty="0"/>
-          </a:p>
-        </p:txBody>
-      </p:sp>
-      <p:sp>
-        <p:nvSpPr>
-          <p:cNvPr id="6" name="Shape 4"/>
-          <p:cNvSpPr/>
-          <p:nvPr/>
-        </p:nvSpPr>
-        <p:spPr>
-          <a:xfrm>
-            <a:off x="8823960" y="859536"/>
-            <a:ext cx="1737360" cy="82296"/>
+            <a:off x="3291840" y="1207008"/>
+            <a:ext cx="4151376" cy="310896"/>
           </a:xfrm>
           <a:prstGeom prst="roundRect">
             <a:avLst>
               <a:gd name="adj" fmla="val 50000"/>
-            </a:avLst>
-          </a:prstGeom>
-          <a:solidFill>
-            <a:srgbClr val="B9DDE1"/>
-          </a:solidFill>
-          <a:ln w="12700">
-            <a:solidFill>
-              <a:srgbClr val="B9DDE1"/>
-            </a:solidFill>
-            <a:prstDash val="solid"/>
-          </a:ln>
-        </p:spPr>
-      </p:sp>
-      <p:sp>
-        <p:nvSpPr>
-          <p:cNvPr id="7" name="Shape 5"/>
-          <p:cNvSpPr/>
-          <p:nvPr/>
-        </p:nvSpPr>
-        <p:spPr>
-          <a:xfrm>
-            <a:off x="8823960" y="859536"/>
-            <a:ext cx="1563624" cy="82296"/>
-          </a:xfrm>
-          <a:prstGeom prst="roundRect">
-            <a:avLst>
-              <a:gd name="adj" fmla="val 50000"/>
-            </a:avLst>
-          </a:prstGeom>
-          <a:solidFill>
-            <a:srgbClr val="0A7480"/>
-          </a:solidFill>
-          <a:ln w="12700">
-            <a:solidFill>
-              <a:srgbClr val="0A7480"/>
-            </a:solidFill>
-            <a:prstDash val="solid"/>
-          </a:ln>
-        </p:spPr>
-      </p:sp>
-      <p:sp>
-        <p:nvSpPr>
-          <p:cNvPr id="8" name="Text 6"/>
-          <p:cNvSpPr txBox="1"/>
-          <p:nvPr/>
-        </p:nvSpPr>
-        <p:spPr>
-          <a:xfrm>
-            <a:off x="10634472" y="310896"/>
-            <a:ext cx="914400" cy="713232"/>
-          </a:xfrm>
-          <a:prstGeom prst="rect">
-            <a:avLst/>
-          </a:prstGeom>
-          <a:noFill/>
-          <a:ln/>
-        </p:spPr>
-        <p:txBody>
-          <a:bodyPr wrap="square" lIns="0" tIns="0" rIns="0" bIns="0" rtlCol="0" anchor="ctr"/>
-          <a:lstStyle/>
-          <a:p>
-            <a:pPr algn="r" indent="0" marL="0">
-              <a:buNone/>
-            </a:pPr>
-            <a:r>
-              <a:rPr lang="en-US" sz="3000" b="1" dirty="0">
-                <a:solidFill>
-                  <a:srgbClr val="0A7480"/>
-                </a:solidFill>
-                <a:latin typeface="Calibri" pitchFamily="34" charset="0"/>
-                <a:ea typeface="Calibri" pitchFamily="34" charset="-122"/>
-                <a:cs typeface="Calibri" pitchFamily="34" charset="-120"/>
-              </a:rPr>
-              <a:t>90%</a:t>
-            </a:r>
-            <a:endParaRPr lang="en-US" sz="3000" dirty="0"/>
-          </a:p>
-        </p:txBody>
-      </p:sp>
-      <p:sp>
-        <p:nvSpPr>
-          <p:cNvPr id="9" name="Shape 7"/>
-          <p:cNvSpPr/>
-          <p:nvPr/>
-        </p:nvSpPr>
-        <p:spPr>
-          <a:xfrm>
-            <a:off x="457200" y="1371600"/>
-            <a:ext cx="5564124" cy="2432304"/>
-          </a:xfrm>
-          <a:prstGeom prst="roundRect">
-            <a:avLst>
-              <a:gd name="adj" fmla="val 4511"/>
-            </a:avLst>
-          </a:prstGeom>
-          <a:solidFill>
-            <a:srgbClr val="F1F5F9"/>
-          </a:solidFill>
-          <a:ln w="12700">
-            <a:solidFill>
-              <a:srgbClr val="F1F5F9"/>
-            </a:solidFill>
-            <a:prstDash val="solid"/>
-          </a:ln>
-        </p:spPr>
-      </p:sp>
-      <p:sp>
-        <p:nvSpPr>
-          <p:cNvPr id="10" name="Shape 8"/>
-          <p:cNvSpPr/>
-          <p:nvPr/>
-        </p:nvSpPr>
-        <p:spPr>
-          <a:xfrm>
-            <a:off x="457200" y="1371600"/>
-            <a:ext cx="5564124" cy="676656"/>
-          </a:xfrm>
-          <a:prstGeom prst="roundRect">
-            <a:avLst>
-              <a:gd name="adj" fmla="val 16216"/>
             </a:avLst>
           </a:prstGeom>
           <a:solidFill>
@@ -1274,24 +1071,65 @@
       </p:sp>
       <p:sp>
         <p:nvSpPr>
-          <p:cNvPr id="11" name="Shape 9"/>
+          <p:cNvPr id="5" name="Text 3"/>
+          <p:cNvSpPr txBox="1"/>
+          <p:nvPr/>
+        </p:nvSpPr>
+        <p:spPr>
+          <a:xfrm>
+            <a:off x="3291840" y="1207008"/>
+            <a:ext cx="4151376" cy="310896"/>
+          </a:xfrm>
+          <a:prstGeom prst="rect">
+            <a:avLst/>
+          </a:prstGeom>
+          <a:noFill/>
+          <a:ln/>
+        </p:spPr>
+        <p:txBody>
+          <a:bodyPr wrap="square" lIns="0" tIns="0" rIns="0" bIns="0" rtlCol="0" anchor="ctr"/>
+          <a:lstStyle/>
+          <a:p>
+            <a:pPr algn="ctr" indent="0" marL="0">
+              <a:buNone/>
+            </a:pPr>
+            <a:r>
+              <a:rPr lang="en-US" sz="1200" b="1" dirty="0">
+                <a:solidFill>
+                  <a:srgbClr val="FFFFFF"/>
+                </a:solidFill>
+                <a:latin typeface="Calibri" pitchFamily="34" charset="0"/>
+                <a:ea typeface="Calibri" pitchFamily="34" charset="-122"/>
+                <a:cs typeface="Calibri" pitchFamily="34" charset="-120"/>
+              </a:rPr>
+              <a:t>En seguimiento</a:t>
+            </a:r>
+            <a:endParaRPr lang="en-US" sz="1200" dirty="0"/>
+          </a:p>
+        </p:txBody>
+      </p:sp>
+      <p:sp>
+        <p:nvSpPr>
+          <p:cNvPr id="6" name="Shape 4"/>
           <p:cNvSpPr/>
           <p:nvPr/>
         </p:nvSpPr>
         <p:spPr>
           <a:xfrm>
-            <a:off x="457200" y="1938528"/>
-            <a:ext cx="5564124" cy="182880"/>
-          </a:xfrm>
-          <a:prstGeom prst="rect">
-            <a:avLst/>
-          </a:prstGeom>
-          <a:solidFill>
-            <a:srgbClr val="F1F5F9"/>
+            <a:off x="7580376" y="1207008"/>
+            <a:ext cx="4151376" cy="310896"/>
+          </a:xfrm>
+          <a:prstGeom prst="roundRect">
+            <a:avLst>
+              <a:gd name="adj" fmla="val 50000"/>
+            </a:avLst>
+          </a:prstGeom>
+          <a:solidFill>
+            <a:srgbClr val="0B2545"/>
           </a:solidFill>
           <a:ln w="12700">
             <a:solidFill>
-              <a:srgbClr val="F1F5F9"/>
+              <a:srgbClr val="0B2545"/>
             </a:solidFill>
             <a:prstDash val="solid"/>
           </a:ln>
@@ -1299,32 +1137,98 @@
       </p:sp>
       <p:sp>
         <p:nvSpPr>
-          <p:cNvPr id="12" name="Shape 10"/>
+          <p:cNvPr id="7" name="Text 5"/>
+          <p:cNvSpPr txBox="1"/>
+          <p:nvPr/>
+        </p:nvSpPr>
+        <p:spPr>
+          <a:xfrm>
+            <a:off x="7580376" y="1207008"/>
+            <a:ext cx="4151376" cy="310896"/>
+          </a:xfrm>
+          <a:prstGeom prst="rect">
+            <a:avLst/>
+          </a:prstGeom>
+          <a:noFill/>
+          <a:ln/>
+        </p:spPr>
+        <p:txBody>
+          <a:bodyPr wrap="square" lIns="0" tIns="0" rIns="0" bIns="0" rtlCol="0" anchor="ctr"/>
+          <a:lstStyle/>
+          <a:p>
+            <a:pPr algn="ctr" indent="0" marL="0">
+              <a:buNone/>
+            </a:pPr>
+            <a:r>
+              <a:rPr lang="en-US" sz="1200" b="1" dirty="0">
+                <a:solidFill>
+                  <a:srgbClr val="FFFFFF"/>
+                </a:solidFill>
+                <a:latin typeface="Calibri" pitchFamily="34" charset="0"/>
+                <a:ea typeface="Calibri" pitchFamily="34" charset="-122"/>
+                <a:cs typeface="Calibri" pitchFamily="34" charset="-120"/>
+              </a:rPr>
+              <a:t>Actividades de la semana</a:t>
+            </a:r>
+            <a:endParaRPr lang="en-US" sz="1200" dirty="0"/>
+          </a:p>
+        </p:txBody>
+      </p:sp>
+      <p:sp>
+        <p:nvSpPr>
+          <p:cNvPr id="8" name="Shape 6"/>
           <p:cNvSpPr/>
           <p:nvPr/>
         </p:nvSpPr>
         <p:spPr>
           <a:xfrm>
-            <a:off x="640080" y="1463040"/>
-            <a:ext cx="384048" cy="384048"/>
-          </a:xfrm>
-          <a:prstGeom prst="ellipse">
-            <a:avLst/>
-          </a:prstGeom>
-          <a:solidFill>
-            <a:srgbClr val="FFFFFF"/>
+            <a:off x="457200" y="1645920"/>
+            <a:ext cx="2697480" cy="1115568"/>
+          </a:xfrm>
+          <a:prstGeom prst="roundRect">
+            <a:avLst>
+              <a:gd name="adj" fmla="val 8197"/>
+            </a:avLst>
+          </a:prstGeom>
+          <a:solidFill>
+            <a:srgbClr val="0B2545"/>
           </a:solidFill>
           <a:ln w="12700">
             <a:solidFill>
-              <a:srgbClr val="FFFFFF"/>
+              <a:srgbClr val="0B2545"/>
             </a:solidFill>
             <a:prstDash val="solid"/>
           </a:ln>
         </p:spPr>
       </p:sp>
+      <p:sp>
+        <p:nvSpPr>
+          <p:cNvPr id="9" name="Shape 7"/>
+          <p:cNvSpPr/>
+          <p:nvPr/>
+        </p:nvSpPr>
+        <p:spPr>
+          <a:xfrm>
+            <a:off x="621792" y="2020824"/>
+            <a:ext cx="384048" cy="384048"/>
+          </a:xfrm>
+          <a:prstGeom prst="ellipse">
+            <a:avLst/>
+          </a:prstGeom>
+          <a:solidFill>
+            <a:srgbClr val="2B6CB0"/>
+          </a:solidFill>
+          <a:ln w="12700">
+            <a:solidFill>
+              <a:srgbClr val="2B6CB0"/>
+            </a:solidFill>
+            <a:prstDash val="solid"/>
+          </a:ln>
+        </p:spPr>
+      </p:sp>
       <p:pic>
         <p:nvPicPr>
-          <p:cNvPr id="13" name="Image 0" descr="preencoded.png">    </p:cNvPr>
+          <p:cNvPr id="10" name="Image 0" descr="preencoded.png">    </p:cNvPr>
           <p:cNvPicPr>
             <a:picLocks noChangeAspect="1"/>
           </p:cNvPicPr>
@@ -1338,8 +1242,8 @@
         </p:blipFill>
         <p:spPr>
           <a:xfrm>
-            <a:off x="731520" y="1554480"/>
-            <a:ext cx="201168" cy="201168"/>
+            <a:off x="722376" y="2121408"/>
+            <a:ext cx="182880" cy="182880"/>
           </a:xfrm>
           <a:prstGeom prst="rect">
             <a:avLst/>
@@ -1348,14 +1252,14 @@
       </p:pic>
       <p:sp>
         <p:nvSpPr>
-          <p:cNvPr id="14" name="Text 11"/>
+          <p:cNvPr id="11" name="Text 8"/>
           <p:cNvSpPr txBox="1"/>
           <p:nvPr/>
         </p:nvSpPr>
         <p:spPr>
           <a:xfrm>
-            <a:off x="1170432" y="1463040"/>
-            <a:ext cx="4695444" cy="384048"/>
+            <a:off x="1143000" y="1929384"/>
+            <a:ext cx="1920240" cy="566928"/>
           </a:xfrm>
           <a:prstGeom prst="rect">
             <a:avLst/>
@@ -1371,7 +1275,7 @@
               <a:buNone/>
             </a:pPr>
             <a:r>
-              <a:rPr lang="en-US" sz="1600" b="1" dirty="0">
+              <a:rPr lang="en-US" sz="1350" b="1" dirty="0">
                 <a:solidFill>
                   <a:srgbClr val="FFFFFF"/>
                 </a:solidFill>
@@ -1379,25 +1283,397 @@
                 <a:ea typeface="Calibri" pitchFamily="34" charset="-122"/>
                 <a:cs typeface="Calibri" pitchFamily="34" charset="-120"/>
               </a:rPr>
-              <a:t>Riesgo Operacional y Continuidad</a:t>
-            </a:r>
-            <a:endParaRPr lang="en-US" sz="1600" dirty="0"/>
-          </a:p>
-        </p:txBody>
-      </p:sp>
-      <p:sp>
-        <p:nvSpPr>
-          <p:cNvPr id="15" name="Shape 12"/>
+              <a:t>Cumplimiento Regulatorio</a:t>
+            </a:r>
+            <a:endParaRPr lang="en-US" sz="1350" dirty="0"/>
+          </a:p>
+          <a:p>
+            <a:pPr indent="0" marL="0">
+              <a:buNone/>
+            </a:pPr>
+            <a:r>
+              <a:rPr lang="en-US" sz="1050" dirty="0">
+                <a:solidFill>
+                  <a:srgbClr val="C9D6E6"/>
+                </a:solidFill>
+                <a:latin typeface="Calibri" pitchFamily="34" charset="0"/>
+                <a:ea typeface="Calibri" pitchFamily="34" charset="-122"/>
+                <a:cs typeface="Calibri" pitchFamily="34" charset="-120"/>
+              </a:rPr>
+              <a:t>Requerimientos SSF</a:t>
+            </a:r>
+            <a:endParaRPr lang="en-US" sz="1350" dirty="0"/>
+          </a:p>
+        </p:txBody>
+      </p:sp>
+      <p:sp>
+        <p:nvSpPr>
+          <p:cNvPr id="12" name="Shape 9"/>
           <p:cNvSpPr/>
           <p:nvPr/>
         </p:nvSpPr>
         <p:spPr>
           <a:xfrm>
-            <a:off x="713232" y="2235708"/>
-            <a:ext cx="73152" cy="73152"/>
-          </a:xfrm>
-          <a:prstGeom prst="rect">
-            <a:avLst/>
+            <a:off x="3291840" y="1645920"/>
+            <a:ext cx="4151376" cy="1115568"/>
+          </a:xfrm>
+          <a:prstGeom prst="roundRect">
+            <a:avLst>
+              <a:gd name="adj" fmla="val 8197"/>
+            </a:avLst>
+          </a:prstGeom>
+          <a:solidFill>
+            <a:srgbClr val="EEF2F7"/>
+          </a:solidFill>
+          <a:ln w="12700">
+            <a:solidFill>
+              <a:srgbClr val="EEF2F7"/>
+            </a:solidFill>
+            <a:prstDash val="solid"/>
+          </a:ln>
+        </p:spPr>
+      </p:sp>
+      <p:sp>
+        <p:nvSpPr>
+          <p:cNvPr id="13" name="Text 10"/>
+          <p:cNvSpPr txBox="1"/>
+          <p:nvPr/>
+        </p:nvSpPr>
+        <p:spPr>
+          <a:xfrm>
+            <a:off x="3456432" y="1719072"/>
+            <a:ext cx="3858768" cy="969264"/>
+          </a:xfrm>
+          <a:prstGeom prst="rect">
+            <a:avLst/>
+          </a:prstGeom>
+          <a:noFill/>
+          <a:ln/>
+        </p:spPr>
+        <p:txBody>
+          <a:bodyPr wrap="square" lIns="0" tIns="0" rIns="0" bIns="0" rtlCol="0" anchor="ctr"/>
+          <a:lstStyle/>
+          <a:p>
+            <a:pPr indent="0" marL="0">
+              <a:buNone/>
+            </a:pPr>
+            <a:r>
+              <a:rPr lang="en-US" sz="1150" b="1" dirty="0">
+                <a:solidFill>
+                  <a:srgbClr val="0B2545"/>
+                </a:solidFill>
+                <a:latin typeface="Calibri" pitchFamily="34" charset="0"/>
+                <a:ea typeface="Calibri" pitchFamily="34" charset="-122"/>
+                <a:cs typeface="Calibri" pitchFamily="34" charset="-120"/>
+              </a:rPr>
+              <a:t>PLD/FT  ·  </a:t>
+            </a:r>
+            <a:pPr indent="0" marL="0">
+              <a:buNone/>
+            </a:pPr>
+            <a:r>
+              <a:rPr lang="en-US" sz="1100" dirty="0">
+                <a:solidFill>
+                  <a:srgbClr val="13507F"/>
+                </a:solidFill>
+                <a:latin typeface="Calibri" pitchFamily="34" charset="0"/>
+                <a:ea typeface="Calibri" pitchFamily="34" charset="-122"/>
+                <a:cs typeface="Calibri" pitchFamily="34" charset="-120"/>
+              </a:rPr>
+              <a:t>Circ. 23486</a:t>
+            </a:r>
+            <a:pPr indent="0" marL="0">
+              <a:spcAft>
+                <a:spcPts val="300"/>
+              </a:spcAft>
+              <a:buNone/>
+            </a:pPr>
+            <a:r>
+              <a:rPr lang="en-US" sz="1150" b="1" dirty="0">
+                <a:solidFill>
+                  <a:srgbClr val="B86E00"/>
+                </a:solidFill>
+                <a:latin typeface="Calibri" pitchFamily="34" charset="0"/>
+                <a:ea typeface="Calibri" pitchFamily="34" charset="-122"/>
+                <a:cs typeface="Calibri" pitchFamily="34" charset="-120"/>
+              </a:rPr>
+              <a:t>   Plazo 16/10/2026</a:t>
+            </a:r>
+            <a:endParaRPr lang="en-US" sz="1150" dirty="0"/>
+          </a:p>
+          <a:p>
+            <a:pPr indent="0" marL="0">
+              <a:buNone/>
+            </a:pPr>
+            <a:r>
+              <a:rPr lang="en-US" sz="1150" b="1" dirty="0">
+                <a:solidFill>
+                  <a:srgbClr val="0B2545"/>
+                </a:solidFill>
+                <a:latin typeface="Calibri" pitchFamily="34" charset="0"/>
+                <a:ea typeface="Calibri" pitchFamily="34" charset="-122"/>
+                <a:cs typeface="Calibri" pitchFamily="34" charset="-120"/>
+              </a:rPr>
+              <a:t>Gobierno Corporativo  ·  </a:t>
+            </a:r>
+            <a:pPr indent="0" marL="0">
+              <a:buNone/>
+            </a:pPr>
+            <a:r>
+              <a:rPr lang="en-US" sz="1100" dirty="0">
+                <a:solidFill>
+                  <a:srgbClr val="13507F"/>
+                </a:solidFill>
+                <a:latin typeface="Calibri" pitchFamily="34" charset="0"/>
+                <a:ea typeface="Calibri" pitchFamily="34" charset="-122"/>
+                <a:cs typeface="Calibri" pitchFamily="34" charset="-120"/>
+              </a:rPr>
+              <a:t>Circ. 22741</a:t>
+            </a:r>
+            <a:pPr indent="0" marL="0">
+              <a:spcAft>
+                <a:spcPts val="300"/>
+              </a:spcAft>
+              <a:buNone/>
+            </a:pPr>
+            <a:r>
+              <a:rPr lang="en-US" sz="1150" b="1" dirty="0">
+                <a:solidFill>
+                  <a:srgbClr val="B86E00"/>
+                </a:solidFill>
+                <a:latin typeface="Calibri" pitchFamily="34" charset="0"/>
+                <a:ea typeface="Calibri" pitchFamily="34" charset="-122"/>
+                <a:cs typeface="Calibri" pitchFamily="34" charset="-120"/>
+              </a:rPr>
+              <a:t>   Plazos 23/10 y 30/10</a:t>
+            </a:r>
+            <a:endParaRPr lang="en-US" sz="1150" dirty="0"/>
+          </a:p>
+          <a:p>
+            <a:pPr indent="0" marL="0">
+              <a:buNone/>
+            </a:pPr>
+            <a:r>
+              <a:rPr lang="en-US" sz="1150" b="1" dirty="0">
+                <a:solidFill>
+                  <a:srgbClr val="0B2545"/>
+                </a:solidFill>
+                <a:latin typeface="Calibri" pitchFamily="34" charset="0"/>
+                <a:ea typeface="Calibri" pitchFamily="34" charset="-122"/>
+                <a:cs typeface="Calibri" pitchFamily="34" charset="-120"/>
+              </a:rPr>
+              <a:t>Plan de Recuperación  ·  </a:t>
+            </a:r>
+            <a:pPr indent="0" marL="0">
+              <a:buNone/>
+            </a:pPr>
+            <a:r>
+              <a:rPr lang="en-US" sz="1100" dirty="0">
+                <a:solidFill>
+                  <a:srgbClr val="13507F"/>
+                </a:solidFill>
+                <a:latin typeface="Calibri" pitchFamily="34" charset="0"/>
+                <a:ea typeface="Calibri" pitchFamily="34" charset="-122"/>
+                <a:cs typeface="Calibri" pitchFamily="34" charset="-120"/>
+              </a:rPr>
+              <a:t>Circ. 22737</a:t>
+            </a:r>
+            <a:pPr indent="0" marL="0">
+              <a:spcAft>
+                <a:spcPts val="300"/>
+              </a:spcAft>
+              <a:buNone/>
+            </a:pPr>
+            <a:r>
+              <a:rPr lang="en-US" sz="1150" b="1" dirty="0">
+                <a:solidFill>
+                  <a:srgbClr val="B86E00"/>
+                </a:solidFill>
+                <a:latin typeface="Calibri" pitchFamily="34" charset="0"/>
+                <a:ea typeface="Calibri" pitchFamily="34" charset="-122"/>
+                <a:cs typeface="Calibri" pitchFamily="34" charset="-120"/>
+              </a:rPr>
+              <a:t>   Plazo 03/11/2026</a:t>
+            </a:r>
+            <a:endParaRPr lang="en-US" sz="1150" dirty="0"/>
+          </a:p>
+          <a:p>
+            <a:pPr indent="0" marL="0">
+              <a:buNone/>
+            </a:pPr>
+            <a:r>
+              <a:rPr lang="en-US" sz="1150" b="1" dirty="0">
+                <a:solidFill>
+                  <a:srgbClr val="0B2545"/>
+                </a:solidFill>
+                <a:latin typeface="Calibri" pitchFamily="34" charset="0"/>
+                <a:ea typeface="Calibri" pitchFamily="34" charset="-122"/>
+                <a:cs typeface="Calibri" pitchFamily="34" charset="-120"/>
+              </a:rPr>
+              <a:t>Riesgos Específicos  ·  </a:t>
+            </a:r>
+            <a:pPr indent="0" marL="0">
+              <a:buNone/>
+            </a:pPr>
+            <a:r>
+              <a:rPr lang="en-US" sz="1100" dirty="0">
+                <a:solidFill>
+                  <a:srgbClr val="13507F"/>
+                </a:solidFill>
+                <a:latin typeface="Calibri" pitchFamily="34" charset="0"/>
+                <a:ea typeface="Calibri" pitchFamily="34" charset="-122"/>
+                <a:cs typeface="Calibri" pitchFamily="34" charset="-120"/>
+              </a:rPr>
+              <a:t>Circ. 22742</a:t>
+            </a:r>
+            <a:pPr indent="0" marL="0">
+              <a:spcAft>
+                <a:spcPts val="300"/>
+              </a:spcAft>
+              <a:buNone/>
+            </a:pPr>
+            <a:r>
+              <a:rPr lang="en-US" sz="1150" b="1" dirty="0">
+                <a:solidFill>
+                  <a:srgbClr val="B86E00"/>
+                </a:solidFill>
+                <a:latin typeface="Calibri" pitchFamily="34" charset="0"/>
+                <a:ea typeface="Calibri" pitchFamily="34" charset="-122"/>
+                <a:cs typeface="Calibri" pitchFamily="34" charset="-120"/>
+              </a:rPr>
+              <a:t>   Inicio visita 09/10</a:t>
+            </a:r>
+            <a:endParaRPr lang="en-US" sz="1150" dirty="0"/>
+          </a:p>
+        </p:txBody>
+      </p:sp>
+      <p:sp>
+        <p:nvSpPr>
+          <p:cNvPr id="14" name="Shape 11"/>
+          <p:cNvSpPr/>
+          <p:nvPr/>
+        </p:nvSpPr>
+        <p:spPr>
+          <a:xfrm>
+            <a:off x="7580376" y="1645920"/>
+            <a:ext cx="4151376" cy="1115568"/>
+          </a:xfrm>
+          <a:prstGeom prst="roundRect">
+            <a:avLst>
+              <a:gd name="adj" fmla="val 8197"/>
+            </a:avLst>
+          </a:prstGeom>
+          <a:solidFill>
+            <a:srgbClr val="EEF2F7"/>
+          </a:solidFill>
+          <a:ln w="12700">
+            <a:solidFill>
+              <a:srgbClr val="EEF2F7"/>
+            </a:solidFill>
+            <a:prstDash val="solid"/>
+          </a:ln>
+        </p:spPr>
+      </p:sp>
+      <p:sp>
+        <p:nvSpPr>
+          <p:cNvPr id="15" name="Text 12"/>
+          <p:cNvSpPr txBox="1"/>
+          <p:nvPr/>
+        </p:nvSpPr>
+        <p:spPr>
+          <a:xfrm>
+            <a:off x="7744968" y="1719072"/>
+            <a:ext cx="3858768" cy="969264"/>
+          </a:xfrm>
+          <a:prstGeom prst="rect">
+            <a:avLst/>
+          </a:prstGeom>
+          <a:noFill/>
+          <a:ln/>
+        </p:spPr>
+        <p:txBody>
+          <a:bodyPr wrap="square" lIns="0" tIns="0" rIns="0" bIns="0" rtlCol="0" anchor="ctr"/>
+          <a:lstStyle/>
+          <a:p>
+            <a:pPr marL="152400" indent="-152400">
+              <a:spcAft>
+                <a:spcPts val="300"/>
+              </a:spcAft>
+              <a:buSzPct val="100000"/>
+              <a:buChar char="•"/>
+            </a:pPr>
+            <a:r>
+              <a:rPr lang="en-US" sz="1150" dirty="0">
+                <a:solidFill>
+                  <a:srgbClr val="1B2733"/>
+                </a:solidFill>
+                <a:latin typeface="Calibri" pitchFamily="34" charset="0"/>
+                <a:ea typeface="Calibri" pitchFamily="34" charset="-122"/>
+                <a:cs typeface="Calibri" pitchFamily="34" charset="-120"/>
+              </a:rPr>
+              <a:t>Matriz y requerimiento a áreas – Gob. Corporativo (22741)</a:t>
+            </a:r>
+            <a:endParaRPr lang="en-US" sz="1150" dirty="0"/>
+          </a:p>
+          <a:p>
+            <a:pPr marL="152400" indent="-152400">
+              <a:spcAft>
+                <a:spcPts val="300"/>
+              </a:spcAft>
+              <a:buSzPct val="100000"/>
+              <a:buChar char="•"/>
+            </a:pPr>
+            <a:r>
+              <a:rPr lang="en-US" sz="1150" dirty="0">
+                <a:solidFill>
+                  <a:srgbClr val="1B2733"/>
+                </a:solidFill>
+                <a:latin typeface="Calibri" pitchFamily="34" charset="0"/>
+                <a:ea typeface="Calibri" pitchFamily="34" charset="-122"/>
+                <a:cs typeface="Calibri" pitchFamily="34" charset="-120"/>
+              </a:rPr>
+              <a:t>Seguimiento de pruebas de descargo (22741 y 23486)</a:t>
+            </a:r>
+            <a:endParaRPr lang="en-US" sz="1150" dirty="0"/>
+          </a:p>
+          <a:p>
+            <a:pPr marL="152400" indent="-152400">
+              <a:spcAft>
+                <a:spcPts val="300"/>
+              </a:spcAft>
+              <a:buSzPct val="100000"/>
+              <a:buChar char="•"/>
+            </a:pPr>
+            <a:r>
+              <a:rPr lang="en-US" sz="1150" dirty="0">
+                <a:solidFill>
+                  <a:srgbClr val="1B2733"/>
+                </a:solidFill>
+                <a:latin typeface="Calibri" pitchFamily="34" charset="0"/>
+                <a:ea typeface="Calibri" pitchFamily="34" charset="-122"/>
+                <a:cs typeface="Calibri" pitchFamily="34" charset="-120"/>
+              </a:rPr>
+              <a:t>Presentación de resultados preliminares de Riesgo Específico</a:t>
+            </a:r>
+            <a:endParaRPr lang="en-US" sz="1150" dirty="0"/>
+          </a:p>
+        </p:txBody>
+      </p:sp>
+      <p:sp>
+        <p:nvSpPr>
+          <p:cNvPr id="16" name="Shape 13"/>
+          <p:cNvSpPr/>
+          <p:nvPr/>
+        </p:nvSpPr>
+        <p:spPr>
+          <a:xfrm>
+            <a:off x="457200" y="2852928"/>
+            <a:ext cx="2697480" cy="932688"/>
+          </a:xfrm>
+          <a:prstGeom prst="roundRect">
+            <a:avLst>
+              <a:gd name="adj" fmla="val 9804"/>
+            </a:avLst>
           </a:prstGeom>
           <a:solidFill>
             <a:srgbClr val="0B2545"/>
@@ -1412,406 +1688,32 @@
       </p:sp>
       <p:sp>
         <p:nvSpPr>
-          <p:cNvPr id="16" name="Text 13"/>
-          <p:cNvSpPr txBox="1"/>
-          <p:nvPr/>
-        </p:nvSpPr>
-        <p:spPr>
-          <a:xfrm>
-            <a:off x="896112" y="2139696"/>
-            <a:ext cx="4924044" cy="265176"/>
-          </a:xfrm>
-          <a:prstGeom prst="rect">
-            <a:avLst/>
-          </a:prstGeom>
-          <a:noFill/>
-          <a:ln/>
-        </p:spPr>
-        <p:txBody>
-          <a:bodyPr wrap="square" lIns="0" tIns="0" rIns="0" bIns="0" rtlCol="0" anchor="ctr"/>
-          <a:lstStyle/>
-          <a:p>
-            <a:pPr indent="0" marL="0">
-              <a:buNone/>
-            </a:pPr>
-            <a:r>
-              <a:rPr lang="en-US" sz="1300" dirty="0">
-                <a:solidFill>
-                  <a:srgbClr val="1B2733"/>
-                </a:solidFill>
-                <a:latin typeface="Calibri" pitchFamily="34" charset="0"/>
-                <a:ea typeface="Calibri" pitchFamily="34" charset="-122"/>
-                <a:cs typeface="Calibri" pitchFamily="34" charset="-120"/>
-              </a:rPr>
-              <a:t>Capacitación GIR 2026 e informe de seguimiento del examen</a:t>
-            </a:r>
-            <a:endParaRPr lang="en-US" sz="1300" dirty="0"/>
-          </a:p>
-        </p:txBody>
-      </p:sp>
-      <p:sp>
-        <p:nvSpPr>
           <p:cNvPr id="17" name="Shape 14"/>
           <p:cNvSpPr/>
           <p:nvPr/>
         </p:nvSpPr>
         <p:spPr>
           <a:xfrm>
-            <a:off x="713232" y="2546604"/>
-            <a:ext cx="73152" cy="73152"/>
-          </a:xfrm>
-          <a:prstGeom prst="rect">
-            <a:avLst/>
-          </a:prstGeom>
-          <a:solidFill>
-            <a:srgbClr val="0B2545"/>
+            <a:off x="621792" y="2935224"/>
+            <a:ext cx="384048" cy="384048"/>
+          </a:xfrm>
+          <a:prstGeom prst="ellipse">
+            <a:avLst/>
+          </a:prstGeom>
+          <a:solidFill>
+            <a:srgbClr val="2B6CB0"/>
           </a:solidFill>
           <a:ln w="12700">
             <a:solidFill>
-              <a:srgbClr val="0B2545"/>
+              <a:srgbClr val="2B6CB0"/>
             </a:solidFill>
             <a:prstDash val="solid"/>
           </a:ln>
         </p:spPr>
       </p:sp>
-      <p:sp>
-        <p:nvSpPr>
-          <p:cNvPr id="18" name="Text 15"/>
-          <p:cNvSpPr txBox="1"/>
-          <p:nvPr/>
-        </p:nvSpPr>
-        <p:spPr>
-          <a:xfrm>
-            <a:off x="896112" y="2450592"/>
-            <a:ext cx="4924044" cy="265176"/>
-          </a:xfrm>
-          <a:prstGeom prst="rect">
-            <a:avLst/>
-          </a:prstGeom>
-          <a:noFill/>
-          <a:ln/>
-        </p:spPr>
-        <p:txBody>
-          <a:bodyPr wrap="square" lIns="0" tIns="0" rIns="0" bIns="0" rtlCol="0" anchor="ctr"/>
-          <a:lstStyle/>
-          <a:p>
-            <a:pPr indent="0" marL="0">
-              <a:buNone/>
-            </a:pPr>
-            <a:r>
-              <a:rPr lang="en-US" sz="1300" dirty="0">
-                <a:solidFill>
-                  <a:srgbClr val="1B2733"/>
-                </a:solidFill>
-                <a:latin typeface="Calibri" pitchFamily="34" charset="0"/>
-                <a:ea typeface="Calibri" pitchFamily="34" charset="-122"/>
-                <a:cs typeface="Calibri" pitchFamily="34" charset="-120"/>
-              </a:rPr>
-              <a:t>Informe de la 2.ª prueba de Continuidad del Negocio (01/10/2026)</a:t>
-            </a:r>
-            <a:endParaRPr lang="en-US" sz="1300" dirty="0"/>
-          </a:p>
-        </p:txBody>
-      </p:sp>
-      <p:sp>
-        <p:nvSpPr>
-          <p:cNvPr id="19" name="Shape 16"/>
-          <p:cNvSpPr/>
-          <p:nvPr/>
-        </p:nvSpPr>
-        <p:spPr>
-          <a:xfrm>
-            <a:off x="713232" y="2857500"/>
-            <a:ext cx="73152" cy="73152"/>
-          </a:xfrm>
-          <a:prstGeom prst="rect">
-            <a:avLst/>
-          </a:prstGeom>
-          <a:solidFill>
-            <a:srgbClr val="0B2545"/>
-          </a:solidFill>
-          <a:ln w="12700">
-            <a:solidFill>
-              <a:srgbClr val="0B2545"/>
-            </a:solidFill>
-            <a:prstDash val="solid"/>
-          </a:ln>
-        </p:spPr>
-      </p:sp>
-      <p:sp>
-        <p:nvSpPr>
-          <p:cNvPr id="20" name="Text 17"/>
-          <p:cNvSpPr txBox="1"/>
-          <p:nvPr/>
-        </p:nvSpPr>
-        <p:spPr>
-          <a:xfrm>
-            <a:off x="896112" y="2761488"/>
-            <a:ext cx="4924044" cy="265176"/>
-          </a:xfrm>
-          <a:prstGeom prst="rect">
-            <a:avLst/>
-          </a:prstGeom>
-          <a:noFill/>
-          <a:ln/>
-        </p:spPr>
-        <p:txBody>
-          <a:bodyPr wrap="square" lIns="0" tIns="0" rIns="0" bIns="0" rtlCol="0" anchor="ctr"/>
-          <a:lstStyle/>
-          <a:p>
-            <a:pPr indent="0" marL="0">
-              <a:buNone/>
-            </a:pPr>
-            <a:r>
-              <a:rPr lang="en-US" sz="1300" dirty="0">
-                <a:solidFill>
-                  <a:srgbClr val="1B2733"/>
-                </a:solidFill>
-                <a:latin typeface="Calibri" pitchFamily="34" charset="0"/>
-                <a:ea typeface="Calibri" pitchFamily="34" charset="-122"/>
-                <a:cs typeface="Calibri" pitchFamily="34" charset="-120"/>
-              </a:rPr>
-              <a:t>Seguimiento de planes de acción – Matriz de Riesgos 2026</a:t>
-            </a:r>
-            <a:endParaRPr lang="en-US" sz="1300" dirty="0"/>
-          </a:p>
-        </p:txBody>
-      </p:sp>
-      <p:sp>
-        <p:nvSpPr>
-          <p:cNvPr id="21" name="Shape 18"/>
-          <p:cNvSpPr/>
-          <p:nvPr/>
-        </p:nvSpPr>
-        <p:spPr>
-          <a:xfrm>
-            <a:off x="713232" y="3168396"/>
-            <a:ext cx="73152" cy="73152"/>
-          </a:xfrm>
-          <a:prstGeom prst="rect">
-            <a:avLst/>
-          </a:prstGeom>
-          <a:solidFill>
-            <a:srgbClr val="0B2545"/>
-          </a:solidFill>
-          <a:ln w="12700">
-            <a:solidFill>
-              <a:srgbClr val="0B2545"/>
-            </a:solidFill>
-            <a:prstDash val="solid"/>
-          </a:ln>
-        </p:spPr>
-      </p:sp>
-      <p:sp>
-        <p:nvSpPr>
-          <p:cNvPr id="22" name="Text 19"/>
-          <p:cNvSpPr txBox="1"/>
-          <p:nvPr/>
-        </p:nvSpPr>
-        <p:spPr>
-          <a:xfrm>
-            <a:off x="896112" y="3072384"/>
-            <a:ext cx="4924044" cy="265176"/>
-          </a:xfrm>
-          <a:prstGeom prst="rect">
-            <a:avLst/>
-          </a:prstGeom>
-          <a:noFill/>
-          <a:ln/>
-        </p:spPr>
-        <p:txBody>
-          <a:bodyPr wrap="square" lIns="0" tIns="0" rIns="0" bIns="0" rtlCol="0" anchor="ctr"/>
-          <a:lstStyle/>
-          <a:p>
-            <a:pPr indent="0" marL="0">
-              <a:buNone/>
-            </a:pPr>
-            <a:r>
-              <a:rPr lang="en-US" sz="1300" dirty="0">
-                <a:solidFill>
-                  <a:srgbClr val="1B2733"/>
-                </a:solidFill>
-                <a:latin typeface="Calibri" pitchFamily="34" charset="0"/>
-                <a:ea typeface="Calibri" pitchFamily="34" charset="-122"/>
-                <a:cs typeface="Calibri" pitchFamily="34" charset="-120"/>
-              </a:rPr>
-              <a:t>Eventos de riesgo: caídas de TC (25/09) y Orion (26/09)</a:t>
-            </a:r>
-            <a:endParaRPr lang="en-US" sz="1300" dirty="0"/>
-          </a:p>
-        </p:txBody>
-      </p:sp>
-      <p:sp>
-        <p:nvSpPr>
-          <p:cNvPr id="23" name="Shape 20"/>
-          <p:cNvSpPr/>
-          <p:nvPr/>
-        </p:nvSpPr>
-        <p:spPr>
-          <a:xfrm>
-            <a:off x="713232" y="3479292"/>
-            <a:ext cx="73152" cy="73152"/>
-          </a:xfrm>
-          <a:prstGeom prst="rect">
-            <a:avLst/>
-          </a:prstGeom>
-          <a:solidFill>
-            <a:srgbClr val="0B2545"/>
-          </a:solidFill>
-          <a:ln w="12700">
-            <a:solidFill>
-              <a:srgbClr val="0B2545"/>
-            </a:solidFill>
-            <a:prstDash val="solid"/>
-          </a:ln>
-        </p:spPr>
-      </p:sp>
-      <p:sp>
-        <p:nvSpPr>
-          <p:cNvPr id="24" name="Text 21"/>
-          <p:cNvSpPr txBox="1"/>
-          <p:nvPr/>
-        </p:nvSpPr>
-        <p:spPr>
-          <a:xfrm>
-            <a:off x="896112" y="3383280"/>
-            <a:ext cx="4924044" cy="265176"/>
-          </a:xfrm>
-          <a:prstGeom prst="rect">
-            <a:avLst/>
-          </a:prstGeom>
-          <a:noFill/>
-          <a:ln/>
-        </p:spPr>
-        <p:txBody>
-          <a:bodyPr wrap="square" lIns="0" tIns="0" rIns="0" bIns="0" rtlCol="0" anchor="ctr"/>
-          <a:lstStyle/>
-          <a:p>
-            <a:pPr indent="0" marL="0">
-              <a:buNone/>
-            </a:pPr>
-            <a:r>
-              <a:rPr lang="en-US" sz="1300" dirty="0">
-                <a:solidFill>
-                  <a:srgbClr val="1B2733"/>
-                </a:solidFill>
-                <a:latin typeface="Calibri" pitchFamily="34" charset="0"/>
-                <a:ea typeface="Calibri" pitchFamily="34" charset="-122"/>
-                <a:cs typeface="Calibri" pitchFamily="34" charset="-120"/>
-              </a:rPr>
-              <a:t>Opiniones: Fábrica de Créditos y caso de asociado</a:t>
-            </a:r>
-            <a:endParaRPr lang="en-US" sz="1300" dirty="0"/>
-          </a:p>
-        </p:txBody>
-      </p:sp>
-      <p:sp>
-        <p:nvSpPr>
-          <p:cNvPr id="25" name="Shape 22"/>
-          <p:cNvSpPr/>
-          <p:nvPr/>
-        </p:nvSpPr>
-        <p:spPr>
-          <a:xfrm>
-            <a:off x="6167628" y="1371600"/>
-            <a:ext cx="5564124" cy="2432304"/>
-          </a:xfrm>
-          <a:prstGeom prst="roundRect">
-            <a:avLst>
-              <a:gd name="adj" fmla="val 4511"/>
-            </a:avLst>
-          </a:prstGeom>
-          <a:solidFill>
-            <a:srgbClr val="F1F5F9"/>
-          </a:solidFill>
-          <a:ln w="12700">
-            <a:solidFill>
-              <a:srgbClr val="F1F5F9"/>
-            </a:solidFill>
-            <a:prstDash val="solid"/>
-          </a:ln>
-        </p:spPr>
-      </p:sp>
-      <p:sp>
-        <p:nvSpPr>
-          <p:cNvPr id="26" name="Shape 23"/>
-          <p:cNvSpPr/>
-          <p:nvPr/>
-        </p:nvSpPr>
-        <p:spPr>
-          <a:xfrm>
-            <a:off x="6167628" y="1371600"/>
-            <a:ext cx="5564124" cy="676656"/>
-          </a:xfrm>
-          <a:prstGeom prst="roundRect">
-            <a:avLst>
-              <a:gd name="adj" fmla="val 16216"/>
-            </a:avLst>
-          </a:prstGeom>
-          <a:solidFill>
-            <a:srgbClr val="13507F"/>
-          </a:solidFill>
-          <a:ln w="12700">
-            <a:solidFill>
-              <a:srgbClr val="13507F"/>
-            </a:solidFill>
-            <a:prstDash val="solid"/>
-          </a:ln>
-        </p:spPr>
-      </p:sp>
-      <p:sp>
-        <p:nvSpPr>
-          <p:cNvPr id="27" name="Shape 24"/>
-          <p:cNvSpPr/>
-          <p:nvPr/>
-        </p:nvSpPr>
-        <p:spPr>
-          <a:xfrm>
-            <a:off x="6167628" y="1938528"/>
-            <a:ext cx="5564124" cy="182880"/>
-          </a:xfrm>
-          <a:prstGeom prst="rect">
-            <a:avLst/>
-          </a:prstGeom>
-          <a:solidFill>
-            <a:srgbClr val="F1F5F9"/>
-          </a:solidFill>
-          <a:ln w="12700">
-            <a:solidFill>
-              <a:srgbClr val="F1F5F9"/>
-            </a:solidFill>
-            <a:prstDash val="solid"/>
-          </a:ln>
-        </p:spPr>
-      </p:sp>
-      <p:sp>
-        <p:nvSpPr>
-          <p:cNvPr id="28" name="Shape 25"/>
-          <p:cNvSpPr/>
-          <p:nvPr/>
-        </p:nvSpPr>
-        <p:spPr>
-          <a:xfrm>
-            <a:off x="6350508" y="1463040"/>
-            <a:ext cx="384048" cy="384048"/>
-          </a:xfrm>
-          <a:prstGeom prst="ellipse">
-            <a:avLst/>
-          </a:prstGeom>
-          <a:solidFill>
-            <a:srgbClr val="FFFFFF"/>
-          </a:solidFill>
-          <a:ln w="12700">
-            <a:solidFill>
-              <a:srgbClr val="FFFFFF"/>
-            </a:solidFill>
-            <a:prstDash val="solid"/>
-          </a:ln>
-        </p:spPr>
-      </p:sp>
       <p:pic>
         <p:nvPicPr>
-          <p:cNvPr id="29" name="Image 1" descr="preencoded.png">    </p:cNvPr>
+          <p:cNvPr id="18" name="Image 1" descr="preencoded.png">    </p:cNvPr>
           <p:cNvPicPr>
             <a:picLocks noChangeAspect="1"/>
           </p:cNvPicPr>
@@ -1825,8 +1727,8 @@
         </p:blipFill>
         <p:spPr>
           <a:xfrm>
-            <a:off x="6441948" y="1554480"/>
-            <a:ext cx="201168" cy="201168"/>
+            <a:off x="722376" y="3035808"/>
+            <a:ext cx="182880" cy="182880"/>
           </a:xfrm>
           <a:prstGeom prst="rect">
             <a:avLst/>
@@ -1835,14 +1737,14 @@
       </p:pic>
       <p:sp>
         <p:nvSpPr>
-          <p:cNvPr id="30" name="Text 26"/>
+          <p:cNvPr id="19" name="Text 15"/>
           <p:cNvSpPr txBox="1"/>
           <p:nvPr/>
         </p:nvSpPr>
         <p:spPr>
           <a:xfrm>
-            <a:off x="6880860" y="1463040"/>
-            <a:ext cx="4695444" cy="384048"/>
+            <a:off x="1143000" y="2843784"/>
+            <a:ext cx="1920240" cy="566928"/>
           </a:xfrm>
           <a:prstGeom prst="rect">
             <a:avLst/>
@@ -1858,7 +1760,7 @@
               <a:buNone/>
             </a:pPr>
             <a:r>
-              <a:rPr lang="en-US" sz="1600" b="1" dirty="0">
+              <a:rPr lang="en-US" sz="1350" b="1" dirty="0">
                 <a:solidFill>
                   <a:srgbClr val="FFFFFF"/>
                 </a:solidFill>
@@ -1866,32 +1768,90 @@
                 <a:ea typeface="Calibri" pitchFamily="34" charset="-122"/>
                 <a:cs typeface="Calibri" pitchFamily="34" charset="-120"/>
               </a:rPr>
-              <a:t>Riesgo Normativo</a:t>
-            </a:r>
-            <a:endParaRPr lang="en-US" sz="1600" dirty="0"/>
-          </a:p>
-        </p:txBody>
-      </p:sp>
-      <p:sp>
-        <p:nvSpPr>
-          <p:cNvPr id="31" name="Shape 27"/>
+              <a:t>Riesgos No Financieros</a:t>
+            </a:r>
+            <a:endParaRPr lang="en-US" sz="1350" dirty="0"/>
+          </a:p>
+          <a:p>
+            <a:pPr indent="0" marL="0">
+              <a:buNone/>
+            </a:pPr>
+            <a:r>
+              <a:rPr lang="en-US" sz="1050" dirty="0">
+                <a:solidFill>
+                  <a:srgbClr val="C9D6E6"/>
+                </a:solidFill>
+                <a:latin typeface="Calibri" pitchFamily="34" charset="0"/>
+                <a:ea typeface="Calibri" pitchFamily="34" charset="-122"/>
+                <a:cs typeface="Calibri" pitchFamily="34" charset="-120"/>
+              </a:rPr>
+              <a:t>Riesgo Operacional</a:t>
+            </a:r>
+            <a:endParaRPr lang="en-US" sz="1350" dirty="0"/>
+          </a:p>
+        </p:txBody>
+      </p:sp>
+      <p:sp>
+        <p:nvSpPr>
+          <p:cNvPr id="20" name="Text 16"/>
+          <p:cNvSpPr txBox="1"/>
+          <p:nvPr/>
+        </p:nvSpPr>
+        <p:spPr>
+          <a:xfrm>
+            <a:off x="621792" y="3374136"/>
+            <a:ext cx="1463040" cy="182880"/>
+          </a:xfrm>
+          <a:prstGeom prst="rect">
+            <a:avLst/>
+          </a:prstGeom>
+          <a:noFill/>
+          <a:ln/>
+        </p:spPr>
+        <p:txBody>
+          <a:bodyPr wrap="square" lIns="0" tIns="0" rIns="0" bIns="0" rtlCol="0" anchor="ctr"/>
+          <a:lstStyle/>
+          <a:p>
+            <a:pPr indent="0" marL="0">
+              <a:buNone/>
+            </a:pPr>
+            <a:r>
+              <a:rPr lang="en-US" sz="950" b="1" dirty="0">
+                <a:solidFill>
+                  <a:srgbClr val="C9D6E6"/>
+                </a:solidFill>
+                <a:latin typeface="Calibri" pitchFamily="34" charset="0"/>
+                <a:ea typeface="Calibri" pitchFamily="34" charset="-122"/>
+                <a:cs typeface="Calibri" pitchFamily="34" charset="-120"/>
+              </a:rPr>
+              <a:t>Examen GIR 2026</a:t>
+            </a:r>
+            <a:endParaRPr lang="en-US" sz="950" dirty="0"/>
+          </a:p>
+        </p:txBody>
+      </p:sp>
+      <p:sp>
+        <p:nvSpPr>
+          <p:cNvPr id="21" name="Shape 17"/>
           <p:cNvSpPr/>
           <p:nvPr/>
         </p:nvSpPr>
         <p:spPr>
           <a:xfrm>
-            <a:off x="6423660" y="2235708"/>
-            <a:ext cx="73152" cy="73152"/>
-          </a:xfrm>
-          <a:prstGeom prst="rect">
-            <a:avLst/>
-          </a:prstGeom>
-          <a:solidFill>
-            <a:srgbClr val="13507F"/>
+            <a:off x="621792" y="3593592"/>
+            <a:ext cx="1828800" cy="100584"/>
+          </a:xfrm>
+          <a:prstGeom prst="roundRect">
+            <a:avLst>
+              <a:gd name="adj" fmla="val 45455"/>
+            </a:avLst>
+          </a:prstGeom>
+          <a:solidFill>
+            <a:srgbClr val="3C5A80"/>
           </a:solidFill>
           <a:ln w="12700">
             <a:solidFill>
-              <a:srgbClr val="13507F"/>
+              <a:srgbClr val="3C5A80"/>
             </a:solidFill>
             <a:prstDash val="solid"/>
           </a:ln>
@@ -1899,63 +1859,26 @@
       </p:sp>
       <p:sp>
         <p:nvSpPr>
-          <p:cNvPr id="32" name="Text 28"/>
-          <p:cNvSpPr txBox="1"/>
-          <p:nvPr/>
-        </p:nvSpPr>
-        <p:spPr>
-          <a:xfrm>
-            <a:off x="6606540" y="2139696"/>
-            <a:ext cx="4924044" cy="265176"/>
-          </a:xfrm>
-          <a:prstGeom prst="rect">
-            <a:avLst/>
-          </a:prstGeom>
-          <a:noFill/>
-          <a:ln/>
-        </p:spPr>
-        <p:txBody>
-          <a:bodyPr wrap="square" lIns="0" tIns="0" rIns="0" bIns="0" rtlCol="0" anchor="ctr"/>
-          <a:lstStyle/>
-          <a:p>
-            <a:pPr indent="0" marL="0">
-              <a:buNone/>
-            </a:pPr>
-            <a:r>
-              <a:rPr lang="en-US" sz="1300" dirty="0">
-                <a:solidFill>
-                  <a:srgbClr val="1B2733"/>
-                </a:solidFill>
-                <a:latin typeface="Calibri" pitchFamily="34" charset="0"/>
-                <a:ea typeface="Calibri" pitchFamily="34" charset="-122"/>
-                <a:cs typeface="Calibri" pitchFamily="34" charset="-120"/>
-              </a:rPr>
-              <a:t>Gobierno Corporativo (nota 22741): matriz y requerimiento a áreas</a:t>
-            </a:r>
-            <a:endParaRPr lang="en-US" sz="1300" dirty="0"/>
-          </a:p>
-        </p:txBody>
-      </p:sp>
-      <p:sp>
-        <p:nvSpPr>
-          <p:cNvPr id="33" name="Shape 29"/>
+          <p:cNvPr id="22" name="Shape 18"/>
           <p:cNvSpPr/>
           <p:nvPr/>
         </p:nvSpPr>
         <p:spPr>
           <a:xfrm>
-            <a:off x="6423660" y="2546604"/>
-            <a:ext cx="73152" cy="73152"/>
-          </a:xfrm>
-          <a:prstGeom prst="rect">
-            <a:avLst/>
-          </a:prstGeom>
-          <a:solidFill>
-            <a:srgbClr val="13507F"/>
+            <a:off x="621792" y="3593592"/>
+            <a:ext cx="1645920" cy="100584"/>
+          </a:xfrm>
+          <a:prstGeom prst="roundRect">
+            <a:avLst>
+              <a:gd name="adj" fmla="val 45455"/>
+            </a:avLst>
+          </a:prstGeom>
+          <a:solidFill>
+            <a:srgbClr val="F2B544"/>
           </a:solidFill>
           <a:ln w="12700">
             <a:solidFill>
-              <a:srgbClr val="13507F"/>
+              <a:srgbClr val="F2B544"/>
             </a:solidFill>
             <a:prstDash val="solid"/>
           </a:ln>
@@ -1963,14 +1886,14 @@
       </p:sp>
       <p:sp>
         <p:nvSpPr>
-          <p:cNvPr id="34" name="Text 30"/>
+          <p:cNvPr id="23" name="Text 19"/>
           <p:cNvSpPr txBox="1"/>
           <p:nvPr/>
         </p:nvSpPr>
         <p:spPr>
           <a:xfrm>
-            <a:off x="6606540" y="2450592"/>
-            <a:ext cx="4924044" cy="265176"/>
+            <a:off x="2496312" y="3483864"/>
+            <a:ext cx="548640" cy="310896"/>
           </a:xfrm>
           <a:prstGeom prst="rect">
             <a:avLst/>
@@ -1982,44 +1905,46 @@
           <a:bodyPr wrap="square" lIns="0" tIns="0" rIns="0" bIns="0" rtlCol="0" anchor="ctr"/>
           <a:lstStyle/>
           <a:p>
-            <a:pPr indent="0" marL="0">
-              <a:buNone/>
-            </a:pPr>
-            <a:r>
-              <a:rPr lang="en-US" sz="1300" dirty="0">
-                <a:solidFill>
-                  <a:srgbClr val="1B2733"/>
-                </a:solidFill>
-                <a:latin typeface="Calibri" pitchFamily="34" charset="0"/>
-                <a:ea typeface="Calibri" pitchFamily="34" charset="-122"/>
-                <a:cs typeface="Calibri" pitchFamily="34" charset="-120"/>
-              </a:rPr>
-              <a:t>Seguimiento de pruebas de descargo – notas 22741 y 23486</a:t>
-            </a:r>
-            <a:endParaRPr lang="en-US" sz="1300" dirty="0"/>
-          </a:p>
-        </p:txBody>
-      </p:sp>
-      <p:sp>
-        <p:nvSpPr>
-          <p:cNvPr id="35" name="Shape 31"/>
+            <a:pPr algn="r" indent="0" marL="0">
+              <a:buNone/>
+            </a:pPr>
+            <a:r>
+              <a:rPr lang="en-US" sz="1400" b="1" dirty="0">
+                <a:solidFill>
+                  <a:srgbClr val="FFFFFF"/>
+                </a:solidFill>
+                <a:latin typeface="Calibri" pitchFamily="34" charset="0"/>
+                <a:ea typeface="Calibri" pitchFamily="34" charset="-122"/>
+                <a:cs typeface="Calibri" pitchFamily="34" charset="-120"/>
+              </a:rPr>
+              <a:t>90%</a:t>
+            </a:r>
+            <a:endParaRPr lang="en-US" sz="1400" dirty="0"/>
+          </a:p>
+        </p:txBody>
+      </p:sp>
+      <p:sp>
+        <p:nvSpPr>
+          <p:cNvPr id="24" name="Shape 20"/>
           <p:cNvSpPr/>
           <p:nvPr/>
         </p:nvSpPr>
         <p:spPr>
           <a:xfrm>
-            <a:off x="6423660" y="2857500"/>
-            <a:ext cx="73152" cy="73152"/>
-          </a:xfrm>
-          <a:prstGeom prst="rect">
-            <a:avLst/>
-          </a:prstGeom>
-          <a:solidFill>
-            <a:srgbClr val="13507F"/>
+            <a:off x="3291840" y="2852928"/>
+            <a:ext cx="4151376" cy="932688"/>
+          </a:xfrm>
+          <a:prstGeom prst="roundRect">
+            <a:avLst>
+              <a:gd name="adj" fmla="val 9804"/>
+            </a:avLst>
+          </a:prstGeom>
+          <a:solidFill>
+            <a:srgbClr val="EEF2F7"/>
           </a:solidFill>
           <a:ln w="12700">
             <a:solidFill>
-              <a:srgbClr val="13507F"/>
+              <a:srgbClr val="EEF2F7"/>
             </a:solidFill>
             <a:prstDash val="solid"/>
           </a:ln>
@@ -2027,14 +1952,14 @@
       </p:sp>
       <p:sp>
         <p:nvSpPr>
-          <p:cNvPr id="36" name="Text 32"/>
+          <p:cNvPr id="25" name="Text 21"/>
           <p:cNvSpPr txBox="1"/>
           <p:nvPr/>
         </p:nvSpPr>
         <p:spPr>
           <a:xfrm>
-            <a:off x="6606540" y="2761488"/>
-            <a:ext cx="4924044" cy="265176"/>
+            <a:off x="3456432" y="2926080"/>
+            <a:ext cx="3858768" cy="786384"/>
           </a:xfrm>
           <a:prstGeom prst="rect">
             <a:avLst/>
@@ -2046,11 +1971,15 @@
           <a:bodyPr wrap="square" lIns="0" tIns="0" rIns="0" bIns="0" rtlCol="0" anchor="ctr"/>
           <a:lstStyle/>
           <a:p>
-            <a:pPr indent="0" marL="0">
-              <a:buNone/>
-            </a:pPr>
-            <a:r>
-              <a:rPr lang="en-US" sz="1300" dirty="0">
+            <a:pPr marL="152400" indent="-152400">
+              <a:spcAft>
+                <a:spcPts val="300"/>
+              </a:spcAft>
+              <a:buSzPct val="100000"/>
+              <a:buChar char="•"/>
+            </a:pPr>
+            <a:r>
+              <a:rPr lang="en-US" sz="1150" dirty="0">
                 <a:solidFill>
                   <a:srgbClr val="1B2733"/>
                 </a:solidFill>
@@ -2058,32 +1987,76 @@
                 <a:ea typeface="Calibri" pitchFamily="34" charset="-122"/>
                 <a:cs typeface="Calibri" pitchFamily="34" charset="-120"/>
               </a:rPr>
-              <a:t>Presentación de resultados preliminares de Riesgo Específico</a:t>
-            </a:r>
-            <a:endParaRPr lang="en-US" sz="1300" dirty="0"/>
-          </a:p>
-        </p:txBody>
-      </p:sp>
-      <p:sp>
-        <p:nvSpPr>
-          <p:cNvPr id="37" name="Shape 33"/>
+              <a:t>Capacitación y Examen GIR 2026</a:t>
+            </a:r>
+            <a:endParaRPr lang="en-US" sz="1150" dirty="0"/>
+          </a:p>
+          <a:p>
+            <a:pPr marL="152400" indent="-152400">
+              <a:spcAft>
+                <a:spcPts val="300"/>
+              </a:spcAft>
+              <a:buSzPct val="100000"/>
+              <a:buChar char="•"/>
+            </a:pPr>
+            <a:r>
+              <a:rPr lang="en-US" sz="1150" dirty="0">
+                <a:solidFill>
+                  <a:srgbClr val="1B2733"/>
+                </a:solidFill>
+                <a:latin typeface="Calibri" pitchFamily="34" charset="0"/>
+                <a:ea typeface="Calibri" pitchFamily="34" charset="-122"/>
+                <a:cs typeface="Calibri" pitchFamily="34" charset="-120"/>
+              </a:rPr>
+              <a:t>Segunda prueba de continuidad de negocio</a:t>
+            </a:r>
+            <a:endParaRPr lang="en-US" sz="1150" dirty="0"/>
+          </a:p>
+          <a:p>
+            <a:pPr marL="152400" indent="-152400">
+              <a:spcAft>
+                <a:spcPts val="300"/>
+              </a:spcAft>
+              <a:buSzPct val="100000"/>
+              <a:buChar char="•"/>
+            </a:pPr>
+            <a:r>
+              <a:rPr lang="en-US" sz="1150" dirty="0">
+                <a:solidFill>
+                  <a:srgbClr val="1B2733"/>
+                </a:solidFill>
+                <a:latin typeface="Calibri" pitchFamily="34" charset="0"/>
+                <a:ea typeface="Calibri" pitchFamily="34" charset="-122"/>
+                <a:cs typeface="Calibri" pitchFamily="34" charset="-120"/>
+              </a:rPr>
+              <a:t>Opinión Fábrica de Créditos</a:t>
+            </a:r>
+            <a:endParaRPr lang="en-US" sz="1150" dirty="0"/>
+          </a:p>
+        </p:txBody>
+      </p:sp>
+      <p:sp>
+        <p:nvSpPr>
+          <p:cNvPr id="26" name="Shape 22"/>
           <p:cNvSpPr/>
           <p:nvPr/>
         </p:nvSpPr>
         <p:spPr>
           <a:xfrm>
-            <a:off x="6423660" y="3168396"/>
-            <a:ext cx="73152" cy="73152"/>
-          </a:xfrm>
-          <a:prstGeom prst="rect">
-            <a:avLst/>
-          </a:prstGeom>
-          <a:solidFill>
-            <a:srgbClr val="13507F"/>
+            <a:off x="7580376" y="2852928"/>
+            <a:ext cx="4151376" cy="932688"/>
+          </a:xfrm>
+          <a:prstGeom prst="roundRect">
+            <a:avLst>
+              <a:gd name="adj" fmla="val 9804"/>
+            </a:avLst>
+          </a:prstGeom>
+          <a:solidFill>
+            <a:srgbClr val="EEF2F7"/>
           </a:solidFill>
           <a:ln w="12700">
             <a:solidFill>
-              <a:srgbClr val="13507F"/>
+              <a:srgbClr val="EEF2F7"/>
             </a:solidFill>
             <a:prstDash val="solid"/>
           </a:ln>
@@ -2091,14 +2064,14 @@
       </p:sp>
       <p:sp>
         <p:nvSpPr>
-          <p:cNvPr id="38" name="Text 34"/>
+          <p:cNvPr id="27" name="Text 23"/>
           <p:cNvSpPr txBox="1"/>
           <p:nvPr/>
         </p:nvSpPr>
         <p:spPr>
           <a:xfrm>
-            <a:off x="6606540" y="3072384"/>
-            <a:ext cx="4924044" cy="265176"/>
+            <a:off x="7744968" y="2926080"/>
+            <a:ext cx="3858768" cy="786384"/>
           </a:xfrm>
           <a:prstGeom prst="rect">
             <a:avLst/>
@@ -2110,11 +2083,15 @@
           <a:bodyPr wrap="square" lIns="0" tIns="0" rIns="0" bIns="0" rtlCol="0" anchor="ctr"/>
           <a:lstStyle/>
           <a:p>
-            <a:pPr indent="0" marL="0">
-              <a:buNone/>
-            </a:pPr>
-            <a:r>
-              <a:rPr lang="en-US" sz="1300" dirty="0">
+            <a:pPr marL="152400" indent="-152400">
+              <a:spcAft>
+                <a:spcPts val="300"/>
+              </a:spcAft>
+              <a:buSzPct val="100000"/>
+              <a:buChar char="•"/>
+            </a:pPr>
+            <a:r>
+              <a:rPr lang="en-US" sz="1150" dirty="0">
                 <a:solidFill>
                   <a:srgbClr val="1B2733"/>
                 </a:solidFill>
@@ -2122,32 +2099,76 @@
                 <a:ea typeface="Calibri" pitchFamily="34" charset="-122"/>
                 <a:cs typeface="Calibri" pitchFamily="34" charset="-120"/>
               </a:rPr>
-              <a:t>Control de avalúos: asignación a perito y aviso a asociados</a:t>
-            </a:r>
-            <a:endParaRPr lang="en-US" sz="1300" dirty="0"/>
-          </a:p>
-        </p:txBody>
-      </p:sp>
-      <p:sp>
-        <p:nvSpPr>
-          <p:cNvPr id="39" name="Shape 35"/>
+              <a:t>Informe de la 2.ª prueba de continuidad (01/10/2026)</a:t>
+            </a:r>
+            <a:endParaRPr lang="en-US" sz="1150" dirty="0"/>
+          </a:p>
+          <a:p>
+            <a:pPr marL="152400" indent="-152400">
+              <a:spcAft>
+                <a:spcPts val="300"/>
+              </a:spcAft>
+              <a:buSzPct val="100000"/>
+              <a:buChar char="•"/>
+            </a:pPr>
+            <a:r>
+              <a:rPr lang="en-US" sz="1150" dirty="0">
+                <a:solidFill>
+                  <a:srgbClr val="1B2733"/>
+                </a:solidFill>
+                <a:latin typeface="Calibri" pitchFamily="34" charset="0"/>
+                <a:ea typeface="Calibri" pitchFamily="34" charset="-122"/>
+                <a:cs typeface="Calibri" pitchFamily="34" charset="-120"/>
+              </a:rPr>
+              <a:t>Seguimiento planes de acción – Matriz de Riesgos 2026</a:t>
+            </a:r>
+            <a:endParaRPr lang="en-US" sz="1150" dirty="0"/>
+          </a:p>
+          <a:p>
+            <a:pPr marL="152400" indent="-152400">
+              <a:spcAft>
+                <a:spcPts val="300"/>
+              </a:spcAft>
+              <a:buSzPct val="100000"/>
+              <a:buChar char="•"/>
+            </a:pPr>
+            <a:r>
+              <a:rPr lang="en-US" sz="1150" dirty="0">
+                <a:solidFill>
+                  <a:srgbClr val="1B2733"/>
+                </a:solidFill>
+                <a:latin typeface="Calibri" pitchFamily="34" charset="0"/>
+                <a:ea typeface="Calibri" pitchFamily="34" charset="-122"/>
+                <a:cs typeface="Calibri" pitchFamily="34" charset="-120"/>
+              </a:rPr>
+              <a:t>Eventos de riesgo: caídas de TC (25/09) y Orion (26/09)</a:t>
+            </a:r>
+            <a:endParaRPr lang="en-US" sz="1150" dirty="0"/>
+          </a:p>
+        </p:txBody>
+      </p:sp>
+      <p:sp>
+        <p:nvSpPr>
+          <p:cNvPr id="28" name="Shape 24"/>
           <p:cNvSpPr/>
           <p:nvPr/>
         </p:nvSpPr>
         <p:spPr>
           <a:xfrm>
-            <a:off x="6423660" y="3479292"/>
-            <a:ext cx="73152" cy="73152"/>
-          </a:xfrm>
-          <a:prstGeom prst="rect">
-            <a:avLst/>
-          </a:prstGeom>
-          <a:solidFill>
-            <a:srgbClr val="13507F"/>
+            <a:off x="457200" y="3877056"/>
+            <a:ext cx="2697480" cy="731520"/>
+          </a:xfrm>
+          <a:prstGeom prst="roundRect">
+            <a:avLst>
+              <a:gd name="adj" fmla="val 12500"/>
+            </a:avLst>
+          </a:prstGeom>
+          <a:solidFill>
+            <a:srgbClr val="0B2545"/>
           </a:solidFill>
           <a:ln w="12700">
             <a:solidFill>
-              <a:srgbClr val="13507F"/>
+              <a:srgbClr val="0B2545"/>
             </a:solidFill>
             <a:prstDash val="solid"/>
           </a:ln>
@@ -2155,150 +2176,32 @@
       </p:sp>
       <p:sp>
         <p:nvSpPr>
-          <p:cNvPr id="40" name="Text 36"/>
-          <p:cNvSpPr txBox="1"/>
-          <p:nvPr/>
-        </p:nvSpPr>
-        <p:spPr>
-          <a:xfrm>
-            <a:off x="6606540" y="3383280"/>
-            <a:ext cx="4924044" cy="265176"/>
-          </a:xfrm>
-          <a:prstGeom prst="rect">
-            <a:avLst/>
-          </a:prstGeom>
-          <a:noFill/>
-          <a:ln/>
-        </p:spPr>
-        <p:txBody>
-          <a:bodyPr wrap="square" lIns="0" tIns="0" rIns="0" bIns="0" rtlCol="0" anchor="ctr"/>
-          <a:lstStyle/>
-          <a:p>
-            <a:pPr indent="0" marL="0">
-              <a:buNone/>
-            </a:pPr>
-            <a:r>
-              <a:rPr lang="en-US" sz="1300" dirty="0">
-                <a:solidFill>
-                  <a:srgbClr val="1B2733"/>
-                </a:solidFill>
-                <a:latin typeface="Calibri" pitchFamily="34" charset="0"/>
-                <a:ea typeface="Calibri" pitchFamily="34" charset="-122"/>
-                <a:cs typeface="Calibri" pitchFamily="34" charset="-120"/>
-              </a:rPr>
-              <a:t>Acuerdos Semestrales del Comité de Riesgos y acta del 29/08</a:t>
-            </a:r>
-            <a:endParaRPr lang="en-US" sz="1300" dirty="0"/>
-          </a:p>
-        </p:txBody>
-      </p:sp>
-      <p:sp>
-        <p:nvSpPr>
-          <p:cNvPr id="41" name="Shape 37"/>
+          <p:cNvPr id="29" name="Shape 25"/>
           <p:cNvSpPr/>
           <p:nvPr/>
         </p:nvSpPr>
         <p:spPr>
           <a:xfrm>
-            <a:off x="457200" y="3968496"/>
-            <a:ext cx="5564124" cy="2432304"/>
-          </a:xfrm>
-          <a:prstGeom prst="roundRect">
-            <a:avLst>
-              <a:gd name="adj" fmla="val 4511"/>
-            </a:avLst>
-          </a:prstGeom>
-          <a:solidFill>
-            <a:srgbClr val="F1F5F9"/>
+            <a:off x="621792" y="4059936"/>
+            <a:ext cx="384048" cy="384048"/>
+          </a:xfrm>
+          <a:prstGeom prst="ellipse">
+            <a:avLst/>
+          </a:prstGeom>
+          <a:solidFill>
+            <a:srgbClr val="2B6CB0"/>
           </a:solidFill>
           <a:ln w="12700">
             <a:solidFill>
-              <a:srgbClr val="F1F5F9"/>
+              <a:srgbClr val="2B6CB0"/>
             </a:solidFill>
             <a:prstDash val="solid"/>
           </a:ln>
         </p:spPr>
       </p:sp>
-      <p:sp>
-        <p:nvSpPr>
-          <p:cNvPr id="42" name="Shape 38"/>
-          <p:cNvSpPr/>
-          <p:nvPr/>
-        </p:nvSpPr>
-        <p:spPr>
-          <a:xfrm>
-            <a:off x="457200" y="3968496"/>
-            <a:ext cx="5564124" cy="676656"/>
-          </a:xfrm>
-          <a:prstGeom prst="roundRect">
-            <a:avLst>
-              <a:gd name="adj" fmla="val 16216"/>
-            </a:avLst>
-          </a:prstGeom>
-          <a:solidFill>
-            <a:srgbClr val="0A7480"/>
-          </a:solidFill>
-          <a:ln w="12700">
-            <a:solidFill>
-              <a:srgbClr val="0A7480"/>
-            </a:solidFill>
-            <a:prstDash val="solid"/>
-          </a:ln>
-        </p:spPr>
-      </p:sp>
-      <p:sp>
-        <p:nvSpPr>
-          <p:cNvPr id="43" name="Shape 39"/>
-          <p:cNvSpPr/>
-          <p:nvPr/>
-        </p:nvSpPr>
-        <p:spPr>
-          <a:xfrm>
-            <a:off x="457200" y="4535424"/>
-            <a:ext cx="5564124" cy="182880"/>
-          </a:xfrm>
-          <a:prstGeom prst="rect">
-            <a:avLst/>
-          </a:prstGeom>
-          <a:solidFill>
-            <a:srgbClr val="F1F5F9"/>
-          </a:solidFill>
-          <a:ln w="12700">
-            <a:solidFill>
-              <a:srgbClr val="F1F5F9"/>
-            </a:solidFill>
-            <a:prstDash val="solid"/>
-          </a:ln>
-        </p:spPr>
-      </p:sp>
-      <p:sp>
-        <p:nvSpPr>
-          <p:cNvPr id="44" name="Shape 40"/>
-          <p:cNvSpPr/>
-          <p:nvPr/>
-        </p:nvSpPr>
-        <p:spPr>
-          <a:xfrm>
-            <a:off x="640080" y="4059936"/>
-            <a:ext cx="384048" cy="384048"/>
-          </a:xfrm>
-          <a:prstGeom prst="ellipse">
-            <a:avLst/>
-          </a:prstGeom>
-          <a:solidFill>
-            <a:srgbClr val="FFFFFF"/>
-          </a:solidFill>
-          <a:ln w="12700">
-            <a:solidFill>
-              <a:srgbClr val="FFFFFF"/>
-            </a:solidFill>
-            <a:prstDash val="solid"/>
-          </a:ln>
-        </p:spPr>
-      </p:sp>
       <p:pic>
         <p:nvPicPr>
-          <p:cNvPr id="45" name="Image 2" descr="preencoded.png">    </p:cNvPr>
+          <p:cNvPr id="30" name="Image 2" descr="preencoded.png">    </p:cNvPr>
           <p:cNvPicPr>
             <a:picLocks noChangeAspect="1"/>
           </p:cNvPicPr>
@@ -2312,8 +2215,8 @@
         </p:blipFill>
         <p:spPr>
           <a:xfrm>
-            <a:off x="731520" y="4151376"/>
-            <a:ext cx="201168" cy="201168"/>
+            <a:off x="722376" y="4160520"/>
+            <a:ext cx="182880" cy="182880"/>
           </a:xfrm>
           <a:prstGeom prst="rect">
             <a:avLst/>
@@ -2322,14 +2225,14 @@
       </p:pic>
       <p:sp>
         <p:nvSpPr>
-          <p:cNvPr id="46" name="Text 41"/>
+          <p:cNvPr id="31" name="Text 26"/>
           <p:cNvSpPr txBox="1"/>
           <p:nvPr/>
         </p:nvSpPr>
         <p:spPr>
           <a:xfrm>
-            <a:off x="1170432" y="4059936"/>
-            <a:ext cx="4695444" cy="384048"/>
+            <a:off x="1143000" y="3968496"/>
+            <a:ext cx="1920240" cy="566928"/>
           </a:xfrm>
           <a:prstGeom prst="rect">
             <a:avLst/>
@@ -2345,7 +2248,7 @@
               <a:buNone/>
             </a:pPr>
             <a:r>
-              <a:rPr lang="en-US" sz="1600" b="1" dirty="0">
+              <a:rPr lang="en-US" sz="1350" b="1" dirty="0">
                 <a:solidFill>
                   <a:srgbClr val="FFFFFF"/>
                 </a:solidFill>
@@ -2353,32 +2256,51 @@
                 <a:ea typeface="Calibri" pitchFamily="34" charset="-122"/>
                 <a:cs typeface="Calibri" pitchFamily="34" charset="-120"/>
               </a:rPr>
-              <a:t>Riesgo Financiero y Crediticio</a:t>
-            </a:r>
-            <a:endParaRPr lang="en-US" sz="1600" dirty="0"/>
-          </a:p>
-        </p:txBody>
-      </p:sp>
-      <p:sp>
-        <p:nvSpPr>
-          <p:cNvPr id="47" name="Shape 42"/>
+              <a:t>Cumplimiento Normativo</a:t>
+            </a:r>
+            <a:endParaRPr lang="en-US" sz="1350" dirty="0"/>
+          </a:p>
+          <a:p>
+            <a:pPr indent="0" marL="0">
+              <a:buNone/>
+            </a:pPr>
+            <a:r>
+              <a:rPr lang="en-US" sz="1050" dirty="0">
+                <a:solidFill>
+                  <a:srgbClr val="C9D6E6"/>
+                </a:solidFill>
+                <a:latin typeface="Calibri" pitchFamily="34" charset="0"/>
+                <a:ea typeface="Calibri" pitchFamily="34" charset="-122"/>
+                <a:cs typeface="Calibri" pitchFamily="34" charset="-120"/>
+              </a:rPr>
+              <a:t>Envíos y auditorías</a:t>
+            </a:r>
+            <a:endParaRPr lang="en-US" sz="1350" dirty="0"/>
+          </a:p>
+        </p:txBody>
+      </p:sp>
+      <p:sp>
+        <p:nvSpPr>
+          <p:cNvPr id="32" name="Shape 27"/>
           <p:cNvSpPr/>
           <p:nvPr/>
         </p:nvSpPr>
         <p:spPr>
           <a:xfrm>
-            <a:off x="713232" y="4832604"/>
-            <a:ext cx="73152" cy="73152"/>
-          </a:xfrm>
-          <a:prstGeom prst="rect">
-            <a:avLst/>
-          </a:prstGeom>
-          <a:solidFill>
-            <a:srgbClr val="0A7480"/>
+            <a:off x="3291840" y="3877056"/>
+            <a:ext cx="4151376" cy="731520"/>
+          </a:xfrm>
+          <a:prstGeom prst="roundRect">
+            <a:avLst>
+              <a:gd name="adj" fmla="val 12500"/>
+            </a:avLst>
+          </a:prstGeom>
+          <a:solidFill>
+            <a:srgbClr val="EEF2F7"/>
           </a:solidFill>
           <a:ln w="12700">
             <a:solidFill>
-              <a:srgbClr val="0A7480"/>
+              <a:srgbClr val="EEF2F7"/>
             </a:solidFill>
             <a:prstDash val="solid"/>
           </a:ln>
@@ -2386,14 +2308,14 @@
       </p:sp>
       <p:sp>
         <p:nvSpPr>
-          <p:cNvPr id="48" name="Text 43"/>
+          <p:cNvPr id="33" name="Text 28"/>
           <p:cNvSpPr txBox="1"/>
           <p:nvPr/>
         </p:nvSpPr>
         <p:spPr>
           <a:xfrm>
-            <a:off x="896112" y="4736592"/>
-            <a:ext cx="4924044" cy="265176"/>
+            <a:off x="3456432" y="3950208"/>
+            <a:ext cx="3858768" cy="585216"/>
           </a:xfrm>
           <a:prstGeom prst="rect">
             <a:avLst/>
@@ -2405,11 +2327,15 @@
           <a:bodyPr wrap="square" lIns="0" tIns="0" rIns="0" bIns="0" rtlCol="0" anchor="ctr"/>
           <a:lstStyle/>
           <a:p>
-            <a:pPr indent="0" marL="0">
-              <a:buNone/>
-            </a:pPr>
-            <a:r>
-              <a:rPr lang="en-US" sz="1300" dirty="0">
+            <a:pPr marL="152400" indent="-152400">
+              <a:spcAft>
+                <a:spcPts val="300"/>
+              </a:spcAft>
+              <a:buSzPct val="100000"/>
+              <a:buChar char="•"/>
+            </a:pPr>
+            <a:r>
+              <a:rPr lang="en-US" sz="1150" dirty="0">
                 <a:solidFill>
                   <a:srgbClr val="1B2733"/>
                 </a:solidFill>
@@ -2417,32 +2343,55 @@
                 <a:ea typeface="Calibri" pitchFamily="34" charset="-122"/>
                 <a:cs typeface="Calibri" pitchFamily="34" charset="-120"/>
               </a:rPr>
-              <a:t>Informes al Comité: riesgo de crédito, liquidez y mercado</a:t>
-            </a:r>
-            <a:endParaRPr lang="en-US" sz="1300" dirty="0"/>
-          </a:p>
-        </p:txBody>
-      </p:sp>
-      <p:sp>
-        <p:nvSpPr>
-          <p:cNvPr id="49" name="Shape 44"/>
+              <a:t>Auditoría Interna – Evaluación NRP-24</a:t>
+            </a:r>
+            <a:endParaRPr lang="en-US" sz="1150" dirty="0"/>
+          </a:p>
+          <a:p>
+            <a:pPr marL="152400" indent="-152400">
+              <a:spcAft>
+                <a:spcPts val="300"/>
+              </a:spcAft>
+              <a:buSzPct val="100000"/>
+              <a:buChar char="•"/>
+            </a:pPr>
+            <a:r>
+              <a:rPr lang="en-US" sz="1150" dirty="0">
+                <a:solidFill>
+                  <a:srgbClr val="1B2733"/>
+                </a:solidFill>
+                <a:latin typeface="Calibri" pitchFamily="34" charset="0"/>
+                <a:ea typeface="Calibri" pitchFamily="34" charset="-122"/>
+                <a:cs typeface="Calibri" pitchFamily="34" charset="-120"/>
+              </a:rPr>
+              <a:t>Auditoría Externa</a:t>
+            </a:r>
+            <a:endParaRPr lang="en-US" sz="1150" dirty="0"/>
+          </a:p>
+        </p:txBody>
+      </p:sp>
+      <p:sp>
+        <p:nvSpPr>
+          <p:cNvPr id="34" name="Shape 29"/>
           <p:cNvSpPr/>
           <p:nvPr/>
         </p:nvSpPr>
         <p:spPr>
           <a:xfrm>
-            <a:off x="713232" y="5143500"/>
-            <a:ext cx="73152" cy="73152"/>
-          </a:xfrm>
-          <a:prstGeom prst="rect">
-            <a:avLst/>
-          </a:prstGeom>
-          <a:solidFill>
-            <a:srgbClr val="0A7480"/>
+            <a:off x="7580376" y="3877056"/>
+            <a:ext cx="4151376" cy="731520"/>
+          </a:xfrm>
+          <a:prstGeom prst="roundRect">
+            <a:avLst>
+              <a:gd name="adj" fmla="val 12500"/>
+            </a:avLst>
+          </a:prstGeom>
+          <a:solidFill>
+            <a:srgbClr val="EEF2F7"/>
           </a:solidFill>
           <a:ln w="12700">
             <a:solidFill>
-              <a:srgbClr val="0A7480"/>
+              <a:srgbClr val="EEF2F7"/>
             </a:solidFill>
             <a:prstDash val="solid"/>
           </a:ln>
@@ -2450,14 +2399,14 @@
       </p:sp>
       <p:sp>
         <p:nvSpPr>
-          <p:cNvPr id="50" name="Text 45"/>
+          <p:cNvPr id="35" name="Text 30"/>
           <p:cNvSpPr txBox="1"/>
           <p:nvPr/>
         </p:nvSpPr>
         <p:spPr>
           <a:xfrm>
-            <a:off x="896112" y="5047488"/>
-            <a:ext cx="4924044" cy="265176"/>
+            <a:off x="7744968" y="3950208"/>
+            <a:ext cx="3858768" cy="585216"/>
           </a:xfrm>
           <a:prstGeom prst="rect">
             <a:avLst/>
@@ -2469,11 +2418,15 @@
           <a:bodyPr wrap="square" lIns="0" tIns="0" rIns="0" bIns="0" rtlCol="0" anchor="ctr"/>
           <a:lstStyle/>
           <a:p>
-            <a:pPr indent="0" marL="0">
-              <a:buNone/>
-            </a:pPr>
-            <a:r>
-              <a:rPr lang="en-US" sz="1300" dirty="0">
+            <a:pPr marL="152400" indent="-152400">
+              <a:spcAft>
+                <a:spcPts val="300"/>
+              </a:spcAft>
+              <a:buSzPct val="100000"/>
+              <a:buChar char="•"/>
+            </a:pPr>
+            <a:r>
+              <a:rPr lang="en-US" sz="1150" dirty="0">
                 <a:solidFill>
                   <a:srgbClr val="1B2733"/>
                 </a:solidFill>
@@ -2481,32 +2434,55 @@
                 <a:ea typeface="Calibri" pitchFamily="34" charset="-122"/>
                 <a:cs typeface="Calibri" pitchFamily="34" charset="-120"/>
               </a:rPr>
-              <a:t>Envíos SSF: NRP-05, NCB-022, Central de Riesgo, CTRI-RECR</a:t>
-            </a:r>
-            <a:endParaRPr lang="en-US" sz="1300" dirty="0"/>
-          </a:p>
-        </p:txBody>
-      </p:sp>
-      <p:sp>
-        <p:nvSpPr>
-          <p:cNvPr id="51" name="Shape 46"/>
+              <a:t>Información remitida a Auditoría Interna y Externa</a:t>
+            </a:r>
+            <a:endParaRPr lang="en-US" sz="1150" dirty="0"/>
+          </a:p>
+          <a:p>
+            <a:pPr marL="152400" indent="-152400">
+              <a:spcAft>
+                <a:spcPts val="300"/>
+              </a:spcAft>
+              <a:buSzPct val="100000"/>
+              <a:buChar char="•"/>
+            </a:pPr>
+            <a:r>
+              <a:rPr lang="en-US" sz="1150" dirty="0">
+                <a:solidFill>
+                  <a:srgbClr val="1B2733"/>
+                </a:solidFill>
+                <a:latin typeface="Calibri" pitchFamily="34" charset="0"/>
+                <a:ea typeface="Calibri" pitchFamily="34" charset="-122"/>
+                <a:cs typeface="Calibri" pitchFamily="34" charset="-120"/>
+              </a:rPr>
+              <a:t>Acuerdos Semestrales del Comité de Riesgos</a:t>
+            </a:r>
+            <a:endParaRPr lang="en-US" sz="1150" dirty="0"/>
+          </a:p>
+        </p:txBody>
+      </p:sp>
+      <p:sp>
+        <p:nvSpPr>
+          <p:cNvPr id="36" name="Shape 31"/>
           <p:cNvSpPr/>
           <p:nvPr/>
         </p:nvSpPr>
         <p:spPr>
           <a:xfrm>
-            <a:off x="713232" y="5454396"/>
-            <a:ext cx="73152" cy="73152"/>
-          </a:xfrm>
-          <a:prstGeom prst="rect">
-            <a:avLst/>
-          </a:prstGeom>
-          <a:solidFill>
-            <a:srgbClr val="0A7480"/>
+            <a:off x="457200" y="4700016"/>
+            <a:ext cx="2697480" cy="731520"/>
+          </a:xfrm>
+          <a:prstGeom prst="roundRect">
+            <a:avLst>
+              <a:gd name="adj" fmla="val 12500"/>
+            </a:avLst>
+          </a:prstGeom>
+          <a:solidFill>
+            <a:srgbClr val="0B2545"/>
           </a:solidFill>
           <a:ln w="12700">
             <a:solidFill>
-              <a:srgbClr val="0A7480"/>
+              <a:srgbClr val="0B2545"/>
             </a:solidFill>
             <a:prstDash val="solid"/>
           </a:ln>
@@ -2514,278 +2490,32 @@
       </p:sp>
       <p:sp>
         <p:nvSpPr>
-          <p:cNvPr id="52" name="Text 47"/>
-          <p:cNvSpPr txBox="1"/>
-          <p:nvPr/>
-        </p:nvSpPr>
-        <p:spPr>
-          <a:xfrm>
-            <a:off x="896112" y="5358384"/>
-            <a:ext cx="4924044" cy="265176"/>
-          </a:xfrm>
-          <a:prstGeom prst="rect">
-            <a:avLst/>
-          </a:prstGeom>
-          <a:noFill/>
-          <a:ln/>
-        </p:spPr>
-        <p:txBody>
-          <a:bodyPr wrap="square" lIns="0" tIns="0" rIns="0" bIns="0" rtlCol="0" anchor="ctr"/>
-          <a:lstStyle/>
-          <a:p>
-            <a:pPr indent="0" marL="0">
-              <a:buNone/>
-            </a:pPr>
-            <a:r>
-              <a:rPr lang="en-US" sz="1300" dirty="0">
-                <a:solidFill>
-                  <a:srgbClr val="1B2733"/>
-                </a:solidFill>
-                <a:latin typeface="Calibri" pitchFamily="34" charset="0"/>
-                <a:ea typeface="Calibri" pitchFamily="34" charset="-122"/>
-                <a:cs typeface="Calibri" pitchFamily="34" charset="-120"/>
-              </a:rPr>
-              <a:t>Cartera de tarjeta de crédito y reserva de saneamiento</a:t>
-            </a:r>
-            <a:endParaRPr lang="en-US" sz="1300" dirty="0"/>
-          </a:p>
-        </p:txBody>
-      </p:sp>
-      <p:sp>
-        <p:nvSpPr>
-          <p:cNvPr id="53" name="Shape 48"/>
+          <p:cNvPr id="37" name="Shape 32"/>
           <p:cNvSpPr/>
           <p:nvPr/>
         </p:nvSpPr>
         <p:spPr>
           <a:xfrm>
-            <a:off x="713232" y="5765292"/>
-            <a:ext cx="73152" cy="73152"/>
-          </a:xfrm>
-          <a:prstGeom prst="rect">
-            <a:avLst/>
-          </a:prstGeom>
-          <a:solidFill>
-            <a:srgbClr val="0A7480"/>
+            <a:off x="621792" y="4882896"/>
+            <a:ext cx="384048" cy="384048"/>
+          </a:xfrm>
+          <a:prstGeom prst="ellipse">
+            <a:avLst/>
+          </a:prstGeom>
+          <a:solidFill>
+            <a:srgbClr val="2B6CB0"/>
           </a:solidFill>
           <a:ln w="12700">
             <a:solidFill>
-              <a:srgbClr val="0A7480"/>
+              <a:srgbClr val="2B6CB0"/>
             </a:solidFill>
             <a:prstDash val="solid"/>
           </a:ln>
         </p:spPr>
       </p:sp>
-      <p:sp>
-        <p:nvSpPr>
-          <p:cNvPr id="54" name="Text 49"/>
-          <p:cNvSpPr txBox="1"/>
-          <p:nvPr/>
-        </p:nvSpPr>
-        <p:spPr>
-          <a:xfrm>
-            <a:off x="896112" y="5669280"/>
-            <a:ext cx="4924044" cy="265176"/>
-          </a:xfrm>
-          <a:prstGeom prst="rect">
-            <a:avLst/>
-          </a:prstGeom>
-          <a:noFill/>
-          <a:ln/>
-        </p:spPr>
-        <p:txBody>
-          <a:bodyPr wrap="square" lIns="0" tIns="0" rIns="0" bIns="0" rtlCol="0" anchor="ctr"/>
-          <a:lstStyle/>
-          <a:p>
-            <a:pPr indent="0" marL="0">
-              <a:buNone/>
-            </a:pPr>
-            <a:r>
-              <a:rPr lang="en-US" sz="1300" dirty="0">
-                <a:solidFill>
-                  <a:srgbClr val="1B2733"/>
-                </a:solidFill>
-                <a:latin typeface="Calibri" pitchFamily="34" charset="0"/>
-                <a:ea typeface="Calibri" pitchFamily="34" charset="-122"/>
-                <a:cs typeface="Calibri" pitchFamily="34" charset="-120"/>
-              </a:rPr>
-              <a:t>Traslados de deuda y segmentación de productos</a:t>
-            </a:r>
-            <a:endParaRPr lang="en-US" sz="1300" dirty="0"/>
-          </a:p>
-        </p:txBody>
-      </p:sp>
-      <p:sp>
-        <p:nvSpPr>
-          <p:cNvPr id="55" name="Shape 50"/>
-          <p:cNvSpPr/>
-          <p:nvPr/>
-        </p:nvSpPr>
-        <p:spPr>
-          <a:xfrm>
-            <a:off x="713232" y="6076188"/>
-            <a:ext cx="73152" cy="73152"/>
-          </a:xfrm>
-          <a:prstGeom prst="rect">
-            <a:avLst/>
-          </a:prstGeom>
-          <a:solidFill>
-            <a:srgbClr val="0A7480"/>
-          </a:solidFill>
-          <a:ln w="12700">
-            <a:solidFill>
-              <a:srgbClr val="0A7480"/>
-            </a:solidFill>
-            <a:prstDash val="solid"/>
-          </a:ln>
-        </p:spPr>
-      </p:sp>
-      <p:sp>
-        <p:nvSpPr>
-          <p:cNvPr id="56" name="Text 51"/>
-          <p:cNvSpPr txBox="1"/>
-          <p:nvPr/>
-        </p:nvSpPr>
-        <p:spPr>
-          <a:xfrm>
-            <a:off x="896112" y="5980176"/>
-            <a:ext cx="4924044" cy="265176"/>
-          </a:xfrm>
-          <a:prstGeom prst="rect">
-            <a:avLst/>
-          </a:prstGeom>
-          <a:noFill/>
-          <a:ln/>
-        </p:spPr>
-        <p:txBody>
-          <a:bodyPr wrap="square" lIns="0" tIns="0" rIns="0" bIns="0" rtlCol="0" anchor="ctr"/>
-          <a:lstStyle/>
-          <a:p>
-            <a:pPr indent="0" marL="0">
-              <a:buNone/>
-            </a:pPr>
-            <a:r>
-              <a:rPr lang="en-US" sz="1300" dirty="0">
-                <a:solidFill>
-                  <a:srgbClr val="1B2733"/>
-                </a:solidFill>
-                <a:latin typeface="Calibri" pitchFamily="34" charset="0"/>
-                <a:ea typeface="Calibri" pitchFamily="34" charset="-122"/>
-                <a:cs typeface="Calibri" pitchFamily="34" charset="-120"/>
-              </a:rPr>
-              <a:t>Largo plazo: Política de TC y sistema de créditos NRP-41</a:t>
-            </a:r>
-            <a:endParaRPr lang="en-US" sz="1300" dirty="0"/>
-          </a:p>
-        </p:txBody>
-      </p:sp>
-      <p:sp>
-        <p:nvSpPr>
-          <p:cNvPr id="57" name="Shape 52"/>
-          <p:cNvSpPr/>
-          <p:nvPr/>
-        </p:nvSpPr>
-        <p:spPr>
-          <a:xfrm>
-            <a:off x="6167628" y="3968496"/>
-            <a:ext cx="5564124" cy="2432304"/>
-          </a:xfrm>
-          <a:prstGeom prst="roundRect">
-            <a:avLst>
-              <a:gd name="adj" fmla="val 4511"/>
-            </a:avLst>
-          </a:prstGeom>
-          <a:solidFill>
-            <a:srgbClr val="F1F5F9"/>
-          </a:solidFill>
-          <a:ln w="12700">
-            <a:solidFill>
-              <a:srgbClr val="F1F5F9"/>
-            </a:solidFill>
-            <a:prstDash val="solid"/>
-          </a:ln>
-        </p:spPr>
-      </p:sp>
-      <p:sp>
-        <p:nvSpPr>
-          <p:cNvPr id="58" name="Shape 53"/>
-          <p:cNvSpPr/>
-          <p:nvPr/>
-        </p:nvSpPr>
-        <p:spPr>
-          <a:xfrm>
-            <a:off x="6167628" y="3968496"/>
-            <a:ext cx="5564124" cy="676656"/>
-          </a:xfrm>
-          <a:prstGeom prst="roundRect">
-            <a:avLst>
-              <a:gd name="adj" fmla="val 16216"/>
-            </a:avLst>
-          </a:prstGeom>
-          <a:solidFill>
-            <a:srgbClr val="2E4A73"/>
-          </a:solidFill>
-          <a:ln w="12700">
-            <a:solidFill>
-              <a:srgbClr val="2E4A73"/>
-            </a:solidFill>
-            <a:prstDash val="solid"/>
-          </a:ln>
-        </p:spPr>
-      </p:sp>
-      <p:sp>
-        <p:nvSpPr>
-          <p:cNvPr id="59" name="Shape 54"/>
-          <p:cNvSpPr/>
-          <p:nvPr/>
-        </p:nvSpPr>
-        <p:spPr>
-          <a:xfrm>
-            <a:off x="6167628" y="4535424"/>
-            <a:ext cx="5564124" cy="182880"/>
-          </a:xfrm>
-          <a:prstGeom prst="rect">
-            <a:avLst/>
-          </a:prstGeom>
-          <a:solidFill>
-            <a:srgbClr val="F1F5F9"/>
-          </a:solidFill>
-          <a:ln w="12700">
-            <a:solidFill>
-              <a:srgbClr val="F1F5F9"/>
-            </a:solidFill>
-            <a:prstDash val="solid"/>
-          </a:ln>
-        </p:spPr>
-      </p:sp>
-      <p:sp>
-        <p:nvSpPr>
-          <p:cNvPr id="60" name="Shape 55"/>
-          <p:cNvSpPr/>
-          <p:nvPr/>
-        </p:nvSpPr>
-        <p:spPr>
-          <a:xfrm>
-            <a:off x="6350508" y="4059936"/>
-            <a:ext cx="384048" cy="384048"/>
-          </a:xfrm>
-          <a:prstGeom prst="ellipse">
-            <a:avLst/>
-          </a:prstGeom>
-          <a:solidFill>
-            <a:srgbClr val="FFFFFF"/>
-          </a:solidFill>
-          <a:ln w="12700">
-            <a:solidFill>
-              <a:srgbClr val="FFFFFF"/>
-            </a:solidFill>
-            <a:prstDash val="solid"/>
-          </a:ln>
-        </p:spPr>
-      </p:sp>
       <p:pic>
         <p:nvPicPr>
-          <p:cNvPr id="61" name="Image 3" descr="preencoded.png">    </p:cNvPr>
+          <p:cNvPr id="38" name="Image 3" descr="preencoded.png">    </p:cNvPr>
           <p:cNvPicPr>
             <a:picLocks noChangeAspect="1"/>
           </p:cNvPicPr>
@@ -2799,8 +2529,8 @@
         </p:blipFill>
         <p:spPr>
           <a:xfrm>
-            <a:off x="6441948" y="4151376"/>
-            <a:ext cx="201168" cy="201168"/>
+            <a:off x="722376" y="4983480"/>
+            <a:ext cx="182880" cy="182880"/>
           </a:xfrm>
           <a:prstGeom prst="rect">
             <a:avLst/>
@@ -2809,14 +2539,14 @@
       </p:pic>
       <p:sp>
         <p:nvSpPr>
-          <p:cNvPr id="62" name="Text 56"/>
+          <p:cNvPr id="39" name="Text 33"/>
           <p:cNvSpPr txBox="1"/>
           <p:nvPr/>
         </p:nvSpPr>
         <p:spPr>
           <a:xfrm>
-            <a:off x="6880860" y="4059936"/>
-            <a:ext cx="4695444" cy="384048"/>
+            <a:off x="1143000" y="4791456"/>
+            <a:ext cx="1920240" cy="566928"/>
           </a:xfrm>
           <a:prstGeom prst="rect">
             <a:avLst/>
@@ -2832,7 +2562,7 @@
               <a:buNone/>
             </a:pPr>
             <a:r>
-              <a:rPr lang="en-US" sz="1600" b="1" dirty="0">
+              <a:rPr lang="en-US" sz="1350" b="1" dirty="0">
                 <a:solidFill>
                   <a:srgbClr val="FFFFFF"/>
                 </a:solidFill>
@@ -2840,32 +2570,51 @@
                 <a:ea typeface="Calibri" pitchFamily="34" charset="-122"/>
                 <a:cs typeface="Calibri" pitchFamily="34" charset="-120"/>
               </a:rPr>
-              <a:t>Proyectos y Coordinación</a:t>
-            </a:r>
-            <a:endParaRPr lang="en-US" sz="1600" dirty="0"/>
-          </a:p>
-        </p:txBody>
-      </p:sp>
-      <p:sp>
-        <p:nvSpPr>
-          <p:cNvPr id="63" name="Shape 57"/>
+              <a:t>Riesgos Financieros</a:t>
+            </a:r>
+            <a:endParaRPr lang="en-US" sz="1350" dirty="0"/>
+          </a:p>
+          <a:p>
+            <a:pPr indent="0" marL="0">
+              <a:buNone/>
+            </a:pPr>
+            <a:r>
+              <a:rPr lang="en-US" sz="1050" dirty="0">
+                <a:solidFill>
+                  <a:srgbClr val="C9D6E6"/>
+                </a:solidFill>
+                <a:latin typeface="Calibri" pitchFamily="34" charset="0"/>
+                <a:ea typeface="Calibri" pitchFamily="34" charset="-122"/>
+                <a:cs typeface="Calibri" pitchFamily="34" charset="-120"/>
+              </a:rPr>
+              <a:t>Crédito, liquidez y TC</a:t>
+            </a:r>
+            <a:endParaRPr lang="en-US" sz="1350" dirty="0"/>
+          </a:p>
+        </p:txBody>
+      </p:sp>
+      <p:sp>
+        <p:nvSpPr>
+          <p:cNvPr id="40" name="Shape 34"/>
           <p:cNvSpPr/>
           <p:nvPr/>
         </p:nvSpPr>
         <p:spPr>
           <a:xfrm>
-            <a:off x="6423660" y="4832604"/>
-            <a:ext cx="73152" cy="73152"/>
-          </a:xfrm>
-          <a:prstGeom prst="rect">
-            <a:avLst/>
-          </a:prstGeom>
-          <a:solidFill>
-            <a:srgbClr val="2E4A73"/>
+            <a:off x="3291840" y="4700016"/>
+            <a:ext cx="4151376" cy="731520"/>
+          </a:xfrm>
+          <a:prstGeom prst="roundRect">
+            <a:avLst>
+              <a:gd name="adj" fmla="val 12500"/>
+            </a:avLst>
+          </a:prstGeom>
+          <a:solidFill>
+            <a:srgbClr val="EEF2F7"/>
           </a:solidFill>
           <a:ln w="12700">
             <a:solidFill>
-              <a:srgbClr val="2E4A73"/>
+              <a:srgbClr val="EEF2F7"/>
             </a:solidFill>
             <a:prstDash val="solid"/>
           </a:ln>
@@ -2873,14 +2622,14 @@
       </p:sp>
       <p:sp>
         <p:nvSpPr>
-          <p:cNvPr id="64" name="Text 58"/>
+          <p:cNvPr id="41" name="Text 35"/>
           <p:cNvSpPr txBox="1"/>
           <p:nvPr/>
         </p:nvSpPr>
         <p:spPr>
           <a:xfrm>
-            <a:off x="6606540" y="4736592"/>
-            <a:ext cx="4924044" cy="265176"/>
+            <a:off x="3456432" y="4773168"/>
+            <a:ext cx="3858768" cy="585216"/>
           </a:xfrm>
           <a:prstGeom prst="rect">
             <a:avLst/>
@@ -2892,11 +2641,15 @@
           <a:bodyPr wrap="square" lIns="0" tIns="0" rIns="0" bIns="0" rtlCol="0" anchor="ctr"/>
           <a:lstStyle/>
           <a:p>
-            <a:pPr indent="0" marL="0">
-              <a:buNone/>
-            </a:pPr>
-            <a:r>
-              <a:rPr lang="en-US" sz="1300" dirty="0">
+            <a:pPr marL="152400" indent="-152400">
+              <a:spcAft>
+                <a:spcPts val="300"/>
+              </a:spcAft>
+              <a:buSzPct val="100000"/>
+              <a:buChar char="•"/>
+            </a:pPr>
+            <a:r>
+              <a:rPr lang="en-US" sz="1150" dirty="0">
                 <a:solidFill>
                   <a:srgbClr val="1B2733"/>
                 </a:solidFill>
@@ -2904,32 +2657,55 @@
                 <a:ea typeface="Calibri" pitchFamily="34" charset="-122"/>
                 <a:cs typeface="Calibri" pitchFamily="34" charset="-120"/>
               </a:rPr>
-              <a:t>Unificación de formularios Actualización de Datos y Conozca tu Cliente</a:t>
-            </a:r>
-            <a:endParaRPr lang="en-US" sz="1300" dirty="0"/>
-          </a:p>
-        </p:txBody>
-      </p:sp>
-      <p:sp>
-        <p:nvSpPr>
-          <p:cNvPr id="65" name="Shape 59"/>
+              <a:t>Actualización de Política de TC</a:t>
+            </a:r>
+            <a:endParaRPr lang="en-US" sz="1150" dirty="0"/>
+          </a:p>
+          <a:p>
+            <a:pPr marL="152400" indent="-152400">
+              <a:spcAft>
+                <a:spcPts val="300"/>
+              </a:spcAft>
+              <a:buSzPct val="100000"/>
+              <a:buChar char="•"/>
+            </a:pPr>
+            <a:r>
+              <a:rPr lang="en-US" sz="1150" dirty="0">
+                <a:solidFill>
+                  <a:srgbClr val="1B2733"/>
+                </a:solidFill>
+                <a:latin typeface="Calibri" pitchFamily="34" charset="0"/>
+                <a:ea typeface="Calibri" pitchFamily="34" charset="-122"/>
+                <a:cs typeface="Calibri" pitchFamily="34" charset="-120"/>
+              </a:rPr>
+              <a:t>Simulación de cartera vencida</a:t>
+            </a:r>
+            <a:endParaRPr lang="en-US" sz="1150" dirty="0"/>
+          </a:p>
+        </p:txBody>
+      </p:sp>
+      <p:sp>
+        <p:nvSpPr>
+          <p:cNvPr id="42" name="Shape 36"/>
           <p:cNvSpPr/>
           <p:nvPr/>
         </p:nvSpPr>
         <p:spPr>
           <a:xfrm>
-            <a:off x="6423660" y="5143500"/>
-            <a:ext cx="73152" cy="73152"/>
-          </a:xfrm>
-          <a:prstGeom prst="rect">
-            <a:avLst/>
-          </a:prstGeom>
-          <a:solidFill>
-            <a:srgbClr val="2E4A73"/>
+            <a:off x="7580376" y="4700016"/>
+            <a:ext cx="4151376" cy="731520"/>
+          </a:xfrm>
+          <a:prstGeom prst="roundRect">
+            <a:avLst>
+              <a:gd name="adj" fmla="val 12500"/>
+            </a:avLst>
+          </a:prstGeom>
+          <a:solidFill>
+            <a:srgbClr val="EEF2F7"/>
           </a:solidFill>
           <a:ln w="12700">
             <a:solidFill>
-              <a:srgbClr val="2E4A73"/>
+              <a:srgbClr val="EEF2F7"/>
             </a:solidFill>
             <a:prstDash val="solid"/>
           </a:ln>
@@ -2937,14 +2713,14 @@
       </p:sp>
       <p:sp>
         <p:nvSpPr>
-          <p:cNvPr id="66" name="Text 60"/>
+          <p:cNvPr id="43" name="Text 37"/>
           <p:cNvSpPr txBox="1"/>
           <p:nvPr/>
         </p:nvSpPr>
         <p:spPr>
           <a:xfrm>
-            <a:off x="6606540" y="5047488"/>
-            <a:ext cx="4924044" cy="265176"/>
+            <a:off x="7744968" y="4773168"/>
+            <a:ext cx="3858768" cy="585216"/>
           </a:xfrm>
           <a:prstGeom prst="rect">
             <a:avLst/>
@@ -2956,11 +2732,15 @@
           <a:bodyPr wrap="square" lIns="0" tIns="0" rIns="0" bIns="0" rtlCol="0" anchor="ctr"/>
           <a:lstStyle/>
           <a:p>
-            <a:pPr indent="0" marL="0">
-              <a:buNone/>
-            </a:pPr>
-            <a:r>
-              <a:rPr lang="en-US" sz="1300" dirty="0">
+            <a:pPr marL="152400" indent="-152400">
+              <a:spcAft>
+                <a:spcPts val="300"/>
+              </a:spcAft>
+              <a:buSzPct val="100000"/>
+              <a:buChar char="•"/>
+            </a:pPr>
+            <a:r>
+              <a:rPr lang="en-US" sz="1150" dirty="0">
                 <a:solidFill>
                   <a:srgbClr val="1B2733"/>
                 </a:solidFill>
@@ -2968,32 +2748,55 @@
                 <a:ea typeface="Calibri" pitchFamily="34" charset="-122"/>
                 <a:cs typeface="Calibri" pitchFamily="34" charset="-120"/>
               </a:rPr>
-              <a:t>Cuestionario para entrevistas BIA</a:t>
-            </a:r>
-            <a:endParaRPr lang="en-US" sz="1300" dirty="0"/>
-          </a:p>
-        </p:txBody>
-      </p:sp>
-      <p:sp>
-        <p:nvSpPr>
-          <p:cNvPr id="67" name="Shape 61"/>
+              <a:t>Informes al Comité: crédito, liquidez y mercado</a:t>
+            </a:r>
+            <a:endParaRPr lang="en-US" sz="1150" dirty="0"/>
+          </a:p>
+          <a:p>
+            <a:pPr marL="152400" indent="-152400">
+              <a:spcAft>
+                <a:spcPts val="300"/>
+              </a:spcAft>
+              <a:buSzPct val="100000"/>
+              <a:buChar char="•"/>
+            </a:pPr>
+            <a:r>
+              <a:rPr lang="en-US" sz="1150" dirty="0">
+                <a:solidFill>
+                  <a:srgbClr val="1B2733"/>
+                </a:solidFill>
+                <a:latin typeface="Calibri" pitchFamily="34" charset="0"/>
+                <a:ea typeface="Calibri" pitchFamily="34" charset="-122"/>
+                <a:cs typeface="Calibri" pitchFamily="34" charset="-120"/>
+              </a:rPr>
+              <a:t>Reserva de saneamiento y traslados de deuda</a:t>
+            </a:r>
+            <a:endParaRPr lang="en-US" sz="1150" dirty="0"/>
+          </a:p>
+        </p:txBody>
+      </p:sp>
+      <p:sp>
+        <p:nvSpPr>
+          <p:cNvPr id="44" name="Shape 38"/>
           <p:cNvSpPr/>
           <p:nvPr/>
         </p:nvSpPr>
         <p:spPr>
           <a:xfrm>
-            <a:off x="6423660" y="5454396"/>
-            <a:ext cx="73152" cy="73152"/>
-          </a:xfrm>
-          <a:prstGeom prst="rect">
-            <a:avLst/>
-          </a:prstGeom>
-          <a:solidFill>
-            <a:srgbClr val="2E4A73"/>
+            <a:off x="457200" y="5522976"/>
+            <a:ext cx="2697480" cy="731520"/>
+          </a:xfrm>
+          <a:prstGeom prst="roundRect">
+            <a:avLst>
+              <a:gd name="adj" fmla="val 12500"/>
+            </a:avLst>
+          </a:prstGeom>
+          <a:solidFill>
+            <a:srgbClr val="0B2545"/>
           </a:solidFill>
           <a:ln w="12700">
             <a:solidFill>
-              <a:srgbClr val="2E4A73"/>
+              <a:srgbClr val="0B2545"/>
             </a:solidFill>
             <a:prstDash val="solid"/>
           </a:ln>
@@ -3001,78 +2804,63 @@
       </p:sp>
       <p:sp>
         <p:nvSpPr>
-          <p:cNvPr id="68" name="Text 62"/>
-          <p:cNvSpPr txBox="1"/>
-          <p:nvPr/>
-        </p:nvSpPr>
-        <p:spPr>
-          <a:xfrm>
-            <a:off x="6606540" y="5358384"/>
-            <a:ext cx="4924044" cy="265176"/>
-          </a:xfrm>
-          <a:prstGeom prst="rect">
-            <a:avLst/>
-          </a:prstGeom>
-          <a:noFill/>
-          <a:ln/>
-        </p:spPr>
-        <p:txBody>
-          <a:bodyPr wrap="square" lIns="0" tIns="0" rIns="0" bIns="0" rtlCol="0" anchor="ctr"/>
-          <a:lstStyle/>
-          <a:p>
-            <a:pPr indent="0" marL="0">
-              <a:buNone/>
-            </a:pPr>
-            <a:r>
-              <a:rPr lang="en-US" sz="1300" dirty="0">
-                <a:solidFill>
-                  <a:srgbClr val="1B2733"/>
-                </a:solidFill>
-                <a:latin typeface="Calibri" pitchFamily="34" charset="0"/>
-                <a:ea typeface="Calibri" pitchFamily="34" charset="-122"/>
-                <a:cs typeface="Calibri" pitchFamily="34" charset="-120"/>
-              </a:rPr>
-              <a:t>Comparativos de políticas: tercerizados y gobierno corporativo</a:t>
-            </a:r>
-            <a:endParaRPr lang="en-US" sz="1300" dirty="0"/>
-          </a:p>
-        </p:txBody>
-      </p:sp>
-      <p:sp>
-        <p:nvSpPr>
-          <p:cNvPr id="69" name="Shape 63"/>
+          <p:cNvPr id="45" name="Shape 39"/>
           <p:cNvSpPr/>
           <p:nvPr/>
         </p:nvSpPr>
         <p:spPr>
           <a:xfrm>
-            <a:off x="6423660" y="5765292"/>
-            <a:ext cx="73152" cy="73152"/>
-          </a:xfrm>
-          <a:prstGeom prst="rect">
-            <a:avLst/>
-          </a:prstGeom>
-          <a:solidFill>
-            <a:srgbClr val="2E4A73"/>
+            <a:off x="621792" y="5705856"/>
+            <a:ext cx="384048" cy="384048"/>
+          </a:xfrm>
+          <a:prstGeom prst="ellipse">
+            <a:avLst/>
+          </a:prstGeom>
+          <a:solidFill>
+            <a:srgbClr val="2B6CB0"/>
           </a:solidFill>
           <a:ln w="12700">
             <a:solidFill>
-              <a:srgbClr val="2E4A73"/>
+              <a:srgbClr val="2B6CB0"/>
             </a:solidFill>
             <a:prstDash val="solid"/>
           </a:ln>
         </p:spPr>
       </p:sp>
-      <p:sp>
-        <p:nvSpPr>
-          <p:cNvPr id="70" name="Text 64"/>
+      <p:pic>
+        <p:nvPicPr>
+          <p:cNvPr id="46" name="Image 4" descr="preencoded.png">    </p:cNvPr>
+          <p:cNvPicPr>
+            <a:picLocks noChangeAspect="1"/>
+          </p:cNvPicPr>
+          <p:nvPr/>
+        </p:nvPicPr>
+        <p:blipFill>
+          <a:blip r:embed="rId5"/>
+          <a:stretch>
+            <a:fillRect/>
+          </a:stretch>
+        </p:blipFill>
+        <p:spPr>
+          <a:xfrm>
+            <a:off x="722376" y="5806440"/>
+            <a:ext cx="182880" cy="182880"/>
+          </a:xfrm>
+          <a:prstGeom prst="rect">
+            <a:avLst/>
+          </a:prstGeom>
+        </p:spPr>
+      </p:pic>
+      <p:sp>
+        <p:nvSpPr>
+          <p:cNvPr id="47" name="Text 40"/>
           <p:cNvSpPr txBox="1"/>
           <p:nvPr/>
         </p:nvSpPr>
         <p:spPr>
           <a:xfrm>
-            <a:off x="6606540" y="5669280"/>
-            <a:ext cx="4924044" cy="265176"/>
+            <a:off x="1143000" y="5614416"/>
+            <a:ext cx="1920240" cy="566928"/>
           </a:xfrm>
           <a:prstGeom prst="rect">
             <a:avLst/>
@@ -3088,40 +2876,59 @@
               <a:buNone/>
             </a:pPr>
             <a:r>
-              <a:rPr lang="en-US" sz="1300" dirty="0">
-                <a:solidFill>
-                  <a:srgbClr val="1B2733"/>
-                </a:solidFill>
-                <a:latin typeface="Calibri" pitchFamily="34" charset="0"/>
-                <a:ea typeface="Calibri" pitchFamily="34" charset="-122"/>
-                <a:cs typeface="Calibri" pitchFamily="34" charset="-120"/>
-              </a:rPr>
-              <a:t>Procesos: Matriz de Sistemas Informáticos y estructura del Depto.</a:t>
-            </a:r>
-            <a:endParaRPr lang="en-US" sz="1300" dirty="0"/>
-          </a:p>
-        </p:txBody>
-      </p:sp>
-      <p:sp>
-        <p:nvSpPr>
-          <p:cNvPr id="71" name="Shape 65"/>
+              <a:rPr lang="en-US" sz="1350" b="1" dirty="0">
+                <a:solidFill>
+                  <a:srgbClr val="FFFFFF"/>
+                </a:solidFill>
+                <a:latin typeface="Calibri" pitchFamily="34" charset="0"/>
+                <a:ea typeface="Calibri" pitchFamily="34" charset="-122"/>
+                <a:cs typeface="Calibri" pitchFamily="34" charset="-120"/>
+              </a:rPr>
+              <a:t>Avalúos y Proyectos</a:t>
+            </a:r>
+            <a:endParaRPr lang="en-US" sz="1350" dirty="0"/>
+          </a:p>
+          <a:p>
+            <a:pPr indent="0" marL="0">
+              <a:buNone/>
+            </a:pPr>
+            <a:r>
+              <a:rPr lang="en-US" sz="1050" dirty="0">
+                <a:solidFill>
+                  <a:srgbClr val="C9D6E6"/>
+                </a:solidFill>
+                <a:latin typeface="Calibri" pitchFamily="34" charset="0"/>
+                <a:ea typeface="Calibri" pitchFamily="34" charset="-122"/>
+                <a:cs typeface="Calibri" pitchFamily="34" charset="-120"/>
+              </a:rPr>
+              <a:t>Mejora institucional</a:t>
+            </a:r>
+            <a:endParaRPr lang="en-US" sz="1350" dirty="0"/>
+          </a:p>
+        </p:txBody>
+      </p:sp>
+      <p:sp>
+        <p:nvSpPr>
+          <p:cNvPr id="48" name="Shape 41"/>
           <p:cNvSpPr/>
           <p:nvPr/>
         </p:nvSpPr>
         <p:spPr>
           <a:xfrm>
-            <a:off x="6423660" y="6076188"/>
-            <a:ext cx="73152" cy="73152"/>
-          </a:xfrm>
-          <a:prstGeom prst="rect">
-            <a:avLst/>
-          </a:prstGeom>
-          <a:solidFill>
-            <a:srgbClr val="2E4A73"/>
+            <a:off x="3291840" y="5522976"/>
+            <a:ext cx="4151376" cy="731520"/>
+          </a:xfrm>
+          <a:prstGeom prst="roundRect">
+            <a:avLst>
+              <a:gd name="adj" fmla="val 12500"/>
+            </a:avLst>
+          </a:prstGeom>
+          <a:solidFill>
+            <a:srgbClr val="EEF2F7"/>
           </a:solidFill>
           <a:ln w="12700">
             <a:solidFill>
-              <a:srgbClr val="2E4A73"/>
+              <a:srgbClr val="EEF2F7"/>
             </a:solidFill>
             <a:prstDash val="solid"/>
           </a:ln>
@@ -3129,14 +2936,14 @@
       </p:sp>
       <p:sp>
         <p:nvSpPr>
-          <p:cNvPr id="72" name="Text 66"/>
+          <p:cNvPr id="49" name="Text 42"/>
           <p:cNvSpPr txBox="1"/>
           <p:nvPr/>
         </p:nvSpPr>
         <p:spPr>
           <a:xfrm>
-            <a:off x="6606540" y="5980176"/>
-            <a:ext cx="4924044" cy="265176"/>
+            <a:off x="3456432" y="5596128"/>
+            <a:ext cx="3858768" cy="585216"/>
           </a:xfrm>
           <a:prstGeom prst="rect">
             <a:avLst/>
@@ -3148,11 +2955,15 @@
           <a:bodyPr wrap="square" lIns="0" tIns="0" rIns="0" bIns="0" rtlCol="0" anchor="ctr"/>
           <a:lstStyle/>
           <a:p>
-            <a:pPr indent="0" marL="0">
-              <a:buNone/>
-            </a:pPr>
-            <a:r>
-              <a:rPr lang="en-US" sz="1300" dirty="0">
+            <a:pPr marL="152400" indent="-152400">
+              <a:spcAft>
+                <a:spcPts val="300"/>
+              </a:spcAft>
+              <a:buSzPct val="100000"/>
+              <a:buChar char="•"/>
+            </a:pPr>
+            <a:r>
+              <a:rPr lang="en-US" sz="1150" dirty="0">
                 <a:solidFill>
                   <a:srgbClr val="1B2733"/>
                 </a:solidFill>
@@ -3160,15 +2971,127 @@
                 <a:ea typeface="Calibri" pitchFamily="34" charset="-122"/>
                 <a:cs typeface="Calibri" pitchFamily="34" charset="-120"/>
               </a:rPr>
-              <a:t>Información para Auditoría Interna (NRP-24) y Auditoría Externa</a:t>
-            </a:r>
-            <a:endParaRPr lang="en-US" sz="1300" dirty="0"/>
-          </a:p>
-        </p:txBody>
-      </p:sp>
-      <p:sp>
-        <p:nvSpPr>
-          <p:cNvPr id="73" name="Text 67"/>
+              <a:t>Revisión de Política y Procedimientos de Avalúos</a:t>
+            </a:r>
+            <a:endParaRPr lang="en-US" sz="1150" dirty="0"/>
+          </a:p>
+          <a:p>
+            <a:pPr marL="152400" indent="-152400">
+              <a:spcAft>
+                <a:spcPts val="300"/>
+              </a:spcAft>
+              <a:buSzPct val="100000"/>
+              <a:buChar char="•"/>
+            </a:pPr>
+            <a:r>
+              <a:rPr lang="en-US" sz="1150" dirty="0">
+                <a:solidFill>
+                  <a:srgbClr val="1B2733"/>
+                </a:solidFill>
+                <a:latin typeface="Calibri" pitchFamily="34" charset="0"/>
+                <a:ea typeface="Calibri" pitchFamily="34" charset="-122"/>
+                <a:cs typeface="Calibri" pitchFamily="34" charset="-120"/>
+              </a:rPr>
+              <a:t>Revisión de Perfil de Revisor</a:t>
+            </a:r>
+            <a:endParaRPr lang="en-US" sz="1150" dirty="0"/>
+          </a:p>
+        </p:txBody>
+      </p:sp>
+      <p:sp>
+        <p:nvSpPr>
+          <p:cNvPr id="50" name="Shape 43"/>
+          <p:cNvSpPr/>
+          <p:nvPr/>
+        </p:nvSpPr>
+        <p:spPr>
+          <a:xfrm>
+            <a:off x="7580376" y="5522976"/>
+            <a:ext cx="4151376" cy="731520"/>
+          </a:xfrm>
+          <a:prstGeom prst="roundRect">
+            <a:avLst>
+              <a:gd name="adj" fmla="val 12500"/>
+            </a:avLst>
+          </a:prstGeom>
+          <a:solidFill>
+            <a:srgbClr val="EEF2F7"/>
+          </a:solidFill>
+          <a:ln w="12700">
+            <a:solidFill>
+              <a:srgbClr val="EEF2F7"/>
+            </a:solidFill>
+            <a:prstDash val="solid"/>
+          </a:ln>
+        </p:spPr>
+      </p:sp>
+      <p:sp>
+        <p:nvSpPr>
+          <p:cNvPr id="51" name="Text 44"/>
+          <p:cNvSpPr txBox="1"/>
+          <p:nvPr/>
+        </p:nvSpPr>
+        <p:spPr>
+          <a:xfrm>
+            <a:off x="7744968" y="5596128"/>
+            <a:ext cx="3858768" cy="585216"/>
+          </a:xfrm>
+          <a:prstGeom prst="rect">
+            <a:avLst/>
+          </a:prstGeom>
+          <a:noFill/>
+          <a:ln/>
+        </p:spPr>
+        <p:txBody>
+          <a:bodyPr wrap="square" lIns="0" tIns="0" rIns="0" bIns="0" rtlCol="0" anchor="ctr"/>
+          <a:lstStyle/>
+          <a:p>
+            <a:pPr marL="152400" indent="-152400">
+              <a:spcAft>
+                <a:spcPts val="300"/>
+              </a:spcAft>
+              <a:buSzPct val="100000"/>
+              <a:buChar char="•"/>
+            </a:pPr>
+            <a:r>
+              <a:rPr lang="en-US" sz="1150" dirty="0">
+                <a:solidFill>
+                  <a:srgbClr val="1B2733"/>
+                </a:solidFill>
+                <a:latin typeface="Calibri" pitchFamily="34" charset="0"/>
+                <a:ea typeface="Calibri" pitchFamily="34" charset="-122"/>
+                <a:cs typeface="Calibri" pitchFamily="34" charset="-120"/>
+              </a:rPr>
+              <a:t>Avalúos: asignación a perito y aviso a asociados</a:t>
+            </a:r>
+            <a:endParaRPr lang="en-US" sz="1150" dirty="0"/>
+          </a:p>
+          <a:p>
+            <a:pPr marL="152400" indent="-152400">
+              <a:spcAft>
+                <a:spcPts val="300"/>
+              </a:spcAft>
+              <a:buSzPct val="100000"/>
+              <a:buChar char="•"/>
+            </a:pPr>
+            <a:r>
+              <a:rPr lang="en-US" sz="1150" dirty="0">
+                <a:solidFill>
+                  <a:srgbClr val="1B2733"/>
+                </a:solidFill>
+                <a:latin typeface="Calibri" pitchFamily="34" charset="0"/>
+                <a:ea typeface="Calibri" pitchFamily="34" charset="-122"/>
+                <a:cs typeface="Calibri" pitchFamily="34" charset="-120"/>
+              </a:rPr>
+              <a:t>Cuestionario BIA y comparativos de políticas</a:t>
+            </a:r>
+            <a:endParaRPr lang="en-US" sz="1150" dirty="0"/>
+          </a:p>
+        </p:txBody>
+      </p:sp>
+      <p:sp>
+        <p:nvSpPr>
+          <p:cNvPr id="52" name="Text 45"/>
           <p:cNvSpPr txBox="1"/>
           <p:nvPr/>
         </p:nvSpPr>
@@ -3199,7 +3122,7 @@
                 <a:ea typeface="Calibri" pitchFamily="34" charset="-122"/>
                 <a:cs typeface="Calibri" pitchFamily="34" charset="-120"/>
               </a:rPr>
-              <a:t>Fuente: documento de actividades semanales.</a:t>
+              <a:t>«En seguimiento»: asuntos del informe anterior que siguen vigentes. «Actividades de la semana»: documento de actividades semanales.</a:t>
             </a:r>
             <a:endParaRPr lang="en-US" sz="900" dirty="0"/>
           </a:p>

</xml_diff>

<commit_message>
Slide 1: organize rows by the weekly-activities document sections
Co-Authored-By: Claude Opus 5.5 <noreply@anthropic.com>
Claude-Session: https://claude.ai/code/session_01QGTe9h3kfUS6BTZosfrxzF
</commit_message>
<xml_diff>
--- a/resumen-ejecutivo-semanal/Resumen_Ejecutivo_Riesgos_COMEDICA_2_Slides.pptx
+++ b/resumen-ejecutivo-semanal/Resumen_Ejecutivo_Riesgos_COMEDICA_2_Slides.pptx
@@ -1182,12 +1182,12 @@
         </p:nvSpPr>
         <p:spPr>
           <a:xfrm>
-            <a:off x="457200" y="1645920"/>
-            <a:ext cx="2697480" cy="1115568"/>
+            <a:off x="457200" y="1627632"/>
+            <a:ext cx="2697480" cy="1051560"/>
           </a:xfrm>
           <a:prstGeom prst="roundRect">
             <a:avLst>
-              <a:gd name="adj" fmla="val 8197"/>
+              <a:gd name="adj" fmla="val 8696"/>
             </a:avLst>
           </a:prstGeom>
           <a:solidFill>
@@ -1209,7 +1209,7 @@
         </p:nvSpPr>
         <p:spPr>
           <a:xfrm>
-            <a:off x="621792" y="2020824"/>
+            <a:off x="621792" y="1970532"/>
             <a:ext cx="384048" cy="384048"/>
           </a:xfrm>
           <a:prstGeom prst="ellipse">
@@ -1242,7 +1242,7 @@
         </p:blipFill>
         <p:spPr>
           <a:xfrm>
-            <a:off x="722376" y="2121408"/>
+            <a:off x="722376" y="2071116"/>
             <a:ext cx="182880" cy="182880"/>
           </a:xfrm>
           <a:prstGeom prst="rect">
@@ -1258,7 +1258,7 @@
         </p:nvSpPr>
         <p:spPr>
           <a:xfrm>
-            <a:off x="1143000" y="1929384"/>
+            <a:off x="1143000" y="1879092"/>
             <a:ext cx="1920240" cy="566928"/>
           </a:xfrm>
           <a:prstGeom prst="rect">
@@ -1314,12 +1314,12 @@
         </p:nvSpPr>
         <p:spPr>
           <a:xfrm>
-            <a:off x="3291840" y="1645920"/>
-            <a:ext cx="4151376" cy="1115568"/>
+            <a:off x="3291840" y="1627632"/>
+            <a:ext cx="4151376" cy="1051560"/>
           </a:xfrm>
           <a:prstGeom prst="roundRect">
             <a:avLst>
-              <a:gd name="adj" fmla="val 8197"/>
+              <a:gd name="adj" fmla="val 8696"/>
             </a:avLst>
           </a:prstGeom>
           <a:solidFill>
@@ -1341,8 +1341,8 @@
         </p:nvSpPr>
         <p:spPr>
           <a:xfrm>
-            <a:off x="3456432" y="1719072"/>
-            <a:ext cx="3858768" cy="969264"/>
+            <a:off x="3456432" y="1700784"/>
+            <a:ext cx="3858768" cy="905256"/>
           </a:xfrm>
           <a:prstGeom prst="rect">
             <a:avLst/>
@@ -1555,12 +1555,12 @@
         </p:nvSpPr>
         <p:spPr>
           <a:xfrm>
-            <a:off x="7580376" y="1645920"/>
-            <a:ext cx="4151376" cy="1115568"/>
+            <a:off x="7580376" y="1627632"/>
+            <a:ext cx="4151376" cy="1051560"/>
           </a:xfrm>
           <a:prstGeom prst="roundRect">
             <a:avLst>
-              <a:gd name="adj" fmla="val 8197"/>
+              <a:gd name="adj" fmla="val 8696"/>
             </a:avLst>
           </a:prstGeom>
           <a:solidFill>
@@ -1582,8 +1582,8 @@
         </p:nvSpPr>
         <p:spPr>
           <a:xfrm>
-            <a:off x="7744968" y="1719072"/>
-            <a:ext cx="3858768" cy="969264"/>
+            <a:off x="7744968" y="1700784"/>
+            <a:ext cx="3858768" cy="905256"/>
           </a:xfrm>
           <a:prstGeom prst="rect">
             <a:avLst/>
@@ -1597,13 +1597,13 @@
           <a:p>
             <a:pPr marL="152400" indent="-152400">
               <a:spcAft>
-                <a:spcPts val="300"/>
+                <a:spcPts val="200"/>
               </a:spcAft>
               <a:buSzPct val="100000"/>
               <a:buChar char="•"/>
             </a:pPr>
             <a:r>
-              <a:rPr lang="en-US" sz="1150" dirty="0">
+              <a:rPr lang="en-US" sz="1100" dirty="0">
                 <a:solidFill>
                   <a:srgbClr val="1B2733"/>
                 </a:solidFill>
@@ -1611,20 +1611,20 @@
                 <a:ea typeface="Calibri" pitchFamily="34" charset="-122"/>
                 <a:cs typeface="Calibri" pitchFamily="34" charset="-120"/>
               </a:rPr>
-              <a:t>Matriz y requerimiento a áreas – Gob. Corporativo (22741)</a:t>
-            </a:r>
-            <a:endParaRPr lang="en-US" sz="1150" dirty="0"/>
+              <a:t>Matriz y requerimiento a áreas – nota 22741</a:t>
+            </a:r>
+            <a:endParaRPr lang="en-US" sz="1100" dirty="0"/>
           </a:p>
           <a:p>
             <a:pPr marL="152400" indent="-152400">
               <a:spcAft>
-                <a:spcPts val="300"/>
+                <a:spcPts val="200"/>
               </a:spcAft>
               <a:buSzPct val="100000"/>
               <a:buChar char="•"/>
             </a:pPr>
             <a:r>
-              <a:rPr lang="en-US" sz="1150" dirty="0">
+              <a:rPr lang="en-US" sz="1100" dirty="0">
                 <a:solidFill>
                   <a:srgbClr val="1B2733"/>
                 </a:solidFill>
@@ -1632,20 +1632,20 @@
                 <a:ea typeface="Calibri" pitchFamily="34" charset="-122"/>
                 <a:cs typeface="Calibri" pitchFamily="34" charset="-120"/>
               </a:rPr>
-              <a:t>Seguimiento de pruebas de descargo (22741 y 23486)</a:t>
-            </a:r>
-            <a:endParaRPr lang="en-US" sz="1150" dirty="0"/>
+              <a:t>Pruebas de descargo – notas 22741 y 23486</a:t>
+            </a:r>
+            <a:endParaRPr lang="en-US" sz="1100" dirty="0"/>
           </a:p>
           <a:p>
             <a:pPr marL="152400" indent="-152400">
               <a:spcAft>
-                <a:spcPts val="300"/>
+                <a:spcPts val="200"/>
               </a:spcAft>
               <a:buSzPct val="100000"/>
               <a:buChar char="•"/>
             </a:pPr>
             <a:r>
-              <a:rPr lang="en-US" sz="1150" dirty="0">
+              <a:rPr lang="en-US" sz="1100" dirty="0">
                 <a:solidFill>
                   <a:srgbClr val="1B2733"/>
                 </a:solidFill>
@@ -1653,9 +1653,30 @@
                 <a:ea typeface="Calibri" pitchFamily="34" charset="-122"/>
                 <a:cs typeface="Calibri" pitchFamily="34" charset="-120"/>
               </a:rPr>
-              <a:t>Presentación de resultados preliminares de Riesgo Específico</a:t>
-            </a:r>
-            <a:endParaRPr lang="en-US" sz="1150" dirty="0"/>
+              <a:t>Presentación visita de supervisión Gob. Corporativo</a:t>
+            </a:r>
+            <a:endParaRPr lang="en-US" sz="1100" dirty="0"/>
+          </a:p>
+          <a:p>
+            <a:pPr marL="152400" indent="-152400">
+              <a:spcAft>
+                <a:spcPts val="200"/>
+              </a:spcAft>
+              <a:buSzPct val="100000"/>
+              <a:buChar char="•"/>
+            </a:pPr>
+            <a:r>
+              <a:rPr lang="en-US" sz="1100" dirty="0">
+                <a:solidFill>
+                  <a:srgbClr val="1B2733"/>
+                </a:solidFill>
+                <a:latin typeface="Calibri" pitchFamily="34" charset="0"/>
+                <a:ea typeface="Calibri" pitchFamily="34" charset="-122"/>
+                <a:cs typeface="Calibri" pitchFamily="34" charset="-120"/>
+              </a:rPr>
+              <a:t>Resultados preliminares de Riesgo Específico</a:t>
+            </a:r>
+            <a:endParaRPr lang="en-US" sz="1100" dirty="0"/>
           </a:p>
         </p:txBody>
       </p:sp>
@@ -1667,12 +1688,12 @@
         </p:nvSpPr>
         <p:spPr>
           <a:xfrm>
-            <a:off x="457200" y="2852928"/>
-            <a:ext cx="2697480" cy="932688"/>
+            <a:off x="457200" y="2761488"/>
+            <a:ext cx="2697480" cy="1170432"/>
           </a:xfrm>
           <a:prstGeom prst="roundRect">
             <a:avLst>
-              <a:gd name="adj" fmla="val 9804"/>
+              <a:gd name="adj" fmla="val 7813"/>
             </a:avLst>
           </a:prstGeom>
           <a:solidFill>
@@ -1694,7 +1715,7 @@
         </p:nvSpPr>
         <p:spPr>
           <a:xfrm>
-            <a:off x="621792" y="2935224"/>
+            <a:off x="621792" y="2962656"/>
             <a:ext cx="384048" cy="384048"/>
           </a:xfrm>
           <a:prstGeom prst="ellipse">
@@ -1727,7 +1748,7 @@
         </p:blipFill>
         <p:spPr>
           <a:xfrm>
-            <a:off x="722376" y="3035808"/>
+            <a:off x="722376" y="3063240"/>
             <a:ext cx="182880" cy="182880"/>
           </a:xfrm>
           <a:prstGeom prst="rect">
@@ -1743,7 +1764,7 @@
         </p:nvSpPr>
         <p:spPr>
           <a:xfrm>
-            <a:off x="1143000" y="2843784"/>
+            <a:off x="1143000" y="2871216"/>
             <a:ext cx="1920240" cy="566928"/>
           </a:xfrm>
           <a:prstGeom prst="rect">
@@ -1768,7 +1789,7 @@
                 <a:ea typeface="Calibri" pitchFamily="34" charset="-122"/>
                 <a:cs typeface="Calibri" pitchFamily="34" charset="-120"/>
               </a:rPr>
-              <a:t>Riesgos No Financieros</a:t>
+              <a:t>Riesgo Operacional</a:t>
             </a:r>
             <a:endParaRPr lang="en-US" sz="1350" dirty="0"/>
           </a:p>
@@ -1785,7 +1806,7 @@
                 <a:ea typeface="Calibri" pitchFamily="34" charset="-122"/>
                 <a:cs typeface="Calibri" pitchFamily="34" charset="-120"/>
               </a:rPr>
-              <a:t>Riesgo Operacional</a:t>
+              <a:t>Continuidad y control</a:t>
             </a:r>
             <a:endParaRPr lang="en-US" sz="1350" dirty="0"/>
           </a:p>
@@ -1799,7 +1820,7 @@
         </p:nvSpPr>
         <p:spPr>
           <a:xfrm>
-            <a:off x="621792" y="3374136"/>
+            <a:off x="621792" y="3401568"/>
             <a:ext cx="1463040" cy="182880"/>
           </a:xfrm>
           <a:prstGeom prst="rect">
@@ -1838,7 +1859,7 @@
         </p:nvSpPr>
         <p:spPr>
           <a:xfrm>
-            <a:off x="621792" y="3593592"/>
+            <a:off x="621792" y="3621024"/>
             <a:ext cx="1828800" cy="100584"/>
           </a:xfrm>
           <a:prstGeom prst="roundRect">
@@ -1865,7 +1886,7 @@
         </p:nvSpPr>
         <p:spPr>
           <a:xfrm>
-            <a:off x="621792" y="3593592"/>
+            <a:off x="621792" y="3621024"/>
             <a:ext cx="1645920" cy="100584"/>
           </a:xfrm>
           <a:prstGeom prst="roundRect">
@@ -1892,7 +1913,7 @@
         </p:nvSpPr>
         <p:spPr>
           <a:xfrm>
-            <a:off x="2496312" y="3483864"/>
+            <a:off x="2496312" y="3511296"/>
             <a:ext cx="548640" cy="310896"/>
           </a:xfrm>
           <a:prstGeom prst="rect">
@@ -1931,12 +1952,12 @@
         </p:nvSpPr>
         <p:spPr>
           <a:xfrm>
-            <a:off x="3291840" y="2852928"/>
-            <a:ext cx="4151376" cy="932688"/>
+            <a:off x="3291840" y="2761488"/>
+            <a:ext cx="4151376" cy="1170432"/>
           </a:xfrm>
           <a:prstGeom prst="roundRect">
             <a:avLst>
-              <a:gd name="adj" fmla="val 9804"/>
+              <a:gd name="adj" fmla="val 7813"/>
             </a:avLst>
           </a:prstGeom>
           <a:solidFill>
@@ -1958,8 +1979,8 @@
         </p:nvSpPr>
         <p:spPr>
           <a:xfrm>
-            <a:off x="3456432" y="2926080"/>
-            <a:ext cx="3858768" cy="786384"/>
+            <a:off x="3456432" y="2834640"/>
+            <a:ext cx="3858768" cy="1024128"/>
           </a:xfrm>
           <a:prstGeom prst="rect">
             <a:avLst/>
@@ -1973,13 +1994,13 @@
           <a:p>
             <a:pPr marL="152400" indent="-152400">
               <a:spcAft>
-                <a:spcPts val="300"/>
+                <a:spcPts val="200"/>
               </a:spcAft>
               <a:buSzPct val="100000"/>
               <a:buChar char="•"/>
             </a:pPr>
             <a:r>
-              <a:rPr lang="en-US" sz="1150" dirty="0">
+              <a:rPr lang="en-US" sz="1100" dirty="0">
                 <a:solidFill>
                   <a:srgbClr val="1B2733"/>
                 </a:solidFill>
@@ -1987,20 +2008,20 @@
                 <a:ea typeface="Calibri" pitchFamily="34" charset="-122"/>
                 <a:cs typeface="Calibri" pitchFamily="34" charset="-120"/>
               </a:rPr>
-              <a:t>Capacitación y Examen GIR 2026</a:t>
-            </a:r>
-            <a:endParaRPr lang="en-US" sz="1150" dirty="0"/>
+              <a:t>Actualización Matriz BIA</a:t>
+            </a:r>
+            <a:endParaRPr lang="en-US" sz="1100" dirty="0"/>
           </a:p>
           <a:p>
             <a:pPr marL="152400" indent="-152400">
               <a:spcAft>
-                <a:spcPts val="300"/>
+                <a:spcPts val="200"/>
               </a:spcAft>
               <a:buSzPct val="100000"/>
               <a:buChar char="•"/>
             </a:pPr>
             <a:r>
-              <a:rPr lang="en-US" sz="1150" dirty="0">
+              <a:rPr lang="en-US" sz="1100" dirty="0">
                 <a:solidFill>
                   <a:srgbClr val="1B2733"/>
                 </a:solidFill>
@@ -2008,20 +2029,20 @@
                 <a:ea typeface="Calibri" pitchFamily="34" charset="-122"/>
                 <a:cs typeface="Calibri" pitchFamily="34" charset="-120"/>
               </a:rPr>
-              <a:t>Segunda prueba de continuidad de negocio</a:t>
-            </a:r>
-            <a:endParaRPr lang="en-US" sz="1150" dirty="0"/>
+              <a:t>Indicadores de Gob. Corporativo y Reputacional</a:t>
+            </a:r>
+            <a:endParaRPr lang="en-US" sz="1100" dirty="0"/>
           </a:p>
           <a:p>
             <a:pPr marL="152400" indent="-152400">
               <a:spcAft>
-                <a:spcPts val="300"/>
+                <a:spcPts val="200"/>
               </a:spcAft>
               <a:buSzPct val="100000"/>
               <a:buChar char="•"/>
             </a:pPr>
             <a:r>
-              <a:rPr lang="en-US" sz="1150" dirty="0">
+              <a:rPr lang="en-US" sz="1100" dirty="0">
                 <a:solidFill>
                   <a:srgbClr val="1B2733"/>
                 </a:solidFill>
@@ -2029,9 +2050,9 @@
                 <a:ea typeface="Calibri" pitchFamily="34" charset="-122"/>
                 <a:cs typeface="Calibri" pitchFamily="34" charset="-120"/>
               </a:rPr>
-              <a:t>Opinión Fábrica de Créditos</a:t>
-            </a:r>
-            <a:endParaRPr lang="en-US" sz="1150" dirty="0"/>
+              <a:t>Segunda prueba de continuidad de negocio</a:t>
+            </a:r>
+            <a:endParaRPr lang="en-US" sz="1100" dirty="0"/>
           </a:p>
         </p:txBody>
       </p:sp>
@@ -2043,12 +2064,12 @@
         </p:nvSpPr>
         <p:spPr>
           <a:xfrm>
-            <a:off x="7580376" y="2852928"/>
-            <a:ext cx="4151376" cy="932688"/>
+            <a:off x="7580376" y="2761488"/>
+            <a:ext cx="4151376" cy="1170432"/>
           </a:xfrm>
           <a:prstGeom prst="roundRect">
             <a:avLst>
-              <a:gd name="adj" fmla="val 9804"/>
+              <a:gd name="adj" fmla="val 7813"/>
             </a:avLst>
           </a:prstGeom>
           <a:solidFill>
@@ -2070,8 +2091,8 @@
         </p:nvSpPr>
         <p:spPr>
           <a:xfrm>
-            <a:off x="7744968" y="2926080"/>
-            <a:ext cx="3858768" cy="786384"/>
+            <a:off x="7744968" y="2834640"/>
+            <a:ext cx="3858768" cy="1024128"/>
           </a:xfrm>
           <a:prstGeom prst="rect">
             <a:avLst/>
@@ -2085,13 +2106,13 @@
           <a:p>
             <a:pPr marL="152400" indent="-152400">
               <a:spcAft>
-                <a:spcPts val="300"/>
+                <a:spcPts val="200"/>
               </a:spcAft>
               <a:buSzPct val="100000"/>
               <a:buChar char="•"/>
             </a:pPr>
             <a:r>
-              <a:rPr lang="en-US" sz="1150" dirty="0">
+              <a:rPr lang="en-US" sz="1100" dirty="0">
                 <a:solidFill>
                   <a:srgbClr val="1B2733"/>
                 </a:solidFill>
@@ -2099,20 +2120,20 @@
                 <a:ea typeface="Calibri" pitchFamily="34" charset="-122"/>
                 <a:cs typeface="Calibri" pitchFamily="34" charset="-120"/>
               </a:rPr>
-              <a:t>Informe de la 2.ª prueba de continuidad (01/10/2026)</a:t>
-            </a:r>
-            <a:endParaRPr lang="en-US" sz="1150" dirty="0"/>
+              <a:t>Capacitación GIR 2026 e informe de seguimiento del examen</a:t>
+            </a:r>
+            <a:endParaRPr lang="en-US" sz="1100" dirty="0"/>
           </a:p>
           <a:p>
             <a:pPr marL="152400" indent="-152400">
               <a:spcAft>
-                <a:spcPts val="300"/>
+                <a:spcPts val="200"/>
               </a:spcAft>
               <a:buSzPct val="100000"/>
               <a:buChar char="•"/>
             </a:pPr>
             <a:r>
-              <a:rPr lang="en-US" sz="1150" dirty="0">
+              <a:rPr lang="en-US" sz="1100" dirty="0">
                 <a:solidFill>
                   <a:srgbClr val="1B2733"/>
                 </a:solidFill>
@@ -2120,20 +2141,20 @@
                 <a:ea typeface="Calibri" pitchFamily="34" charset="-122"/>
                 <a:cs typeface="Calibri" pitchFamily="34" charset="-120"/>
               </a:rPr>
-              <a:t>Seguimiento planes de acción – Matriz de Riesgos 2026</a:t>
-            </a:r>
-            <a:endParaRPr lang="en-US" sz="1150" dirty="0"/>
+              <a:t>Informe 2.ª prueba de continuidad (01/10/2026)</a:t>
+            </a:r>
+            <a:endParaRPr lang="en-US" sz="1100" dirty="0"/>
           </a:p>
           <a:p>
             <a:pPr marL="152400" indent="-152400">
               <a:spcAft>
-                <a:spcPts val="300"/>
+                <a:spcPts val="200"/>
               </a:spcAft>
               <a:buSzPct val="100000"/>
               <a:buChar char="•"/>
             </a:pPr>
             <a:r>
-              <a:rPr lang="en-US" sz="1150" dirty="0">
+              <a:rPr lang="en-US" sz="1100" dirty="0">
                 <a:solidFill>
                   <a:srgbClr val="1B2733"/>
                 </a:solidFill>
@@ -2141,9 +2162,51 @@
                 <a:ea typeface="Calibri" pitchFamily="34" charset="-122"/>
                 <a:cs typeface="Calibri" pitchFamily="34" charset="-120"/>
               </a:rPr>
-              <a:t>Eventos de riesgo: caídas de TC (25/09) y Orion (26/09)</a:t>
-            </a:r>
-            <a:endParaRPr lang="en-US" sz="1150" dirty="0"/>
+              <a:t>Planes de acción Matriz 2026 y eventos TC / Orion</a:t>
+            </a:r>
+            <a:endParaRPr lang="en-US" sz="1100" dirty="0"/>
+          </a:p>
+          <a:p>
+            <a:pPr marL="152400" indent="-152400">
+              <a:spcAft>
+                <a:spcPts val="200"/>
+              </a:spcAft>
+              <a:buSzPct val="100000"/>
+              <a:buChar char="•"/>
+            </a:pPr>
+            <a:r>
+              <a:rPr lang="en-US" sz="1100" dirty="0">
+                <a:solidFill>
+                  <a:srgbClr val="1B2733"/>
+                </a:solidFill>
+                <a:latin typeface="Calibri" pitchFamily="34" charset="0"/>
+                <a:ea typeface="Calibri" pitchFamily="34" charset="-122"/>
+                <a:cs typeface="Calibri" pitchFamily="34" charset="-120"/>
+              </a:rPr>
+              <a:t>Opiniones: Fábrica de Créditos y caso de asociado</a:t>
+            </a:r>
+            <a:endParaRPr lang="en-US" sz="1100" dirty="0"/>
+          </a:p>
+          <a:p>
+            <a:pPr marL="152400" indent="-152400">
+              <a:spcAft>
+                <a:spcPts val="200"/>
+              </a:spcAft>
+              <a:buSzPct val="100000"/>
+              <a:buChar char="•"/>
+            </a:pPr>
+            <a:r>
+              <a:rPr lang="en-US" sz="1100" dirty="0">
+                <a:solidFill>
+                  <a:srgbClr val="1B2733"/>
+                </a:solidFill>
+                <a:latin typeface="Calibri" pitchFamily="34" charset="0"/>
+                <a:ea typeface="Calibri" pitchFamily="34" charset="-122"/>
+                <a:cs typeface="Calibri" pitchFamily="34" charset="-120"/>
+              </a:rPr>
+              <a:t>Información a Auditoría Interna (NRP-24) y Externa</a:t>
+            </a:r>
+            <a:endParaRPr lang="en-US" sz="1100" dirty="0"/>
           </a:p>
         </p:txBody>
       </p:sp>
@@ -2155,12 +2218,12 @@
         </p:nvSpPr>
         <p:spPr>
           <a:xfrm>
-            <a:off x="457200" y="3877056"/>
-            <a:ext cx="2697480" cy="731520"/>
+            <a:off x="457200" y="4014216"/>
+            <a:ext cx="2697480" cy="1170432"/>
           </a:xfrm>
           <a:prstGeom prst="roundRect">
             <a:avLst>
-              <a:gd name="adj" fmla="val 12500"/>
+              <a:gd name="adj" fmla="val 7813"/>
             </a:avLst>
           </a:prstGeom>
           <a:solidFill>
@@ -2182,7 +2245,7 @@
         </p:nvSpPr>
         <p:spPr>
           <a:xfrm>
-            <a:off x="621792" y="4059936"/>
+            <a:off x="621792" y="4416552"/>
             <a:ext cx="384048" cy="384048"/>
           </a:xfrm>
           <a:prstGeom prst="ellipse">
@@ -2215,7 +2278,7 @@
         </p:blipFill>
         <p:spPr>
           <a:xfrm>
-            <a:off x="722376" y="4160520"/>
+            <a:off x="722376" y="4517136"/>
             <a:ext cx="182880" cy="182880"/>
           </a:xfrm>
           <a:prstGeom prst="rect">
@@ -2231,7 +2294,7 @@
         </p:nvSpPr>
         <p:spPr>
           <a:xfrm>
-            <a:off x="1143000" y="3968496"/>
+            <a:off x="1143000" y="4325112"/>
             <a:ext cx="1920240" cy="566928"/>
           </a:xfrm>
           <a:prstGeom prst="rect">
@@ -2256,7 +2319,7 @@
                 <a:ea typeface="Calibri" pitchFamily="34" charset="-122"/>
                 <a:cs typeface="Calibri" pitchFamily="34" charset="-120"/>
               </a:rPr>
-              <a:t>Cumplimiento Normativo</a:t>
+              <a:t>Riesgo Normativo</a:t>
             </a:r>
             <a:endParaRPr lang="en-US" sz="1350" dirty="0"/>
           </a:p>
@@ -2273,7 +2336,7 @@
                 <a:ea typeface="Calibri" pitchFamily="34" charset="-122"/>
                 <a:cs typeface="Calibri" pitchFamily="34" charset="-120"/>
               </a:rPr>
-              <a:t>Envíos y auditorías</a:t>
+              <a:t>Avalúos y políticas</a:t>
             </a:r>
             <a:endParaRPr lang="en-US" sz="1350" dirty="0"/>
           </a:p>
@@ -2287,12 +2350,12 @@
         </p:nvSpPr>
         <p:spPr>
           <a:xfrm>
-            <a:off x="3291840" y="3877056"/>
-            <a:ext cx="4151376" cy="731520"/>
+            <a:off x="3291840" y="4014216"/>
+            <a:ext cx="4151376" cy="1170432"/>
           </a:xfrm>
           <a:prstGeom prst="roundRect">
             <a:avLst>
-              <a:gd name="adj" fmla="val 12500"/>
+              <a:gd name="adj" fmla="val 7813"/>
             </a:avLst>
           </a:prstGeom>
           <a:solidFill>
@@ -2314,8 +2377,8 @@
         </p:nvSpPr>
         <p:spPr>
           <a:xfrm>
-            <a:off x="3456432" y="3950208"/>
-            <a:ext cx="3858768" cy="585216"/>
+            <a:off x="3456432" y="4087368"/>
+            <a:ext cx="3858768" cy="1024128"/>
           </a:xfrm>
           <a:prstGeom prst="rect">
             <a:avLst/>
@@ -2329,13 +2392,13 @@
           <a:p>
             <a:pPr marL="152400" indent="-152400">
               <a:spcAft>
-                <a:spcPts val="300"/>
+                <a:spcPts val="200"/>
               </a:spcAft>
               <a:buSzPct val="100000"/>
               <a:buChar char="•"/>
             </a:pPr>
             <a:r>
-              <a:rPr lang="en-US" sz="1150" dirty="0">
+              <a:rPr lang="en-US" sz="1100" dirty="0">
                 <a:solidFill>
                   <a:srgbClr val="1B2733"/>
                 </a:solidFill>
@@ -2343,20 +2406,20 @@
                 <a:ea typeface="Calibri" pitchFamily="34" charset="-122"/>
                 <a:cs typeface="Calibri" pitchFamily="34" charset="-120"/>
               </a:rPr>
-              <a:t>Auditoría Interna – Evaluación NRP-24</a:t>
-            </a:r>
-            <a:endParaRPr lang="en-US" sz="1150" dirty="0"/>
+              <a:t>Revisión de Política y Procedimientos de Avalúos</a:t>
+            </a:r>
+            <a:endParaRPr lang="en-US" sz="1100" dirty="0"/>
           </a:p>
           <a:p>
             <a:pPr marL="152400" indent="-152400">
               <a:spcAft>
-                <a:spcPts val="300"/>
+                <a:spcPts val="200"/>
               </a:spcAft>
               <a:buSzPct val="100000"/>
               <a:buChar char="•"/>
             </a:pPr>
             <a:r>
-              <a:rPr lang="en-US" sz="1150" dirty="0">
+              <a:rPr lang="en-US" sz="1100" dirty="0">
                 <a:solidFill>
                   <a:srgbClr val="1B2733"/>
                 </a:solidFill>
@@ -2364,9 +2427,30 @@
                 <a:ea typeface="Calibri" pitchFamily="34" charset="-122"/>
                 <a:cs typeface="Calibri" pitchFamily="34" charset="-120"/>
               </a:rPr>
-              <a:t>Auditoría Externa</a:t>
-            </a:r>
-            <a:endParaRPr lang="en-US" sz="1150" dirty="0"/>
+              <a:t>Revisión de Perfil de Revisor</a:t>
+            </a:r>
+            <a:endParaRPr lang="en-US" sz="1100" dirty="0"/>
+          </a:p>
+          <a:p>
+            <a:pPr marL="152400" indent="-152400">
+              <a:spcAft>
+                <a:spcPts val="200"/>
+              </a:spcAft>
+              <a:buSzPct val="100000"/>
+              <a:buChar char="•"/>
+            </a:pPr>
+            <a:r>
+              <a:rPr lang="en-US" sz="1100" dirty="0">
+                <a:solidFill>
+                  <a:srgbClr val="1B2733"/>
+                </a:solidFill>
+                <a:latin typeface="Calibri" pitchFamily="34" charset="0"/>
+                <a:ea typeface="Calibri" pitchFamily="34" charset="-122"/>
+                <a:cs typeface="Calibri" pitchFamily="34" charset="-120"/>
+              </a:rPr>
+              <a:t>Envíos regulatorios (DAR)</a:t>
+            </a:r>
+            <a:endParaRPr lang="en-US" sz="1100" dirty="0"/>
           </a:p>
         </p:txBody>
       </p:sp>
@@ -2378,12 +2462,12 @@
         </p:nvSpPr>
         <p:spPr>
           <a:xfrm>
-            <a:off x="7580376" y="3877056"/>
-            <a:ext cx="4151376" cy="731520"/>
+            <a:off x="7580376" y="4014216"/>
+            <a:ext cx="4151376" cy="1170432"/>
           </a:xfrm>
           <a:prstGeom prst="roundRect">
             <a:avLst>
-              <a:gd name="adj" fmla="val 12500"/>
+              <a:gd name="adj" fmla="val 7813"/>
             </a:avLst>
           </a:prstGeom>
           <a:solidFill>
@@ -2405,8 +2489,8 @@
         </p:nvSpPr>
         <p:spPr>
           <a:xfrm>
-            <a:off x="7744968" y="3950208"/>
-            <a:ext cx="3858768" cy="585216"/>
+            <a:off x="7744968" y="4087368"/>
+            <a:ext cx="3858768" cy="1024128"/>
           </a:xfrm>
           <a:prstGeom prst="rect">
             <a:avLst/>
@@ -2420,13 +2504,13 @@
           <a:p>
             <a:pPr marL="152400" indent="-152400">
               <a:spcAft>
-                <a:spcPts val="300"/>
+                <a:spcPts val="200"/>
               </a:spcAft>
               <a:buSzPct val="100000"/>
               <a:buChar char="•"/>
             </a:pPr>
             <a:r>
-              <a:rPr lang="en-US" sz="1150" dirty="0">
+              <a:rPr lang="en-US" sz="1100" dirty="0">
                 <a:solidFill>
                   <a:srgbClr val="1B2733"/>
                 </a:solidFill>
@@ -2434,20 +2518,20 @@
                 <a:ea typeface="Calibri" pitchFamily="34" charset="-122"/>
                 <a:cs typeface="Calibri" pitchFamily="34" charset="-120"/>
               </a:rPr>
-              <a:t>Información remitida a Auditoría Interna y Externa</a:t>
-            </a:r>
-            <a:endParaRPr lang="en-US" sz="1150" dirty="0"/>
+              <a:t>Avalúos: perito, gestión electrónica y aviso a asociados</a:t>
+            </a:r>
+            <a:endParaRPr lang="en-US" sz="1100" dirty="0"/>
           </a:p>
           <a:p>
             <a:pPr marL="152400" indent="-152400">
               <a:spcAft>
-                <a:spcPts val="300"/>
+                <a:spcPts val="200"/>
               </a:spcAft>
               <a:buSzPct val="100000"/>
               <a:buChar char="•"/>
             </a:pPr>
             <a:r>
-              <a:rPr lang="en-US" sz="1150" dirty="0">
+              <a:rPr lang="en-US" sz="1100" dirty="0">
                 <a:solidFill>
                   <a:srgbClr val="1B2733"/>
                 </a:solidFill>
@@ -2455,9 +2539,72 @@
                 <a:ea typeface="Calibri" pitchFamily="34" charset="-122"/>
                 <a:cs typeface="Calibri" pitchFamily="34" charset="-120"/>
               </a:rPr>
+              <a:t>Descargo de avalúo anterior y mutuo hipotecario</a:t>
+            </a:r>
+            <a:endParaRPr lang="en-US" sz="1100" dirty="0"/>
+          </a:p>
+          <a:p>
+            <a:pPr marL="152400" indent="-152400">
+              <a:spcAft>
+                <a:spcPts val="200"/>
+              </a:spcAft>
+              <a:buSzPct val="100000"/>
+              <a:buChar char="•"/>
+            </a:pPr>
+            <a:r>
+              <a:rPr lang="en-US" sz="1100" dirty="0">
+                <a:solidFill>
+                  <a:srgbClr val="1B2733"/>
+                </a:solidFill>
+                <a:latin typeface="Calibri" pitchFamily="34" charset="0"/>
+                <a:ea typeface="Calibri" pitchFamily="34" charset="-122"/>
+                <a:cs typeface="Calibri" pitchFamily="34" charset="-120"/>
+              </a:rPr>
+              <a:t>Comparativos de políticas y acta de sesión 29/08/2026</a:t>
+            </a:r>
+            <a:endParaRPr lang="en-US" sz="1100" dirty="0"/>
+          </a:p>
+          <a:p>
+            <a:pPr marL="152400" indent="-152400">
+              <a:spcAft>
+                <a:spcPts val="200"/>
+              </a:spcAft>
+              <a:buSzPct val="100000"/>
+              <a:buChar char="•"/>
+            </a:pPr>
+            <a:r>
+              <a:rPr lang="en-US" sz="1100" dirty="0">
+                <a:solidFill>
+                  <a:srgbClr val="1B2733"/>
+                </a:solidFill>
+                <a:latin typeface="Calibri" pitchFamily="34" charset="0"/>
+                <a:ea typeface="Calibri" pitchFamily="34" charset="-122"/>
+                <a:cs typeface="Calibri" pitchFamily="34" charset="-120"/>
+              </a:rPr>
               <a:t>Acuerdos Semestrales del Comité de Riesgos</a:t>
             </a:r>
-            <a:endParaRPr lang="en-US" sz="1150" dirty="0"/>
+            <a:endParaRPr lang="en-US" sz="1100" dirty="0"/>
+          </a:p>
+          <a:p>
+            <a:pPr marL="152400" indent="-152400">
+              <a:spcAft>
+                <a:spcPts val="200"/>
+              </a:spcAft>
+              <a:buSzPct val="100000"/>
+              <a:buChar char="•"/>
+            </a:pPr>
+            <a:r>
+              <a:rPr lang="en-US" sz="1100" dirty="0">
+                <a:solidFill>
+                  <a:srgbClr val="1B2733"/>
+                </a:solidFill>
+                <a:latin typeface="Calibri" pitchFamily="34" charset="0"/>
+                <a:ea typeface="Calibri" pitchFamily="34" charset="-122"/>
+                <a:cs typeface="Calibri" pitchFamily="34" charset="-120"/>
+              </a:rPr>
+              <a:t>Proyectos: formularios, BIA, Procesos y página web</a:t>
+            </a:r>
+            <a:endParaRPr lang="en-US" sz="1100" dirty="0"/>
           </a:p>
         </p:txBody>
       </p:sp>
@@ -2469,12 +2616,12 @@
         </p:nvSpPr>
         <p:spPr>
           <a:xfrm>
-            <a:off x="457200" y="4700016"/>
-            <a:ext cx="2697480" cy="731520"/>
+            <a:off x="457200" y="5266944"/>
+            <a:ext cx="2697480" cy="1170432"/>
           </a:xfrm>
           <a:prstGeom prst="roundRect">
             <a:avLst>
-              <a:gd name="adj" fmla="val 12500"/>
+              <a:gd name="adj" fmla="val 7813"/>
             </a:avLst>
           </a:prstGeom>
           <a:solidFill>
@@ -2496,7 +2643,7 @@
         </p:nvSpPr>
         <p:spPr>
           <a:xfrm>
-            <a:off x="621792" y="4882896"/>
+            <a:off x="621792" y="5669280"/>
             <a:ext cx="384048" cy="384048"/>
           </a:xfrm>
           <a:prstGeom prst="ellipse">
@@ -2529,7 +2676,7 @@
         </p:blipFill>
         <p:spPr>
           <a:xfrm>
-            <a:off x="722376" y="4983480"/>
+            <a:off x="722376" y="5769864"/>
             <a:ext cx="182880" cy="182880"/>
           </a:xfrm>
           <a:prstGeom prst="rect">
@@ -2545,7 +2692,7 @@
         </p:nvSpPr>
         <p:spPr>
           <a:xfrm>
-            <a:off x="1143000" y="4791456"/>
+            <a:off x="1143000" y="5577840"/>
             <a:ext cx="1920240" cy="566928"/>
           </a:xfrm>
           <a:prstGeom prst="rect">
@@ -2570,7 +2717,7 @@
                 <a:ea typeface="Calibri" pitchFamily="34" charset="-122"/>
                 <a:cs typeface="Calibri" pitchFamily="34" charset="-120"/>
               </a:rPr>
-              <a:t>Riesgos Financieros</a:t>
+              <a:t>Riesgo Financiero</a:t>
             </a:r>
             <a:endParaRPr lang="en-US" sz="1350" dirty="0"/>
           </a:p>
@@ -2601,12 +2748,12 @@
         </p:nvSpPr>
         <p:spPr>
           <a:xfrm>
-            <a:off x="3291840" y="4700016"/>
-            <a:ext cx="4151376" cy="731520"/>
+            <a:off x="3291840" y="5266944"/>
+            <a:ext cx="4151376" cy="1170432"/>
           </a:xfrm>
           <a:prstGeom prst="roundRect">
             <a:avLst>
-              <a:gd name="adj" fmla="val 12500"/>
+              <a:gd name="adj" fmla="val 7813"/>
             </a:avLst>
           </a:prstGeom>
           <a:solidFill>
@@ -2628,8 +2775,8 @@
         </p:nvSpPr>
         <p:spPr>
           <a:xfrm>
-            <a:off x="3456432" y="4773168"/>
-            <a:ext cx="3858768" cy="585216"/>
+            <a:off x="3456432" y="5340096"/>
+            <a:ext cx="3858768" cy="1024128"/>
           </a:xfrm>
           <a:prstGeom prst="rect">
             <a:avLst/>
@@ -2643,13 +2790,13 @@
           <a:p>
             <a:pPr marL="152400" indent="-152400">
               <a:spcAft>
-                <a:spcPts val="300"/>
+                <a:spcPts val="200"/>
               </a:spcAft>
               <a:buSzPct val="100000"/>
               <a:buChar char="•"/>
             </a:pPr>
             <a:r>
-              <a:rPr lang="en-US" sz="1150" dirty="0">
+              <a:rPr lang="en-US" sz="1100" dirty="0">
                 <a:solidFill>
                   <a:srgbClr val="1B2733"/>
                 </a:solidFill>
@@ -2657,20 +2804,20 @@
                 <a:ea typeface="Calibri" pitchFamily="34" charset="-122"/>
                 <a:cs typeface="Calibri" pitchFamily="34" charset="-120"/>
               </a:rPr>
-              <a:t>Actualización de Política de TC</a:t>
-            </a:r>
-            <a:endParaRPr lang="en-US" sz="1150" dirty="0"/>
+              <a:t>Informe de Análisis de Cartera de TC</a:t>
+            </a:r>
+            <a:endParaRPr lang="en-US" sz="1100" dirty="0"/>
           </a:p>
           <a:p>
             <a:pPr marL="152400" indent="-152400">
               <a:spcAft>
-                <a:spcPts val="300"/>
+                <a:spcPts val="200"/>
               </a:spcAft>
               <a:buSzPct val="100000"/>
               <a:buChar char="•"/>
             </a:pPr>
             <a:r>
-              <a:rPr lang="en-US" sz="1150" dirty="0">
+              <a:rPr lang="en-US" sz="1100" dirty="0">
                 <a:solidFill>
                   <a:srgbClr val="1B2733"/>
                 </a:solidFill>
@@ -2680,7 +2827,28 @@
               </a:rPr>
               <a:t>Simulación de cartera vencida</a:t>
             </a:r>
-            <a:endParaRPr lang="en-US" sz="1150" dirty="0"/>
+            <a:endParaRPr lang="en-US" sz="1100" dirty="0"/>
+          </a:p>
+          <a:p>
+            <a:pPr marL="152400" indent="-152400">
+              <a:spcAft>
+                <a:spcPts val="200"/>
+              </a:spcAft>
+              <a:buSzPct val="100000"/>
+              <a:buChar char="•"/>
+            </a:pPr>
+            <a:r>
+              <a:rPr lang="en-US" sz="1100" dirty="0">
+                <a:solidFill>
+                  <a:srgbClr val="1B2733"/>
+                </a:solidFill>
+                <a:latin typeface="Calibri" pitchFamily="34" charset="0"/>
+                <a:ea typeface="Calibri" pitchFamily="34" charset="-122"/>
+                <a:cs typeface="Calibri" pitchFamily="34" charset="-120"/>
+              </a:rPr>
+              <a:t>Actualización de Política de TC</a:t>
+            </a:r>
+            <a:endParaRPr lang="en-US" sz="1100" dirty="0"/>
           </a:p>
         </p:txBody>
       </p:sp>
@@ -2692,12 +2860,12 @@
         </p:nvSpPr>
         <p:spPr>
           <a:xfrm>
-            <a:off x="7580376" y="4700016"/>
-            <a:ext cx="4151376" cy="731520"/>
+            <a:off x="7580376" y="5266944"/>
+            <a:ext cx="4151376" cy="1170432"/>
           </a:xfrm>
           <a:prstGeom prst="roundRect">
             <a:avLst>
-              <a:gd name="adj" fmla="val 12500"/>
+              <a:gd name="adj" fmla="val 7813"/>
             </a:avLst>
           </a:prstGeom>
           <a:solidFill>
@@ -2719,8 +2887,8 @@
         </p:nvSpPr>
         <p:spPr>
           <a:xfrm>
-            <a:off x="7744968" y="4773168"/>
-            <a:ext cx="3858768" cy="585216"/>
+            <a:off x="7744968" y="5340096"/>
+            <a:ext cx="3858768" cy="1024128"/>
           </a:xfrm>
           <a:prstGeom prst="rect">
             <a:avLst/>
@@ -2734,13 +2902,13 @@
           <a:p>
             <a:pPr marL="152400" indent="-152400">
               <a:spcAft>
-                <a:spcPts val="300"/>
+                <a:spcPts val="200"/>
               </a:spcAft>
               <a:buSzPct val="100000"/>
               <a:buChar char="•"/>
             </a:pPr>
             <a:r>
-              <a:rPr lang="en-US" sz="1150" dirty="0">
+              <a:rPr lang="en-US" sz="1100" dirty="0">
                 <a:solidFill>
                   <a:srgbClr val="1B2733"/>
                 </a:solidFill>
@@ -2750,18 +2918,18 @@
               </a:rPr>
               <a:t>Informes al Comité: crédito, liquidez y mercado</a:t>
             </a:r>
-            <a:endParaRPr lang="en-US" sz="1150" dirty="0"/>
+            <a:endParaRPr lang="en-US" sz="1100" dirty="0"/>
           </a:p>
           <a:p>
             <a:pPr marL="152400" indent="-152400">
               <a:spcAft>
-                <a:spcPts val="300"/>
+                <a:spcPts val="200"/>
               </a:spcAft>
               <a:buSzPct val="100000"/>
               <a:buChar char="•"/>
             </a:pPr>
             <a:r>
-              <a:rPr lang="en-US" sz="1150" dirty="0">
+              <a:rPr lang="en-US" sz="1100" dirty="0">
                 <a:solidFill>
                   <a:srgbClr val="1B2733"/>
                 </a:solidFill>
@@ -2769,201 +2937,20 @@
                 <a:ea typeface="Calibri" pitchFamily="34" charset="-122"/>
                 <a:cs typeface="Calibri" pitchFamily="34" charset="-120"/>
               </a:rPr>
-              <a:t>Reserva de saneamiento y traslados de deuda</a:t>
-            </a:r>
-            <a:endParaRPr lang="en-US" sz="1150" dirty="0"/>
-          </a:p>
-        </p:txBody>
-      </p:sp>
-      <p:sp>
-        <p:nvSpPr>
-          <p:cNvPr id="44" name="Shape 38"/>
-          <p:cNvSpPr/>
-          <p:nvPr/>
-        </p:nvSpPr>
-        <p:spPr>
-          <a:xfrm>
-            <a:off x="457200" y="5522976"/>
-            <a:ext cx="2697480" cy="731520"/>
-          </a:xfrm>
-          <a:prstGeom prst="roundRect">
-            <a:avLst>
-              <a:gd name="adj" fmla="val 12500"/>
-            </a:avLst>
-          </a:prstGeom>
-          <a:solidFill>
-            <a:srgbClr val="0B2545"/>
-          </a:solidFill>
-          <a:ln w="12700">
-            <a:solidFill>
-              <a:srgbClr val="0B2545"/>
-            </a:solidFill>
-            <a:prstDash val="solid"/>
-          </a:ln>
-        </p:spPr>
-      </p:sp>
-      <p:sp>
-        <p:nvSpPr>
-          <p:cNvPr id="45" name="Shape 39"/>
-          <p:cNvSpPr/>
-          <p:nvPr/>
-        </p:nvSpPr>
-        <p:spPr>
-          <a:xfrm>
-            <a:off x="621792" y="5705856"/>
-            <a:ext cx="384048" cy="384048"/>
-          </a:xfrm>
-          <a:prstGeom prst="ellipse">
-            <a:avLst/>
-          </a:prstGeom>
-          <a:solidFill>
-            <a:srgbClr val="2B6CB0"/>
-          </a:solidFill>
-          <a:ln w="12700">
-            <a:solidFill>
-              <a:srgbClr val="2B6CB0"/>
-            </a:solidFill>
-            <a:prstDash val="solid"/>
-          </a:ln>
-        </p:spPr>
-      </p:sp>
-      <p:pic>
-        <p:nvPicPr>
-          <p:cNvPr id="46" name="Image 4" descr="preencoded.png">    </p:cNvPr>
-          <p:cNvPicPr>
-            <a:picLocks noChangeAspect="1"/>
-          </p:cNvPicPr>
-          <p:nvPr/>
-        </p:nvPicPr>
-        <p:blipFill>
-          <a:blip r:embed="rId5"/>
-          <a:stretch>
-            <a:fillRect/>
-          </a:stretch>
-        </p:blipFill>
-        <p:spPr>
-          <a:xfrm>
-            <a:off x="722376" y="5806440"/>
-            <a:ext cx="182880" cy="182880"/>
-          </a:xfrm>
-          <a:prstGeom prst="rect">
-            <a:avLst/>
-          </a:prstGeom>
-        </p:spPr>
-      </p:pic>
-      <p:sp>
-        <p:nvSpPr>
-          <p:cNvPr id="47" name="Text 40"/>
-          <p:cNvSpPr txBox="1"/>
-          <p:nvPr/>
-        </p:nvSpPr>
-        <p:spPr>
-          <a:xfrm>
-            <a:off x="1143000" y="5614416"/>
-            <a:ext cx="1920240" cy="566928"/>
-          </a:xfrm>
-          <a:prstGeom prst="rect">
-            <a:avLst/>
-          </a:prstGeom>
-          <a:noFill/>
-          <a:ln/>
-        </p:spPr>
-        <p:txBody>
-          <a:bodyPr wrap="square" lIns="0" tIns="0" rIns="0" bIns="0" rtlCol="0" anchor="ctr"/>
-          <a:lstStyle/>
-          <a:p>
-            <a:pPr indent="0" marL="0">
-              <a:buNone/>
-            </a:pPr>
-            <a:r>
-              <a:rPr lang="en-US" sz="1350" b="1" dirty="0">
-                <a:solidFill>
-                  <a:srgbClr val="FFFFFF"/>
-                </a:solidFill>
-                <a:latin typeface="Calibri" pitchFamily="34" charset="0"/>
-                <a:ea typeface="Calibri" pitchFamily="34" charset="-122"/>
-                <a:cs typeface="Calibri" pitchFamily="34" charset="-120"/>
-              </a:rPr>
-              <a:t>Avalúos y Proyectos</a:t>
-            </a:r>
-            <a:endParaRPr lang="en-US" sz="1350" dirty="0"/>
-          </a:p>
-          <a:p>
-            <a:pPr indent="0" marL="0">
-              <a:buNone/>
-            </a:pPr>
-            <a:r>
-              <a:rPr lang="en-US" sz="1050" dirty="0">
-                <a:solidFill>
-                  <a:srgbClr val="C9D6E6"/>
-                </a:solidFill>
-                <a:latin typeface="Calibri" pitchFamily="34" charset="0"/>
-                <a:ea typeface="Calibri" pitchFamily="34" charset="-122"/>
-                <a:cs typeface="Calibri" pitchFamily="34" charset="-120"/>
-              </a:rPr>
-              <a:t>Mejora institucional</a:t>
-            </a:r>
-            <a:endParaRPr lang="en-US" sz="1350" dirty="0"/>
-          </a:p>
-        </p:txBody>
-      </p:sp>
-      <p:sp>
-        <p:nvSpPr>
-          <p:cNvPr id="48" name="Shape 41"/>
-          <p:cNvSpPr/>
-          <p:nvPr/>
-        </p:nvSpPr>
-        <p:spPr>
-          <a:xfrm>
-            <a:off x="3291840" y="5522976"/>
-            <a:ext cx="4151376" cy="731520"/>
-          </a:xfrm>
-          <a:prstGeom prst="roundRect">
-            <a:avLst>
-              <a:gd name="adj" fmla="val 12500"/>
-            </a:avLst>
-          </a:prstGeom>
-          <a:solidFill>
-            <a:srgbClr val="EEF2F7"/>
-          </a:solidFill>
-          <a:ln w="12700">
-            <a:solidFill>
-              <a:srgbClr val="EEF2F7"/>
-            </a:solidFill>
-            <a:prstDash val="solid"/>
-          </a:ln>
-        </p:spPr>
-      </p:sp>
-      <p:sp>
-        <p:nvSpPr>
-          <p:cNvPr id="49" name="Text 42"/>
-          <p:cNvSpPr txBox="1"/>
-          <p:nvPr/>
-        </p:nvSpPr>
-        <p:spPr>
-          <a:xfrm>
-            <a:off x="3456432" y="5596128"/>
-            <a:ext cx="3858768" cy="585216"/>
-          </a:xfrm>
-          <a:prstGeom prst="rect">
-            <a:avLst/>
-          </a:prstGeom>
-          <a:noFill/>
-          <a:ln/>
-        </p:spPr>
-        <p:txBody>
-          <a:bodyPr wrap="square" lIns="0" tIns="0" rIns="0" bIns="0" rtlCol="0" anchor="ctr"/>
-          <a:lstStyle/>
+              <a:t>Envíos SSF: NRP-05, NCB-022, NRP-41 y CTRI-RECR</a:t>
+            </a:r>
+            <a:endParaRPr lang="en-US" sz="1100" dirty="0"/>
+          </a:p>
           <a:p>
             <a:pPr marL="152400" indent="-152400">
               <a:spcAft>
-                <a:spcPts val="300"/>
+                <a:spcPts val="200"/>
               </a:spcAft>
               <a:buSzPct val="100000"/>
               <a:buChar char="•"/>
             </a:pPr>
             <a:r>
-              <a:rPr lang="en-US" sz="1150" dirty="0">
+              <a:rPr lang="en-US" sz="1100" dirty="0">
                 <a:solidFill>
                   <a:srgbClr val="1B2733"/>
                 </a:solidFill>
@@ -2971,20 +2958,20 @@
                 <a:ea typeface="Calibri" pitchFamily="34" charset="-122"/>
                 <a:cs typeface="Calibri" pitchFamily="34" charset="-120"/>
               </a:rPr>
-              <a:t>Revisión de Política y Procedimientos de Avalúos</a:t>
-            </a:r>
-            <a:endParaRPr lang="en-US" sz="1150" dirty="0"/>
+              <a:t>Cartera TC y reserva de saneamiento</a:t>
+            </a:r>
+            <a:endParaRPr lang="en-US" sz="1100" dirty="0"/>
           </a:p>
           <a:p>
             <a:pPr marL="152400" indent="-152400">
               <a:spcAft>
-                <a:spcPts val="300"/>
+                <a:spcPts val="200"/>
               </a:spcAft>
               <a:buSzPct val="100000"/>
               <a:buChar char="•"/>
             </a:pPr>
             <a:r>
-              <a:rPr lang="en-US" sz="1150" dirty="0">
+              <a:rPr lang="en-US" sz="1100" dirty="0">
                 <a:solidFill>
                   <a:srgbClr val="1B2733"/>
                 </a:solidFill>
@@ -2992,69 +2979,20 @@
                 <a:ea typeface="Calibri" pitchFamily="34" charset="-122"/>
                 <a:cs typeface="Calibri" pitchFamily="34" charset="-120"/>
               </a:rPr>
-              <a:t>Revisión de Perfil de Revisor</a:t>
-            </a:r>
-            <a:endParaRPr lang="en-US" sz="1150" dirty="0"/>
-          </a:p>
-        </p:txBody>
-      </p:sp>
-      <p:sp>
-        <p:nvSpPr>
-          <p:cNvPr id="50" name="Shape 43"/>
-          <p:cNvSpPr/>
-          <p:nvPr/>
-        </p:nvSpPr>
-        <p:spPr>
-          <a:xfrm>
-            <a:off x="7580376" y="5522976"/>
-            <a:ext cx="4151376" cy="731520"/>
-          </a:xfrm>
-          <a:prstGeom prst="roundRect">
-            <a:avLst>
-              <a:gd name="adj" fmla="val 12500"/>
-            </a:avLst>
-          </a:prstGeom>
-          <a:solidFill>
-            <a:srgbClr val="EEF2F7"/>
-          </a:solidFill>
-          <a:ln w="12700">
-            <a:solidFill>
-              <a:srgbClr val="EEF2F7"/>
-            </a:solidFill>
-            <a:prstDash val="solid"/>
-          </a:ln>
-        </p:spPr>
-      </p:sp>
-      <p:sp>
-        <p:nvSpPr>
-          <p:cNvPr id="51" name="Text 44"/>
-          <p:cNvSpPr txBox="1"/>
-          <p:nvPr/>
-        </p:nvSpPr>
-        <p:spPr>
-          <a:xfrm>
-            <a:off x="7744968" y="5596128"/>
-            <a:ext cx="3858768" cy="585216"/>
-          </a:xfrm>
-          <a:prstGeom prst="rect">
-            <a:avLst/>
-          </a:prstGeom>
-          <a:noFill/>
-          <a:ln/>
-        </p:spPr>
-        <p:txBody>
-          <a:bodyPr wrap="square" lIns="0" tIns="0" rIns="0" bIns="0" rtlCol="0" anchor="ctr"/>
-          <a:lstStyle/>
+              <a:t>Traslados de deuda y segmentación de productos</a:t>
+            </a:r>
+            <a:endParaRPr lang="en-US" sz="1100" dirty="0"/>
+          </a:p>
           <a:p>
             <a:pPr marL="152400" indent="-152400">
               <a:spcAft>
-                <a:spcPts val="300"/>
+                <a:spcPts val="200"/>
               </a:spcAft>
               <a:buSzPct val="100000"/>
               <a:buChar char="•"/>
             </a:pPr>
             <a:r>
-              <a:rPr lang="en-US" sz="1150" dirty="0">
+              <a:rPr lang="en-US" sz="1100" dirty="0">
                 <a:solidFill>
                   <a:srgbClr val="1B2733"/>
                 </a:solidFill>
@@ -3062,36 +3000,15 @@
                 <a:ea typeface="Calibri" pitchFamily="34" charset="-122"/>
                 <a:cs typeface="Calibri" pitchFamily="34" charset="-120"/>
               </a:rPr>
-              <a:t>Avalúos: asignación a perito y aviso a asociados</a:t>
-            </a:r>
-            <a:endParaRPr lang="en-US" sz="1150" dirty="0"/>
-          </a:p>
-          <a:p>
-            <a:pPr marL="152400" indent="-152400">
-              <a:spcAft>
-                <a:spcPts val="300"/>
-              </a:spcAft>
-              <a:buSzPct val="100000"/>
-              <a:buChar char="•"/>
-            </a:pPr>
-            <a:r>
-              <a:rPr lang="en-US" sz="1150" dirty="0">
-                <a:solidFill>
-                  <a:srgbClr val="1B2733"/>
-                </a:solidFill>
-                <a:latin typeface="Calibri" pitchFamily="34" charset="0"/>
-                <a:ea typeface="Calibri" pitchFamily="34" charset="-122"/>
-                <a:cs typeface="Calibri" pitchFamily="34" charset="-120"/>
-              </a:rPr>
-              <a:t>Cuestionario BIA y comparativos de políticas</a:t>
-            </a:r>
-            <a:endParaRPr lang="en-US" sz="1150" dirty="0"/>
+              <a:t>Sistema de créditos NRP-41 y TC de alto riesgo</a:t>
+            </a:r>
+            <a:endParaRPr lang="en-US" sz="1100" dirty="0"/>
           </a:p>
         </p:txBody>
       </p:sp>
       <p:sp>
         <p:nvSpPr>
-          <p:cNvPr id="52" name="Text 45"/>
+          <p:cNvPr id="44" name="Text 38"/>
           <p:cNvSpPr txBox="1"/>
           <p:nvPr/>
         </p:nvSpPr>

</xml_diff>

<commit_message>
Slide 2: regulatory calendar with 16/10/2026 cut-off, TODAY marker and day countdown
Co-Authored-By: Claude Opus 5.5 <noreply@anthropic.com>
Claude-Session: https://claude.ai/code/session_01QGTe9h3kfUS6BTZosfrxzF
</commit_message>
<xml_diff>
--- a/resumen-ejecutivo-semanal/Resumen_Ejecutivo_Riesgos_COMEDICA_2_Slides.pptx
+++ b/resumen-ejecutivo-semanal/Resumen_Ejecutivo_Riesgos_COMEDICA_2_Slides.pptx
@@ -591,7 +591,7 @@
           <a:p>
             <a:r>
               <a:rPr lang="en-US" dirty="0"/>
-              <a:t>Línea de tiempo de requerimientos SSF. Plazos: 16/10 PLD/FT (Circ. 23486), 23/10 nuevas observaciones y 30/10 seguimiento de Gobierno Corporativo (Circ. 22741), 03/11 Plan de Recuperación (Circ. 22737). Visita de Riesgos Específicos (Circ. 22742): inicio 09/10, sin plazo de respuesta documentado. No se afirma si los envíos están cumplidos o pendientes.</a:t>
+              <a:t>Corte 16/10. Hoy vence la respuesta PLD/FT (Circ. 23486). Siguen Gobierno Corporativo el 23/10 y 30/10 (Circ. 22741) y el Plan de Recuperación el 03/11 (Circ. 22737).</a:t>
             </a:r>
             <a:endParaRPr lang="en-US" dirty="0"/>
           </a:p>
@@ -3149,7 +3149,7 @@
                 <a:ea typeface="Calibri" pitchFamily="34" charset="-122"/>
                 <a:cs typeface="Calibri" pitchFamily="34" charset="-120"/>
               </a:rPr>
-              <a:t>Requerimientos de la Superintendencia del Sistema Financiero (SSF) · Seguimiento semanal</a:t>
+              <a:t>Calendario de requerimientos SSF · Corte 16/10/2026</a:t>
             </a:r>
             <a:endParaRPr lang="en-US" sz="1300" dirty="0"/>
           </a:p>
@@ -3163,14 +3163,14 @@
         </p:nvSpPr>
         <p:spPr>
           <a:xfrm>
-            <a:off x="9098280" y="484632"/>
+            <a:off x="8641080" y="484632"/>
             <a:ext cx="164592" cy="164592"/>
           </a:xfrm>
           <a:prstGeom prst="ellipse">
             <a:avLst/>
           </a:prstGeom>
           <a:solidFill>
-            <a:srgbClr val="FFFFFF"/>
+            <a:srgbClr val="0B2545"/>
           </a:solidFill>
           <a:ln w="25400">
             <a:solidFill>
@@ -3188,8 +3188,8 @@
         </p:nvSpPr>
         <p:spPr>
           <a:xfrm>
-            <a:off x="9317736" y="457200"/>
-            <a:ext cx="914400" cy="219456"/>
+            <a:off x="8860536" y="457200"/>
+            <a:ext cx="1097280" cy="219456"/>
           </a:xfrm>
           <a:prstGeom prst="rect">
             <a:avLst/>
@@ -3227,7 +3227,7 @@
         </p:nvSpPr>
         <p:spPr>
           <a:xfrm>
-            <a:off x="10012680" y="484632"/>
+            <a:off x="9601200" y="484632"/>
             <a:ext cx="164592" cy="164592"/>
           </a:xfrm>
           <a:prstGeom prst="ellipse">
@@ -3252,8 +3252,8 @@
         </p:nvSpPr>
         <p:spPr>
           <a:xfrm>
-            <a:off x="10232136" y="457200"/>
-            <a:ext cx="914400" cy="219456"/>
+            <a:off x="9820656" y="457200"/>
+            <a:ext cx="1097280" cy="219456"/>
           </a:xfrm>
           <a:prstGeom prst="rect">
             <a:avLst/>
@@ -3291,7 +3291,7 @@
         </p:nvSpPr>
         <p:spPr>
           <a:xfrm>
-            <a:off x="11247120" y="484632"/>
+            <a:off x="10881360" y="484632"/>
             <a:ext cx="164592" cy="164592"/>
           </a:xfrm>
           <a:prstGeom prst="diamond">
@@ -3316,8 +3316,8 @@
         </p:nvSpPr>
         <p:spPr>
           <a:xfrm>
-            <a:off x="11466576" y="457200"/>
-            <a:ext cx="914400" cy="219456"/>
+            <a:off x="11100816" y="457200"/>
+            <a:ext cx="1097280" cy="219456"/>
           </a:xfrm>
           <a:prstGeom prst="rect">
             <a:avLst/>
@@ -3341,7 +3341,7 @@
                 <a:ea typeface="Calibri" pitchFamily="34" charset="-122"/>
                 <a:cs typeface="Calibri" pitchFamily="34" charset="-120"/>
               </a:rPr>
-              <a:t>Plazo</a:t>
+              <a:t>Plazo SSF</a:t>
             </a:r>
             <a:endParaRPr lang="en-US" sz="1000" dirty="0"/>
           </a:p>
@@ -3355,20 +3355,16 @@
         </p:nvSpPr>
         <p:spPr>
           <a:xfrm>
-            <a:off x="6070310" y="1261872"/>
-            <a:ext cx="5661442" cy="2432304"/>
-          </a:xfrm>
-          <a:prstGeom prst="roundRect">
-            <a:avLst>
-              <a:gd name="adj" fmla="val 4511"/>
-            </a:avLst>
-          </a:prstGeom>
-          <a:solidFill>
-            <a:srgbClr val="FDF3E1"/>
-          </a:solidFill>
-          <a:ln w="12700">
+            <a:off x="548640" y="2377440"/>
+            <a:ext cx="6259721" cy="0"/>
+          </a:xfrm>
+          <a:prstGeom prst="line">
+            <a:avLst/>
+          </a:prstGeom>
+          <a:noFill/>
+          <a:ln w="38100">
             <a:solidFill>
-              <a:srgbClr val="FDF3E1"/>
+              <a:srgbClr val="0B2545"/>
             </a:solidFill>
             <a:prstDash val="solid"/>
           </a:ln>
@@ -3376,61 +3372,22 @@
       </p:sp>
       <p:sp>
         <p:nvSpPr>
-          <p:cNvPr id="11" name="Text 9"/>
-          <p:cNvSpPr txBox="1"/>
-          <p:nvPr/>
-        </p:nvSpPr>
-        <p:spPr>
-          <a:xfrm>
-            <a:off x="6207470" y="1316736"/>
-            <a:ext cx="2743200" cy="219456"/>
-          </a:xfrm>
-          <a:prstGeom prst="rect">
+          <p:cNvPr id="11" name="Shape 9"/>
+          <p:cNvSpPr/>
+          <p:nvPr/>
+        </p:nvSpPr>
+        <p:spPr>
+          <a:xfrm>
+            <a:off x="6808361" y="2377440"/>
+            <a:ext cx="4831951" cy="0"/>
+          </a:xfrm>
+          <a:prstGeom prst="line">
             <a:avLst/>
           </a:prstGeom>
           <a:noFill/>
-          <a:ln/>
-        </p:spPr>
-        <p:txBody>
-          <a:bodyPr wrap="square" lIns="0" tIns="0" rIns="0" bIns="0" rtlCol="0" anchor="ctr"/>
-          <a:lstStyle/>
-          <a:p>
-            <a:pPr indent="0" marL="0">
-              <a:buNone/>
-            </a:pPr>
-            <a:r>
-              <a:rPr lang="en-US" sz="900" b="1" spc="100" kern="0" dirty="0">
-                <a:solidFill>
-                  <a:srgbClr val="B86E00"/>
-                </a:solidFill>
-                <a:latin typeface="Calibri" pitchFamily="34" charset="0"/>
-                <a:ea typeface="Calibri" pitchFamily="34" charset="-122"/>
-                <a:cs typeface="Calibri" pitchFamily="34" charset="-120"/>
-              </a:rPr>
-              <a:t>FECHAS DE RESPUESTA SSF</a:t>
-            </a:r>
-            <a:endParaRPr lang="en-US" sz="900" dirty="0"/>
-          </a:p>
-        </p:txBody>
-      </p:sp>
-      <p:sp>
-        <p:nvSpPr>
-          <p:cNvPr id="12" name="Shape 10"/>
-          <p:cNvSpPr/>
-          <p:nvPr/>
-        </p:nvSpPr>
-        <p:spPr>
-          <a:xfrm>
-            <a:off x="548640" y="2505456"/>
-            <a:ext cx="11091672" cy="0"/>
-          </a:xfrm>
-          <a:prstGeom prst="line">
-            <a:avLst/>
-          </a:prstGeom>
-          <a:noFill/>
-          <a:ln w="25400">
+          <a:ln w="38100">
             <a:solidFill>
-              <a:srgbClr val="AFC0D0"/>
+              <a:srgbClr val="C3CFDB"/>
             </a:solidFill>
             <a:prstDash val="solid"/>
           </a:ln>
@@ -3438,14 +3395,14 @@
       </p:sp>
       <p:sp>
         <p:nvSpPr>
-          <p:cNvPr id="13" name="Shape 11"/>
+          <p:cNvPr id="12" name="Shape 10"/>
           <p:cNvSpPr/>
           <p:nvPr/>
         </p:nvSpPr>
         <p:spPr>
           <a:xfrm>
-            <a:off x="1143000" y="2249424"/>
-            <a:ext cx="0" cy="256032"/>
+            <a:off x="1097280" y="2139696"/>
+            <a:ext cx="0" cy="237744"/>
           </a:xfrm>
           <a:prstGeom prst="line">
             <a:avLst/>
@@ -3461,20 +3418,20 @@
       </p:sp>
       <p:sp>
         <p:nvSpPr>
-          <p:cNvPr id="14" name="Shape 12"/>
+          <p:cNvPr id="13" name="Shape 11"/>
           <p:cNvSpPr/>
           <p:nvPr/>
         </p:nvSpPr>
         <p:spPr>
           <a:xfrm>
-            <a:off x="1042416" y="2404872"/>
+            <a:off x="996696" y="2276856"/>
             <a:ext cx="201168" cy="201168"/>
           </a:xfrm>
           <a:prstGeom prst="ellipse">
             <a:avLst/>
           </a:prstGeom>
           <a:solidFill>
-            <a:srgbClr val="FFFFFF"/>
+            <a:srgbClr val="0B2545"/>
           </a:solidFill>
           <a:ln w="25400">
             <a:solidFill>
@@ -3486,14 +3443,14 @@
       </p:sp>
       <p:sp>
         <p:nvSpPr>
-          <p:cNvPr id="15" name="Text 13"/>
+          <p:cNvPr id="14" name="Text 12"/>
           <p:cNvSpPr txBox="1"/>
           <p:nvPr/>
         </p:nvSpPr>
         <p:spPr>
           <a:xfrm>
-            <a:off x="402336" y="1481328"/>
-            <a:ext cx="1481328" cy="749808"/>
+            <a:off x="356616" y="1371600"/>
+            <a:ext cx="1481328" cy="768096"/>
           </a:xfrm>
           <a:prstGeom prst="rect">
             <a:avLst/>
@@ -3506,13 +3463,10 @@
           <a:lstStyle/>
           <a:p>
             <a:pPr algn="ctr" indent="0" marL="0">
-              <a:spcAft>
-                <a:spcPts val="100"/>
-              </a:spcAft>
-              <a:buNone/>
-            </a:pPr>
-            <a:r>
-              <a:rPr lang="en-US" sz="1400" b="1" dirty="0">
+              <a:buNone/>
+            </a:pPr>
+            <a:r>
+              <a:rPr lang="en-US" sz="1300" b="1" dirty="0">
                 <a:solidFill>
                   <a:srgbClr val="0B2545"/>
                 </a:solidFill>
@@ -3522,13 +3476,10 @@
               </a:rPr>
               <a:t>22/09</a:t>
             </a:r>
-            <a:endParaRPr lang="en-US" sz="1400" dirty="0"/>
+            <a:endParaRPr lang="en-US" sz="1300" dirty="0"/>
           </a:p>
           <a:p>
             <a:pPr algn="ctr" indent="0" marL="0">
-              <a:spcAft>
-                <a:spcPts val="100"/>
-              </a:spcAft>
               <a:buNone/>
             </a:pPr>
             <a:r>
@@ -3540,15 +3491,12 @@
                 <a:ea typeface="Calibri" pitchFamily="34" charset="-122"/>
                 <a:cs typeface="Calibri" pitchFamily="34" charset="-120"/>
               </a:rPr>
-              <a:t>Recepción resultado preliminar Plan de Recuperación</a:t>
-            </a:r>
-            <a:endParaRPr lang="en-US" sz="1400" dirty="0"/>
+              <a:t>Resultado preliminar Plan de Recuperación</a:t>
+            </a:r>
+            <a:endParaRPr lang="en-US" sz="1300" dirty="0"/>
           </a:p>
           <a:p>
             <a:pPr algn="ctr" indent="0" marL="0">
-              <a:spcAft>
-                <a:spcPts val="100"/>
-              </a:spcAft>
               <a:buNone/>
             </a:pPr>
             <a:r>
@@ -3562,20 +3510,20 @@
               </a:rPr>
               <a:t>Circ. 22737</a:t>
             </a:r>
-            <a:endParaRPr lang="en-US" sz="1400" dirty="0"/>
+            <a:endParaRPr lang="en-US" sz="1300" dirty="0"/>
           </a:p>
         </p:txBody>
       </p:sp>
       <p:sp>
         <p:nvSpPr>
-          <p:cNvPr id="16" name="Shape 14"/>
+          <p:cNvPr id="15" name="Shape 13"/>
           <p:cNvSpPr/>
           <p:nvPr/>
         </p:nvSpPr>
         <p:spPr>
           <a:xfrm>
-            <a:off x="2557707" y="2505456"/>
-            <a:ext cx="0" cy="256032"/>
+            <a:off x="2525050" y="2377440"/>
+            <a:ext cx="0" cy="237744"/>
           </a:xfrm>
           <a:prstGeom prst="line">
             <a:avLst/>
@@ -3591,20 +3539,20 @@
       </p:sp>
       <p:sp>
         <p:nvSpPr>
-          <p:cNvPr id="17" name="Shape 15"/>
+          <p:cNvPr id="16" name="Shape 14"/>
           <p:cNvSpPr/>
           <p:nvPr/>
         </p:nvSpPr>
         <p:spPr>
           <a:xfrm>
-            <a:off x="2457123" y="2404872"/>
+            <a:off x="2424466" y="2276856"/>
             <a:ext cx="201168" cy="201168"/>
           </a:xfrm>
           <a:prstGeom prst="ellipse">
             <a:avLst/>
           </a:prstGeom>
           <a:solidFill>
-            <a:srgbClr val="FFFFFF"/>
+            <a:srgbClr val="0B2545"/>
           </a:solidFill>
           <a:ln w="25400">
             <a:solidFill>
@@ -3616,14 +3564,14 @@
       </p:sp>
       <p:sp>
         <p:nvSpPr>
-          <p:cNvPr id="18" name="Text 16"/>
+          <p:cNvPr id="17" name="Text 15"/>
           <p:cNvSpPr txBox="1"/>
           <p:nvPr/>
         </p:nvSpPr>
         <p:spPr>
           <a:xfrm>
-            <a:off x="1817043" y="2816352"/>
-            <a:ext cx="1481328" cy="749808"/>
+            <a:off x="1784386" y="2688336"/>
+            <a:ext cx="1481328" cy="768096"/>
           </a:xfrm>
           <a:prstGeom prst="rect">
             <a:avLst/>
@@ -3636,13 +3584,10 @@
           <a:lstStyle/>
           <a:p>
             <a:pPr algn="ctr" indent="0" marL="0">
-              <a:spcAft>
-                <a:spcPts val="100"/>
-              </a:spcAft>
-              <a:buNone/>
-            </a:pPr>
-            <a:r>
-              <a:rPr lang="en-US" sz="1400" b="1" dirty="0">
+              <a:buNone/>
+            </a:pPr>
+            <a:r>
+              <a:rPr lang="en-US" sz="1300" b="1" dirty="0">
                 <a:solidFill>
                   <a:srgbClr val="0B2545"/>
                 </a:solidFill>
@@ -3652,13 +3597,10 @@
               </a:rPr>
               <a:t>24/09</a:t>
             </a:r>
-            <a:endParaRPr lang="en-US" sz="1400" dirty="0"/>
+            <a:endParaRPr lang="en-US" sz="1300" dirty="0"/>
           </a:p>
           <a:p>
             <a:pPr algn="ctr" indent="0" marL="0">
-              <a:spcAft>
-                <a:spcPts val="100"/>
-              </a:spcAft>
               <a:buNone/>
             </a:pPr>
             <a:r>
@@ -3670,15 +3612,12 @@
                 <a:ea typeface="Calibri" pitchFamily="34" charset="-122"/>
                 <a:cs typeface="Calibri" pitchFamily="34" charset="-120"/>
               </a:rPr>
-              <a:t>Recepción visita inicial Riesgos Específicos</a:t>
-            </a:r>
-            <a:endParaRPr lang="en-US" sz="1400" dirty="0"/>
+              <a:t>Visita inicial Riesgos Específicos</a:t>
+            </a:r>
+            <a:endParaRPr lang="en-US" sz="1300" dirty="0"/>
           </a:p>
           <a:p>
             <a:pPr algn="ctr" indent="0" marL="0">
-              <a:spcAft>
-                <a:spcPts val="100"/>
-              </a:spcAft>
               <a:buNone/>
             </a:pPr>
             <a:r>
@@ -3692,20 +3631,20 @@
               </a:rPr>
               <a:t>Circ. 22742</a:t>
             </a:r>
-            <a:endParaRPr lang="en-US" sz="1400" dirty="0"/>
+            <a:endParaRPr lang="en-US" sz="1300" dirty="0"/>
           </a:p>
         </p:txBody>
       </p:sp>
       <p:sp>
         <p:nvSpPr>
-          <p:cNvPr id="19" name="Shape 17"/>
+          <p:cNvPr id="18" name="Shape 16"/>
           <p:cNvSpPr/>
           <p:nvPr/>
         </p:nvSpPr>
         <p:spPr>
           <a:xfrm>
-            <a:off x="3972415" y="2249424"/>
-            <a:ext cx="0" cy="256032"/>
+            <a:off x="3952821" y="2139696"/>
+            <a:ext cx="0" cy="237744"/>
           </a:xfrm>
           <a:prstGeom prst="line">
             <a:avLst/>
@@ -3721,20 +3660,20 @@
       </p:sp>
       <p:sp>
         <p:nvSpPr>
-          <p:cNvPr id="20" name="Shape 18"/>
+          <p:cNvPr id="19" name="Shape 17"/>
           <p:cNvSpPr/>
           <p:nvPr/>
         </p:nvSpPr>
         <p:spPr>
           <a:xfrm>
-            <a:off x="3871831" y="2404872"/>
+            <a:off x="3852237" y="2276856"/>
             <a:ext cx="201168" cy="201168"/>
           </a:xfrm>
           <a:prstGeom prst="ellipse">
             <a:avLst/>
           </a:prstGeom>
           <a:solidFill>
-            <a:srgbClr val="FFFFFF"/>
+            <a:srgbClr val="0B2545"/>
           </a:solidFill>
           <a:ln w="25400">
             <a:solidFill>
@@ -3746,14 +3685,14 @@
       </p:sp>
       <p:sp>
         <p:nvSpPr>
-          <p:cNvPr id="21" name="Text 19"/>
+          <p:cNvPr id="20" name="Text 18"/>
           <p:cNvSpPr txBox="1"/>
           <p:nvPr/>
         </p:nvSpPr>
         <p:spPr>
           <a:xfrm>
-            <a:off x="3231751" y="1481328"/>
-            <a:ext cx="1481328" cy="749808"/>
+            <a:off x="3212157" y="1371600"/>
+            <a:ext cx="1481328" cy="768096"/>
           </a:xfrm>
           <a:prstGeom prst="rect">
             <a:avLst/>
@@ -3766,13 +3705,10 @@
           <a:lstStyle/>
           <a:p>
             <a:pPr algn="ctr" indent="0" marL="0">
-              <a:spcAft>
-                <a:spcPts val="100"/>
-              </a:spcAft>
-              <a:buNone/>
-            </a:pPr>
-            <a:r>
-              <a:rPr lang="en-US" sz="1400" b="1" dirty="0">
+              <a:buNone/>
+            </a:pPr>
+            <a:r>
+              <a:rPr lang="en-US" sz="1300" b="1" dirty="0">
                 <a:solidFill>
                   <a:srgbClr val="0B2545"/>
                 </a:solidFill>
@@ -3782,13 +3718,10 @@
               </a:rPr>
               <a:t>02/10</a:t>
             </a:r>
-            <a:endParaRPr lang="en-US" sz="1400" dirty="0"/>
+            <a:endParaRPr lang="en-US" sz="1300" dirty="0"/>
           </a:p>
           <a:p>
             <a:pPr algn="ctr" indent="0" marL="0">
-              <a:spcAft>
-                <a:spcPts val="100"/>
-              </a:spcAft>
               <a:buNone/>
             </a:pPr>
             <a:r>
@@ -3800,15 +3733,12 @@
                 <a:ea typeface="Calibri" pitchFamily="34" charset="-122"/>
                 <a:cs typeface="Calibri" pitchFamily="34" charset="-120"/>
               </a:rPr>
-              <a:t>Recepción resultados preliminares PLD/FT</a:t>
-            </a:r>
-            <a:endParaRPr lang="en-US" sz="1400" dirty="0"/>
+              <a:t>Resultados preliminares PLD/FT</a:t>
+            </a:r>
+            <a:endParaRPr lang="en-US" sz="1300" dirty="0"/>
           </a:p>
           <a:p>
             <a:pPr algn="ctr" indent="0" marL="0">
-              <a:spcAft>
-                <a:spcPts val="100"/>
-              </a:spcAft>
               <a:buNone/>
             </a:pPr>
             <a:r>
@@ -3822,20 +3752,20 @@
               </a:rPr>
               <a:t>Circ. 23486</a:t>
             </a:r>
-            <a:endParaRPr lang="en-US" sz="1400" dirty="0"/>
+            <a:endParaRPr lang="en-US" sz="1300" dirty="0"/>
           </a:p>
         </p:txBody>
       </p:sp>
       <p:sp>
         <p:nvSpPr>
-          <p:cNvPr id="22" name="Shape 20"/>
+          <p:cNvPr id="21" name="Shape 19"/>
           <p:cNvSpPr/>
           <p:nvPr/>
         </p:nvSpPr>
         <p:spPr>
           <a:xfrm>
-            <a:off x="5387122" y="2505456"/>
-            <a:ext cx="0" cy="256032"/>
+            <a:off x="5380591" y="2377440"/>
+            <a:ext cx="0" cy="237744"/>
           </a:xfrm>
           <a:prstGeom prst="line">
             <a:avLst/>
@@ -3851,13 +3781,13 @@
       </p:sp>
       <p:sp>
         <p:nvSpPr>
-          <p:cNvPr id="23" name="Shape 21"/>
+          <p:cNvPr id="22" name="Shape 20"/>
           <p:cNvSpPr/>
           <p:nvPr/>
         </p:nvSpPr>
         <p:spPr>
           <a:xfrm>
-            <a:off x="5286538" y="2404872"/>
+            <a:off x="5280007" y="2276856"/>
             <a:ext cx="201168" cy="201168"/>
           </a:xfrm>
           <a:prstGeom prst="ellipse">
@@ -3876,14 +3806,14 @@
       </p:sp>
       <p:sp>
         <p:nvSpPr>
-          <p:cNvPr id="24" name="Text 22"/>
+          <p:cNvPr id="23" name="Text 21"/>
           <p:cNvSpPr txBox="1"/>
           <p:nvPr/>
         </p:nvSpPr>
         <p:spPr>
           <a:xfrm>
-            <a:off x="4646458" y="2816352"/>
-            <a:ext cx="1481328" cy="749808"/>
+            <a:off x="4639927" y="2688336"/>
+            <a:ext cx="1481328" cy="768096"/>
           </a:xfrm>
           <a:prstGeom prst="rect">
             <a:avLst/>
@@ -3896,13 +3826,10 @@
           <a:lstStyle/>
           <a:p>
             <a:pPr algn="ctr" indent="0" marL="0">
-              <a:spcAft>
-                <a:spcPts val="100"/>
-              </a:spcAft>
-              <a:buNone/>
-            </a:pPr>
-            <a:r>
-              <a:rPr lang="en-US" sz="1400" b="1" dirty="0">
+              <a:buNone/>
+            </a:pPr>
+            <a:r>
+              <a:rPr lang="en-US" sz="1300" b="1" dirty="0">
                 <a:solidFill>
                   <a:srgbClr val="0B2545"/>
                 </a:solidFill>
@@ -3912,13 +3839,10 @@
               </a:rPr>
               <a:t>09/10</a:t>
             </a:r>
-            <a:endParaRPr lang="en-US" sz="1400" dirty="0"/>
+            <a:endParaRPr lang="en-US" sz="1300" dirty="0"/>
           </a:p>
           <a:p>
             <a:pPr algn="ctr" indent="0" marL="0">
-              <a:spcAft>
-                <a:spcPts val="100"/>
-              </a:spcAft>
               <a:buNone/>
             </a:pPr>
             <a:r>
@@ -3930,15 +3854,12 @@
                 <a:ea typeface="Calibri" pitchFamily="34" charset="-122"/>
                 <a:cs typeface="Calibri" pitchFamily="34" charset="-120"/>
               </a:rPr>
-              <a:t>Inicio visita Riesgos Específicos y recepción resultados Gob. Corp.</a:t>
-            </a:r>
-            <a:endParaRPr lang="en-US" sz="1400" dirty="0"/>
+              <a:t>Inicio visita Riesgos Específicos · Resultados Gob. Corporativo</a:t>
+            </a:r>
+            <a:endParaRPr lang="en-US" sz="1300" dirty="0"/>
           </a:p>
           <a:p>
             <a:pPr algn="ctr" indent="0" marL="0">
-              <a:spcAft>
-                <a:spcPts val="100"/>
-              </a:spcAft>
               <a:buNone/>
             </a:pPr>
             <a:r>
@@ -3952,20 +3873,20 @@
               </a:rPr>
               <a:t>Circ. 22742 · 22741</a:t>
             </a:r>
-            <a:endParaRPr lang="en-US" sz="1400" dirty="0"/>
+            <a:endParaRPr lang="en-US" sz="1300" dirty="0"/>
           </a:p>
         </p:txBody>
       </p:sp>
       <p:sp>
         <p:nvSpPr>
-          <p:cNvPr id="25" name="Shape 23"/>
+          <p:cNvPr id="24" name="Shape 22"/>
           <p:cNvSpPr/>
           <p:nvPr/>
         </p:nvSpPr>
         <p:spPr>
           <a:xfrm>
-            <a:off x="6801830" y="2249424"/>
-            <a:ext cx="0" cy="256032"/>
+            <a:off x="6808361" y="2139696"/>
+            <a:ext cx="0" cy="237744"/>
           </a:xfrm>
           <a:prstGeom prst="line">
             <a:avLst/>
@@ -3981,13 +3902,13 @@
       </p:sp>
       <p:sp>
         <p:nvSpPr>
-          <p:cNvPr id="26" name="Shape 24"/>
+          <p:cNvPr id="25" name="Shape 23"/>
           <p:cNvSpPr/>
           <p:nvPr/>
         </p:nvSpPr>
         <p:spPr>
           <a:xfrm>
-            <a:off x="6682958" y="2386584"/>
+            <a:off x="6689489" y="2258568"/>
             <a:ext cx="237744" cy="237744"/>
           </a:xfrm>
           <a:prstGeom prst="diamond">
@@ -4006,14 +3927,14 @@
       </p:sp>
       <p:sp>
         <p:nvSpPr>
-          <p:cNvPr id="27" name="Text 25"/>
+          <p:cNvPr id="26" name="Text 24"/>
           <p:cNvSpPr txBox="1"/>
           <p:nvPr/>
         </p:nvSpPr>
         <p:spPr>
           <a:xfrm>
-            <a:off x="6061166" y="1481328"/>
-            <a:ext cx="1481328" cy="749808"/>
+            <a:off x="6067697" y="1371600"/>
+            <a:ext cx="1481328" cy="768096"/>
           </a:xfrm>
           <a:prstGeom prst="rect">
             <a:avLst/>
@@ -4026,13 +3947,10 @@
           <a:lstStyle/>
           <a:p>
             <a:pPr algn="ctr" indent="0" marL="0">
-              <a:spcAft>
-                <a:spcPts val="100"/>
-              </a:spcAft>
-              <a:buNone/>
-            </a:pPr>
-            <a:r>
-              <a:rPr lang="en-US" sz="1400" b="1" dirty="0">
+              <a:buNone/>
+            </a:pPr>
+            <a:r>
+              <a:rPr lang="en-US" sz="1300" b="1" dirty="0">
                 <a:solidFill>
                   <a:srgbClr val="B86E00"/>
                 </a:solidFill>
@@ -4040,15 +3958,12 @@
                 <a:ea typeface="Calibri" pitchFamily="34" charset="-122"/>
                 <a:cs typeface="Calibri" pitchFamily="34" charset="-120"/>
               </a:rPr>
-              <a:t>16/10</a:t>
-            </a:r>
-            <a:endParaRPr lang="en-US" sz="1400" dirty="0"/>
+              <a:t>Plazo 16/10</a:t>
+            </a:r>
+            <a:endParaRPr lang="en-US" sz="1300" dirty="0"/>
           </a:p>
           <a:p>
             <a:pPr algn="ctr" indent="0" marL="0">
-              <a:spcAft>
-                <a:spcPts val="100"/>
-              </a:spcAft>
               <a:buNone/>
             </a:pPr>
             <a:r>
@@ -4060,15 +3975,12 @@
                 <a:ea typeface="Calibri" pitchFamily="34" charset="-122"/>
                 <a:cs typeface="Calibri" pitchFamily="34" charset="-120"/>
               </a:rPr>
-              <a:t>Respuesta a resultados preliminares PLD/FT</a:t>
-            </a:r>
-            <a:endParaRPr lang="en-US" sz="1400" dirty="0"/>
+              <a:t>Respuesta resultados preliminares PLD/FT</a:t>
+            </a:r>
+            <a:endParaRPr lang="en-US" sz="1300" dirty="0"/>
           </a:p>
           <a:p>
             <a:pPr algn="ctr" indent="0" marL="0">
-              <a:spcAft>
-                <a:spcPts val="100"/>
-              </a:spcAft>
               <a:buNone/>
             </a:pPr>
             <a:r>
@@ -4082,20 +3994,20 @@
               </a:rPr>
               <a:t>Circ. 23486</a:t>
             </a:r>
-            <a:endParaRPr lang="en-US" sz="1400" dirty="0"/>
+            <a:endParaRPr lang="en-US" sz="1300" dirty="0"/>
           </a:p>
         </p:txBody>
       </p:sp>
       <p:sp>
         <p:nvSpPr>
-          <p:cNvPr id="28" name="Shape 26"/>
+          <p:cNvPr id="27" name="Shape 25"/>
           <p:cNvSpPr/>
           <p:nvPr/>
         </p:nvSpPr>
         <p:spPr>
           <a:xfrm>
-            <a:off x="8216537" y="2505456"/>
-            <a:ext cx="0" cy="256032"/>
+            <a:off x="8236131" y="2377440"/>
+            <a:ext cx="0" cy="237744"/>
           </a:xfrm>
           <a:prstGeom prst="line">
             <a:avLst/>
@@ -4111,13 +4023,13 @@
       </p:sp>
       <p:sp>
         <p:nvSpPr>
-          <p:cNvPr id="29" name="Shape 27"/>
+          <p:cNvPr id="28" name="Shape 26"/>
           <p:cNvSpPr/>
           <p:nvPr/>
         </p:nvSpPr>
         <p:spPr>
           <a:xfrm>
-            <a:off x="8097665" y="2386584"/>
+            <a:off x="8117259" y="2258568"/>
             <a:ext cx="237744" cy="237744"/>
           </a:xfrm>
           <a:prstGeom prst="diamond">
@@ -4136,14 +4048,14 @@
       </p:sp>
       <p:sp>
         <p:nvSpPr>
-          <p:cNvPr id="30" name="Text 28"/>
+          <p:cNvPr id="29" name="Text 27"/>
           <p:cNvSpPr txBox="1"/>
           <p:nvPr/>
         </p:nvSpPr>
         <p:spPr>
           <a:xfrm>
-            <a:off x="7475873" y="2816352"/>
-            <a:ext cx="1481328" cy="749808"/>
+            <a:off x="7495467" y="2688336"/>
+            <a:ext cx="1481328" cy="768096"/>
           </a:xfrm>
           <a:prstGeom prst="rect">
             <a:avLst/>
@@ -4156,13 +4068,10 @@
           <a:lstStyle/>
           <a:p>
             <a:pPr algn="ctr" indent="0" marL="0">
-              <a:spcAft>
-                <a:spcPts val="100"/>
-              </a:spcAft>
-              <a:buNone/>
-            </a:pPr>
-            <a:r>
-              <a:rPr lang="en-US" sz="1400" b="1" dirty="0">
+              <a:buNone/>
+            </a:pPr>
+            <a:r>
+              <a:rPr lang="en-US" sz="1300" b="1" dirty="0">
                 <a:solidFill>
                   <a:srgbClr val="B86E00"/>
                 </a:solidFill>
@@ -4170,15 +4079,12 @@
                 <a:ea typeface="Calibri" pitchFamily="34" charset="-122"/>
                 <a:cs typeface="Calibri" pitchFamily="34" charset="-120"/>
               </a:rPr>
-              <a:t>23/10</a:t>
-            </a:r>
-            <a:endParaRPr lang="en-US" sz="1400" dirty="0"/>
+              <a:t>Plazo 23/10</a:t>
+            </a:r>
+            <a:endParaRPr lang="en-US" sz="1300" dirty="0"/>
           </a:p>
           <a:p>
             <a:pPr algn="ctr" indent="0" marL="0">
-              <a:spcAft>
-                <a:spcPts val="100"/>
-              </a:spcAft>
               <a:buNone/>
             </a:pPr>
             <a:r>
@@ -4190,15 +4096,12 @@
                 <a:ea typeface="Calibri" pitchFamily="34" charset="-122"/>
                 <a:cs typeface="Calibri" pitchFamily="34" charset="-120"/>
               </a:rPr>
-              <a:t>Envío de nuevas observaciones Gob. Corporativo</a:t>
-            </a:r>
-            <a:endParaRPr lang="en-US" sz="1400" dirty="0"/>
+              <a:t>Nuevas observaciones Gob. Corporativo</a:t>
+            </a:r>
+            <a:endParaRPr lang="en-US" sz="1300" dirty="0"/>
           </a:p>
           <a:p>
             <a:pPr algn="ctr" indent="0" marL="0">
-              <a:spcAft>
-                <a:spcPts val="100"/>
-              </a:spcAft>
               <a:buNone/>
             </a:pPr>
             <a:r>
@@ -4212,20 +4115,20 @@
               </a:rPr>
               <a:t>Circ. 22741</a:t>
             </a:r>
-            <a:endParaRPr lang="en-US" sz="1400" dirty="0"/>
+            <a:endParaRPr lang="en-US" sz="1300" dirty="0"/>
           </a:p>
         </p:txBody>
       </p:sp>
       <p:sp>
         <p:nvSpPr>
-          <p:cNvPr id="31" name="Shape 29"/>
+          <p:cNvPr id="30" name="Shape 28"/>
           <p:cNvSpPr/>
           <p:nvPr/>
         </p:nvSpPr>
         <p:spPr>
           <a:xfrm>
-            <a:off x="9631245" y="2249424"/>
-            <a:ext cx="0" cy="256032"/>
+            <a:off x="9663902" y="2139696"/>
+            <a:ext cx="0" cy="237744"/>
           </a:xfrm>
           <a:prstGeom prst="line">
             <a:avLst/>
@@ -4241,13 +4144,13 @@
       </p:sp>
       <p:sp>
         <p:nvSpPr>
-          <p:cNvPr id="32" name="Shape 30"/>
+          <p:cNvPr id="31" name="Shape 29"/>
           <p:cNvSpPr/>
           <p:nvPr/>
         </p:nvSpPr>
         <p:spPr>
           <a:xfrm>
-            <a:off x="9512373" y="2386584"/>
+            <a:off x="9545030" y="2258568"/>
             <a:ext cx="237744" cy="237744"/>
           </a:xfrm>
           <a:prstGeom prst="diamond">
@@ -4266,14 +4169,14 @@
       </p:sp>
       <p:sp>
         <p:nvSpPr>
-          <p:cNvPr id="33" name="Text 31"/>
+          <p:cNvPr id="32" name="Text 30"/>
           <p:cNvSpPr txBox="1"/>
           <p:nvPr/>
         </p:nvSpPr>
         <p:spPr>
           <a:xfrm>
-            <a:off x="8890581" y="1481328"/>
-            <a:ext cx="1481328" cy="749808"/>
+            <a:off x="8923238" y="1371600"/>
+            <a:ext cx="1481328" cy="768096"/>
           </a:xfrm>
           <a:prstGeom prst="rect">
             <a:avLst/>
@@ -4286,13 +4189,10 @@
           <a:lstStyle/>
           <a:p>
             <a:pPr algn="ctr" indent="0" marL="0">
-              <a:spcAft>
-                <a:spcPts val="100"/>
-              </a:spcAft>
-              <a:buNone/>
-            </a:pPr>
-            <a:r>
-              <a:rPr lang="en-US" sz="1400" b="1" dirty="0">
+              <a:buNone/>
+            </a:pPr>
+            <a:r>
+              <a:rPr lang="en-US" sz="1300" b="1" dirty="0">
                 <a:solidFill>
                   <a:srgbClr val="B86E00"/>
                 </a:solidFill>
@@ -4300,15 +4200,12 @@
                 <a:ea typeface="Calibri" pitchFamily="34" charset="-122"/>
                 <a:cs typeface="Calibri" pitchFamily="34" charset="-120"/>
               </a:rPr>
-              <a:t>30/10</a:t>
-            </a:r>
-            <a:endParaRPr lang="en-US" sz="1400" dirty="0"/>
+              <a:t>Plazo 30/10</a:t>
+            </a:r>
+            <a:endParaRPr lang="en-US" sz="1300" dirty="0"/>
           </a:p>
           <a:p>
             <a:pPr algn="ctr" indent="0" marL="0">
-              <a:spcAft>
-                <a:spcPts val="100"/>
-              </a:spcAft>
               <a:buNone/>
             </a:pPr>
             <a:r>
@@ -4322,13 +4219,10 @@
               </a:rPr>
               <a:t>Seguimiento de observaciones Gob. Corporativo</a:t>
             </a:r>
-            <a:endParaRPr lang="en-US" sz="1400" dirty="0"/>
+            <a:endParaRPr lang="en-US" sz="1300" dirty="0"/>
           </a:p>
           <a:p>
             <a:pPr algn="ctr" indent="0" marL="0">
-              <a:spcAft>
-                <a:spcPts val="100"/>
-              </a:spcAft>
               <a:buNone/>
             </a:pPr>
             <a:r>
@@ -4342,20 +4236,20 @@
               </a:rPr>
               <a:t>Circ. 22741</a:t>
             </a:r>
-            <a:endParaRPr lang="en-US" sz="1400" dirty="0"/>
+            <a:endParaRPr lang="en-US" sz="1300" dirty="0"/>
           </a:p>
         </p:txBody>
       </p:sp>
       <p:sp>
         <p:nvSpPr>
-          <p:cNvPr id="34" name="Shape 32"/>
+          <p:cNvPr id="33" name="Shape 31"/>
           <p:cNvSpPr/>
           <p:nvPr/>
         </p:nvSpPr>
         <p:spPr>
           <a:xfrm>
-            <a:off x="11045952" y="2505456"/>
-            <a:ext cx="0" cy="256032"/>
+            <a:off x="11091672" y="2377440"/>
+            <a:ext cx="0" cy="237744"/>
           </a:xfrm>
           <a:prstGeom prst="line">
             <a:avLst/>
@@ -4371,13 +4265,13 @@
       </p:sp>
       <p:sp>
         <p:nvSpPr>
-          <p:cNvPr id="35" name="Shape 33"/>
+          <p:cNvPr id="34" name="Shape 32"/>
           <p:cNvSpPr/>
           <p:nvPr/>
         </p:nvSpPr>
         <p:spPr>
           <a:xfrm>
-            <a:off x="10927080" y="2386584"/>
+            <a:off x="10972800" y="2258568"/>
             <a:ext cx="237744" cy="237744"/>
           </a:xfrm>
           <a:prstGeom prst="diamond">
@@ -4396,14 +4290,14 @@
       </p:sp>
       <p:sp>
         <p:nvSpPr>
-          <p:cNvPr id="36" name="Text 34"/>
+          <p:cNvPr id="35" name="Text 33"/>
           <p:cNvSpPr txBox="1"/>
           <p:nvPr/>
         </p:nvSpPr>
         <p:spPr>
           <a:xfrm>
-            <a:off x="10305288" y="2816352"/>
-            <a:ext cx="1481328" cy="749808"/>
+            <a:off x="10351008" y="2688336"/>
+            <a:ext cx="1481328" cy="768096"/>
           </a:xfrm>
           <a:prstGeom prst="rect">
             <a:avLst/>
@@ -4416,13 +4310,10 @@
           <a:lstStyle/>
           <a:p>
             <a:pPr algn="ctr" indent="0" marL="0">
-              <a:spcAft>
-                <a:spcPts val="100"/>
-              </a:spcAft>
-              <a:buNone/>
-            </a:pPr>
-            <a:r>
-              <a:rPr lang="en-US" sz="1400" b="1" dirty="0">
+              <a:buNone/>
+            </a:pPr>
+            <a:r>
+              <a:rPr lang="en-US" sz="1300" b="1" dirty="0">
                 <a:solidFill>
                   <a:srgbClr val="B86E00"/>
                 </a:solidFill>
@@ -4430,15 +4321,12 @@
                 <a:ea typeface="Calibri" pitchFamily="34" charset="-122"/>
                 <a:cs typeface="Calibri" pitchFamily="34" charset="-120"/>
               </a:rPr>
-              <a:t>03/11</a:t>
-            </a:r>
-            <a:endParaRPr lang="en-US" sz="1400" dirty="0"/>
+              <a:t>Plazo 03/11</a:t>
+            </a:r>
+            <a:endParaRPr lang="en-US" sz="1300" dirty="0"/>
           </a:p>
           <a:p>
             <a:pPr algn="ctr" indent="0" marL="0">
-              <a:spcAft>
-                <a:spcPts val="100"/>
-              </a:spcAft>
               <a:buNone/>
             </a:pPr>
             <a:r>
@@ -4452,13 +4340,10 @@
               </a:rPr>
               <a:t>Envío del Plan de Recuperación</a:t>
             </a:r>
-            <a:endParaRPr lang="en-US" sz="1400" dirty="0"/>
+            <a:endParaRPr lang="en-US" sz="1300" dirty="0"/>
           </a:p>
           <a:p>
             <a:pPr algn="ctr" indent="0" marL="0">
-              <a:spcAft>
-                <a:spcPts val="100"/>
-              </a:spcAft>
               <a:buNone/>
             </a:pPr>
             <a:r>
@@ -4472,9 +4357,32 @@
               </a:rPr>
               <a:t>Circ. 22737</a:t>
             </a:r>
-            <a:endParaRPr lang="en-US" sz="1400" dirty="0"/>
+            <a:endParaRPr lang="en-US" sz="1300" dirty="0"/>
           </a:p>
         </p:txBody>
+      </p:sp>
+      <p:sp>
+        <p:nvSpPr>
+          <p:cNvPr id="36" name="Shape 34"/>
+          <p:cNvSpPr/>
+          <p:nvPr/>
+        </p:nvSpPr>
+        <p:spPr>
+          <a:xfrm>
+            <a:off x="6808361" y="2542032"/>
+            <a:ext cx="0" cy="566928"/>
+          </a:xfrm>
+          <a:prstGeom prst="line">
+            <a:avLst/>
+          </a:prstGeom>
+          <a:noFill/>
+          <a:ln w="19050">
+            <a:solidFill>
+              <a:srgbClr val="B86E00"/>
+            </a:solidFill>
+            <a:prstDash val="dash"/>
+          </a:ln>
+        </p:spPr>
       </p:sp>
       <p:sp>
         <p:nvSpPr>
@@ -4484,12 +4392,117 @@
         </p:nvSpPr>
         <p:spPr>
           <a:xfrm>
-            <a:off x="457200" y="3877056"/>
-            <a:ext cx="1773936" cy="1810512"/>
+            <a:off x="6305441" y="3108960"/>
+            <a:ext cx="1005840" cy="274320"/>
           </a:xfrm>
           <a:prstGeom prst="roundRect">
             <a:avLst>
-              <a:gd name="adj" fmla="val 5155"/>
+              <a:gd name="adj" fmla="val 50000"/>
+            </a:avLst>
+          </a:prstGeom>
+          <a:solidFill>
+            <a:srgbClr val="B86E00"/>
+          </a:solidFill>
+          <a:ln w="12700">
+            <a:solidFill>
+              <a:srgbClr val="B86E00"/>
+            </a:solidFill>
+            <a:prstDash val="solid"/>
+          </a:ln>
+        </p:spPr>
+      </p:sp>
+      <p:sp>
+        <p:nvSpPr>
+          <p:cNvPr id="38" name="Text 36"/>
+          <p:cNvSpPr txBox="1"/>
+          <p:nvPr/>
+        </p:nvSpPr>
+        <p:spPr>
+          <a:xfrm>
+            <a:off x="6305441" y="3108960"/>
+            <a:ext cx="1005840" cy="274320"/>
+          </a:xfrm>
+          <a:prstGeom prst="rect">
+            <a:avLst/>
+          </a:prstGeom>
+          <a:noFill/>
+          <a:ln/>
+        </p:spPr>
+        <p:txBody>
+          <a:bodyPr wrap="square" lIns="0" tIns="0" rIns="0" bIns="0" rtlCol="0" anchor="ctr"/>
+          <a:lstStyle/>
+          <a:p>
+            <a:pPr algn="ctr" indent="0" marL="0">
+              <a:buNone/>
+            </a:pPr>
+            <a:r>
+              <a:rPr lang="en-US" sz="1050" b="1" dirty="0">
+                <a:solidFill>
+                  <a:srgbClr val="FFFFFF"/>
+                </a:solidFill>
+                <a:latin typeface="Calibri" pitchFamily="34" charset="0"/>
+                <a:ea typeface="Calibri" pitchFamily="34" charset="-122"/>
+                <a:cs typeface="Calibri" pitchFamily="34" charset="-120"/>
+              </a:rPr>
+              <a:t>HOY 16/10</a:t>
+            </a:r>
+            <a:endParaRPr lang="en-US" sz="1050" dirty="0"/>
+          </a:p>
+        </p:txBody>
+      </p:sp>
+      <p:sp>
+        <p:nvSpPr>
+          <p:cNvPr id="39" name="Text 37"/>
+          <p:cNvSpPr txBox="1"/>
+          <p:nvPr/>
+        </p:nvSpPr>
+        <p:spPr>
+          <a:xfrm>
+            <a:off x="457200" y="3657600"/>
+            <a:ext cx="5486400" cy="329184"/>
+          </a:xfrm>
+          <a:prstGeom prst="rect">
+            <a:avLst/>
+          </a:prstGeom>
+          <a:noFill/>
+          <a:ln/>
+        </p:spPr>
+        <p:txBody>
+          <a:bodyPr wrap="square" lIns="0" tIns="0" rIns="0" bIns="0" rtlCol="0" anchor="ctr"/>
+          <a:lstStyle/>
+          <a:p>
+            <a:pPr indent="0" marL="0">
+              <a:buNone/>
+            </a:pPr>
+            <a:r>
+              <a:rPr lang="en-US" sz="1600" b="1" dirty="0">
+                <a:solidFill>
+                  <a:srgbClr val="0B2545"/>
+                </a:solidFill>
+                <a:latin typeface="Calibri" pitchFamily="34" charset="0"/>
+                <a:ea typeface="Calibri" pitchFamily="34" charset="-122"/>
+                <a:cs typeface="Calibri" pitchFamily="34" charset="-120"/>
+              </a:rPr>
+              <a:t>Próximos vencimientos</a:t>
+            </a:r>
+            <a:endParaRPr lang="en-US" sz="1600" dirty="0"/>
+          </a:p>
+        </p:txBody>
+      </p:sp>
+      <p:sp>
+        <p:nvSpPr>
+          <p:cNvPr id="40" name="Shape 38"/>
+          <p:cNvSpPr/>
+          <p:nvPr/>
+        </p:nvSpPr>
+        <p:spPr>
+          <a:xfrm>
+            <a:off x="457200" y="4078224"/>
+            <a:ext cx="2681478" cy="2286000"/>
+          </a:xfrm>
+          <a:prstGeom prst="roundRect">
+            <a:avLst>
+              <a:gd name="adj" fmla="val 4800"/>
             </a:avLst>
           </a:prstGeom>
           <a:solidFill>
@@ -4505,14 +4518,14 @@
       </p:sp>
       <p:sp>
         <p:nvSpPr>
-          <p:cNvPr id="38" name="Text 36"/>
+          <p:cNvPr id="41" name="Text 39"/>
           <p:cNvSpPr txBox="1"/>
           <p:nvPr/>
         </p:nvSpPr>
         <p:spPr>
           <a:xfrm>
-            <a:off x="603504" y="3986784"/>
-            <a:ext cx="1499616" cy="182880"/>
+            <a:off x="658368" y="4206240"/>
+            <a:ext cx="2315718" cy="658368"/>
           </a:xfrm>
           <a:prstGeom prst="rect">
             <a:avLst/>
@@ -4528,7 +4541,7 @@
               <a:buNone/>
             </a:pPr>
             <a:r>
-              <a:rPr lang="en-US" sz="850" b="1" spc="100" kern="0" dirty="0">
+              <a:rPr lang="en-US" sz="3000" b="1" dirty="0">
                 <a:solidFill>
                   <a:srgbClr val="F6C26B"/>
                 </a:solidFill>
@@ -4536,61 +4549,22 @@
                 <a:ea typeface="Calibri" pitchFamily="34" charset="-122"/>
                 <a:cs typeface="Calibri" pitchFamily="34" charset="-120"/>
               </a:rPr>
-              <a:t>FECHA LÍMITE</a:t>
-            </a:r>
-            <a:endParaRPr lang="en-US" sz="850" dirty="0"/>
+              <a:t>Vence hoy</a:t>
+            </a:r>
+            <a:endParaRPr lang="en-US" sz="3000" dirty="0"/>
           </a:p>
         </p:txBody>
       </p:sp>
       <p:sp>
         <p:nvSpPr>
-          <p:cNvPr id="39" name="Text 37"/>
+          <p:cNvPr id="42" name="Text 40"/>
           <p:cNvSpPr txBox="1"/>
           <p:nvPr/>
         </p:nvSpPr>
         <p:spPr>
           <a:xfrm>
-            <a:off x="603504" y="4169664"/>
-            <a:ext cx="1499616" cy="347472"/>
-          </a:xfrm>
-          <a:prstGeom prst="rect">
-            <a:avLst/>
-          </a:prstGeom>
-          <a:noFill/>
-          <a:ln/>
-        </p:spPr>
-        <p:txBody>
-          <a:bodyPr wrap="square" lIns="0" tIns="0" rIns="0" bIns="0" rtlCol="0" anchor="ctr"/>
-          <a:lstStyle/>
-          <a:p>
-            <a:pPr indent="0" marL="0">
-              <a:buNone/>
-            </a:pPr>
-            <a:r>
-              <a:rPr lang="en-US" sz="1900" b="1" dirty="0">
-                <a:solidFill>
-                  <a:srgbClr val="FFFFFF"/>
-                </a:solidFill>
-                <a:latin typeface="Calibri" pitchFamily="34" charset="0"/>
-                <a:ea typeface="Calibri" pitchFamily="34" charset="-122"/>
-                <a:cs typeface="Calibri" pitchFamily="34" charset="-120"/>
-              </a:rPr>
-              <a:t>16/10/2026</a:t>
-            </a:r>
-            <a:endParaRPr lang="en-US" sz="1900" dirty="0"/>
-          </a:p>
-        </p:txBody>
-      </p:sp>
-      <p:sp>
-        <p:nvSpPr>
-          <p:cNvPr id="40" name="Text 38"/>
-          <p:cNvSpPr txBox="1"/>
-          <p:nvPr/>
-        </p:nvSpPr>
-        <p:spPr>
-          <a:xfrm>
-            <a:off x="603504" y="4572000"/>
-            <a:ext cx="1517904" cy="1024128"/>
+            <a:off x="658368" y="4919472"/>
+            <a:ext cx="2315718" cy="1335024"/>
           </a:xfrm>
           <a:prstGeom prst="rect">
             <a:avLst/>
@@ -4604,12 +4578,12 @@
           <a:p>
             <a:pPr indent="0" marL="0">
               <a:spcAft>
-                <a:spcPts val="200"/>
+                <a:spcPts val="300"/>
               </a:spcAft>
               <a:buNone/>
             </a:pPr>
             <a:r>
-              <a:rPr lang="en-US" sz="1050" b="1" dirty="0">
+              <a:rPr lang="en-US" sz="1300" b="1" dirty="0">
                 <a:solidFill>
                   <a:srgbClr val="FFFFFF"/>
                 </a:solidFill>
@@ -4617,39 +4591,59 @@
                 <a:ea typeface="Calibri" pitchFamily="34" charset="-122"/>
                 <a:cs typeface="Calibri" pitchFamily="34" charset="-120"/>
               </a:rPr>
-              <a:t>Respuesta resultados preliminares PLD/FT</a:t>
-            </a:r>
-            <a:endParaRPr lang="en-US" sz="1050" dirty="0"/>
+              <a:t>16/10/2026</a:t>
+            </a:r>
+            <a:endParaRPr lang="en-US" sz="1300" dirty="0"/>
           </a:p>
           <a:p>
             <a:pPr indent="0" marL="0">
               <a:spcAft>
-                <a:spcPts val="200"/>
+                <a:spcPts val="300"/>
               </a:spcAft>
               <a:buNone/>
             </a:pPr>
             <a:r>
-              <a:rPr lang="en-US" sz="950" dirty="0">
-                <a:solidFill>
-                  <a:srgbClr val="A9D8DE"/>
-                </a:solidFill>
-                <a:latin typeface="Calibri" pitchFamily="34" charset="0"/>
-                <a:ea typeface="Calibri" pitchFamily="34" charset="-122"/>
-                <a:cs typeface="Calibri" pitchFamily="34" charset="-120"/>
-              </a:rPr>
-              <a:t>Circular 23486</a:t>
-            </a:r>
-            <a:endParaRPr lang="en-US" sz="1050" dirty="0"/>
+              <a:rPr lang="en-US" sz="1150" dirty="0">
+                <a:solidFill>
+                  <a:srgbClr val="FFFFFF"/>
+                </a:solidFill>
+                <a:latin typeface="Calibri" pitchFamily="34" charset="0"/>
+                <a:ea typeface="Calibri" pitchFamily="34" charset="-122"/>
+                <a:cs typeface="Calibri" pitchFamily="34" charset="-120"/>
+              </a:rPr>
+              <a:t>Envío respuesta resultados preliminares PLD/FT</a:t>
+            </a:r>
+            <a:endParaRPr lang="en-US" sz="1300" dirty="0"/>
           </a:p>
           <a:p>
             <a:pPr indent="0" marL="0">
               <a:spcAft>
-                <a:spcPts val="200"/>
+                <a:spcPts val="300"/>
               </a:spcAft>
               <a:buNone/>
             </a:pPr>
             <a:r>
-              <a:rPr lang="en-US" sz="950" i="1" dirty="0">
+              <a:rPr lang="en-US" sz="1000" dirty="0">
+                <a:solidFill>
+                  <a:srgbClr val="A9D8DE"/>
+                </a:solidFill>
+                <a:latin typeface="Calibri" pitchFamily="34" charset="0"/>
+                <a:ea typeface="Calibri" pitchFamily="34" charset="-122"/>
+                <a:cs typeface="Calibri" pitchFamily="34" charset="-120"/>
+              </a:rPr>
+              <a:t>Circular 23486</a:t>
+            </a:r>
+            <a:endParaRPr lang="en-US" sz="1300" dirty="0"/>
+          </a:p>
+          <a:p>
+            <a:pPr indent="0" marL="0">
+              <a:spcAft>
+                <a:spcPts val="300"/>
+              </a:spcAft>
+              <a:buNone/>
+            </a:pPr>
+            <a:r>
+              <a:rPr lang="en-US" sz="1000" i="1" dirty="0">
                 <a:solidFill>
                   <a:srgbClr val="DCE6F0"/>
                 </a:solidFill>
@@ -4657,26 +4651,26 @@
                 <a:ea typeface="Calibri" pitchFamily="34" charset="-122"/>
                 <a:cs typeface="Calibri" pitchFamily="34" charset="-120"/>
               </a:rPr>
-              <a:t>Pruebas de descargo en seguimiento</a:t>
-            </a:r>
-            <a:endParaRPr lang="en-US" sz="1050" dirty="0"/>
+              <a:t>Semana: seguimiento al envío de pruebas de descargo</a:t>
+            </a:r>
+            <a:endParaRPr lang="en-US" sz="1300" dirty="0"/>
           </a:p>
         </p:txBody>
       </p:sp>
       <p:sp>
         <p:nvSpPr>
-          <p:cNvPr id="41" name="Shape 39"/>
+          <p:cNvPr id="43" name="Shape 41"/>
           <p:cNvSpPr/>
           <p:nvPr/>
         </p:nvSpPr>
         <p:spPr>
           <a:xfrm>
-            <a:off x="2377440" y="3877056"/>
-            <a:ext cx="1773936" cy="1810512"/>
+            <a:off x="3321558" y="4078224"/>
+            <a:ext cx="2681478" cy="2286000"/>
           </a:xfrm>
           <a:prstGeom prst="roundRect">
             <a:avLst>
-              <a:gd name="adj" fmla="val 5155"/>
+              <a:gd name="adj" fmla="val 4800"/>
             </a:avLst>
           </a:prstGeom>
           <a:solidFill>
@@ -4692,14 +4686,14 @@
       </p:sp>
       <p:sp>
         <p:nvSpPr>
-          <p:cNvPr id="42" name="Text 40"/>
+          <p:cNvPr id="44" name="Text 42"/>
           <p:cNvSpPr txBox="1"/>
           <p:nvPr/>
         </p:nvSpPr>
         <p:spPr>
           <a:xfrm>
-            <a:off x="2523744" y="3986784"/>
-            <a:ext cx="1499616" cy="182880"/>
+            <a:off x="3522726" y="4206240"/>
+            <a:ext cx="2315718" cy="658368"/>
           </a:xfrm>
           <a:prstGeom prst="rect">
             <a:avLst/>
@@ -4715,7 +4709,7 @@
               <a:buNone/>
             </a:pPr>
             <a:r>
-              <a:rPr lang="en-US" sz="850" b="1" spc="100" kern="0" dirty="0">
+              <a:rPr lang="en-US" sz="4000" b="1" dirty="0">
                 <a:solidFill>
                   <a:srgbClr val="B86E00"/>
                 </a:solidFill>
@@ -4723,61 +4717,36 @@
                 <a:ea typeface="Calibri" pitchFamily="34" charset="-122"/>
                 <a:cs typeface="Calibri" pitchFamily="34" charset="-120"/>
               </a:rPr>
-              <a:t>FECHA LÍMITE</a:t>
-            </a:r>
-            <a:endParaRPr lang="en-US" sz="850" dirty="0"/>
+              <a:t>7</a:t>
+            </a:r>
+            <a:pPr indent="0" marL="0">
+              <a:buNone/>
+            </a:pPr>
+            <a:r>
+              <a:rPr lang="en-US" sz="1500" b="1" dirty="0">
+                <a:solidFill>
+                  <a:srgbClr val="0B2545"/>
+                </a:solidFill>
+                <a:latin typeface="Calibri" pitchFamily="34" charset="0"/>
+                <a:ea typeface="Calibri" pitchFamily="34" charset="-122"/>
+                <a:cs typeface="Calibri" pitchFamily="34" charset="-120"/>
+              </a:rPr>
+              <a:t>  días</a:t>
+            </a:r>
+            <a:endParaRPr lang="en-US" sz="4000" dirty="0"/>
           </a:p>
         </p:txBody>
       </p:sp>
       <p:sp>
         <p:nvSpPr>
-          <p:cNvPr id="43" name="Text 41"/>
+          <p:cNvPr id="45" name="Text 43"/>
           <p:cNvSpPr txBox="1"/>
           <p:nvPr/>
         </p:nvSpPr>
         <p:spPr>
           <a:xfrm>
-            <a:off x="2523744" y="4169664"/>
-            <a:ext cx="1499616" cy="347472"/>
-          </a:xfrm>
-          <a:prstGeom prst="rect">
-            <a:avLst/>
-          </a:prstGeom>
-          <a:noFill/>
-          <a:ln/>
-        </p:spPr>
-        <p:txBody>
-          <a:bodyPr wrap="square" lIns="0" tIns="0" rIns="0" bIns="0" rtlCol="0" anchor="ctr"/>
-          <a:lstStyle/>
-          <a:p>
-            <a:pPr indent="0" marL="0">
-              <a:buNone/>
-            </a:pPr>
-            <a:r>
-              <a:rPr lang="en-US" sz="1900" b="1" dirty="0">
-                <a:solidFill>
-                  <a:srgbClr val="0B2545"/>
-                </a:solidFill>
-                <a:latin typeface="Calibri" pitchFamily="34" charset="0"/>
-                <a:ea typeface="Calibri" pitchFamily="34" charset="-122"/>
-                <a:cs typeface="Calibri" pitchFamily="34" charset="-120"/>
-              </a:rPr>
-              <a:t>23/10/2026</a:t>
-            </a:r>
-            <a:endParaRPr lang="en-US" sz="1900" dirty="0"/>
-          </a:p>
-        </p:txBody>
-      </p:sp>
-      <p:sp>
-        <p:nvSpPr>
-          <p:cNvPr id="44" name="Text 42"/>
-          <p:cNvSpPr txBox="1"/>
-          <p:nvPr/>
-        </p:nvSpPr>
-        <p:spPr>
-          <a:xfrm>
-            <a:off x="2523744" y="4572000"/>
-            <a:ext cx="1517904" cy="1024128"/>
+            <a:off x="3522726" y="4919472"/>
+            <a:ext cx="2315718" cy="1335024"/>
           </a:xfrm>
           <a:prstGeom prst="rect">
             <a:avLst/>
@@ -4791,52 +4760,72 @@
           <a:p>
             <a:pPr indent="0" marL="0">
               <a:spcAft>
-                <a:spcPts val="200"/>
+                <a:spcPts val="300"/>
               </a:spcAft>
               <a:buNone/>
             </a:pPr>
             <a:r>
-              <a:rPr lang="en-US" sz="1050" b="1" dirty="0">
-                <a:solidFill>
-                  <a:srgbClr val="1B2733"/>
-                </a:solidFill>
-                <a:latin typeface="Calibri" pitchFamily="34" charset="0"/>
-                <a:ea typeface="Calibri" pitchFamily="34" charset="-122"/>
-                <a:cs typeface="Calibri" pitchFamily="34" charset="-120"/>
-              </a:rPr>
-              <a:t>Nuevas observaciones – Gob. Corporativo</a:t>
-            </a:r>
-            <a:endParaRPr lang="en-US" sz="1050" dirty="0"/>
+              <a:rPr lang="en-US" sz="1300" b="1" dirty="0">
+                <a:solidFill>
+                  <a:srgbClr val="0B2545"/>
+                </a:solidFill>
+                <a:latin typeface="Calibri" pitchFamily="34" charset="0"/>
+                <a:ea typeface="Calibri" pitchFamily="34" charset="-122"/>
+                <a:cs typeface="Calibri" pitchFamily="34" charset="-120"/>
+              </a:rPr>
+              <a:t>23/10/2026</a:t>
+            </a:r>
+            <a:endParaRPr lang="en-US" sz="1300" dirty="0"/>
           </a:p>
           <a:p>
             <a:pPr indent="0" marL="0">
               <a:spcAft>
-                <a:spcPts val="200"/>
+                <a:spcPts val="300"/>
               </a:spcAft>
               <a:buNone/>
             </a:pPr>
             <a:r>
-              <a:rPr lang="en-US" sz="950" dirty="0">
-                <a:solidFill>
-                  <a:srgbClr val="13507F"/>
-                </a:solidFill>
-                <a:latin typeface="Calibri" pitchFamily="34" charset="0"/>
-                <a:ea typeface="Calibri" pitchFamily="34" charset="-122"/>
-                <a:cs typeface="Calibri" pitchFamily="34" charset="-120"/>
-              </a:rPr>
-              <a:t>Circular 22741</a:t>
-            </a:r>
-            <a:endParaRPr lang="en-US" sz="1050" dirty="0"/>
+              <a:rPr lang="en-US" sz="1150" dirty="0">
+                <a:solidFill>
+                  <a:srgbClr val="1B2733"/>
+                </a:solidFill>
+                <a:latin typeface="Calibri" pitchFamily="34" charset="0"/>
+                <a:ea typeface="Calibri" pitchFamily="34" charset="-122"/>
+                <a:cs typeface="Calibri" pitchFamily="34" charset="-120"/>
+              </a:rPr>
+              <a:t>Envío de nuevas observaciones – Gobierno Corporativo</a:t>
+            </a:r>
+            <a:endParaRPr lang="en-US" sz="1300" dirty="0"/>
           </a:p>
           <a:p>
             <a:pPr indent="0" marL="0">
               <a:spcAft>
-                <a:spcPts val="200"/>
+                <a:spcPts val="300"/>
               </a:spcAft>
               <a:buNone/>
             </a:pPr>
             <a:r>
-              <a:rPr lang="en-US" sz="950" i="1" dirty="0">
+              <a:rPr lang="en-US" sz="1000" dirty="0">
+                <a:solidFill>
+                  <a:srgbClr val="13507F"/>
+                </a:solidFill>
+                <a:latin typeface="Calibri" pitchFamily="34" charset="0"/>
+                <a:ea typeface="Calibri" pitchFamily="34" charset="-122"/>
+                <a:cs typeface="Calibri" pitchFamily="34" charset="-120"/>
+              </a:rPr>
+              <a:t>Circular 22741</a:t>
+            </a:r>
+            <a:endParaRPr lang="en-US" sz="1300" dirty="0"/>
+          </a:p>
+          <a:p>
+            <a:pPr indent="0" marL="0">
+              <a:spcAft>
+                <a:spcPts val="300"/>
+              </a:spcAft>
+              <a:buNone/>
+            </a:pPr>
+            <a:r>
+              <a:rPr lang="en-US" sz="1000" i="1" dirty="0">
                 <a:solidFill>
                   <a:srgbClr val="3E4F60"/>
                 </a:solidFill>
@@ -4844,26 +4833,26 @@
                 <a:ea typeface="Calibri" pitchFamily="34" charset="-122"/>
                 <a:cs typeface="Calibri" pitchFamily="34" charset="-120"/>
               </a:rPr>
-              <a:t>Requerimiento remitido a las áreas</a:t>
-            </a:r>
-            <a:endParaRPr lang="en-US" sz="1050" dirty="0"/>
+              <a:t>Semana: matriz y requerimiento enviado a las áreas</a:t>
+            </a:r>
+            <a:endParaRPr lang="en-US" sz="1300" dirty="0"/>
           </a:p>
         </p:txBody>
       </p:sp>
       <p:sp>
         <p:nvSpPr>
-          <p:cNvPr id="45" name="Shape 43"/>
+          <p:cNvPr id="46" name="Shape 44"/>
           <p:cNvSpPr/>
           <p:nvPr/>
         </p:nvSpPr>
         <p:spPr>
           <a:xfrm>
-            <a:off x="4297680" y="3877056"/>
-            <a:ext cx="1773936" cy="1810512"/>
+            <a:off x="6185916" y="4078224"/>
+            <a:ext cx="2681478" cy="2286000"/>
           </a:xfrm>
           <a:prstGeom prst="roundRect">
             <a:avLst>
-              <a:gd name="adj" fmla="val 5155"/>
+              <a:gd name="adj" fmla="val 4800"/>
             </a:avLst>
           </a:prstGeom>
           <a:solidFill>
@@ -4879,14 +4868,14 @@
       </p:sp>
       <p:sp>
         <p:nvSpPr>
-          <p:cNvPr id="46" name="Text 44"/>
+          <p:cNvPr id="47" name="Text 45"/>
           <p:cNvSpPr txBox="1"/>
           <p:nvPr/>
         </p:nvSpPr>
         <p:spPr>
           <a:xfrm>
-            <a:off x="4443984" y="3986784"/>
-            <a:ext cx="1499616" cy="182880"/>
+            <a:off x="6387084" y="4206240"/>
+            <a:ext cx="2315718" cy="658368"/>
           </a:xfrm>
           <a:prstGeom prst="rect">
             <a:avLst/>
@@ -4902,7 +4891,7 @@
               <a:buNone/>
             </a:pPr>
             <a:r>
-              <a:rPr lang="en-US" sz="850" b="1" spc="100" kern="0" dirty="0">
+              <a:rPr lang="en-US" sz="4000" b="1" dirty="0">
                 <a:solidFill>
                   <a:srgbClr val="B86E00"/>
                 </a:solidFill>
@@ -4910,38 +4899,13 @@
                 <a:ea typeface="Calibri" pitchFamily="34" charset="-122"/>
                 <a:cs typeface="Calibri" pitchFamily="34" charset="-120"/>
               </a:rPr>
-              <a:t>SEGUIMIENTO</a:t>
-            </a:r>
-            <a:endParaRPr lang="en-US" sz="850" dirty="0"/>
-          </a:p>
-        </p:txBody>
-      </p:sp>
-      <p:sp>
-        <p:nvSpPr>
-          <p:cNvPr id="47" name="Text 45"/>
-          <p:cNvSpPr txBox="1"/>
-          <p:nvPr/>
-        </p:nvSpPr>
-        <p:spPr>
-          <a:xfrm>
-            <a:off x="4443984" y="4169664"/>
-            <a:ext cx="1499616" cy="347472"/>
-          </a:xfrm>
-          <a:prstGeom prst="rect">
-            <a:avLst/>
-          </a:prstGeom>
-          <a:noFill/>
-          <a:ln/>
-        </p:spPr>
-        <p:txBody>
-          <a:bodyPr wrap="square" lIns="0" tIns="0" rIns="0" bIns="0" rtlCol="0" anchor="ctr"/>
-          <a:lstStyle/>
-          <a:p>
+              <a:t>14</a:t>
+            </a:r>
             <a:pPr indent="0" marL="0">
               <a:buNone/>
             </a:pPr>
             <a:r>
-              <a:rPr lang="en-US" sz="1900" b="1" dirty="0">
+              <a:rPr lang="en-US" sz="1500" b="1" dirty="0">
                 <a:solidFill>
                   <a:srgbClr val="0B2545"/>
                 </a:solidFill>
@@ -4949,9 +4913,9 @@
                 <a:ea typeface="Calibri" pitchFamily="34" charset="-122"/>
                 <a:cs typeface="Calibri" pitchFamily="34" charset="-120"/>
               </a:rPr>
-              <a:t>30/10/2026</a:t>
-            </a:r>
-            <a:endParaRPr lang="en-US" sz="1900" dirty="0"/>
+              <a:t>  días</a:t>
+            </a:r>
+            <a:endParaRPr lang="en-US" sz="4000" dirty="0"/>
           </a:p>
         </p:txBody>
       </p:sp>
@@ -4963,8 +4927,8 @@
         </p:nvSpPr>
         <p:spPr>
           <a:xfrm>
-            <a:off x="4443984" y="4572000"/>
-            <a:ext cx="1517904" cy="1024128"/>
+            <a:off x="6387084" y="4919472"/>
+            <a:ext cx="2315718" cy="1335024"/>
           </a:xfrm>
           <a:prstGeom prst="rect">
             <a:avLst/>
@@ -4978,52 +4942,72 @@
           <a:p>
             <a:pPr indent="0" marL="0">
               <a:spcAft>
-                <a:spcPts val="200"/>
+                <a:spcPts val="300"/>
               </a:spcAft>
               <a:buNone/>
             </a:pPr>
             <a:r>
-              <a:rPr lang="en-US" sz="1050" b="1" dirty="0">
-                <a:solidFill>
-                  <a:srgbClr val="1B2733"/>
-                </a:solidFill>
-                <a:latin typeface="Calibri" pitchFamily="34" charset="0"/>
-                <a:ea typeface="Calibri" pitchFamily="34" charset="-122"/>
-                <a:cs typeface="Calibri" pitchFamily="34" charset="-120"/>
-              </a:rPr>
-              <a:t>Seguimiento observaciones – Gob. Corporativo</a:t>
-            </a:r>
-            <a:endParaRPr lang="en-US" sz="1050" dirty="0"/>
+              <a:rPr lang="en-US" sz="1300" b="1" dirty="0">
+                <a:solidFill>
+                  <a:srgbClr val="0B2545"/>
+                </a:solidFill>
+                <a:latin typeface="Calibri" pitchFamily="34" charset="0"/>
+                <a:ea typeface="Calibri" pitchFamily="34" charset="-122"/>
+                <a:cs typeface="Calibri" pitchFamily="34" charset="-120"/>
+              </a:rPr>
+              <a:t>30/10/2026</a:t>
+            </a:r>
+            <a:endParaRPr lang="en-US" sz="1300" dirty="0"/>
           </a:p>
           <a:p>
             <a:pPr indent="0" marL="0">
               <a:spcAft>
-                <a:spcPts val="200"/>
+                <a:spcPts val="300"/>
               </a:spcAft>
               <a:buNone/>
             </a:pPr>
             <a:r>
-              <a:rPr lang="en-US" sz="950" dirty="0">
-                <a:solidFill>
-                  <a:srgbClr val="13507F"/>
-                </a:solidFill>
-                <a:latin typeface="Calibri" pitchFamily="34" charset="0"/>
-                <a:ea typeface="Calibri" pitchFamily="34" charset="-122"/>
-                <a:cs typeface="Calibri" pitchFamily="34" charset="-120"/>
-              </a:rPr>
-              <a:t>Circular 22741</a:t>
-            </a:r>
-            <a:endParaRPr lang="en-US" sz="1050" dirty="0"/>
+              <a:rPr lang="en-US" sz="1150" dirty="0">
+                <a:solidFill>
+                  <a:srgbClr val="1B2733"/>
+                </a:solidFill>
+                <a:latin typeface="Calibri" pitchFamily="34" charset="0"/>
+                <a:ea typeface="Calibri" pitchFamily="34" charset="-122"/>
+                <a:cs typeface="Calibri" pitchFamily="34" charset="-120"/>
+              </a:rPr>
+              <a:t>Seguimiento de observaciones – Gobierno Corporativo</a:t>
+            </a:r>
+            <a:endParaRPr lang="en-US" sz="1300" dirty="0"/>
           </a:p>
           <a:p>
             <a:pPr indent="0" marL="0">
               <a:spcAft>
-                <a:spcPts val="200"/>
+                <a:spcPts val="300"/>
               </a:spcAft>
               <a:buNone/>
             </a:pPr>
             <a:r>
-              <a:rPr lang="en-US" sz="950" i="1" dirty="0">
+              <a:rPr lang="en-US" sz="1000" dirty="0">
+                <a:solidFill>
+                  <a:srgbClr val="13507F"/>
+                </a:solidFill>
+                <a:latin typeface="Calibri" pitchFamily="34" charset="0"/>
+                <a:ea typeface="Calibri" pitchFamily="34" charset="-122"/>
+                <a:cs typeface="Calibri" pitchFamily="34" charset="-120"/>
+              </a:rPr>
+              <a:t>Circular 22741</a:t>
+            </a:r>
+            <a:endParaRPr lang="en-US" sz="1300" dirty="0"/>
+          </a:p>
+          <a:p>
+            <a:pPr indent="0" marL="0">
+              <a:spcAft>
+                <a:spcPts val="300"/>
+              </a:spcAft>
+              <a:buNone/>
+            </a:pPr>
+            <a:r>
+              <a:rPr lang="en-US" sz="1000" i="1" dirty="0">
                 <a:solidFill>
                   <a:srgbClr val="3E4F60"/>
                 </a:solidFill>
@@ -5031,9 +5015,9 @@
                 <a:ea typeface="Calibri" pitchFamily="34" charset="-122"/>
                 <a:cs typeface="Calibri" pitchFamily="34" charset="-120"/>
               </a:rPr>
-              <a:t>Plan de solución, visitas anteriores</a:t>
-            </a:r>
-            <a:endParaRPr lang="en-US" sz="1050" dirty="0"/>
+              <a:t>Semana: plan de solución de visitas anteriores</a:t>
+            </a:r>
+            <a:endParaRPr lang="en-US" sz="1300" dirty="0"/>
           </a:p>
         </p:txBody>
       </p:sp>
@@ -5045,12 +5029,12 @@
         </p:nvSpPr>
         <p:spPr>
           <a:xfrm>
-            <a:off x="6217920" y="3877056"/>
-            <a:ext cx="1773936" cy="1810512"/>
+            <a:off x="9050274" y="4078224"/>
+            <a:ext cx="2681478" cy="2286000"/>
           </a:xfrm>
           <a:prstGeom prst="roundRect">
             <a:avLst>
-              <a:gd name="adj" fmla="val 5155"/>
+              <a:gd name="adj" fmla="val 4800"/>
             </a:avLst>
           </a:prstGeom>
           <a:solidFill>
@@ -5072,8 +5056,8 @@
         </p:nvSpPr>
         <p:spPr>
           <a:xfrm>
-            <a:off x="6364224" y="3986784"/>
-            <a:ext cx="1499616" cy="182880"/>
+            <a:off x="9251442" y="4206240"/>
+            <a:ext cx="2315718" cy="658368"/>
           </a:xfrm>
           <a:prstGeom prst="rect">
             <a:avLst/>
@@ -5089,7 +5073,7 @@
               <a:buNone/>
             </a:pPr>
             <a:r>
-              <a:rPr lang="en-US" sz="850" b="1" spc="100" kern="0" dirty="0">
+              <a:rPr lang="en-US" sz="4000" b="1" dirty="0">
                 <a:solidFill>
                   <a:srgbClr val="B86E00"/>
                 </a:solidFill>
@@ -5097,9 +5081,23 @@
                 <a:ea typeface="Calibri" pitchFamily="34" charset="-122"/>
                 <a:cs typeface="Calibri" pitchFamily="34" charset="-120"/>
               </a:rPr>
-              <a:t>FECHA LÍMITE</a:t>
-            </a:r>
-            <a:endParaRPr lang="en-US" sz="850" dirty="0"/>
+              <a:t>18</a:t>
+            </a:r>
+            <a:pPr indent="0" marL="0">
+              <a:buNone/>
+            </a:pPr>
+            <a:r>
+              <a:rPr lang="en-US" sz="1500" b="1" dirty="0">
+                <a:solidFill>
+                  <a:srgbClr val="0B2545"/>
+                </a:solidFill>
+                <a:latin typeface="Calibri" pitchFamily="34" charset="0"/>
+                <a:ea typeface="Calibri" pitchFamily="34" charset="-122"/>
+                <a:cs typeface="Calibri" pitchFamily="34" charset="-120"/>
+              </a:rPr>
+              <a:t>  días</a:t>
+            </a:r>
+            <a:endParaRPr lang="en-US" sz="4000" dirty="0"/>
           </a:p>
         </p:txBody>
       </p:sp>
@@ -5111,8 +5109,90 @@
         </p:nvSpPr>
         <p:spPr>
           <a:xfrm>
-            <a:off x="6364224" y="4169664"/>
-            <a:ext cx="1499616" cy="347472"/>
+            <a:off x="9251442" y="4919472"/>
+            <a:ext cx="2315718" cy="1335024"/>
+          </a:xfrm>
+          <a:prstGeom prst="rect">
+            <a:avLst/>
+          </a:prstGeom>
+          <a:noFill/>
+          <a:ln/>
+        </p:spPr>
+        <p:txBody>
+          <a:bodyPr wrap="square" lIns="0" tIns="0" rIns="0" bIns="0" rtlCol="0" anchor="t"/>
+          <a:lstStyle/>
+          <a:p>
+            <a:pPr indent="0" marL="0">
+              <a:spcAft>
+                <a:spcPts val="300"/>
+              </a:spcAft>
+              <a:buNone/>
+            </a:pPr>
+            <a:r>
+              <a:rPr lang="en-US" sz="1300" b="1" dirty="0">
+                <a:solidFill>
+                  <a:srgbClr val="0B2545"/>
+                </a:solidFill>
+                <a:latin typeface="Calibri" pitchFamily="34" charset="0"/>
+                <a:ea typeface="Calibri" pitchFamily="34" charset="-122"/>
+                <a:cs typeface="Calibri" pitchFamily="34" charset="-120"/>
+              </a:rPr>
+              <a:t>03/11/2026</a:t>
+            </a:r>
+            <a:endParaRPr lang="en-US" sz="1300" dirty="0"/>
+          </a:p>
+          <a:p>
+            <a:pPr indent="0" marL="0">
+              <a:spcAft>
+                <a:spcPts val="300"/>
+              </a:spcAft>
+              <a:buNone/>
+            </a:pPr>
+            <a:r>
+              <a:rPr lang="en-US" sz="1150" dirty="0">
+                <a:solidFill>
+                  <a:srgbClr val="1B2733"/>
+                </a:solidFill>
+                <a:latin typeface="Calibri" pitchFamily="34" charset="0"/>
+                <a:ea typeface="Calibri" pitchFamily="34" charset="-122"/>
+                <a:cs typeface="Calibri" pitchFamily="34" charset="-120"/>
+              </a:rPr>
+              <a:t>Envío del Plan de Recuperación</a:t>
+            </a:r>
+            <a:endParaRPr lang="en-US" sz="1300" dirty="0"/>
+          </a:p>
+          <a:p>
+            <a:pPr indent="0" marL="0">
+              <a:spcAft>
+                <a:spcPts val="300"/>
+              </a:spcAft>
+              <a:buNone/>
+            </a:pPr>
+            <a:r>
+              <a:rPr lang="en-US" sz="1000" dirty="0">
+                <a:solidFill>
+                  <a:srgbClr val="13507F"/>
+                </a:solidFill>
+                <a:latin typeface="Calibri" pitchFamily="34" charset="0"/>
+                <a:ea typeface="Calibri" pitchFamily="34" charset="-122"/>
+                <a:cs typeface="Calibri" pitchFamily="34" charset="-120"/>
+              </a:rPr>
+              <a:t>Circular 22737</a:t>
+            </a:r>
+            <a:endParaRPr lang="en-US" sz="1300" dirty="0"/>
+          </a:p>
+        </p:txBody>
+      </p:sp>
+      <p:sp>
+        <p:nvSpPr>
+          <p:cNvPr id="52" name="Text 50"/>
+          <p:cNvSpPr txBox="1"/>
+          <p:nvPr/>
+        </p:nvSpPr>
+        <p:spPr>
+          <a:xfrm>
+            <a:off x="457200" y="6519672"/>
+            <a:ext cx="11274552" cy="219456"/>
           </a:xfrm>
           <a:prstGeom prst="rect">
             <a:avLst/>
@@ -5128,742 +5208,6 @@
               <a:buNone/>
             </a:pPr>
             <a:r>
-              <a:rPr lang="en-US" sz="1900" b="1" dirty="0">
-                <a:solidFill>
-                  <a:srgbClr val="0B2545"/>
-                </a:solidFill>
-                <a:latin typeface="Calibri" pitchFamily="34" charset="0"/>
-                <a:ea typeface="Calibri" pitchFamily="34" charset="-122"/>
-                <a:cs typeface="Calibri" pitchFamily="34" charset="-120"/>
-              </a:rPr>
-              <a:t>03/11/2026</a:t>
-            </a:r>
-            <a:endParaRPr lang="en-US" sz="1900" dirty="0"/>
-          </a:p>
-        </p:txBody>
-      </p:sp>
-      <p:sp>
-        <p:nvSpPr>
-          <p:cNvPr id="52" name="Text 50"/>
-          <p:cNvSpPr txBox="1"/>
-          <p:nvPr/>
-        </p:nvSpPr>
-        <p:spPr>
-          <a:xfrm>
-            <a:off x="6364224" y="4572000"/>
-            <a:ext cx="1517904" cy="1024128"/>
-          </a:xfrm>
-          <a:prstGeom prst="rect">
-            <a:avLst/>
-          </a:prstGeom>
-          <a:noFill/>
-          <a:ln/>
-        </p:spPr>
-        <p:txBody>
-          <a:bodyPr wrap="square" lIns="0" tIns="0" rIns="0" bIns="0" rtlCol="0" anchor="t"/>
-          <a:lstStyle/>
-          <a:p>
-            <a:pPr indent="0" marL="0">
-              <a:spcAft>
-                <a:spcPts val="200"/>
-              </a:spcAft>
-              <a:buNone/>
-            </a:pPr>
-            <a:r>
-              <a:rPr lang="en-US" sz="1050" b="1" dirty="0">
-                <a:solidFill>
-                  <a:srgbClr val="1B2733"/>
-                </a:solidFill>
-                <a:latin typeface="Calibri" pitchFamily="34" charset="0"/>
-                <a:ea typeface="Calibri" pitchFamily="34" charset="-122"/>
-                <a:cs typeface="Calibri" pitchFamily="34" charset="-120"/>
-              </a:rPr>
-              <a:t>Envío del Plan de Recuperación</a:t>
-            </a:r>
-            <a:endParaRPr lang="en-US" sz="1050" dirty="0"/>
-          </a:p>
-          <a:p>
-            <a:pPr indent="0" marL="0">
-              <a:spcAft>
-                <a:spcPts val="200"/>
-              </a:spcAft>
-              <a:buNone/>
-            </a:pPr>
-            <a:r>
-              <a:rPr lang="en-US" sz="950" dirty="0">
-                <a:solidFill>
-                  <a:srgbClr val="13507F"/>
-                </a:solidFill>
-                <a:latin typeface="Calibri" pitchFamily="34" charset="0"/>
-                <a:ea typeface="Calibri" pitchFamily="34" charset="-122"/>
-                <a:cs typeface="Calibri" pitchFamily="34" charset="-120"/>
-              </a:rPr>
-              <a:t>Circular 22737</a:t>
-            </a:r>
-            <a:endParaRPr lang="en-US" sz="1050" dirty="0"/>
-          </a:p>
-          <a:p>
-            <a:pPr indent="0" marL="0">
-              <a:spcAft>
-                <a:spcPts val="200"/>
-              </a:spcAft>
-              <a:buNone/>
-            </a:pPr>
-            <a:r>
-              <a:rPr lang="en-US" sz="950" i="1" dirty="0">
-                <a:solidFill>
-                  <a:srgbClr val="3E4F60"/>
-                </a:solidFill>
-                <a:latin typeface="Calibri" pitchFamily="34" charset="0"/>
-                <a:ea typeface="Calibri" pitchFamily="34" charset="-122"/>
-                <a:cs typeface="Calibri" pitchFamily="34" charset="-120"/>
-              </a:rPr>
-              <a:t>Indicadores Gob. Corp. y Reputacional</a:t>
-            </a:r>
-            <a:endParaRPr lang="en-US" sz="1050" dirty="0"/>
-          </a:p>
-        </p:txBody>
-      </p:sp>
-      <p:sp>
-        <p:nvSpPr>
-          <p:cNvPr id="53" name="Shape 51"/>
-          <p:cNvSpPr/>
-          <p:nvPr/>
-        </p:nvSpPr>
-        <p:spPr>
-          <a:xfrm>
-            <a:off x="457200" y="5815584"/>
-            <a:ext cx="7534656" cy="621792"/>
-          </a:xfrm>
-          <a:prstGeom prst="roundRect">
-            <a:avLst>
-              <a:gd name="adj" fmla="val 14706"/>
-            </a:avLst>
-          </a:prstGeom>
-          <a:solidFill>
-            <a:srgbClr val="D7F0F2"/>
-          </a:solidFill>
-          <a:ln w="12700">
-            <a:solidFill>
-              <a:srgbClr val="D7F0F2"/>
-            </a:solidFill>
-            <a:prstDash val="solid"/>
-          </a:ln>
-        </p:spPr>
-      </p:sp>
-      <p:sp>
-        <p:nvSpPr>
-          <p:cNvPr id="54" name="Shape 52"/>
-          <p:cNvSpPr/>
-          <p:nvPr/>
-        </p:nvSpPr>
-        <p:spPr>
-          <a:xfrm>
-            <a:off x="585216" y="5925312"/>
-            <a:ext cx="402336" cy="402336"/>
-          </a:xfrm>
-          <a:prstGeom prst="ellipse">
-            <a:avLst/>
-          </a:prstGeom>
-          <a:solidFill>
-            <a:srgbClr val="0E9AA7"/>
-          </a:solidFill>
-          <a:ln w="12700">
-            <a:solidFill>
-              <a:srgbClr val="0E9AA7"/>
-            </a:solidFill>
-            <a:prstDash val="solid"/>
-          </a:ln>
-        </p:spPr>
-      </p:sp>
-      <p:pic>
-        <p:nvPicPr>
-          <p:cNvPr id="55" name="Image 0" descr="preencoded.png">    </p:cNvPr>
-          <p:cNvPicPr>
-            <a:picLocks noChangeAspect="1"/>
-          </p:cNvPicPr>
-          <p:nvPr/>
-        </p:nvPicPr>
-        <p:blipFill>
-          <a:blip r:embed="rId1"/>
-          <a:stretch>
-            <a:fillRect/>
-          </a:stretch>
-        </p:blipFill>
-        <p:spPr>
-          <a:xfrm>
-            <a:off x="685800" y="6025896"/>
-            <a:ext cx="201168" cy="201168"/>
-          </a:xfrm>
-          <a:prstGeom prst="rect">
-            <a:avLst/>
-          </a:prstGeom>
-        </p:spPr>
-      </p:pic>
-      <p:sp>
-        <p:nvSpPr>
-          <p:cNvPr id="56" name="Text 53"/>
-          <p:cNvSpPr txBox="1"/>
-          <p:nvPr/>
-        </p:nvSpPr>
-        <p:spPr>
-          <a:xfrm>
-            <a:off x="1115568" y="5870448"/>
-            <a:ext cx="6757416" cy="512064"/>
-          </a:xfrm>
-          <a:prstGeom prst="rect">
-            <a:avLst/>
-          </a:prstGeom>
-          <a:noFill/>
-          <a:ln/>
-        </p:spPr>
-        <p:txBody>
-          <a:bodyPr wrap="square" lIns="0" tIns="0" rIns="0" bIns="0" rtlCol="0" anchor="ctr"/>
-          <a:lstStyle/>
-          <a:p>
-            <a:pPr indent="0" marL="0">
-              <a:buNone/>
-            </a:pPr>
-            <a:r>
-              <a:rPr lang="en-US" sz="1100" b="1" dirty="0">
-                <a:solidFill>
-                  <a:srgbClr val="0B2545"/>
-                </a:solidFill>
-                <a:latin typeface="Calibri" pitchFamily="34" charset="0"/>
-                <a:ea typeface="Calibri" pitchFamily="34" charset="-122"/>
-                <a:cs typeface="Calibri" pitchFamily="34" charset="-120"/>
-              </a:rPr>
-              <a:t>Visita inicial Riesgos Específicos · Circ. 22742  </a:t>
-            </a:r>
-            <a:pPr indent="0" marL="0">
-              <a:buNone/>
-            </a:pPr>
-            <a:r>
-              <a:rPr lang="en-US" sz="1050" dirty="0">
-                <a:solidFill>
-                  <a:srgbClr val="1B2733"/>
-                </a:solidFill>
-                <a:latin typeface="Calibri" pitchFamily="34" charset="0"/>
-                <a:ea typeface="Calibri" pitchFamily="34" charset="-122"/>
-                <a:cs typeface="Calibri" pitchFamily="34" charset="-120"/>
-              </a:rPr>
-              <a:t>Crédito, Liquidez y Mercado · recepción 24/09/2026, inicio 09/10/2026. Presentación de resultados preliminares registrada; plazo de respuesta no documentado.</a:t>
-            </a:r>
-            <a:endParaRPr lang="en-US" sz="1100" dirty="0"/>
-          </a:p>
-        </p:txBody>
-      </p:sp>
-      <p:sp>
-        <p:nvSpPr>
-          <p:cNvPr id="57" name="Shape 54"/>
-          <p:cNvSpPr/>
-          <p:nvPr/>
-        </p:nvSpPr>
-        <p:spPr>
-          <a:xfrm>
-            <a:off x="8193024" y="3877056"/>
-            <a:ext cx="3538728" cy="2560320"/>
-          </a:xfrm>
-          <a:prstGeom prst="roundRect">
-            <a:avLst>
-              <a:gd name="adj" fmla="val 4286"/>
-            </a:avLst>
-          </a:prstGeom>
-          <a:solidFill>
-            <a:srgbClr val="0B2545"/>
-          </a:solidFill>
-          <a:ln w="12700">
-            <a:solidFill>
-              <a:srgbClr val="0B2545"/>
-            </a:solidFill>
-            <a:prstDash val="solid"/>
-          </a:ln>
-        </p:spPr>
-      </p:sp>
-      <p:sp>
-        <p:nvSpPr>
-          <p:cNvPr id="58" name="Text 55"/>
-          <p:cNvSpPr txBox="1"/>
-          <p:nvPr/>
-        </p:nvSpPr>
-        <p:spPr>
-          <a:xfrm>
-            <a:off x="8421624" y="4005072"/>
-            <a:ext cx="3172968" cy="310896"/>
-          </a:xfrm>
-          <a:prstGeom prst="rect">
-            <a:avLst/>
-          </a:prstGeom>
-          <a:noFill/>
-          <a:ln/>
-        </p:spPr>
-        <p:txBody>
-          <a:bodyPr wrap="square" lIns="0" tIns="0" rIns="0" bIns="0" rtlCol="0" anchor="ctr"/>
-          <a:lstStyle/>
-          <a:p>
-            <a:pPr indent="0" marL="0">
-              <a:buNone/>
-            </a:pPr>
-            <a:r>
-              <a:rPr lang="en-US" sz="1500" b="1" dirty="0">
-                <a:solidFill>
-                  <a:srgbClr val="FFFFFF"/>
-                </a:solidFill>
-                <a:latin typeface="Calibri" pitchFamily="34" charset="0"/>
-                <a:ea typeface="Calibri" pitchFamily="34" charset="-122"/>
-                <a:cs typeface="Calibri" pitchFamily="34" charset="-120"/>
-              </a:rPr>
-              <a:t>Puntos de control gerencial</a:t>
-            </a:r>
-            <a:endParaRPr lang="en-US" sz="1500" dirty="0"/>
-          </a:p>
-        </p:txBody>
-      </p:sp>
-      <p:sp>
-        <p:nvSpPr>
-          <p:cNvPr id="59" name="Shape 56"/>
-          <p:cNvSpPr/>
-          <p:nvPr/>
-        </p:nvSpPr>
-        <p:spPr>
-          <a:xfrm>
-            <a:off x="8421624" y="4425696"/>
-            <a:ext cx="329184" cy="329184"/>
-          </a:xfrm>
-          <a:prstGeom prst="ellipse">
-            <a:avLst/>
-          </a:prstGeom>
-          <a:solidFill>
-            <a:srgbClr val="0E9AA7"/>
-          </a:solidFill>
-          <a:ln w="12700">
-            <a:solidFill>
-              <a:srgbClr val="0E9AA7"/>
-            </a:solidFill>
-            <a:prstDash val="solid"/>
-          </a:ln>
-        </p:spPr>
-      </p:sp>
-      <p:pic>
-        <p:nvPicPr>
-          <p:cNvPr id="60" name="Image 1" descr="preencoded.png">    </p:cNvPr>
-          <p:cNvPicPr>
-            <a:picLocks noChangeAspect="1"/>
-          </p:cNvPicPr>
-          <p:nvPr/>
-        </p:nvPicPr>
-        <p:blipFill>
-          <a:blip r:embed="rId2"/>
-          <a:stretch>
-            <a:fillRect/>
-          </a:stretch>
-        </p:blipFill>
-        <p:spPr>
-          <a:xfrm>
-            <a:off x="8503920" y="4507992"/>
-            <a:ext cx="164592" cy="164592"/>
-          </a:xfrm>
-          <a:prstGeom prst="rect">
-            <a:avLst/>
-          </a:prstGeom>
-        </p:spPr>
-      </p:pic>
-      <p:sp>
-        <p:nvSpPr>
-          <p:cNvPr id="61" name="Text 57"/>
-          <p:cNvSpPr txBox="1"/>
-          <p:nvPr/>
-        </p:nvSpPr>
-        <p:spPr>
-          <a:xfrm>
-            <a:off x="8869680" y="4389120"/>
-            <a:ext cx="2697480" cy="530352"/>
-          </a:xfrm>
-          <a:prstGeom prst="rect">
-            <a:avLst/>
-          </a:prstGeom>
-          <a:noFill/>
-          <a:ln/>
-        </p:spPr>
-        <p:txBody>
-          <a:bodyPr wrap="square" lIns="0" tIns="0" rIns="0" bIns="0" rtlCol="0" anchor="t"/>
-          <a:lstStyle/>
-          <a:p>
-            <a:pPr indent="0" marL="0">
-              <a:buNone/>
-            </a:pPr>
-            <a:r>
-              <a:rPr lang="en-US" sz="1100" b="1" dirty="0">
-                <a:solidFill>
-                  <a:srgbClr val="FFFFFF"/>
-                </a:solidFill>
-                <a:latin typeface="Calibri" pitchFamily="34" charset="0"/>
-                <a:ea typeface="Calibri" pitchFamily="34" charset="-122"/>
-                <a:cs typeface="Calibri" pitchFamily="34" charset="-120"/>
-              </a:rPr>
-              <a:t>Coordinación entre áreas</a:t>
-            </a:r>
-            <a:endParaRPr lang="en-US" sz="1100" dirty="0"/>
-          </a:p>
-          <a:p>
-            <a:pPr indent="0" marL="0">
-              <a:buNone/>
-            </a:pPr>
-            <a:r>
-              <a:rPr lang="en-US" sz="950" dirty="0">
-                <a:solidFill>
-                  <a:srgbClr val="D3DEEA"/>
-                </a:solidFill>
-                <a:latin typeface="Calibri" pitchFamily="34" charset="0"/>
-                <a:ea typeface="Calibri" pitchFamily="34" charset="-122"/>
-                <a:cs typeface="Calibri" pitchFamily="34" charset="-120"/>
-              </a:rPr>
-              <a:t>Nota 22741: Gerencia Financiera, Cumplimiento, Talento Humano, Procesos y otras áreas</a:t>
-            </a:r>
-            <a:endParaRPr lang="en-US" sz="1100" dirty="0"/>
-          </a:p>
-        </p:txBody>
-      </p:sp>
-      <p:sp>
-        <p:nvSpPr>
-          <p:cNvPr id="62" name="Shape 58"/>
-          <p:cNvSpPr/>
-          <p:nvPr/>
-        </p:nvSpPr>
-        <p:spPr>
-          <a:xfrm>
-            <a:off x="8421624" y="4928616"/>
-            <a:ext cx="329184" cy="329184"/>
-          </a:xfrm>
-          <a:prstGeom prst="ellipse">
-            <a:avLst/>
-          </a:prstGeom>
-          <a:solidFill>
-            <a:srgbClr val="0E9AA7"/>
-          </a:solidFill>
-          <a:ln w="12700">
-            <a:solidFill>
-              <a:srgbClr val="0E9AA7"/>
-            </a:solidFill>
-            <a:prstDash val="solid"/>
-          </a:ln>
-        </p:spPr>
-      </p:sp>
-      <p:pic>
-        <p:nvPicPr>
-          <p:cNvPr id="63" name="Image 2" descr="preencoded.png">    </p:cNvPr>
-          <p:cNvPicPr>
-            <a:picLocks noChangeAspect="1"/>
-          </p:cNvPicPr>
-          <p:nvPr/>
-        </p:nvPicPr>
-        <p:blipFill>
-          <a:blip r:embed="rId3"/>
-          <a:stretch>
-            <a:fillRect/>
-          </a:stretch>
-        </p:blipFill>
-        <p:spPr>
-          <a:xfrm>
-            <a:off x="8503920" y="5010912"/>
-            <a:ext cx="164592" cy="164592"/>
-          </a:xfrm>
-          <a:prstGeom prst="rect">
-            <a:avLst/>
-          </a:prstGeom>
-        </p:spPr>
-      </p:pic>
-      <p:sp>
-        <p:nvSpPr>
-          <p:cNvPr id="64" name="Text 59"/>
-          <p:cNvSpPr txBox="1"/>
-          <p:nvPr/>
-        </p:nvSpPr>
-        <p:spPr>
-          <a:xfrm>
-            <a:off x="8869680" y="4892040"/>
-            <a:ext cx="2697480" cy="530352"/>
-          </a:xfrm>
-          <a:prstGeom prst="rect">
-            <a:avLst/>
-          </a:prstGeom>
-          <a:noFill/>
-          <a:ln/>
-        </p:spPr>
-        <p:txBody>
-          <a:bodyPr wrap="square" lIns="0" tIns="0" rIns="0" bIns="0" rtlCol="0" anchor="t"/>
-          <a:lstStyle/>
-          <a:p>
-            <a:pPr indent="0" marL="0">
-              <a:buNone/>
-            </a:pPr>
-            <a:r>
-              <a:rPr lang="en-US" sz="1100" b="1" dirty="0">
-                <a:solidFill>
-                  <a:srgbClr val="FFFFFF"/>
-                </a:solidFill>
-                <a:latin typeface="Calibri" pitchFamily="34" charset="0"/>
-                <a:ea typeface="Calibri" pitchFamily="34" charset="-122"/>
-                <a:cs typeface="Calibri" pitchFamily="34" charset="-120"/>
-              </a:rPr>
-              <a:t>Evidencias y pruebas de descargo</a:t>
-            </a:r>
-            <a:endParaRPr lang="en-US" sz="1100" dirty="0"/>
-          </a:p>
-          <a:p>
-            <a:pPr indent="0" marL="0">
-              <a:buNone/>
-            </a:pPr>
-            <a:r>
-              <a:rPr lang="en-US" sz="950" dirty="0">
-                <a:solidFill>
-                  <a:srgbClr val="D3DEEA"/>
-                </a:solidFill>
-                <a:latin typeface="Calibri" pitchFamily="34" charset="0"/>
-                <a:ea typeface="Calibri" pitchFamily="34" charset="-122"/>
-                <a:cs typeface="Calibri" pitchFamily="34" charset="-120"/>
-              </a:rPr>
-              <a:t>Revisión y remisión para notas 22741 y 23486</a:t>
-            </a:r>
-            <a:endParaRPr lang="en-US" sz="1100" dirty="0"/>
-          </a:p>
-        </p:txBody>
-      </p:sp>
-      <p:sp>
-        <p:nvSpPr>
-          <p:cNvPr id="65" name="Shape 60"/>
-          <p:cNvSpPr/>
-          <p:nvPr/>
-        </p:nvSpPr>
-        <p:spPr>
-          <a:xfrm>
-            <a:off x="8421624" y="5431536"/>
-            <a:ext cx="329184" cy="329184"/>
-          </a:xfrm>
-          <a:prstGeom prst="ellipse">
-            <a:avLst/>
-          </a:prstGeom>
-          <a:solidFill>
-            <a:srgbClr val="0E9AA7"/>
-          </a:solidFill>
-          <a:ln w="12700">
-            <a:solidFill>
-              <a:srgbClr val="0E9AA7"/>
-            </a:solidFill>
-            <a:prstDash val="solid"/>
-          </a:ln>
-        </p:spPr>
-      </p:sp>
-      <p:pic>
-        <p:nvPicPr>
-          <p:cNvPr id="66" name="Image 3" descr="preencoded.png">    </p:cNvPr>
-          <p:cNvPicPr>
-            <a:picLocks noChangeAspect="1"/>
-          </p:cNvPicPr>
-          <p:nvPr/>
-        </p:nvPicPr>
-        <p:blipFill>
-          <a:blip r:embed="rId4"/>
-          <a:stretch>
-            <a:fillRect/>
-          </a:stretch>
-        </p:blipFill>
-        <p:spPr>
-          <a:xfrm>
-            <a:off x="8503920" y="5513832"/>
-            <a:ext cx="164592" cy="164592"/>
-          </a:xfrm>
-          <a:prstGeom prst="rect">
-            <a:avLst/>
-          </a:prstGeom>
-        </p:spPr>
-      </p:pic>
-      <p:sp>
-        <p:nvSpPr>
-          <p:cNvPr id="67" name="Text 61"/>
-          <p:cNvSpPr txBox="1"/>
-          <p:nvPr/>
-        </p:nvSpPr>
-        <p:spPr>
-          <a:xfrm>
-            <a:off x="8869680" y="5394960"/>
-            <a:ext cx="2697480" cy="530352"/>
-          </a:xfrm>
-          <a:prstGeom prst="rect">
-            <a:avLst/>
-          </a:prstGeom>
-          <a:noFill/>
-          <a:ln/>
-        </p:spPr>
-        <p:txBody>
-          <a:bodyPr wrap="square" lIns="0" tIns="0" rIns="0" bIns="0" rtlCol="0" anchor="t"/>
-          <a:lstStyle/>
-          <a:p>
-            <a:pPr indent="0" marL="0">
-              <a:buNone/>
-            </a:pPr>
-            <a:r>
-              <a:rPr lang="en-US" sz="1100" b="1" dirty="0">
-                <a:solidFill>
-                  <a:srgbClr val="FFFFFF"/>
-                </a:solidFill>
-                <a:latin typeface="Calibri" pitchFamily="34" charset="0"/>
-                <a:ea typeface="Calibri" pitchFamily="34" charset="-122"/>
-                <a:cs typeface="Calibri" pitchFamily="34" charset="-120"/>
-              </a:rPr>
-              <a:t>Entregables y planes de acción</a:t>
-            </a:r>
-            <a:endParaRPr lang="en-US" sz="1100" dirty="0"/>
-          </a:p>
-          <a:p>
-            <a:pPr indent="0" marL="0">
-              <a:buNone/>
-            </a:pPr>
-            <a:r>
-              <a:rPr lang="en-US" sz="950" dirty="0">
-                <a:solidFill>
-                  <a:srgbClr val="D3DEEA"/>
-                </a:solidFill>
-                <a:latin typeface="Calibri" pitchFamily="34" charset="0"/>
-                <a:ea typeface="Calibri" pitchFamily="34" charset="-122"/>
-                <a:cs typeface="Calibri" pitchFamily="34" charset="-120"/>
-              </a:rPr>
-              <a:t>Matriz de Riesgos 2026, informes al Comité de Riesgos, Plan de Recuperación</a:t>
-            </a:r>
-            <a:endParaRPr lang="en-US" sz="1100" dirty="0"/>
-          </a:p>
-        </p:txBody>
-      </p:sp>
-      <p:sp>
-        <p:nvSpPr>
-          <p:cNvPr id="68" name="Shape 62"/>
-          <p:cNvSpPr/>
-          <p:nvPr/>
-        </p:nvSpPr>
-        <p:spPr>
-          <a:xfrm>
-            <a:off x="8421624" y="5934456"/>
-            <a:ext cx="329184" cy="329184"/>
-          </a:xfrm>
-          <a:prstGeom prst="ellipse">
-            <a:avLst/>
-          </a:prstGeom>
-          <a:solidFill>
-            <a:srgbClr val="0E9AA7"/>
-          </a:solidFill>
-          <a:ln w="12700">
-            <a:solidFill>
-              <a:srgbClr val="0E9AA7"/>
-            </a:solidFill>
-            <a:prstDash val="solid"/>
-          </a:ln>
-        </p:spPr>
-      </p:sp>
-      <p:pic>
-        <p:nvPicPr>
-          <p:cNvPr id="69" name="Image 4" descr="preencoded.png">    </p:cNvPr>
-          <p:cNvPicPr>
-            <a:picLocks noChangeAspect="1"/>
-          </p:cNvPicPr>
-          <p:nvPr/>
-        </p:nvPicPr>
-        <p:blipFill>
-          <a:blip r:embed="rId5"/>
-          <a:stretch>
-            <a:fillRect/>
-          </a:stretch>
-        </p:blipFill>
-        <p:spPr>
-          <a:xfrm>
-            <a:off x="8503920" y="6016752"/>
-            <a:ext cx="164592" cy="164592"/>
-          </a:xfrm>
-          <a:prstGeom prst="rect">
-            <a:avLst/>
-          </a:prstGeom>
-        </p:spPr>
-      </p:pic>
-      <p:sp>
-        <p:nvSpPr>
-          <p:cNvPr id="70" name="Text 63"/>
-          <p:cNvSpPr txBox="1"/>
-          <p:nvPr/>
-        </p:nvSpPr>
-        <p:spPr>
-          <a:xfrm>
-            <a:off x="8869680" y="5897880"/>
-            <a:ext cx="2697480" cy="530352"/>
-          </a:xfrm>
-          <a:prstGeom prst="rect">
-            <a:avLst/>
-          </a:prstGeom>
-          <a:noFill/>
-          <a:ln/>
-        </p:spPr>
-        <p:txBody>
-          <a:bodyPr wrap="square" lIns="0" tIns="0" rIns="0" bIns="0" rtlCol="0" anchor="t"/>
-          <a:lstStyle/>
-          <a:p>
-            <a:pPr indent="0" marL="0">
-              <a:buNone/>
-            </a:pPr>
-            <a:r>
-              <a:rPr lang="en-US" sz="1100" b="1" dirty="0">
-                <a:solidFill>
-                  <a:srgbClr val="FFFFFF"/>
-                </a:solidFill>
-                <a:latin typeface="Calibri" pitchFamily="34" charset="0"/>
-                <a:ea typeface="Calibri" pitchFamily="34" charset="-122"/>
-                <a:cs typeface="Calibri" pitchFamily="34" charset="-120"/>
-              </a:rPr>
-              <a:t>Por confirmar</a:t>
-            </a:r>
-            <a:endParaRPr lang="en-US" sz="1100" dirty="0"/>
-          </a:p>
-          <a:p>
-            <a:pPr indent="0" marL="0">
-              <a:buNone/>
-            </a:pPr>
-            <a:r>
-              <a:rPr lang="en-US" sz="950" dirty="0">
-                <a:solidFill>
-                  <a:srgbClr val="D3DEEA"/>
-                </a:solidFill>
-                <a:latin typeface="Calibri" pitchFamily="34" charset="0"/>
-                <a:ea typeface="Calibri" pitchFamily="34" charset="-122"/>
-                <a:cs typeface="Calibri" pitchFamily="34" charset="-120"/>
-              </a:rPr>
-              <a:t>Estado de envío de cada requerimiento y responsable asignado</a:t>
-            </a:r>
-            <a:endParaRPr lang="en-US" sz="1100" dirty="0"/>
-          </a:p>
-        </p:txBody>
-      </p:sp>
-      <p:sp>
-        <p:nvSpPr>
-          <p:cNvPr id="71" name="Text 64"/>
-          <p:cNvSpPr txBox="1"/>
-          <p:nvPr/>
-        </p:nvSpPr>
-        <p:spPr>
-          <a:xfrm>
-            <a:off x="457200" y="6519672"/>
-            <a:ext cx="11274552" cy="219456"/>
-          </a:xfrm>
-          <a:prstGeom prst="rect">
-            <a:avLst/>
-          </a:prstGeom>
-          <a:noFill/>
-          <a:ln/>
-        </p:spPr>
-        <p:txBody>
-          <a:bodyPr wrap="square" lIns="0" tIns="0" rIns="0" bIns="0" rtlCol="0" anchor="ctr"/>
-          <a:lstStyle/>
-          <a:p>
-            <a:pPr indent="0" marL="0">
-              <a:buNone/>
-            </a:pPr>
-            <a:r>
               <a:rPr lang="en-US" sz="900" dirty="0">
                 <a:solidFill>
                   <a:srgbClr val="4A5A6A"/>
@@ -5872,7 +5216,7 @@
                 <a:ea typeface="Calibri" pitchFamily="34" charset="-122"/>
                 <a:cs typeface="Calibri" pitchFamily="34" charset="-120"/>
               </a:rPr>
-              <a:t>Fechas según la presentación base (referencia 10/10/2026). Fecha límite, inicio de visita y recepción se distinguen en la leyenda; el estado de cada envío está por confirmar.</a:t>
+              <a:t>Riesgos Específicos (Circ. 22742): visita iniciada el 09/10/2026, sin plazo de respuesta documentado. El estado de envío de cada requerimiento está por confirmar.</a:t>
             </a:r>
             <a:endParaRPr lang="en-US" sz="900" dirty="0"/>
           </a:p>

</xml_diff>

<commit_message>
Slide 2: replace 'Vence hoy' with the deadline date
Co-Authored-By: Claude Opus 5.5 <noreply@anthropic.com>
Claude-Session: https://claude.ai/code/session_01QGTe9h3kfUS6BTZosfrxzF
</commit_message>
<xml_diff>
--- a/resumen-ejecutivo-semanal/Resumen_Ejecutivo_Riesgos_COMEDICA_2_Slides.pptx
+++ b/resumen-ejecutivo-semanal/Resumen_Ejecutivo_Riesgos_COMEDICA_2_Slides.pptx
@@ -591,7 +591,7 @@
           <a:p>
             <a:r>
               <a:rPr lang="en-US" dirty="0"/>
-              <a:t>Corte 16/10. Hoy vence la respuesta PLD/FT (Circ. 23486). Siguen Gobierno Corporativo el 23/10 y 30/10 (Circ. 22741) y el Plan de Recuperación el 03/11 (Circ. 22737).</a:t>
+              <a:t>Corte 16/10. Plazo de respuesta PLD/FT: 16/10 (Circ. 23486). Siguen Gobierno Corporativo el 23/10 y 30/10 (Circ. 22741) y el Plan de Recuperación el 03/11 (Circ. 22737).</a:t>
             </a:r>
             <a:endParaRPr lang="en-US" dirty="0"/>
           </a:p>
@@ -4541,7 +4541,7 @@
               <a:buNone/>
             </a:pPr>
             <a:r>
-              <a:rPr lang="en-US" sz="3000" b="1" dirty="0">
+              <a:rPr lang="en-US" sz="4000" b="1" dirty="0">
                 <a:solidFill>
                   <a:srgbClr val="F6C26B"/>
                 </a:solidFill>
@@ -4549,9 +4549,9 @@
                 <a:ea typeface="Calibri" pitchFamily="34" charset="-122"/>
                 <a:cs typeface="Calibri" pitchFamily="34" charset="-120"/>
               </a:rPr>
-              <a:t>Vence hoy</a:t>
-            </a:r>
-            <a:endParaRPr lang="en-US" sz="3000" dirty="0"/>
+              <a:t>16/10</a:t>
+            </a:r>
+            <a:endParaRPr lang="en-US" sz="4000" dirty="0"/>
           </a:p>
         </p:txBody>
       </p:sp>
@@ -4583,7 +4583,7 @@
               <a:buNone/>
             </a:pPr>
             <a:r>
-              <a:rPr lang="en-US" sz="1300" b="1" dirty="0">
+              <a:rPr lang="en-US" sz="1150" dirty="0">
                 <a:solidFill>
                   <a:srgbClr val="FFFFFF"/>
                 </a:solidFill>
@@ -4591,9 +4591,9 @@
                 <a:ea typeface="Calibri" pitchFamily="34" charset="-122"/>
                 <a:cs typeface="Calibri" pitchFamily="34" charset="-120"/>
               </a:rPr>
-              <a:t>16/10/2026</a:t>
-            </a:r>
-            <a:endParaRPr lang="en-US" sz="1300" dirty="0"/>
+              <a:t>Envío respuesta resultados preliminares PLD/FT</a:t>
+            </a:r>
+            <a:endParaRPr lang="en-US" sz="1150" dirty="0"/>
           </a:p>
           <a:p>
             <a:pPr indent="0" marL="0">
@@ -4603,17 +4603,17 @@
               <a:buNone/>
             </a:pPr>
             <a:r>
-              <a:rPr lang="en-US" sz="1150" dirty="0">
-                <a:solidFill>
-                  <a:srgbClr val="FFFFFF"/>
-                </a:solidFill>
-                <a:latin typeface="Calibri" pitchFamily="34" charset="0"/>
-                <a:ea typeface="Calibri" pitchFamily="34" charset="-122"/>
-                <a:cs typeface="Calibri" pitchFamily="34" charset="-120"/>
-              </a:rPr>
-              <a:t>Envío respuesta resultados preliminares PLD/FT</a:t>
-            </a:r>
-            <a:endParaRPr lang="en-US" sz="1300" dirty="0"/>
+              <a:rPr lang="en-US" sz="1000" dirty="0">
+                <a:solidFill>
+                  <a:srgbClr val="A9D8DE"/>
+                </a:solidFill>
+                <a:latin typeface="Calibri" pitchFamily="34" charset="0"/>
+                <a:ea typeface="Calibri" pitchFamily="34" charset="-122"/>
+                <a:cs typeface="Calibri" pitchFamily="34" charset="-120"/>
+              </a:rPr>
+              <a:t>Circular 23486</a:t>
+            </a:r>
+            <a:endParaRPr lang="en-US" sz="1150" dirty="0"/>
           </a:p>
           <a:p>
             <a:pPr indent="0" marL="0">
@@ -4623,26 +4623,6 @@
               <a:buNone/>
             </a:pPr>
             <a:r>
-              <a:rPr lang="en-US" sz="1000" dirty="0">
-                <a:solidFill>
-                  <a:srgbClr val="A9D8DE"/>
-                </a:solidFill>
-                <a:latin typeface="Calibri" pitchFamily="34" charset="0"/>
-                <a:ea typeface="Calibri" pitchFamily="34" charset="-122"/>
-                <a:cs typeface="Calibri" pitchFamily="34" charset="-120"/>
-              </a:rPr>
-              <a:t>Circular 23486</a:t>
-            </a:r>
-            <a:endParaRPr lang="en-US" sz="1300" dirty="0"/>
-          </a:p>
-          <a:p>
-            <a:pPr indent="0" marL="0">
-              <a:spcAft>
-                <a:spcPts val="300"/>
-              </a:spcAft>
-              <a:buNone/>
-            </a:pPr>
-            <a:r>
               <a:rPr lang="en-US" sz="1000" i="1" dirty="0">
                 <a:solidFill>
                   <a:srgbClr val="DCE6F0"/>
@@ -4653,7 +4633,7 @@
               </a:rPr>
               <a:t>Semana: seguimiento al envío de pruebas de descargo</a:t>
             </a:r>
-            <a:endParaRPr lang="en-US" sz="1300" dirty="0"/>
+            <a:endParaRPr lang="en-US" sz="1150" dirty="0"/>
           </a:p>
         </p:txBody>
       </p:sp>

</xml_diff>

<commit_message>
Slide 2: rename to 'Calendario de requerimientos SSF', date-proportional progress timeline
Co-Authored-By: Claude Opus 5.5 <noreply@anthropic.com>
Claude-Session: https://claude.ai/code/session_01QGTe9h3kfUS6BTZosfrxzF
</commit_message>
<xml_diff>
--- a/resumen-ejecutivo-semanal/Resumen_Ejecutivo_Riesgos_COMEDICA_2_Slides.pptx
+++ b/resumen-ejecutivo-semanal/Resumen_Ejecutivo_Riesgos_COMEDICA_2_Slides.pptx
@@ -3110,7 +3110,7 @@
                 <a:ea typeface="Calibri" pitchFamily="34" charset="-122"/>
                 <a:cs typeface="Calibri" pitchFamily="34" charset="-120"/>
               </a:rPr>
-              <a:t>Compromisos Regulatorios y Próximos Hitos</a:t>
+              <a:t>Calendario de requerimientos SSF</a:t>
             </a:r>
             <a:endParaRPr lang="en-US" sz="2600" dirty="0"/>
           </a:p>
@@ -3149,7 +3149,7 @@
                 <a:ea typeface="Calibri" pitchFamily="34" charset="-122"/>
                 <a:cs typeface="Calibri" pitchFamily="34" charset="-120"/>
               </a:rPr>
-              <a:t>Calendario de requerimientos SSF · Corte 16/10/2026</a:t>
+              <a:t>Compromisos regulatorios y próximos hitos · Corte 16/10/2026</a:t>
             </a:r>
             <a:endParaRPr lang="en-US" sz="1300" dirty="0"/>
           </a:p>
@@ -3355,14 +3355,45 @@
         </p:nvSpPr>
         <p:spPr>
           <a:xfrm>
-            <a:off x="548640" y="2377440"/>
-            <a:ext cx="6259721" cy="0"/>
-          </a:xfrm>
-          <a:prstGeom prst="line">
-            <a:avLst/>
-          </a:prstGeom>
-          <a:noFill/>
-          <a:ln w="38100">
+            <a:off x="1143000" y="2322576"/>
+            <a:ext cx="9966960" cy="109728"/>
+          </a:xfrm>
+          <a:prstGeom prst="roundRect">
+            <a:avLst>
+              <a:gd name="adj" fmla="val 50000"/>
+            </a:avLst>
+          </a:prstGeom>
+          <a:solidFill>
+            <a:srgbClr val="D5DEE8"/>
+          </a:solidFill>
+          <a:ln w="12700">
+            <a:solidFill>
+              <a:srgbClr val="D5DEE8"/>
+            </a:solidFill>
+            <a:prstDash val="solid"/>
+          </a:ln>
+        </p:spPr>
+      </p:sp>
+      <p:sp>
+        <p:nvSpPr>
+          <p:cNvPr id="11" name="Shape 9"/>
+          <p:cNvSpPr/>
+          <p:nvPr/>
+        </p:nvSpPr>
+        <p:spPr>
+          <a:xfrm>
+            <a:off x="1143000" y="2322576"/>
+            <a:ext cx="5675811" cy="109728"/>
+          </a:xfrm>
+          <a:prstGeom prst="roundRect">
+            <a:avLst>
+              <a:gd name="adj" fmla="val 50000"/>
+            </a:avLst>
+          </a:prstGeom>
+          <a:solidFill>
+            <a:srgbClr val="0B2545"/>
+          </a:solidFill>
+          <a:ln w="12700">
             <a:solidFill>
               <a:srgbClr val="0B2545"/>
             </a:solidFill>
@@ -3372,36 +3403,13 @@
       </p:sp>
       <p:sp>
         <p:nvSpPr>
-          <p:cNvPr id="11" name="Shape 9"/>
-          <p:cNvSpPr/>
-          <p:nvPr/>
-        </p:nvSpPr>
-        <p:spPr>
-          <a:xfrm>
-            <a:off x="6808361" y="2377440"/>
-            <a:ext cx="4831951" cy="0"/>
-          </a:xfrm>
-          <a:prstGeom prst="line">
-            <a:avLst/>
-          </a:prstGeom>
-          <a:noFill/>
-          <a:ln w="38100">
-            <a:solidFill>
-              <a:srgbClr val="C3CFDB"/>
-            </a:solidFill>
-            <a:prstDash val="solid"/>
-          </a:ln>
-        </p:spPr>
-      </p:sp>
-      <p:sp>
-        <p:nvSpPr>
           <p:cNvPr id="12" name="Shape 10"/>
           <p:cNvSpPr/>
           <p:nvPr/>
         </p:nvSpPr>
         <p:spPr>
           <a:xfrm>
-            <a:off x="1097280" y="2139696"/>
+            <a:off x="1280160" y="2139696"/>
             <a:ext cx="0" cy="237744"/>
           </a:xfrm>
           <a:prstGeom prst="line">
@@ -3424,7 +3432,7 @@
         </p:nvSpPr>
         <p:spPr>
           <a:xfrm>
-            <a:off x="996696" y="2276856"/>
+            <a:off x="1179576" y="2276856"/>
             <a:ext cx="201168" cy="201168"/>
           </a:xfrm>
           <a:prstGeom prst="ellipse">
@@ -3449,8 +3457,8 @@
         </p:nvSpPr>
         <p:spPr>
           <a:xfrm>
-            <a:off x="356616" y="1371600"/>
-            <a:ext cx="1481328" cy="768096"/>
+            <a:off x="571500" y="1371600"/>
+            <a:ext cx="1417320" cy="768096"/>
           </a:xfrm>
           <a:prstGeom prst="rect">
             <a:avLst/>
@@ -3522,7 +3530,7 @@
         </p:nvSpPr>
         <p:spPr>
           <a:xfrm>
-            <a:off x="2525050" y="2377440"/>
+            <a:off x="1741714" y="2377440"/>
             <a:ext cx="0" cy="237744"/>
           </a:xfrm>
           <a:prstGeom prst="line">
@@ -3545,7 +3553,7 @@
         </p:nvSpPr>
         <p:spPr>
           <a:xfrm>
-            <a:off x="2424466" y="2276856"/>
+            <a:off x="1641130" y="2276856"/>
             <a:ext cx="201168" cy="201168"/>
           </a:xfrm>
           <a:prstGeom prst="ellipse">
@@ -3570,8 +3578,8 @@
         </p:nvSpPr>
         <p:spPr>
           <a:xfrm>
-            <a:off x="1784386" y="2688336"/>
-            <a:ext cx="1481328" cy="768096"/>
+            <a:off x="1033054" y="2688336"/>
+            <a:ext cx="1417320" cy="768096"/>
           </a:xfrm>
           <a:prstGeom prst="rect">
             <a:avLst/>
@@ -3643,7 +3651,7 @@
         </p:nvSpPr>
         <p:spPr>
           <a:xfrm>
-            <a:off x="3952821" y="2139696"/>
+            <a:off x="3587931" y="2139696"/>
             <a:ext cx="0" cy="237744"/>
           </a:xfrm>
           <a:prstGeom prst="line">
@@ -3666,7 +3674,7 @@
         </p:nvSpPr>
         <p:spPr>
           <a:xfrm>
-            <a:off x="3852237" y="2276856"/>
+            <a:off x="3487347" y="2276856"/>
             <a:ext cx="201168" cy="201168"/>
           </a:xfrm>
           <a:prstGeom prst="ellipse">
@@ -3691,8 +3699,8 @@
         </p:nvSpPr>
         <p:spPr>
           <a:xfrm>
-            <a:off x="3212157" y="1371600"/>
-            <a:ext cx="1481328" cy="768096"/>
+            <a:off x="2879271" y="1371600"/>
+            <a:ext cx="1417320" cy="768096"/>
           </a:xfrm>
           <a:prstGeom prst="rect">
             <a:avLst/>
@@ -3764,7 +3772,7 @@
         </p:nvSpPr>
         <p:spPr>
           <a:xfrm>
-            <a:off x="5380591" y="2377440"/>
+            <a:off x="5203371" y="2377440"/>
             <a:ext cx="0" cy="237744"/>
           </a:xfrm>
           <a:prstGeom prst="line">
@@ -3787,7 +3795,7 @@
         </p:nvSpPr>
         <p:spPr>
           <a:xfrm>
-            <a:off x="5280007" y="2276856"/>
+            <a:off x="5102787" y="2276856"/>
             <a:ext cx="201168" cy="201168"/>
           </a:xfrm>
           <a:prstGeom prst="ellipse">
@@ -3812,8 +3820,8 @@
         </p:nvSpPr>
         <p:spPr>
           <a:xfrm>
-            <a:off x="4639927" y="2688336"/>
-            <a:ext cx="1481328" cy="768096"/>
+            <a:off x="4494711" y="2688336"/>
+            <a:ext cx="1417320" cy="768096"/>
           </a:xfrm>
           <a:prstGeom prst="rect">
             <a:avLst/>
@@ -3885,7 +3893,7 @@
         </p:nvSpPr>
         <p:spPr>
           <a:xfrm>
-            <a:off x="6808361" y="2139696"/>
+            <a:off x="6818811" y="2139696"/>
             <a:ext cx="0" cy="237744"/>
           </a:xfrm>
           <a:prstGeom prst="line">
@@ -3908,7 +3916,7 @@
         </p:nvSpPr>
         <p:spPr>
           <a:xfrm>
-            <a:off x="6689489" y="2258568"/>
+            <a:off x="6699939" y="2258568"/>
             <a:ext cx="237744" cy="237744"/>
           </a:xfrm>
           <a:prstGeom prst="diamond">
@@ -3933,8 +3941,8 @@
         </p:nvSpPr>
         <p:spPr>
           <a:xfrm>
-            <a:off x="6067697" y="1371600"/>
-            <a:ext cx="1481328" cy="768096"/>
+            <a:off x="6110151" y="1371600"/>
+            <a:ext cx="1417320" cy="768096"/>
           </a:xfrm>
           <a:prstGeom prst="rect">
             <a:avLst/>
@@ -4006,7 +4014,7 @@
         </p:nvSpPr>
         <p:spPr>
           <a:xfrm>
-            <a:off x="8236131" y="2377440"/>
+            <a:off x="8434251" y="2377440"/>
             <a:ext cx="0" cy="237744"/>
           </a:xfrm>
           <a:prstGeom prst="line">
@@ -4029,7 +4037,7 @@
         </p:nvSpPr>
         <p:spPr>
           <a:xfrm>
-            <a:off x="8117259" y="2258568"/>
+            <a:off x="8315379" y="2258568"/>
             <a:ext cx="237744" cy="237744"/>
           </a:xfrm>
           <a:prstGeom prst="diamond">
@@ -4054,8 +4062,8 @@
         </p:nvSpPr>
         <p:spPr>
           <a:xfrm>
-            <a:off x="7495467" y="2688336"/>
-            <a:ext cx="1481328" cy="768096"/>
+            <a:off x="7725591" y="2688336"/>
+            <a:ext cx="1417320" cy="768096"/>
           </a:xfrm>
           <a:prstGeom prst="rect">
             <a:avLst/>
@@ -4127,7 +4135,7 @@
         </p:nvSpPr>
         <p:spPr>
           <a:xfrm>
-            <a:off x="9663902" y="2139696"/>
+            <a:off x="10049691" y="2139696"/>
             <a:ext cx="0" cy="237744"/>
           </a:xfrm>
           <a:prstGeom prst="line">
@@ -4150,7 +4158,7 @@
         </p:nvSpPr>
         <p:spPr>
           <a:xfrm>
-            <a:off x="9545030" y="2258568"/>
+            <a:off x="9930819" y="2258568"/>
             <a:ext cx="237744" cy="237744"/>
           </a:xfrm>
           <a:prstGeom prst="diamond">
@@ -4175,8 +4183,8 @@
         </p:nvSpPr>
         <p:spPr>
           <a:xfrm>
-            <a:off x="8923238" y="1371600"/>
-            <a:ext cx="1481328" cy="768096"/>
+            <a:off x="9341031" y="1371600"/>
+            <a:ext cx="1417320" cy="768096"/>
           </a:xfrm>
           <a:prstGeom prst="rect">
             <a:avLst/>
@@ -4248,7 +4256,7 @@
         </p:nvSpPr>
         <p:spPr>
           <a:xfrm>
-            <a:off x="11091672" y="2377440"/>
+            <a:off x="10972800" y="2377440"/>
             <a:ext cx="0" cy="237744"/>
           </a:xfrm>
           <a:prstGeom prst="line">
@@ -4271,7 +4279,7 @@
         </p:nvSpPr>
         <p:spPr>
           <a:xfrm>
-            <a:off x="10972800" y="2258568"/>
+            <a:off x="10853928" y="2258568"/>
             <a:ext cx="237744" cy="237744"/>
           </a:xfrm>
           <a:prstGeom prst="diamond">
@@ -4296,8 +4304,8 @@
         </p:nvSpPr>
         <p:spPr>
           <a:xfrm>
-            <a:off x="10351008" y="2688336"/>
-            <a:ext cx="1481328" cy="768096"/>
+            <a:off x="10264140" y="2688336"/>
+            <a:ext cx="1417320" cy="768096"/>
           </a:xfrm>
           <a:prstGeom prst="rect">
             <a:avLst/>
@@ -4369,7 +4377,7 @@
         </p:nvSpPr>
         <p:spPr>
           <a:xfrm>
-            <a:off x="6808361" y="2542032"/>
+            <a:off x="6818811" y="2542032"/>
             <a:ext cx="0" cy="566928"/>
           </a:xfrm>
           <a:prstGeom prst="line">
@@ -4392,7 +4400,7 @@
         </p:nvSpPr>
         <p:spPr>
           <a:xfrm>
-            <a:off x="6305441" y="3108960"/>
+            <a:off x="6315891" y="3108960"/>
             <a:ext cx="1005840" cy="274320"/>
           </a:xfrm>
           <a:prstGeom prst="roundRect">
@@ -4419,7 +4427,7 @@
         </p:nvSpPr>
         <p:spPr>
           <a:xfrm>
-            <a:off x="6305441" y="3108960"/>
+            <a:off x="6315891" y="3108960"/>
             <a:ext cx="1005840" cy="274320"/>
           </a:xfrm>
           <a:prstGeom prst="rect">
@@ -4458,8 +4466,8 @@
         </p:nvSpPr>
         <p:spPr>
           <a:xfrm>
-            <a:off x="457200" y="3657600"/>
-            <a:ext cx="5486400" cy="329184"/>
+            <a:off x="5995851" y="3410712"/>
+            <a:ext cx="1645920" cy="201168"/>
           </a:xfrm>
           <a:prstGeom prst="rect">
             <a:avLst/>
@@ -4471,6 +4479,45 @@
           <a:bodyPr wrap="square" lIns="0" tIns="0" rIns="0" bIns="0" rtlCol="0" anchor="ctr"/>
           <a:lstStyle/>
           <a:p>
+            <a:pPr algn="ctr" indent="0" marL="0">
+              <a:buNone/>
+            </a:pPr>
+            <a:r>
+              <a:rPr lang="en-US" sz="950" b="1" dirty="0">
+                <a:solidFill>
+                  <a:srgbClr val="B86E00"/>
+                </a:solidFill>
+                <a:latin typeface="Calibri" pitchFamily="34" charset="0"/>
+                <a:ea typeface="Calibri" pitchFamily="34" charset="-122"/>
+                <a:cs typeface="Calibri" pitchFamily="34" charset="-120"/>
+              </a:rPr>
+              <a:t>Día 24 de 42 del calendario</a:t>
+            </a:r>
+            <a:endParaRPr lang="en-US" sz="950" dirty="0"/>
+          </a:p>
+        </p:txBody>
+      </p:sp>
+      <p:sp>
+        <p:nvSpPr>
+          <p:cNvPr id="40" name="Text 38"/>
+          <p:cNvSpPr txBox="1"/>
+          <p:nvPr/>
+        </p:nvSpPr>
+        <p:spPr>
+          <a:xfrm>
+            <a:off x="457200" y="3657600"/>
+            <a:ext cx="5486400" cy="329184"/>
+          </a:xfrm>
+          <a:prstGeom prst="rect">
+            <a:avLst/>
+          </a:prstGeom>
+          <a:noFill/>
+          <a:ln/>
+        </p:spPr>
+        <p:txBody>
+          <a:bodyPr wrap="square" lIns="0" tIns="0" rIns="0" bIns="0" rtlCol="0" anchor="ctr"/>
+          <a:lstStyle/>
+          <a:p>
             <a:pPr indent="0" marL="0">
               <a:buNone/>
             </a:pPr>
@@ -4491,7 +4538,7 @@
       </p:sp>
       <p:sp>
         <p:nvSpPr>
-          <p:cNvPr id="40" name="Shape 38"/>
+          <p:cNvPr id="41" name="Shape 39"/>
           <p:cNvSpPr/>
           <p:nvPr/>
         </p:nvSpPr>
@@ -4518,7 +4565,7 @@
       </p:sp>
       <p:sp>
         <p:nvSpPr>
-          <p:cNvPr id="41" name="Text 39"/>
+          <p:cNvPr id="42" name="Text 40"/>
           <p:cNvSpPr txBox="1"/>
           <p:nvPr/>
         </p:nvSpPr>
@@ -4557,7 +4604,7 @@
       </p:sp>
       <p:sp>
         <p:nvSpPr>
-          <p:cNvPr id="42" name="Text 40"/>
+          <p:cNvPr id="43" name="Text 41"/>
           <p:cNvSpPr txBox="1"/>
           <p:nvPr/>
         </p:nvSpPr>
@@ -4639,7 +4686,7 @@
       </p:sp>
       <p:sp>
         <p:nvSpPr>
-          <p:cNvPr id="43" name="Shape 41"/>
+          <p:cNvPr id="44" name="Shape 42"/>
           <p:cNvSpPr/>
           <p:nvPr/>
         </p:nvSpPr>
@@ -4666,7 +4713,7 @@
       </p:sp>
       <p:sp>
         <p:nvSpPr>
-          <p:cNvPr id="44" name="Text 42"/>
+          <p:cNvPr id="45" name="Text 43"/>
           <p:cNvSpPr txBox="1"/>
           <p:nvPr/>
         </p:nvSpPr>
@@ -4719,7 +4766,7 @@
       </p:sp>
       <p:sp>
         <p:nvSpPr>
-          <p:cNvPr id="45" name="Text 43"/>
+          <p:cNvPr id="46" name="Text 44"/>
           <p:cNvSpPr txBox="1"/>
           <p:nvPr/>
         </p:nvSpPr>
@@ -4821,7 +4868,7 @@
       </p:sp>
       <p:sp>
         <p:nvSpPr>
-          <p:cNvPr id="46" name="Shape 44"/>
+          <p:cNvPr id="47" name="Shape 45"/>
           <p:cNvSpPr/>
           <p:nvPr/>
         </p:nvSpPr>
@@ -4848,7 +4895,7 @@
       </p:sp>
       <p:sp>
         <p:nvSpPr>
-          <p:cNvPr id="47" name="Text 45"/>
+          <p:cNvPr id="48" name="Text 46"/>
           <p:cNvSpPr txBox="1"/>
           <p:nvPr/>
         </p:nvSpPr>
@@ -4901,7 +4948,7 @@
       </p:sp>
       <p:sp>
         <p:nvSpPr>
-          <p:cNvPr id="48" name="Text 46"/>
+          <p:cNvPr id="49" name="Text 47"/>
           <p:cNvSpPr txBox="1"/>
           <p:nvPr/>
         </p:nvSpPr>
@@ -5003,7 +5050,7 @@
       </p:sp>
       <p:sp>
         <p:nvSpPr>
-          <p:cNvPr id="49" name="Shape 47"/>
+          <p:cNvPr id="50" name="Shape 48"/>
           <p:cNvSpPr/>
           <p:nvPr/>
         </p:nvSpPr>
@@ -5030,7 +5077,7 @@
       </p:sp>
       <p:sp>
         <p:nvSpPr>
-          <p:cNvPr id="50" name="Text 48"/>
+          <p:cNvPr id="51" name="Text 49"/>
           <p:cNvSpPr txBox="1"/>
           <p:nvPr/>
         </p:nvSpPr>
@@ -5083,7 +5130,7 @@
       </p:sp>
       <p:sp>
         <p:nvSpPr>
-          <p:cNvPr id="51" name="Text 49"/>
+          <p:cNvPr id="52" name="Text 50"/>
           <p:cNvSpPr txBox="1"/>
           <p:nvPr/>
         </p:nvSpPr>
@@ -5165,7 +5212,7 @@
       </p:sp>
       <p:sp>
         <p:nvSpPr>
-          <p:cNvPr id="52" name="Text 50"/>
+          <p:cNvPr id="53" name="Text 51"/>
           <p:cNvSpPr txBox="1"/>
           <p:nvPr/>
         </p:nvSpPr>

</xml_diff>

<commit_message>
Slide 2: elapsed events in green with check marks and shaded zone
Co-Authored-By: Claude Opus 5.5 <noreply@anthropic.com>
Claude-Session: https://claude.ai/code/session_01QGTe9h3kfUS6BTZosfrxzF
</commit_message>
<xml_diff>
--- a/resumen-ejecutivo-semanal/Resumen_Ejecutivo_Riesgos_COMEDICA_2_Slides.pptx
+++ b/resumen-ejecutivo-semanal/Resumen_Ejecutivo_Riesgos_COMEDICA_2_Slides.pptx
@@ -3163,32 +3163,56 @@
         </p:nvSpPr>
         <p:spPr>
           <a:xfrm>
-            <a:off x="8641080" y="484632"/>
+            <a:off x="9144000" y="484632"/>
             <a:ext cx="164592" cy="164592"/>
           </a:xfrm>
           <a:prstGeom prst="ellipse">
             <a:avLst/>
           </a:prstGeom>
           <a:solidFill>
-            <a:srgbClr val="0B2545"/>
-          </a:solidFill>
-          <a:ln w="25400">
+            <a:srgbClr val="2E7D4F"/>
+          </a:solidFill>
+          <a:ln w="12700">
             <a:solidFill>
-              <a:srgbClr val="0B2545"/>
+              <a:srgbClr val="2E7D4F"/>
             </a:solidFill>
             <a:prstDash val="solid"/>
           </a:ln>
         </p:spPr>
       </p:sp>
-      <p:sp>
-        <p:nvSpPr>
-          <p:cNvPr id="5" name="Text 3"/>
+      <p:pic>
+        <p:nvPicPr>
+          <p:cNvPr id="5" name="Image 0" descr="preencoded.png">    </p:cNvPr>
+          <p:cNvPicPr>
+            <a:picLocks noChangeAspect="1"/>
+          </p:cNvPicPr>
+          <p:nvPr/>
+        </p:nvPicPr>
+        <p:blipFill>
+          <a:blip r:embed="rId1"/>
+          <a:stretch>
+            <a:fillRect/>
+          </a:stretch>
+        </p:blipFill>
+        <p:spPr>
+          <a:xfrm>
+            <a:off x="9180576" y="521208"/>
+            <a:ext cx="91440" cy="91440"/>
+          </a:xfrm>
+          <a:prstGeom prst="rect">
+            <a:avLst/>
+          </a:prstGeom>
+        </p:spPr>
+      </p:pic>
+      <p:sp>
+        <p:nvSpPr>
+          <p:cNvPr id="6" name="Text 3"/>
           <p:cNvSpPr txBox="1"/>
           <p:nvPr/>
         </p:nvSpPr>
         <p:spPr>
           <a:xfrm>
-            <a:off x="8860536" y="457200"/>
+            <a:off x="9363456" y="457200"/>
             <a:ext cx="1097280" cy="219456"/>
           </a:xfrm>
           <a:prstGeom prst="rect">
@@ -3213,7 +3237,7 @@
                 <a:ea typeface="Calibri" pitchFamily="34" charset="-122"/>
                 <a:cs typeface="Calibri" pitchFamily="34" charset="-120"/>
               </a:rPr>
-              <a:t>Recepción</a:t>
+              <a:t>Transcurrido</a:t>
             </a:r>
             <a:endParaRPr lang="en-US" sz="1000" dirty="0"/>
           </a:p>
@@ -3221,77 +3245,13 @@
       </p:sp>
       <p:sp>
         <p:nvSpPr>
-          <p:cNvPr id="6" name="Shape 4"/>
+          <p:cNvPr id="7" name="Shape 4"/>
           <p:cNvSpPr/>
           <p:nvPr/>
         </p:nvSpPr>
         <p:spPr>
           <a:xfrm>
-            <a:off x="9601200" y="484632"/>
-            <a:ext cx="164592" cy="164592"/>
-          </a:xfrm>
-          <a:prstGeom prst="ellipse">
-            <a:avLst/>
-          </a:prstGeom>
-          <a:solidFill>
-            <a:srgbClr val="0E9AA7"/>
-          </a:solidFill>
-          <a:ln w="12700">
-            <a:solidFill>
-              <a:srgbClr val="0E9AA7"/>
-            </a:solidFill>
-            <a:prstDash val="solid"/>
-          </a:ln>
-        </p:spPr>
-      </p:sp>
-      <p:sp>
-        <p:nvSpPr>
-          <p:cNvPr id="7" name="Text 5"/>
-          <p:cNvSpPr txBox="1"/>
-          <p:nvPr/>
-        </p:nvSpPr>
-        <p:spPr>
-          <a:xfrm>
-            <a:off x="9820656" y="457200"/>
-            <a:ext cx="1097280" cy="219456"/>
-          </a:xfrm>
-          <a:prstGeom prst="rect">
-            <a:avLst/>
-          </a:prstGeom>
-          <a:noFill/>
-          <a:ln/>
-        </p:spPr>
-        <p:txBody>
-          <a:bodyPr wrap="square" lIns="0" tIns="0" rIns="0" bIns="0" rtlCol="0" anchor="ctr"/>
-          <a:lstStyle/>
-          <a:p>
-            <a:pPr indent="0" marL="0">
-              <a:buNone/>
-            </a:pPr>
-            <a:r>
-              <a:rPr lang="en-US" sz="1000" dirty="0">
-                <a:solidFill>
-                  <a:srgbClr val="1B2733"/>
-                </a:solidFill>
-                <a:latin typeface="Calibri" pitchFamily="34" charset="0"/>
-                <a:ea typeface="Calibri" pitchFamily="34" charset="-122"/>
-                <a:cs typeface="Calibri" pitchFamily="34" charset="-120"/>
-              </a:rPr>
-              <a:t>Inicio de visita</a:t>
-            </a:r>
-            <a:endParaRPr lang="en-US" sz="1000" dirty="0"/>
-          </a:p>
-        </p:txBody>
-      </p:sp>
-      <p:sp>
-        <p:nvSpPr>
-          <p:cNvPr id="8" name="Shape 6"/>
-          <p:cNvSpPr/>
-          <p:nvPr/>
-        </p:nvSpPr>
-        <p:spPr>
-          <a:xfrm>
-            <a:off x="10881360" y="484632"/>
+            <a:off x="10469880" y="484632"/>
             <a:ext cx="164592" cy="164592"/>
           </a:xfrm>
           <a:prstGeom prst="diamond">
@@ -3310,13 +3270,13 @@
       </p:sp>
       <p:sp>
         <p:nvSpPr>
-          <p:cNvPr id="9" name="Text 7"/>
+          <p:cNvPr id="8" name="Text 5"/>
           <p:cNvSpPr txBox="1"/>
           <p:nvPr/>
         </p:nvSpPr>
         <p:spPr>
           <a:xfrm>
-            <a:off x="11100816" y="457200"/>
+            <a:off x="10689336" y="457200"/>
             <a:ext cx="1097280" cy="219456"/>
           </a:xfrm>
           <a:prstGeom prst="rect">
@@ -3349,7 +3309,73 @@
       </p:sp>
       <p:sp>
         <p:nvSpPr>
-          <p:cNvPr id="10" name="Shape 8"/>
+          <p:cNvPr id="9" name="Shape 6"/>
+          <p:cNvSpPr/>
+          <p:nvPr/>
+        </p:nvSpPr>
+        <p:spPr>
+          <a:xfrm>
+            <a:off x="457200" y="1261872"/>
+            <a:ext cx="5575227" cy="2267712"/>
+          </a:xfrm>
+          <a:prstGeom prst="roundRect">
+            <a:avLst>
+              <a:gd name="adj" fmla="val 4839"/>
+            </a:avLst>
+          </a:prstGeom>
+          <a:solidFill>
+            <a:srgbClr val="E5F2EA"/>
+          </a:solidFill>
+          <a:ln w="12700">
+            <a:solidFill>
+              <a:srgbClr val="E5F2EA"/>
+            </a:solidFill>
+            <a:prstDash val="solid"/>
+          </a:ln>
+        </p:spPr>
+      </p:sp>
+      <p:sp>
+        <p:nvSpPr>
+          <p:cNvPr id="10" name="Text 7"/>
+          <p:cNvSpPr txBox="1"/>
+          <p:nvPr/>
+        </p:nvSpPr>
+        <p:spPr>
+          <a:xfrm>
+            <a:off x="594360" y="1307592"/>
+            <a:ext cx="1828800" cy="201168"/>
+          </a:xfrm>
+          <a:prstGeom prst="rect">
+            <a:avLst/>
+          </a:prstGeom>
+          <a:noFill/>
+          <a:ln/>
+        </p:spPr>
+        <p:txBody>
+          <a:bodyPr wrap="square" lIns="0" tIns="0" rIns="0" bIns="0" rtlCol="0" anchor="ctr"/>
+          <a:lstStyle/>
+          <a:p>
+            <a:pPr indent="0" marL="0">
+              <a:buNone/>
+            </a:pPr>
+            <a:r>
+              <a:rPr lang="en-US" sz="900" b="1" spc="100" kern="0" dirty="0">
+                <a:solidFill>
+                  <a:srgbClr val="2E7D4F"/>
+                </a:solidFill>
+                <a:latin typeface="Calibri" pitchFamily="34" charset="0"/>
+                <a:ea typeface="Calibri" pitchFamily="34" charset="-122"/>
+                <a:cs typeface="Calibri" pitchFamily="34" charset="-120"/>
+              </a:rPr>
+              <a:t>TRANSCURRIDO</a:t>
+            </a:r>
+            <a:endParaRPr lang="en-US" sz="900" dirty="0"/>
+          </a:p>
+        </p:txBody>
+      </p:sp>
+      <p:sp>
+        <p:nvSpPr>
+          <p:cNvPr id="11" name="Shape 8"/>
           <p:cNvSpPr/>
           <p:nvPr/>
         </p:nvSpPr>
@@ -3376,7 +3402,7 @@
       </p:sp>
       <p:sp>
         <p:nvSpPr>
-          <p:cNvPr id="11" name="Shape 9"/>
+          <p:cNvPr id="12" name="Shape 9"/>
           <p:cNvSpPr/>
           <p:nvPr/>
         </p:nvSpPr>
@@ -3391,11 +3417,11 @@
             </a:avLst>
           </a:prstGeom>
           <a:solidFill>
-            <a:srgbClr val="0B2545"/>
+            <a:srgbClr val="2E7D4F"/>
           </a:solidFill>
           <a:ln w="12700">
             <a:solidFill>
-              <a:srgbClr val="0B2545"/>
+              <a:srgbClr val="2E7D4F"/>
             </a:solidFill>
             <a:prstDash val="solid"/>
           </a:ln>
@@ -3403,7 +3429,7 @@
       </p:sp>
       <p:sp>
         <p:nvSpPr>
-          <p:cNvPr id="12" name="Shape 10"/>
+          <p:cNvPr id="13" name="Shape 10"/>
           <p:cNvSpPr/>
           <p:nvPr/>
         </p:nvSpPr>
@@ -3418,7 +3444,7 @@
           <a:noFill/>
           <a:ln w="12700">
             <a:solidFill>
-              <a:srgbClr val="8FA3B8"/>
+              <a:srgbClr val="2E7D4F"/>
             </a:solidFill>
             <a:prstDash val="solid"/>
           </a:ln>
@@ -3426,32 +3452,56 @@
       </p:sp>
       <p:sp>
         <p:nvSpPr>
-          <p:cNvPr id="13" name="Shape 11"/>
+          <p:cNvPr id="14" name="Shape 11"/>
           <p:cNvSpPr/>
           <p:nvPr/>
         </p:nvSpPr>
         <p:spPr>
           <a:xfrm>
-            <a:off x="1179576" y="2276856"/>
-            <a:ext cx="201168" cy="201168"/>
+            <a:off x="1152144" y="2249424"/>
+            <a:ext cx="256032" cy="256032"/>
           </a:xfrm>
           <a:prstGeom prst="ellipse">
             <a:avLst/>
           </a:prstGeom>
           <a:solidFill>
-            <a:srgbClr val="0B2545"/>
-          </a:solidFill>
-          <a:ln w="25400">
+            <a:srgbClr val="2E7D4F"/>
+          </a:solidFill>
+          <a:ln w="19050">
             <a:solidFill>
-              <a:srgbClr val="0B2545"/>
+              <a:srgbClr val="FFFFFF"/>
             </a:solidFill>
             <a:prstDash val="solid"/>
           </a:ln>
         </p:spPr>
       </p:sp>
-      <p:sp>
-        <p:nvSpPr>
-          <p:cNvPr id="14" name="Text 12"/>
+      <p:pic>
+        <p:nvPicPr>
+          <p:cNvPr id="15" name="Image 1" descr="preencoded.png">    </p:cNvPr>
+          <p:cNvPicPr>
+            <a:picLocks noChangeAspect="1"/>
+          </p:cNvPicPr>
+          <p:nvPr/>
+        </p:nvPicPr>
+        <p:blipFill>
+          <a:blip r:embed="rId2"/>
+          <a:stretch>
+            <a:fillRect/>
+          </a:stretch>
+        </p:blipFill>
+        <p:spPr>
+          <a:xfrm>
+            <a:off x="1216152" y="2313432"/>
+            <a:ext cx="128016" cy="128016"/>
+          </a:xfrm>
+          <a:prstGeom prst="rect">
+            <a:avLst/>
+          </a:prstGeom>
+        </p:spPr>
+      </p:pic>
+      <p:sp>
+        <p:nvSpPr>
+          <p:cNvPr id="16" name="Text 12"/>
           <p:cNvSpPr txBox="1"/>
           <p:nvPr/>
         </p:nvSpPr>
@@ -3476,7 +3526,7 @@
             <a:r>
               <a:rPr lang="en-US" sz="1300" b="1" dirty="0">
                 <a:solidFill>
-                  <a:srgbClr val="0B2545"/>
+                  <a:srgbClr val="2E7D4F"/>
                 </a:solidFill>
                 <a:latin typeface="Calibri" pitchFamily="34" charset="0"/>
                 <a:ea typeface="Calibri" pitchFamily="34" charset="-122"/>
@@ -3524,7 +3574,7 @@
       </p:sp>
       <p:sp>
         <p:nvSpPr>
-          <p:cNvPr id="15" name="Shape 13"/>
+          <p:cNvPr id="17" name="Shape 13"/>
           <p:cNvSpPr/>
           <p:nvPr/>
         </p:nvSpPr>
@@ -3539,7 +3589,7 @@
           <a:noFill/>
           <a:ln w="12700">
             <a:solidFill>
-              <a:srgbClr val="8FA3B8"/>
+              <a:srgbClr val="2E7D4F"/>
             </a:solidFill>
             <a:prstDash val="solid"/>
           </a:ln>
@@ -3547,32 +3597,56 @@
       </p:sp>
       <p:sp>
         <p:nvSpPr>
-          <p:cNvPr id="16" name="Shape 14"/>
+          <p:cNvPr id="18" name="Shape 14"/>
           <p:cNvSpPr/>
           <p:nvPr/>
         </p:nvSpPr>
         <p:spPr>
           <a:xfrm>
-            <a:off x="1641130" y="2276856"/>
-            <a:ext cx="201168" cy="201168"/>
+            <a:off x="1613698" y="2249424"/>
+            <a:ext cx="256032" cy="256032"/>
           </a:xfrm>
           <a:prstGeom prst="ellipse">
             <a:avLst/>
           </a:prstGeom>
           <a:solidFill>
-            <a:srgbClr val="0B2545"/>
-          </a:solidFill>
-          <a:ln w="25400">
+            <a:srgbClr val="2E7D4F"/>
+          </a:solidFill>
+          <a:ln w="19050">
             <a:solidFill>
-              <a:srgbClr val="0B2545"/>
+              <a:srgbClr val="FFFFFF"/>
             </a:solidFill>
             <a:prstDash val="solid"/>
           </a:ln>
         </p:spPr>
       </p:sp>
-      <p:sp>
-        <p:nvSpPr>
-          <p:cNvPr id="17" name="Text 15"/>
+      <p:pic>
+        <p:nvPicPr>
+          <p:cNvPr id="19" name="Image 2" descr="preencoded.png">    </p:cNvPr>
+          <p:cNvPicPr>
+            <a:picLocks noChangeAspect="1"/>
+          </p:cNvPicPr>
+          <p:nvPr/>
+        </p:nvPicPr>
+        <p:blipFill>
+          <a:blip r:embed="rId3"/>
+          <a:stretch>
+            <a:fillRect/>
+          </a:stretch>
+        </p:blipFill>
+        <p:spPr>
+          <a:xfrm>
+            <a:off x="1677706" y="2313432"/>
+            <a:ext cx="128016" cy="128016"/>
+          </a:xfrm>
+          <a:prstGeom prst="rect">
+            <a:avLst/>
+          </a:prstGeom>
+        </p:spPr>
+      </p:pic>
+      <p:sp>
+        <p:nvSpPr>
+          <p:cNvPr id="20" name="Text 15"/>
           <p:cNvSpPr txBox="1"/>
           <p:nvPr/>
         </p:nvSpPr>
@@ -3597,7 +3671,7 @@
             <a:r>
               <a:rPr lang="en-US" sz="1300" b="1" dirty="0">
                 <a:solidFill>
-                  <a:srgbClr val="0B2545"/>
+                  <a:srgbClr val="2E7D4F"/>
                 </a:solidFill>
                 <a:latin typeface="Calibri" pitchFamily="34" charset="0"/>
                 <a:ea typeface="Calibri" pitchFamily="34" charset="-122"/>
@@ -3645,7 +3719,7 @@
       </p:sp>
       <p:sp>
         <p:nvSpPr>
-          <p:cNvPr id="18" name="Shape 16"/>
+          <p:cNvPr id="21" name="Shape 16"/>
           <p:cNvSpPr/>
           <p:nvPr/>
         </p:nvSpPr>
@@ -3660,7 +3734,7 @@
           <a:noFill/>
           <a:ln w="12700">
             <a:solidFill>
-              <a:srgbClr val="8FA3B8"/>
+              <a:srgbClr val="2E7D4F"/>
             </a:solidFill>
             <a:prstDash val="solid"/>
           </a:ln>
@@ -3668,32 +3742,56 @@
       </p:sp>
       <p:sp>
         <p:nvSpPr>
-          <p:cNvPr id="19" name="Shape 17"/>
+          <p:cNvPr id="22" name="Shape 17"/>
           <p:cNvSpPr/>
           <p:nvPr/>
         </p:nvSpPr>
         <p:spPr>
           <a:xfrm>
-            <a:off x="3487347" y="2276856"/>
-            <a:ext cx="201168" cy="201168"/>
+            <a:off x="3459915" y="2249424"/>
+            <a:ext cx="256032" cy="256032"/>
           </a:xfrm>
           <a:prstGeom prst="ellipse">
             <a:avLst/>
           </a:prstGeom>
           <a:solidFill>
-            <a:srgbClr val="0B2545"/>
-          </a:solidFill>
-          <a:ln w="25400">
+            <a:srgbClr val="2E7D4F"/>
+          </a:solidFill>
+          <a:ln w="19050">
             <a:solidFill>
-              <a:srgbClr val="0B2545"/>
+              <a:srgbClr val="FFFFFF"/>
             </a:solidFill>
             <a:prstDash val="solid"/>
           </a:ln>
         </p:spPr>
       </p:sp>
-      <p:sp>
-        <p:nvSpPr>
-          <p:cNvPr id="20" name="Text 18"/>
+      <p:pic>
+        <p:nvPicPr>
+          <p:cNvPr id="23" name="Image 3" descr="preencoded.png">    </p:cNvPr>
+          <p:cNvPicPr>
+            <a:picLocks noChangeAspect="1"/>
+          </p:cNvPicPr>
+          <p:nvPr/>
+        </p:nvPicPr>
+        <p:blipFill>
+          <a:blip r:embed="rId4"/>
+          <a:stretch>
+            <a:fillRect/>
+          </a:stretch>
+        </p:blipFill>
+        <p:spPr>
+          <a:xfrm>
+            <a:off x="3523923" y="2313432"/>
+            <a:ext cx="128016" cy="128016"/>
+          </a:xfrm>
+          <a:prstGeom prst="rect">
+            <a:avLst/>
+          </a:prstGeom>
+        </p:spPr>
+      </p:pic>
+      <p:sp>
+        <p:nvSpPr>
+          <p:cNvPr id="24" name="Text 18"/>
           <p:cNvSpPr txBox="1"/>
           <p:nvPr/>
         </p:nvSpPr>
@@ -3718,7 +3816,7 @@
             <a:r>
               <a:rPr lang="en-US" sz="1300" b="1" dirty="0">
                 <a:solidFill>
-                  <a:srgbClr val="0B2545"/>
+                  <a:srgbClr val="2E7D4F"/>
                 </a:solidFill>
                 <a:latin typeface="Calibri" pitchFamily="34" charset="0"/>
                 <a:ea typeface="Calibri" pitchFamily="34" charset="-122"/>
@@ -3766,7 +3864,7 @@
       </p:sp>
       <p:sp>
         <p:nvSpPr>
-          <p:cNvPr id="21" name="Shape 19"/>
+          <p:cNvPr id="25" name="Shape 19"/>
           <p:cNvSpPr/>
           <p:nvPr/>
         </p:nvSpPr>
@@ -3781,7 +3879,7 @@
           <a:noFill/>
           <a:ln w="12700">
             <a:solidFill>
-              <a:srgbClr val="8FA3B8"/>
+              <a:srgbClr val="2E7D4F"/>
             </a:solidFill>
             <a:prstDash val="solid"/>
           </a:ln>
@@ -3789,32 +3887,56 @@
       </p:sp>
       <p:sp>
         <p:nvSpPr>
-          <p:cNvPr id="22" name="Shape 20"/>
+          <p:cNvPr id="26" name="Shape 20"/>
           <p:cNvSpPr/>
           <p:nvPr/>
         </p:nvSpPr>
         <p:spPr>
           <a:xfrm>
-            <a:off x="5102787" y="2276856"/>
-            <a:ext cx="201168" cy="201168"/>
+            <a:off x="5075355" y="2249424"/>
+            <a:ext cx="256032" cy="256032"/>
           </a:xfrm>
           <a:prstGeom prst="ellipse">
             <a:avLst/>
           </a:prstGeom>
           <a:solidFill>
-            <a:srgbClr val="0E9AA7"/>
-          </a:solidFill>
-          <a:ln w="12700">
+            <a:srgbClr val="2E7D4F"/>
+          </a:solidFill>
+          <a:ln w="19050">
             <a:solidFill>
-              <a:srgbClr val="0E9AA7"/>
+              <a:srgbClr val="FFFFFF"/>
             </a:solidFill>
             <a:prstDash val="solid"/>
           </a:ln>
         </p:spPr>
       </p:sp>
-      <p:sp>
-        <p:nvSpPr>
-          <p:cNvPr id="23" name="Text 21"/>
+      <p:pic>
+        <p:nvPicPr>
+          <p:cNvPr id="27" name="Image 4" descr="preencoded.png">    </p:cNvPr>
+          <p:cNvPicPr>
+            <a:picLocks noChangeAspect="1"/>
+          </p:cNvPicPr>
+          <p:nvPr/>
+        </p:nvPicPr>
+        <p:blipFill>
+          <a:blip r:embed="rId5"/>
+          <a:stretch>
+            <a:fillRect/>
+          </a:stretch>
+        </p:blipFill>
+        <p:spPr>
+          <a:xfrm>
+            <a:off x="5139363" y="2313432"/>
+            <a:ext cx="128016" cy="128016"/>
+          </a:xfrm>
+          <a:prstGeom prst="rect">
+            <a:avLst/>
+          </a:prstGeom>
+        </p:spPr>
+      </p:pic>
+      <p:sp>
+        <p:nvSpPr>
+          <p:cNvPr id="28" name="Text 21"/>
           <p:cNvSpPr txBox="1"/>
           <p:nvPr/>
         </p:nvSpPr>
@@ -3839,7 +3961,7 @@
             <a:r>
               <a:rPr lang="en-US" sz="1300" b="1" dirty="0">
                 <a:solidFill>
-                  <a:srgbClr val="0B2545"/>
+                  <a:srgbClr val="2E7D4F"/>
                 </a:solidFill>
                 <a:latin typeface="Calibri" pitchFamily="34" charset="0"/>
                 <a:ea typeface="Calibri" pitchFamily="34" charset="-122"/>
@@ -3887,7 +4009,7 @@
       </p:sp>
       <p:sp>
         <p:nvSpPr>
-          <p:cNvPr id="24" name="Shape 22"/>
+          <p:cNvPr id="29" name="Shape 22"/>
           <p:cNvSpPr/>
           <p:nvPr/>
         </p:nvSpPr>
@@ -3910,7 +4032,7 @@
       </p:sp>
       <p:sp>
         <p:nvSpPr>
-          <p:cNvPr id="25" name="Shape 23"/>
+          <p:cNvPr id="30" name="Shape 23"/>
           <p:cNvSpPr/>
           <p:nvPr/>
         </p:nvSpPr>
@@ -3935,7 +4057,7 @@
       </p:sp>
       <p:sp>
         <p:nvSpPr>
-          <p:cNvPr id="26" name="Text 24"/>
+          <p:cNvPr id="31" name="Text 24"/>
           <p:cNvSpPr txBox="1"/>
           <p:nvPr/>
         </p:nvSpPr>
@@ -4008,7 +4130,7 @@
       </p:sp>
       <p:sp>
         <p:nvSpPr>
-          <p:cNvPr id="27" name="Shape 25"/>
+          <p:cNvPr id="32" name="Shape 25"/>
           <p:cNvSpPr/>
           <p:nvPr/>
         </p:nvSpPr>
@@ -4031,7 +4153,7 @@
       </p:sp>
       <p:sp>
         <p:nvSpPr>
-          <p:cNvPr id="28" name="Shape 26"/>
+          <p:cNvPr id="33" name="Shape 26"/>
           <p:cNvSpPr/>
           <p:nvPr/>
         </p:nvSpPr>
@@ -4056,7 +4178,7 @@
       </p:sp>
       <p:sp>
         <p:nvSpPr>
-          <p:cNvPr id="29" name="Text 27"/>
+          <p:cNvPr id="34" name="Text 27"/>
           <p:cNvSpPr txBox="1"/>
           <p:nvPr/>
         </p:nvSpPr>
@@ -4129,7 +4251,7 @@
       </p:sp>
       <p:sp>
         <p:nvSpPr>
-          <p:cNvPr id="30" name="Shape 28"/>
+          <p:cNvPr id="35" name="Shape 28"/>
           <p:cNvSpPr/>
           <p:nvPr/>
         </p:nvSpPr>
@@ -4152,7 +4274,7 @@
       </p:sp>
       <p:sp>
         <p:nvSpPr>
-          <p:cNvPr id="31" name="Shape 29"/>
+          <p:cNvPr id="36" name="Shape 29"/>
           <p:cNvSpPr/>
           <p:nvPr/>
         </p:nvSpPr>
@@ -4177,7 +4299,7 @@
       </p:sp>
       <p:sp>
         <p:nvSpPr>
-          <p:cNvPr id="32" name="Text 30"/>
+          <p:cNvPr id="37" name="Text 30"/>
           <p:cNvSpPr txBox="1"/>
           <p:nvPr/>
         </p:nvSpPr>
@@ -4250,7 +4372,7 @@
       </p:sp>
       <p:sp>
         <p:nvSpPr>
-          <p:cNvPr id="33" name="Shape 31"/>
+          <p:cNvPr id="38" name="Shape 31"/>
           <p:cNvSpPr/>
           <p:nvPr/>
         </p:nvSpPr>
@@ -4273,7 +4395,7 @@
       </p:sp>
       <p:sp>
         <p:nvSpPr>
-          <p:cNvPr id="34" name="Shape 32"/>
+          <p:cNvPr id="39" name="Shape 32"/>
           <p:cNvSpPr/>
           <p:nvPr/>
         </p:nvSpPr>
@@ -4298,7 +4420,7 @@
       </p:sp>
       <p:sp>
         <p:nvSpPr>
-          <p:cNvPr id="35" name="Text 33"/>
+          <p:cNvPr id="40" name="Text 33"/>
           <p:cNvSpPr txBox="1"/>
           <p:nvPr/>
         </p:nvSpPr>
@@ -4371,7 +4493,7 @@
       </p:sp>
       <p:sp>
         <p:nvSpPr>
-          <p:cNvPr id="36" name="Shape 34"/>
+          <p:cNvPr id="41" name="Shape 34"/>
           <p:cNvSpPr/>
           <p:nvPr/>
         </p:nvSpPr>
@@ -4394,7 +4516,7 @@
       </p:sp>
       <p:sp>
         <p:nvSpPr>
-          <p:cNvPr id="37" name="Shape 35"/>
+          <p:cNvPr id="42" name="Shape 35"/>
           <p:cNvSpPr/>
           <p:nvPr/>
         </p:nvSpPr>
@@ -4421,7 +4543,7 @@
       </p:sp>
       <p:sp>
         <p:nvSpPr>
-          <p:cNvPr id="38" name="Text 36"/>
+          <p:cNvPr id="43" name="Text 36"/>
           <p:cNvSpPr txBox="1"/>
           <p:nvPr/>
         </p:nvSpPr>
@@ -4460,7 +4582,7 @@
       </p:sp>
       <p:sp>
         <p:nvSpPr>
-          <p:cNvPr id="39" name="Text 37"/>
+          <p:cNvPr id="44" name="Text 37"/>
           <p:cNvSpPr txBox="1"/>
           <p:nvPr/>
         </p:nvSpPr>
@@ -4499,7 +4621,7 @@
       </p:sp>
       <p:sp>
         <p:nvSpPr>
-          <p:cNvPr id="40" name="Text 38"/>
+          <p:cNvPr id="45" name="Text 38"/>
           <p:cNvSpPr txBox="1"/>
           <p:nvPr/>
         </p:nvSpPr>
@@ -4538,7 +4660,7 @@
       </p:sp>
       <p:sp>
         <p:nvSpPr>
-          <p:cNvPr id="41" name="Shape 39"/>
+          <p:cNvPr id="46" name="Shape 39"/>
           <p:cNvSpPr/>
           <p:nvPr/>
         </p:nvSpPr>
@@ -4565,7 +4687,7 @@
       </p:sp>
       <p:sp>
         <p:nvSpPr>
-          <p:cNvPr id="42" name="Text 40"/>
+          <p:cNvPr id="47" name="Text 40"/>
           <p:cNvSpPr txBox="1"/>
           <p:nvPr/>
         </p:nvSpPr>
@@ -4604,7 +4726,7 @@
       </p:sp>
       <p:sp>
         <p:nvSpPr>
-          <p:cNvPr id="43" name="Text 41"/>
+          <p:cNvPr id="48" name="Text 41"/>
           <p:cNvSpPr txBox="1"/>
           <p:nvPr/>
         </p:nvSpPr>
@@ -4686,7 +4808,7 @@
       </p:sp>
       <p:sp>
         <p:nvSpPr>
-          <p:cNvPr id="44" name="Shape 42"/>
+          <p:cNvPr id="49" name="Shape 42"/>
           <p:cNvSpPr/>
           <p:nvPr/>
         </p:nvSpPr>
@@ -4713,7 +4835,7 @@
       </p:sp>
       <p:sp>
         <p:nvSpPr>
-          <p:cNvPr id="45" name="Text 43"/>
+          <p:cNvPr id="50" name="Text 43"/>
           <p:cNvSpPr txBox="1"/>
           <p:nvPr/>
         </p:nvSpPr>
@@ -4766,7 +4888,7 @@
       </p:sp>
       <p:sp>
         <p:nvSpPr>
-          <p:cNvPr id="46" name="Text 44"/>
+          <p:cNvPr id="51" name="Text 44"/>
           <p:cNvSpPr txBox="1"/>
           <p:nvPr/>
         </p:nvSpPr>
@@ -4868,7 +4990,7 @@
       </p:sp>
       <p:sp>
         <p:nvSpPr>
-          <p:cNvPr id="47" name="Shape 45"/>
+          <p:cNvPr id="52" name="Shape 45"/>
           <p:cNvSpPr/>
           <p:nvPr/>
         </p:nvSpPr>
@@ -4895,7 +5017,7 @@
       </p:sp>
       <p:sp>
         <p:nvSpPr>
-          <p:cNvPr id="48" name="Text 46"/>
+          <p:cNvPr id="53" name="Text 46"/>
           <p:cNvSpPr txBox="1"/>
           <p:nvPr/>
         </p:nvSpPr>
@@ -4948,7 +5070,7 @@
       </p:sp>
       <p:sp>
         <p:nvSpPr>
-          <p:cNvPr id="49" name="Text 47"/>
+          <p:cNvPr id="54" name="Text 47"/>
           <p:cNvSpPr txBox="1"/>
           <p:nvPr/>
         </p:nvSpPr>
@@ -5050,7 +5172,7 @@
       </p:sp>
       <p:sp>
         <p:nvSpPr>
-          <p:cNvPr id="50" name="Shape 48"/>
+          <p:cNvPr id="55" name="Shape 48"/>
           <p:cNvSpPr/>
           <p:nvPr/>
         </p:nvSpPr>
@@ -5077,7 +5199,7 @@
       </p:sp>
       <p:sp>
         <p:nvSpPr>
-          <p:cNvPr id="51" name="Text 49"/>
+          <p:cNvPr id="56" name="Text 49"/>
           <p:cNvSpPr txBox="1"/>
           <p:nvPr/>
         </p:nvSpPr>
@@ -5130,7 +5252,7 @@
       </p:sp>
       <p:sp>
         <p:nvSpPr>
-          <p:cNvPr id="52" name="Text 50"/>
+          <p:cNvPr id="57" name="Text 50"/>
           <p:cNvSpPr txBox="1"/>
           <p:nvPr/>
         </p:nvSpPr>
@@ -5212,7 +5334,7 @@
       </p:sp>
       <p:sp>
         <p:nvSpPr>
-          <p:cNvPr id="53" name="Text 51"/>
+          <p:cNvPr id="58" name="Text 51"/>
           <p:cNvSpPr txBox="1"/>
           <p:nvPr/>
         </p:nvSpPr>

</xml_diff>

<commit_message>
Use source wording verbatim on slide 1; drop added commentary on slide 2
Co-Authored-By: Claude Opus 5.5 <noreply@anthropic.com>
Claude-Session: https://claude.ai/code/session_01QGTe9h3kfUS6BTZosfrxzF
</commit_message>
<xml_diff>
--- a/resumen-ejecutivo-semanal/Resumen_Ejecutivo_Riesgos_COMEDICA_2_Slides.pptx
+++ b/resumen-ejecutivo-semanal/Resumen_Ejecutivo_Riesgos_COMEDICA_2_Slides.pptx
@@ -1036,7 +1036,7 @@
                 <a:ea typeface="Calibri" pitchFamily="34" charset="-122"/>
                 <a:cs typeface="Calibri" pitchFamily="34" charset="-120"/>
               </a:rPr>
-              <a:t>Informe semanal · Resumen ejecutivo</a:t>
+              <a:t>Informe semanal</a:t>
             </a:r>
             <a:endParaRPr lang="en-US" sz="1300" dirty="0"/>
           </a:p>
@@ -1183,11 +1183,11 @@
         <p:spPr>
           <a:xfrm>
             <a:off x="457200" y="1627632"/>
-            <a:ext cx="2697480" cy="1051560"/>
+            <a:ext cx="2697480" cy="1417320"/>
           </a:xfrm>
           <a:prstGeom prst="roundRect">
             <a:avLst>
-              <a:gd name="adj" fmla="val 8696"/>
+              <a:gd name="adj" fmla="val 6452"/>
             </a:avLst>
           </a:prstGeom>
           <a:solidFill>
@@ -1209,7 +1209,7 @@
         </p:nvSpPr>
         <p:spPr>
           <a:xfrm>
-            <a:off x="621792" y="1970532"/>
+            <a:off x="621792" y="2153412"/>
             <a:ext cx="384048" cy="384048"/>
           </a:xfrm>
           <a:prstGeom prst="ellipse">
@@ -1242,7 +1242,7 @@
         </p:blipFill>
         <p:spPr>
           <a:xfrm>
-            <a:off x="722376" y="2071116"/>
+            <a:off x="722376" y="2253996"/>
             <a:ext cx="182880" cy="182880"/>
           </a:xfrm>
           <a:prstGeom prst="rect">
@@ -1258,7 +1258,7 @@
         </p:nvSpPr>
         <p:spPr>
           <a:xfrm>
-            <a:off x="1143000" y="1879092"/>
+            <a:off x="1143000" y="2061972"/>
             <a:ext cx="1920240" cy="566928"/>
           </a:xfrm>
           <a:prstGeom prst="rect">
@@ -1315,11 +1315,11 @@
         <p:spPr>
           <a:xfrm>
             <a:off x="3291840" y="1627632"/>
-            <a:ext cx="4151376" cy="1051560"/>
+            <a:ext cx="4151376" cy="1417320"/>
           </a:xfrm>
           <a:prstGeom prst="roundRect">
             <a:avLst>
-              <a:gd name="adj" fmla="val 8696"/>
+              <a:gd name="adj" fmla="val 6452"/>
             </a:avLst>
           </a:prstGeom>
           <a:solidFill>
@@ -1342,7 +1342,7 @@
         <p:spPr>
           <a:xfrm>
             <a:off x="3456432" y="1700784"/>
-            <a:ext cx="3858768" cy="905256"/>
+            <a:ext cx="3858768" cy="1271016"/>
           </a:xfrm>
           <a:prstGeom prst="rect">
             <a:avLst/>
@@ -1358,7 +1358,7 @@
               <a:buNone/>
             </a:pPr>
             <a:r>
-              <a:rPr lang="en-US" sz="1150" b="1" dirty="0">
+              <a:rPr lang="en-US" sz="1050" b="1" dirty="0">
                 <a:solidFill>
                   <a:srgbClr val="0B2545"/>
                 </a:solidFill>
@@ -1366,13 +1366,13 @@
                 <a:ea typeface="Calibri" pitchFamily="34" charset="-122"/>
                 <a:cs typeface="Calibri" pitchFamily="34" charset="-120"/>
               </a:rPr>
-              <a:t>PLD/FT  ·  </a:t>
+              <a:t>Resultados preliminares – PLD/FT  ·  </a:t>
             </a:r>
             <a:pPr indent="0" marL="0">
               <a:buNone/>
             </a:pPr>
             <a:r>
-              <a:rPr lang="en-US" sz="1100" dirty="0">
+              <a:rPr lang="en-US" sz="1050" dirty="0">
                 <a:solidFill>
                   <a:srgbClr val="13507F"/>
                 </a:solidFill>
@@ -1382,6 +1382,9 @@
               </a:rPr>
               <a:t>Circ. 23486</a:t>
             </a:r>
+            <a:endParaRPr lang="en-US" sz="1050" dirty="0"/>
+          </a:p>
+          <a:p>
             <a:pPr indent="0" marL="0">
               <a:spcAft>
                 <a:spcPts val="300"/>
@@ -1389,7 +1392,7 @@
               <a:buNone/>
             </a:pPr>
             <a:r>
-              <a:rPr lang="en-US" sz="1150" b="1" dirty="0">
+              <a:rPr lang="en-US" sz="1050" b="1" dirty="0">
                 <a:solidFill>
                   <a:srgbClr val="B86E00"/>
                 </a:solidFill>
@@ -1397,16 +1400,16 @@
                 <a:ea typeface="Calibri" pitchFamily="34" charset="-122"/>
                 <a:cs typeface="Calibri" pitchFamily="34" charset="-120"/>
               </a:rPr>
-              <a:t>   Plazo 16/10/2026</a:t>
-            </a:r>
-            <a:endParaRPr lang="en-US" sz="1150" dirty="0"/>
+              <a:t>Plazo 16/10/2026</a:t>
+            </a:r>
+            <a:endParaRPr lang="en-US" sz="1050" dirty="0"/>
           </a:p>
           <a:p>
             <a:pPr indent="0" marL="0">
               <a:buNone/>
             </a:pPr>
             <a:r>
-              <a:rPr lang="en-US" sz="1150" b="1" dirty="0">
+              <a:rPr lang="en-US" sz="1050" b="1" dirty="0">
                 <a:solidFill>
                   <a:srgbClr val="0B2545"/>
                 </a:solidFill>
@@ -1414,13 +1417,13 @@
                 <a:ea typeface="Calibri" pitchFamily="34" charset="-122"/>
                 <a:cs typeface="Calibri" pitchFamily="34" charset="-120"/>
               </a:rPr>
-              <a:t>Gobierno Corporativo  ·  </a:t>
+              <a:t>Resultados preliminares – Gobierno Corporativo  ·  </a:t>
             </a:r>
             <a:pPr indent="0" marL="0">
               <a:buNone/>
             </a:pPr>
             <a:r>
-              <a:rPr lang="en-US" sz="1100" dirty="0">
+              <a:rPr lang="en-US" sz="1050" dirty="0">
                 <a:solidFill>
                   <a:srgbClr val="13507F"/>
                 </a:solidFill>
@@ -1430,6 +1433,26 @@
               </a:rPr>
               <a:t>Circ. 22741</a:t>
             </a:r>
+            <a:endParaRPr lang="en-US" sz="1050" dirty="0"/>
+          </a:p>
+          <a:p>
+            <a:pPr indent="0" marL="0">
+              <a:buNone/>
+            </a:pPr>
+            <a:r>
+              <a:rPr lang="en-US" sz="1050" b="1" dirty="0">
+                <a:solidFill>
+                  <a:srgbClr val="B86E00"/>
+                </a:solidFill>
+                <a:latin typeface="Calibri" pitchFamily="34" charset="0"/>
+                <a:ea typeface="Calibri" pitchFamily="34" charset="-122"/>
+                <a:cs typeface="Calibri" pitchFamily="34" charset="-120"/>
+              </a:rPr>
+              <a:t>Plazo 23/10/2026 · Nuevas observaciones</a:t>
+            </a:r>
+            <a:endParaRPr lang="en-US" sz="1050" dirty="0"/>
+          </a:p>
+          <a:p>
             <a:pPr indent="0" marL="0">
               <a:spcAft>
                 <a:spcPts val="300"/>
@@ -1437,7 +1460,7 @@
               <a:buNone/>
             </a:pPr>
             <a:r>
-              <a:rPr lang="en-US" sz="1150" b="1" dirty="0">
+              <a:rPr lang="en-US" sz="1050" b="1" dirty="0">
                 <a:solidFill>
                   <a:srgbClr val="B86E00"/>
                 </a:solidFill>
@@ -1445,16 +1468,16 @@
                 <a:ea typeface="Calibri" pitchFamily="34" charset="-122"/>
                 <a:cs typeface="Calibri" pitchFamily="34" charset="-120"/>
               </a:rPr>
-              <a:t>   Plazos 23/10 y 30/10</a:t>
-            </a:r>
-            <a:endParaRPr lang="en-US" sz="1150" dirty="0"/>
+              <a:t>Plazo 30/10/2026 · Seguimiento de observaciones</a:t>
+            </a:r>
+            <a:endParaRPr lang="en-US" sz="1050" dirty="0"/>
           </a:p>
           <a:p>
             <a:pPr indent="0" marL="0">
               <a:buNone/>
             </a:pPr>
             <a:r>
-              <a:rPr lang="en-US" sz="1150" b="1" dirty="0">
+              <a:rPr lang="en-US" sz="1050" b="1" dirty="0">
                 <a:solidFill>
                   <a:srgbClr val="0B2545"/>
                 </a:solidFill>
@@ -1462,13 +1485,13 @@
                 <a:ea typeface="Calibri" pitchFamily="34" charset="-122"/>
                 <a:cs typeface="Calibri" pitchFamily="34" charset="-120"/>
               </a:rPr>
-              <a:t>Plan de Recuperación  ·  </a:t>
+              <a:t>Resultado preliminar Plan de Recuperación  ·  </a:t>
             </a:r>
             <a:pPr indent="0" marL="0">
               <a:buNone/>
             </a:pPr>
             <a:r>
-              <a:rPr lang="en-US" sz="1100" dirty="0">
+              <a:rPr lang="en-US" sz="1050" dirty="0">
                 <a:solidFill>
                   <a:srgbClr val="13507F"/>
                 </a:solidFill>
@@ -1478,6 +1501,9 @@
               </a:rPr>
               <a:t>Circ. 22737</a:t>
             </a:r>
+            <a:endParaRPr lang="en-US" sz="1050" dirty="0"/>
+          </a:p>
+          <a:p>
             <a:pPr indent="0" marL="0">
               <a:spcAft>
                 <a:spcPts val="300"/>
@@ -1485,7 +1511,7 @@
               <a:buNone/>
             </a:pPr>
             <a:r>
-              <a:rPr lang="en-US" sz="1150" b="1" dirty="0">
+              <a:rPr lang="en-US" sz="1050" b="1" dirty="0">
                 <a:solidFill>
                   <a:srgbClr val="B86E00"/>
                 </a:solidFill>
@@ -1493,57 +1519,9 @@
                 <a:ea typeface="Calibri" pitchFamily="34" charset="-122"/>
                 <a:cs typeface="Calibri" pitchFamily="34" charset="-120"/>
               </a:rPr>
-              <a:t>   Plazo 03/11/2026</a:t>
-            </a:r>
-            <a:endParaRPr lang="en-US" sz="1150" dirty="0"/>
-          </a:p>
-          <a:p>
-            <a:pPr indent="0" marL="0">
-              <a:buNone/>
-            </a:pPr>
-            <a:r>
-              <a:rPr lang="en-US" sz="1150" b="1" dirty="0">
-                <a:solidFill>
-                  <a:srgbClr val="0B2545"/>
-                </a:solidFill>
-                <a:latin typeface="Calibri" pitchFamily="34" charset="0"/>
-                <a:ea typeface="Calibri" pitchFamily="34" charset="-122"/>
-                <a:cs typeface="Calibri" pitchFamily="34" charset="-120"/>
-              </a:rPr>
-              <a:t>Riesgos Específicos  ·  </a:t>
-            </a:r>
-            <a:pPr indent="0" marL="0">
-              <a:buNone/>
-            </a:pPr>
-            <a:r>
-              <a:rPr lang="en-US" sz="1100" dirty="0">
-                <a:solidFill>
-                  <a:srgbClr val="13507F"/>
-                </a:solidFill>
-                <a:latin typeface="Calibri" pitchFamily="34" charset="0"/>
-                <a:ea typeface="Calibri" pitchFamily="34" charset="-122"/>
-                <a:cs typeface="Calibri" pitchFamily="34" charset="-120"/>
-              </a:rPr>
-              <a:t>Circ. 22742</a:t>
-            </a:r>
-            <a:pPr indent="0" marL="0">
-              <a:spcAft>
-                <a:spcPts val="300"/>
-              </a:spcAft>
-              <a:buNone/>
-            </a:pPr>
-            <a:r>
-              <a:rPr lang="en-US" sz="1150" b="1" dirty="0">
-                <a:solidFill>
-                  <a:srgbClr val="B86E00"/>
-                </a:solidFill>
-                <a:latin typeface="Calibri" pitchFamily="34" charset="0"/>
-                <a:ea typeface="Calibri" pitchFamily="34" charset="-122"/>
-                <a:cs typeface="Calibri" pitchFamily="34" charset="-120"/>
-              </a:rPr>
-              <a:t>   Inicio visita 09/10</a:t>
-            </a:r>
-            <a:endParaRPr lang="en-US" sz="1150" dirty="0"/>
+              <a:t>Plazo 03/11/2026</a:t>
+            </a:r>
+            <a:endParaRPr lang="en-US" sz="1050" dirty="0"/>
           </a:p>
         </p:txBody>
       </p:sp>
@@ -1556,11 +1534,11 @@
         <p:spPr>
           <a:xfrm>
             <a:off x="7580376" y="1627632"/>
-            <a:ext cx="4151376" cy="1051560"/>
+            <a:ext cx="4151376" cy="1417320"/>
           </a:xfrm>
           <a:prstGeom prst="roundRect">
             <a:avLst>
-              <a:gd name="adj" fmla="val 8696"/>
+              <a:gd name="adj" fmla="val 6452"/>
             </a:avLst>
           </a:prstGeom>
           <a:solidFill>
@@ -1583,7 +1561,7 @@
         <p:spPr>
           <a:xfrm>
             <a:off x="7744968" y="1700784"/>
-            <a:ext cx="3858768" cy="905256"/>
+            <a:ext cx="3858768" cy="1271016"/>
           </a:xfrm>
           <a:prstGeom prst="rect">
             <a:avLst/>
@@ -1603,7 +1581,7 @@
               <a:buChar char="•"/>
             </a:pPr>
             <a:r>
-              <a:rPr lang="en-US" sz="1100" dirty="0">
+              <a:rPr lang="en-US" sz="1050" dirty="0">
                 <a:solidFill>
                   <a:srgbClr val="1B2733"/>
                 </a:solidFill>
@@ -1611,9 +1589,9 @@
                 <a:ea typeface="Calibri" pitchFamily="34" charset="-122"/>
                 <a:cs typeface="Calibri" pitchFamily="34" charset="-120"/>
               </a:rPr>
-              <a:t>Matriz y requerimiento a áreas – nota 22741</a:t>
-            </a:r>
-            <a:endParaRPr lang="en-US" sz="1100" dirty="0"/>
+              <a:t>Requerimiento según nota DS-SABAO-BCS-BC-22741</a:t>
+            </a:r>
+            <a:endParaRPr lang="en-US" sz="1050" dirty="0"/>
           </a:p>
           <a:p>
             <a:pPr marL="152400" indent="-152400">
@@ -1624,7 +1602,7 @@
               <a:buChar char="•"/>
             </a:pPr>
             <a:r>
-              <a:rPr lang="en-US" sz="1100" dirty="0">
+              <a:rPr lang="en-US" sz="1050" dirty="0">
                 <a:solidFill>
                   <a:srgbClr val="1B2733"/>
                 </a:solidFill>
@@ -1632,9 +1610,9 @@
                 <a:ea typeface="Calibri" pitchFamily="34" charset="-122"/>
                 <a:cs typeface="Calibri" pitchFamily="34" charset="-120"/>
               </a:rPr>
-              <a:t>Pruebas de descargo – notas 22741 y 23486</a:t>
-            </a:r>
-            <a:endParaRPr lang="en-US" sz="1100" dirty="0"/>
+              <a:t>Requerimiento según nota DS-SABAO-BCS-BC-23486</a:t>
+            </a:r>
+            <a:endParaRPr lang="en-US" sz="1050" dirty="0"/>
           </a:p>
           <a:p>
             <a:pPr marL="152400" indent="-152400">
@@ -1645,7 +1623,7 @@
               <a:buChar char="•"/>
             </a:pPr>
             <a:r>
-              <a:rPr lang="en-US" sz="1100" dirty="0">
+              <a:rPr lang="en-US" sz="1050" dirty="0">
                 <a:solidFill>
                   <a:srgbClr val="1B2733"/>
                 </a:solidFill>
@@ -1653,9 +1631,9 @@
                 <a:ea typeface="Calibri" pitchFamily="34" charset="-122"/>
                 <a:cs typeface="Calibri" pitchFamily="34" charset="-120"/>
               </a:rPr>
-              <a:t>Presentación visita de supervisión Gob. Corporativo</a:t>
-            </a:r>
-            <a:endParaRPr lang="en-US" sz="1100" dirty="0"/>
+              <a:t>Presentación resultados preliminares de Gestión de Riesgo Específico</a:t>
+            </a:r>
+            <a:endParaRPr lang="en-US" sz="1050" dirty="0"/>
           </a:p>
           <a:p>
             <a:pPr marL="152400" indent="-152400">
@@ -1666,7 +1644,7 @@
               <a:buChar char="•"/>
             </a:pPr>
             <a:r>
-              <a:rPr lang="en-US" sz="1100" dirty="0">
+              <a:rPr lang="en-US" sz="1050" dirty="0">
                 <a:solidFill>
                   <a:srgbClr val="1B2733"/>
                 </a:solidFill>
@@ -1674,9 +1652,9 @@
                 <a:ea typeface="Calibri" pitchFamily="34" charset="-122"/>
                 <a:cs typeface="Calibri" pitchFamily="34" charset="-120"/>
               </a:rPr>
-              <a:t>Resultados preliminares de Riesgo Específico</a:t>
-            </a:r>
-            <a:endParaRPr lang="en-US" sz="1100" dirty="0"/>
+              <a:t>Presentación visita de supervisión gobierno corporativo</a:t>
+            </a:r>
+            <a:endParaRPr lang="en-US" sz="1050" dirty="0"/>
           </a:p>
         </p:txBody>
       </p:sp>
@@ -1688,12 +1666,12 @@
         </p:nvSpPr>
         <p:spPr>
           <a:xfrm>
-            <a:off x="457200" y="2761488"/>
-            <a:ext cx="2697480" cy="1170432"/>
+            <a:off x="457200" y="3127248"/>
+            <a:ext cx="2697480" cy="1188720"/>
           </a:xfrm>
           <a:prstGeom prst="roundRect">
             <a:avLst>
-              <a:gd name="adj" fmla="val 7813"/>
+              <a:gd name="adj" fmla="val 7692"/>
             </a:avLst>
           </a:prstGeom>
           <a:solidFill>
@@ -1715,7 +1693,7 @@
         </p:nvSpPr>
         <p:spPr>
           <a:xfrm>
-            <a:off x="621792" y="2962656"/>
+            <a:off x="621792" y="3337560"/>
             <a:ext cx="384048" cy="384048"/>
           </a:xfrm>
           <a:prstGeom prst="ellipse">
@@ -1748,7 +1726,7 @@
         </p:blipFill>
         <p:spPr>
           <a:xfrm>
-            <a:off x="722376" y="3063240"/>
+            <a:off x="722376" y="3438144"/>
             <a:ext cx="182880" cy="182880"/>
           </a:xfrm>
           <a:prstGeom prst="rect">
@@ -1764,7 +1742,7 @@
         </p:nvSpPr>
         <p:spPr>
           <a:xfrm>
-            <a:off x="1143000" y="2871216"/>
+            <a:off x="1143000" y="3246120"/>
             <a:ext cx="1920240" cy="566928"/>
           </a:xfrm>
           <a:prstGeom prst="rect">
@@ -1793,23 +1771,6 @@
             </a:r>
             <a:endParaRPr lang="en-US" sz="1350" dirty="0"/>
           </a:p>
-          <a:p>
-            <a:pPr indent="0" marL="0">
-              <a:buNone/>
-            </a:pPr>
-            <a:r>
-              <a:rPr lang="en-US" sz="1050" dirty="0">
-                <a:solidFill>
-                  <a:srgbClr val="C9D6E6"/>
-                </a:solidFill>
-                <a:latin typeface="Calibri" pitchFamily="34" charset="0"/>
-                <a:ea typeface="Calibri" pitchFamily="34" charset="-122"/>
-                <a:cs typeface="Calibri" pitchFamily="34" charset="-120"/>
-              </a:rPr>
-              <a:t>Continuidad y control</a:t>
-            </a:r>
-            <a:endParaRPr lang="en-US" sz="1350" dirty="0"/>
-          </a:p>
         </p:txBody>
       </p:sp>
       <p:sp>
@@ -1820,8 +1781,8 @@
         </p:nvSpPr>
         <p:spPr>
           <a:xfrm>
-            <a:off x="621792" y="3401568"/>
-            <a:ext cx="1463040" cy="182880"/>
+            <a:off x="621792" y="3776472"/>
+            <a:ext cx="2103120" cy="182880"/>
           </a:xfrm>
           <a:prstGeom prst="rect">
             <a:avLst/>
@@ -1845,7 +1806,7 @@
                 <a:ea typeface="Calibri" pitchFamily="34" charset="-122"/>
                 <a:cs typeface="Calibri" pitchFamily="34" charset="-120"/>
               </a:rPr>
-              <a:t>Examen GIR 2026</a:t>
+              <a:t>Capacitación y Examen GIR 2026</a:t>
             </a:r>
             <a:endParaRPr lang="en-US" sz="950" dirty="0"/>
           </a:p>
@@ -1859,7 +1820,7 @@
         </p:nvSpPr>
         <p:spPr>
           <a:xfrm>
-            <a:off x="621792" y="3621024"/>
+            <a:off x="621792" y="3995928"/>
             <a:ext cx="1828800" cy="100584"/>
           </a:xfrm>
           <a:prstGeom prst="roundRect">
@@ -1886,7 +1847,7 @@
         </p:nvSpPr>
         <p:spPr>
           <a:xfrm>
-            <a:off x="621792" y="3621024"/>
+            <a:off x="621792" y="3995928"/>
             <a:ext cx="1645920" cy="100584"/>
           </a:xfrm>
           <a:prstGeom prst="roundRect">
@@ -1913,7 +1874,7 @@
         </p:nvSpPr>
         <p:spPr>
           <a:xfrm>
-            <a:off x="2496312" y="3511296"/>
+            <a:off x="2496312" y="3886200"/>
             <a:ext cx="548640" cy="310896"/>
           </a:xfrm>
           <a:prstGeom prst="rect">
@@ -1952,12 +1913,12 @@
         </p:nvSpPr>
         <p:spPr>
           <a:xfrm>
-            <a:off x="3291840" y="2761488"/>
-            <a:ext cx="4151376" cy="1170432"/>
+            <a:off x="3291840" y="3127248"/>
+            <a:ext cx="4151376" cy="1188720"/>
           </a:xfrm>
           <a:prstGeom prst="roundRect">
             <a:avLst>
-              <a:gd name="adj" fmla="val 7813"/>
+              <a:gd name="adj" fmla="val 7692"/>
             </a:avLst>
           </a:prstGeom>
           <a:solidFill>
@@ -1979,8 +1940,8 @@
         </p:nvSpPr>
         <p:spPr>
           <a:xfrm>
-            <a:off x="3456432" y="2834640"/>
-            <a:ext cx="3858768" cy="1024128"/>
+            <a:off x="3456432" y="3200400"/>
+            <a:ext cx="3858768" cy="1042416"/>
           </a:xfrm>
           <a:prstGeom prst="rect">
             <a:avLst/>
@@ -2000,7 +1961,7 @@
               <a:buChar char="•"/>
             </a:pPr>
             <a:r>
-              <a:rPr lang="en-US" sz="1100" dirty="0">
+              <a:rPr lang="en-US" sz="1050" dirty="0">
                 <a:solidFill>
                   <a:srgbClr val="1B2733"/>
                 </a:solidFill>
@@ -2008,9 +1969,9 @@
                 <a:ea typeface="Calibri" pitchFamily="34" charset="-122"/>
                 <a:cs typeface="Calibri" pitchFamily="34" charset="-120"/>
               </a:rPr>
-              <a:t>Actualización Matriz BIA</a:t>
-            </a:r>
-            <a:endParaRPr lang="en-US" sz="1100" dirty="0"/>
+              <a:t>Capacitación y Examen GIR 2026</a:t>
+            </a:r>
+            <a:endParaRPr lang="en-US" sz="1050" dirty="0"/>
           </a:p>
           <a:p>
             <a:pPr marL="152400" indent="-152400">
@@ -2021,7 +1982,7 @@
               <a:buChar char="•"/>
             </a:pPr>
             <a:r>
-              <a:rPr lang="en-US" sz="1100" dirty="0">
+              <a:rPr lang="en-US" sz="1050" dirty="0">
                 <a:solidFill>
                   <a:srgbClr val="1B2733"/>
                 </a:solidFill>
@@ -2029,9 +1990,9 @@
                 <a:ea typeface="Calibri" pitchFamily="34" charset="-122"/>
                 <a:cs typeface="Calibri" pitchFamily="34" charset="-120"/>
               </a:rPr>
-              <a:t>Indicadores de Gob. Corporativo y Reputacional</a:t>
-            </a:r>
-            <a:endParaRPr lang="en-US" sz="1100" dirty="0"/>
+              <a:t>Actualización Matriz BIA</a:t>
+            </a:r>
+            <a:endParaRPr lang="en-US" sz="1050" dirty="0"/>
           </a:p>
           <a:p>
             <a:pPr marL="152400" indent="-152400">
@@ -2042,7 +2003,7 @@
               <a:buChar char="•"/>
             </a:pPr>
             <a:r>
-              <a:rPr lang="en-US" sz="1100" dirty="0">
+              <a:rPr lang="en-US" sz="1050" dirty="0">
                 <a:solidFill>
                   <a:srgbClr val="1B2733"/>
                 </a:solidFill>
@@ -2052,7 +2013,7 @@
               </a:rPr>
               <a:t>Segunda prueba de continuidad de negocio</a:t>
             </a:r>
-            <a:endParaRPr lang="en-US" sz="1100" dirty="0"/>
+            <a:endParaRPr lang="en-US" sz="1050" dirty="0"/>
           </a:p>
         </p:txBody>
       </p:sp>
@@ -2064,12 +2025,12 @@
         </p:nvSpPr>
         <p:spPr>
           <a:xfrm>
-            <a:off x="7580376" y="2761488"/>
-            <a:ext cx="4151376" cy="1170432"/>
+            <a:off x="7580376" y="3127248"/>
+            <a:ext cx="4151376" cy="1188720"/>
           </a:xfrm>
           <a:prstGeom prst="roundRect">
             <a:avLst>
-              <a:gd name="adj" fmla="val 7813"/>
+              <a:gd name="adj" fmla="val 7692"/>
             </a:avLst>
           </a:prstGeom>
           <a:solidFill>
@@ -2091,8 +2052,8 @@
         </p:nvSpPr>
         <p:spPr>
           <a:xfrm>
-            <a:off x="7744968" y="2834640"/>
-            <a:ext cx="3858768" cy="1024128"/>
+            <a:off x="7744968" y="3200400"/>
+            <a:ext cx="3858768" cy="1042416"/>
           </a:xfrm>
           <a:prstGeom prst="rect">
             <a:avLst/>
@@ -2112,7 +2073,7 @@
               <a:buChar char="•"/>
             </a:pPr>
             <a:r>
-              <a:rPr lang="en-US" sz="1100" dirty="0">
+              <a:rPr lang="en-US" sz="1050" dirty="0">
                 <a:solidFill>
                   <a:srgbClr val="1B2733"/>
                 </a:solidFill>
@@ -2120,9 +2081,9 @@
                 <a:ea typeface="Calibri" pitchFamily="34" charset="-122"/>
                 <a:cs typeface="Calibri" pitchFamily="34" charset="-120"/>
               </a:rPr>
-              <a:t>Capacitación GIR 2026 e informe de seguimiento del examen</a:t>
-            </a:r>
-            <a:endParaRPr lang="en-US" sz="1100" dirty="0"/>
+              <a:t>Capacitación de GIR 2026</a:t>
+            </a:r>
+            <a:endParaRPr lang="en-US" sz="1050" dirty="0"/>
           </a:p>
           <a:p>
             <a:pPr marL="152400" indent="-152400">
@@ -2133,7 +2094,7 @@
               <a:buChar char="•"/>
             </a:pPr>
             <a:r>
-              <a:rPr lang="en-US" sz="1100" dirty="0">
+              <a:rPr lang="en-US" sz="1050" dirty="0">
                 <a:solidFill>
                   <a:srgbClr val="1B2733"/>
                 </a:solidFill>
@@ -2141,9 +2102,9 @@
                 <a:ea typeface="Calibri" pitchFamily="34" charset="-122"/>
                 <a:cs typeface="Calibri" pitchFamily="34" charset="-120"/>
               </a:rPr>
-              <a:t>Informe 2.ª prueba de continuidad (01/10/2026)</a:t>
-            </a:r>
-            <a:endParaRPr lang="en-US" sz="1100" dirty="0"/>
+              <a:t>Informe de segunda prueba de Continuidad del Negocio realizada el 01.10.2026</a:t>
+            </a:r>
+            <a:endParaRPr lang="en-US" sz="1050" dirty="0"/>
           </a:p>
           <a:p>
             <a:pPr marL="152400" indent="-152400">
@@ -2154,7 +2115,7 @@
               <a:buChar char="•"/>
             </a:pPr>
             <a:r>
-              <a:rPr lang="en-US" sz="1100" dirty="0">
+              <a:rPr lang="en-US" sz="1050" dirty="0">
                 <a:solidFill>
                   <a:srgbClr val="1B2733"/>
                 </a:solidFill>
@@ -2162,9 +2123,9 @@
                 <a:ea typeface="Calibri" pitchFamily="34" charset="-122"/>
                 <a:cs typeface="Calibri" pitchFamily="34" charset="-120"/>
               </a:rPr>
-              <a:t>Planes de acción Matriz 2026 y eventos TC / Orion</a:t>
-            </a:r>
-            <a:endParaRPr lang="en-US" sz="1100" dirty="0"/>
+              <a:t>Seguimiento planes de acción Matriz de Riesgos Institucional 2026</a:t>
+            </a:r>
+            <a:endParaRPr lang="en-US" sz="1050" dirty="0"/>
           </a:p>
           <a:p>
             <a:pPr marL="152400" indent="-152400">
@@ -2175,7 +2136,7 @@
               <a:buChar char="•"/>
             </a:pPr>
             <a:r>
-              <a:rPr lang="en-US" sz="1100" dirty="0">
+              <a:rPr lang="en-US" sz="1050" dirty="0">
                 <a:solidFill>
                   <a:srgbClr val="1B2733"/>
                 </a:solidFill>
@@ -2183,30 +2144,9 @@
                 <a:ea typeface="Calibri" pitchFamily="34" charset="-122"/>
                 <a:cs typeface="Calibri" pitchFamily="34" charset="-120"/>
               </a:rPr>
-              <a:t>Opiniones: Fábrica de Créditos y caso de asociado</a:t>
-            </a:r>
-            <a:endParaRPr lang="en-US" sz="1100" dirty="0"/>
-          </a:p>
-          <a:p>
-            <a:pPr marL="152400" indent="-152400">
-              <a:spcAft>
-                <a:spcPts val="200"/>
-              </a:spcAft>
-              <a:buSzPct val="100000"/>
-              <a:buChar char="•"/>
-            </a:pPr>
-            <a:r>
-              <a:rPr lang="en-US" sz="1100" dirty="0">
-                <a:solidFill>
-                  <a:srgbClr val="1B2733"/>
-                </a:solidFill>
-                <a:latin typeface="Calibri" pitchFamily="34" charset="0"/>
-                <a:ea typeface="Calibri" pitchFamily="34" charset="-122"/>
-                <a:cs typeface="Calibri" pitchFamily="34" charset="-120"/>
-              </a:rPr>
-              <a:t>Información a Auditoría Interna (NRP-24) y Externa</a:t>
-            </a:r>
-            <a:endParaRPr lang="en-US" sz="1100" dirty="0"/>
+              <a:t>Seguimiento eventos de riesgos por caídas de TC 25.09.2026 y Orion 26.09.2026</a:t>
+            </a:r>
+            <a:endParaRPr lang="en-US" sz="1050" dirty="0"/>
           </a:p>
         </p:txBody>
       </p:sp>
@@ -2218,12 +2158,12 @@
         </p:nvSpPr>
         <p:spPr>
           <a:xfrm>
-            <a:off x="457200" y="4014216"/>
-            <a:ext cx="2697480" cy="1170432"/>
+            <a:off x="457200" y="4398264"/>
+            <a:ext cx="2697480" cy="987552"/>
           </a:xfrm>
           <a:prstGeom prst="roundRect">
             <a:avLst>
-              <a:gd name="adj" fmla="val 7813"/>
+              <a:gd name="adj" fmla="val 9259"/>
             </a:avLst>
           </a:prstGeom>
           <a:solidFill>
@@ -2245,7 +2185,7 @@
         </p:nvSpPr>
         <p:spPr>
           <a:xfrm>
-            <a:off x="621792" y="4416552"/>
+            <a:off x="621792" y="4709160"/>
             <a:ext cx="384048" cy="384048"/>
           </a:xfrm>
           <a:prstGeom prst="ellipse">
@@ -2278,7 +2218,7 @@
         </p:blipFill>
         <p:spPr>
           <a:xfrm>
-            <a:off x="722376" y="4517136"/>
+            <a:off x="722376" y="4809744"/>
             <a:ext cx="182880" cy="182880"/>
           </a:xfrm>
           <a:prstGeom prst="rect">
@@ -2294,7 +2234,7 @@
         </p:nvSpPr>
         <p:spPr>
           <a:xfrm>
-            <a:off x="1143000" y="4325112"/>
+            <a:off x="1143000" y="4617720"/>
             <a:ext cx="1920240" cy="566928"/>
           </a:xfrm>
           <a:prstGeom prst="rect">
@@ -2323,23 +2263,6 @@
             </a:r>
             <a:endParaRPr lang="en-US" sz="1350" dirty="0"/>
           </a:p>
-          <a:p>
-            <a:pPr indent="0" marL="0">
-              <a:buNone/>
-            </a:pPr>
-            <a:r>
-              <a:rPr lang="en-US" sz="1050" dirty="0">
-                <a:solidFill>
-                  <a:srgbClr val="C9D6E6"/>
-                </a:solidFill>
-                <a:latin typeface="Calibri" pitchFamily="34" charset="0"/>
-                <a:ea typeface="Calibri" pitchFamily="34" charset="-122"/>
-                <a:cs typeface="Calibri" pitchFamily="34" charset="-120"/>
-              </a:rPr>
-              <a:t>Avalúos y políticas</a:t>
-            </a:r>
-            <a:endParaRPr lang="en-US" sz="1350" dirty="0"/>
-          </a:p>
         </p:txBody>
       </p:sp>
       <p:sp>
@@ -2350,12 +2273,12 @@
         </p:nvSpPr>
         <p:spPr>
           <a:xfrm>
-            <a:off x="3291840" y="4014216"/>
-            <a:ext cx="4151376" cy="1170432"/>
+            <a:off x="3291840" y="4398264"/>
+            <a:ext cx="4151376" cy="987552"/>
           </a:xfrm>
           <a:prstGeom prst="roundRect">
             <a:avLst>
-              <a:gd name="adj" fmla="val 7813"/>
+              <a:gd name="adj" fmla="val 9259"/>
             </a:avLst>
           </a:prstGeom>
           <a:solidFill>
@@ -2377,8 +2300,8 @@
         </p:nvSpPr>
         <p:spPr>
           <a:xfrm>
-            <a:off x="3456432" y="4087368"/>
-            <a:ext cx="3858768" cy="1024128"/>
+            <a:off x="3456432" y="4471416"/>
+            <a:ext cx="3858768" cy="841248"/>
           </a:xfrm>
           <a:prstGeom prst="rect">
             <a:avLst/>
@@ -2398,7 +2321,7 @@
               <a:buChar char="•"/>
             </a:pPr>
             <a:r>
-              <a:rPr lang="en-US" sz="1100" dirty="0">
+              <a:rPr lang="en-US" sz="1050" dirty="0">
                 <a:solidFill>
                   <a:srgbClr val="1B2733"/>
                 </a:solidFill>
@@ -2406,9 +2329,9 @@
                 <a:ea typeface="Calibri" pitchFamily="34" charset="-122"/>
                 <a:cs typeface="Calibri" pitchFamily="34" charset="-120"/>
               </a:rPr>
-              <a:t>Revisión de Política y Procedimientos de Avalúos</a:t>
-            </a:r>
-            <a:endParaRPr lang="en-US" sz="1100" dirty="0"/>
+              <a:t>Revisión de Política de Avalúos</a:t>
+            </a:r>
+            <a:endParaRPr lang="en-US" sz="1050" dirty="0"/>
           </a:p>
           <a:p>
             <a:pPr marL="152400" indent="-152400">
@@ -2419,7 +2342,7 @@
               <a:buChar char="•"/>
             </a:pPr>
             <a:r>
-              <a:rPr lang="en-US" sz="1100" dirty="0">
+              <a:rPr lang="en-US" sz="1050" dirty="0">
                 <a:solidFill>
                   <a:srgbClr val="1B2733"/>
                 </a:solidFill>
@@ -2427,9 +2350,9 @@
                 <a:ea typeface="Calibri" pitchFamily="34" charset="-122"/>
                 <a:cs typeface="Calibri" pitchFamily="34" charset="-120"/>
               </a:rPr>
-              <a:t>Revisión de Perfil de Revisor</a:t>
-            </a:r>
-            <a:endParaRPr lang="en-US" sz="1100" dirty="0"/>
+              <a:t>Revisión de Procedimientos de Administración de Avalúos</a:t>
+            </a:r>
+            <a:endParaRPr lang="en-US" sz="1050" dirty="0"/>
           </a:p>
           <a:p>
             <a:pPr marL="152400" indent="-152400">
@@ -2440,7 +2363,7 @@
               <a:buChar char="•"/>
             </a:pPr>
             <a:r>
-              <a:rPr lang="en-US" sz="1100" dirty="0">
+              <a:rPr lang="en-US" sz="1050" dirty="0">
                 <a:solidFill>
                   <a:srgbClr val="1B2733"/>
                 </a:solidFill>
@@ -2448,9 +2371,9 @@
                 <a:ea typeface="Calibri" pitchFamily="34" charset="-122"/>
                 <a:cs typeface="Calibri" pitchFamily="34" charset="-120"/>
               </a:rPr>
-              <a:t>Envíos regulatorios (DAR)</a:t>
-            </a:r>
-            <a:endParaRPr lang="en-US" sz="1100" dirty="0"/>
+              <a:t>Revisión de Perfil de Revisor</a:t>
+            </a:r>
+            <a:endParaRPr lang="en-US" sz="1050" dirty="0"/>
           </a:p>
         </p:txBody>
       </p:sp>
@@ -2462,12 +2385,12 @@
         </p:nvSpPr>
         <p:spPr>
           <a:xfrm>
-            <a:off x="7580376" y="4014216"/>
-            <a:ext cx="4151376" cy="1170432"/>
+            <a:off x="7580376" y="4398264"/>
+            <a:ext cx="4151376" cy="987552"/>
           </a:xfrm>
           <a:prstGeom prst="roundRect">
             <a:avLst>
-              <a:gd name="adj" fmla="val 7813"/>
+              <a:gd name="adj" fmla="val 9259"/>
             </a:avLst>
           </a:prstGeom>
           <a:solidFill>
@@ -2489,8 +2412,8 @@
         </p:nvSpPr>
         <p:spPr>
           <a:xfrm>
-            <a:off x="7744968" y="4087368"/>
-            <a:ext cx="3858768" cy="1024128"/>
+            <a:off x="7744968" y="4471416"/>
+            <a:ext cx="3858768" cy="841248"/>
           </a:xfrm>
           <a:prstGeom prst="rect">
             <a:avLst/>
@@ -2510,7 +2433,7 @@
               <a:buChar char="•"/>
             </a:pPr>
             <a:r>
-              <a:rPr lang="en-US" sz="1100" dirty="0">
+              <a:rPr lang="en-US" sz="1050" dirty="0">
                 <a:solidFill>
                   <a:srgbClr val="1B2733"/>
                 </a:solidFill>
@@ -2518,9 +2441,9 @@
                 <a:ea typeface="Calibri" pitchFamily="34" charset="-122"/>
                 <a:cs typeface="Calibri" pitchFamily="34" charset="-120"/>
               </a:rPr>
-              <a:t>Avalúos: perito, gestión electrónica y aviso a asociados</a:t>
-            </a:r>
-            <a:endParaRPr lang="en-US" sz="1100" dirty="0"/>
+              <a:t>Asignación a perito valuador</a:t>
+            </a:r>
+            <a:endParaRPr lang="en-US" sz="1050" dirty="0"/>
           </a:p>
           <a:p>
             <a:pPr marL="152400" indent="-152400">
@@ -2531,7 +2454,7 @@
               <a:buChar char="•"/>
             </a:pPr>
             <a:r>
-              <a:rPr lang="en-US" sz="1100" dirty="0">
+              <a:rPr lang="en-US" sz="1050" dirty="0">
                 <a:solidFill>
                   <a:srgbClr val="1B2733"/>
                 </a:solidFill>
@@ -2539,9 +2462,9 @@
                 <a:ea typeface="Calibri" pitchFamily="34" charset="-122"/>
                 <a:cs typeface="Calibri" pitchFamily="34" charset="-120"/>
               </a:rPr>
-              <a:t>Descargo de avalúo anterior y mutuo hipotecario</a:t>
-            </a:r>
-            <a:endParaRPr lang="en-US" sz="1100" dirty="0"/>
+              <a:t>Descargo de avalúo anterior y documento mutuo hipotecario</a:t>
+            </a:r>
+            <a:endParaRPr lang="en-US" sz="1050" dirty="0"/>
           </a:p>
           <a:p>
             <a:pPr marL="152400" indent="-152400">
@@ -2552,7 +2475,7 @@
               <a:buChar char="•"/>
             </a:pPr>
             <a:r>
-              <a:rPr lang="en-US" sz="1100" dirty="0">
+              <a:rPr lang="en-US" sz="1050" dirty="0">
                 <a:solidFill>
                   <a:srgbClr val="1B2733"/>
                 </a:solidFill>
@@ -2560,51 +2483,9 @@
                 <a:ea typeface="Calibri" pitchFamily="34" charset="-122"/>
                 <a:cs typeface="Calibri" pitchFamily="34" charset="-120"/>
               </a:rPr>
-              <a:t>Comparativos de políticas y acta de sesión 29/08/2026</a:t>
-            </a:r>
-            <a:endParaRPr lang="en-US" sz="1100" dirty="0"/>
-          </a:p>
-          <a:p>
-            <a:pPr marL="152400" indent="-152400">
-              <a:spcAft>
-                <a:spcPts val="200"/>
-              </a:spcAft>
-              <a:buSzPct val="100000"/>
-              <a:buChar char="•"/>
-            </a:pPr>
-            <a:r>
-              <a:rPr lang="en-US" sz="1100" dirty="0">
-                <a:solidFill>
-                  <a:srgbClr val="1B2733"/>
-                </a:solidFill>
-                <a:latin typeface="Calibri" pitchFamily="34" charset="0"/>
-                <a:ea typeface="Calibri" pitchFamily="34" charset="-122"/>
-                <a:cs typeface="Calibri" pitchFamily="34" charset="-120"/>
-              </a:rPr>
-              <a:t>Acuerdos Semestrales del Comité de Riesgos</a:t>
-            </a:r>
-            <a:endParaRPr lang="en-US" sz="1100" dirty="0"/>
-          </a:p>
-          <a:p>
-            <a:pPr marL="152400" indent="-152400">
-              <a:spcAft>
-                <a:spcPts val="200"/>
-              </a:spcAft>
-              <a:buSzPct val="100000"/>
-              <a:buChar char="•"/>
-            </a:pPr>
-            <a:r>
-              <a:rPr lang="en-US" sz="1100" dirty="0">
-                <a:solidFill>
-                  <a:srgbClr val="1B2733"/>
-                </a:solidFill>
-                <a:latin typeface="Calibri" pitchFamily="34" charset="0"/>
-                <a:ea typeface="Calibri" pitchFamily="34" charset="-122"/>
-                <a:cs typeface="Calibri" pitchFamily="34" charset="-120"/>
-              </a:rPr>
-              <a:t>Proyectos: formularios, BIA, Procesos y página web</a:t>
-            </a:r>
-            <a:endParaRPr lang="en-US" sz="1100" dirty="0"/>
+              <a:t>Elaboración de acta de sesión de fecha 29/08/2026</a:t>
+            </a:r>
+            <a:endParaRPr lang="en-US" sz="1050" dirty="0"/>
           </a:p>
         </p:txBody>
       </p:sp>
@@ -2616,12 +2497,12 @@
         </p:nvSpPr>
         <p:spPr>
           <a:xfrm>
-            <a:off x="457200" y="5266944"/>
-            <a:ext cx="2697480" cy="1170432"/>
+            <a:off x="457200" y="5468112"/>
+            <a:ext cx="2697480" cy="987552"/>
           </a:xfrm>
           <a:prstGeom prst="roundRect">
             <a:avLst>
-              <a:gd name="adj" fmla="val 7813"/>
+              <a:gd name="adj" fmla="val 9259"/>
             </a:avLst>
           </a:prstGeom>
           <a:solidFill>
@@ -2643,7 +2524,7 @@
         </p:nvSpPr>
         <p:spPr>
           <a:xfrm>
-            <a:off x="621792" y="5669280"/>
+            <a:off x="621792" y="5779008"/>
             <a:ext cx="384048" cy="384048"/>
           </a:xfrm>
           <a:prstGeom prst="ellipse">
@@ -2676,7 +2557,7 @@
         </p:blipFill>
         <p:spPr>
           <a:xfrm>
-            <a:off x="722376" y="5769864"/>
+            <a:off x="722376" y="5879592"/>
             <a:ext cx="182880" cy="182880"/>
           </a:xfrm>
           <a:prstGeom prst="rect">
@@ -2692,7 +2573,7 @@
         </p:nvSpPr>
         <p:spPr>
           <a:xfrm>
-            <a:off x="1143000" y="5577840"/>
+            <a:off x="1143000" y="5687568"/>
             <a:ext cx="1920240" cy="566928"/>
           </a:xfrm>
           <a:prstGeom prst="rect">
@@ -2721,23 +2602,6 @@
             </a:r>
             <a:endParaRPr lang="en-US" sz="1350" dirty="0"/>
           </a:p>
-          <a:p>
-            <a:pPr indent="0" marL="0">
-              <a:buNone/>
-            </a:pPr>
-            <a:r>
-              <a:rPr lang="en-US" sz="1050" dirty="0">
-                <a:solidFill>
-                  <a:srgbClr val="C9D6E6"/>
-                </a:solidFill>
-                <a:latin typeface="Calibri" pitchFamily="34" charset="0"/>
-                <a:ea typeface="Calibri" pitchFamily="34" charset="-122"/>
-                <a:cs typeface="Calibri" pitchFamily="34" charset="-120"/>
-              </a:rPr>
-              <a:t>Crédito, liquidez y TC</a:t>
-            </a:r>
-            <a:endParaRPr lang="en-US" sz="1350" dirty="0"/>
-          </a:p>
         </p:txBody>
       </p:sp>
       <p:sp>
@@ -2748,12 +2612,12 @@
         </p:nvSpPr>
         <p:spPr>
           <a:xfrm>
-            <a:off x="3291840" y="5266944"/>
-            <a:ext cx="4151376" cy="1170432"/>
+            <a:off x="3291840" y="5468112"/>
+            <a:ext cx="4151376" cy="987552"/>
           </a:xfrm>
           <a:prstGeom prst="roundRect">
             <a:avLst>
-              <a:gd name="adj" fmla="val 7813"/>
+              <a:gd name="adj" fmla="val 9259"/>
             </a:avLst>
           </a:prstGeom>
           <a:solidFill>
@@ -2775,8 +2639,8 @@
         </p:nvSpPr>
         <p:spPr>
           <a:xfrm>
-            <a:off x="3456432" y="5340096"/>
-            <a:ext cx="3858768" cy="1024128"/>
+            <a:off x="3456432" y="5541264"/>
+            <a:ext cx="3858768" cy="841248"/>
           </a:xfrm>
           <a:prstGeom prst="rect">
             <a:avLst/>
@@ -2796,7 +2660,7 @@
               <a:buChar char="•"/>
             </a:pPr>
             <a:r>
-              <a:rPr lang="en-US" sz="1100" dirty="0">
+              <a:rPr lang="en-US" sz="1050" dirty="0">
                 <a:solidFill>
                   <a:srgbClr val="1B2733"/>
                 </a:solidFill>
@@ -2806,7 +2670,7 @@
               </a:rPr>
               <a:t>Informe de Análisis de Cartera de TC</a:t>
             </a:r>
-            <a:endParaRPr lang="en-US" sz="1100" dirty="0"/>
+            <a:endParaRPr lang="en-US" sz="1050" dirty="0"/>
           </a:p>
           <a:p>
             <a:pPr marL="152400" indent="-152400">
@@ -2817,7 +2681,7 @@
               <a:buChar char="•"/>
             </a:pPr>
             <a:r>
-              <a:rPr lang="en-US" sz="1100" dirty="0">
+              <a:rPr lang="en-US" sz="1050" dirty="0">
                 <a:solidFill>
                   <a:srgbClr val="1B2733"/>
                 </a:solidFill>
@@ -2827,7 +2691,7 @@
               </a:rPr>
               <a:t>Simulación de cartera vencida</a:t>
             </a:r>
-            <a:endParaRPr lang="en-US" sz="1100" dirty="0"/>
+            <a:endParaRPr lang="en-US" sz="1050" dirty="0"/>
           </a:p>
           <a:p>
             <a:pPr marL="152400" indent="-152400">
@@ -2838,7 +2702,7 @@
               <a:buChar char="•"/>
             </a:pPr>
             <a:r>
-              <a:rPr lang="en-US" sz="1100" dirty="0">
+              <a:rPr lang="en-US" sz="1050" dirty="0">
                 <a:solidFill>
                   <a:srgbClr val="1B2733"/>
                 </a:solidFill>
@@ -2848,7 +2712,7 @@
               </a:rPr>
               <a:t>Actualización de Política de TC</a:t>
             </a:r>
-            <a:endParaRPr lang="en-US" sz="1100" dirty="0"/>
+            <a:endParaRPr lang="en-US" sz="1050" dirty="0"/>
           </a:p>
         </p:txBody>
       </p:sp>
@@ -2860,12 +2724,12 @@
         </p:nvSpPr>
         <p:spPr>
           <a:xfrm>
-            <a:off x="7580376" y="5266944"/>
-            <a:ext cx="4151376" cy="1170432"/>
+            <a:off x="7580376" y="5468112"/>
+            <a:ext cx="4151376" cy="987552"/>
           </a:xfrm>
           <a:prstGeom prst="roundRect">
             <a:avLst>
-              <a:gd name="adj" fmla="val 7813"/>
+              <a:gd name="adj" fmla="val 9259"/>
             </a:avLst>
           </a:prstGeom>
           <a:solidFill>
@@ -2887,8 +2751,8 @@
         </p:nvSpPr>
         <p:spPr>
           <a:xfrm>
-            <a:off x="7744968" y="5340096"/>
-            <a:ext cx="3858768" cy="1024128"/>
+            <a:off x="7744968" y="5541264"/>
+            <a:ext cx="3858768" cy="841248"/>
           </a:xfrm>
           <a:prstGeom prst="rect">
             <a:avLst/>
@@ -2908,7 +2772,7 @@
               <a:buChar char="•"/>
             </a:pPr>
             <a:r>
-              <a:rPr lang="en-US" sz="1100" dirty="0">
+              <a:rPr lang="en-US" sz="1050" dirty="0">
                 <a:solidFill>
                   <a:srgbClr val="1B2733"/>
                 </a:solidFill>
@@ -2916,9 +2780,9 @@
                 <a:ea typeface="Calibri" pitchFamily="34" charset="-122"/>
                 <a:cs typeface="Calibri" pitchFamily="34" charset="-120"/>
               </a:rPr>
-              <a:t>Informes al Comité: crédito, liquidez y mercado</a:t>
-            </a:r>
-            <a:endParaRPr lang="en-US" sz="1100" dirty="0"/>
+              <a:t>Envío de información a la Central de Riesgo (NRP-41)</a:t>
+            </a:r>
+            <a:endParaRPr lang="en-US" sz="1050" dirty="0"/>
           </a:p>
           <a:p>
             <a:pPr marL="152400" indent="-152400">
@@ -2929,7 +2793,7 @@
               <a:buChar char="•"/>
             </a:pPr>
             <a:r>
-              <a:rPr lang="en-US" sz="1100" dirty="0">
+              <a:rPr lang="en-US" sz="1050" dirty="0">
                 <a:solidFill>
                   <a:srgbClr val="1B2733"/>
                 </a:solidFill>
@@ -2937,9 +2801,9 @@
                 <a:ea typeface="Calibri" pitchFamily="34" charset="-122"/>
                 <a:cs typeface="Calibri" pitchFamily="34" charset="-120"/>
               </a:rPr>
-              <a:t>Envíos SSF: NRP-05, NCB-022, NRP-41 y CTRI-RECR</a:t>
-            </a:r>
-            <a:endParaRPr lang="en-US" sz="1100" dirty="0"/>
+              <a:t>Monitoreo semanal de la reserva de saneamiento</a:t>
+            </a:r>
+            <a:endParaRPr lang="en-US" sz="1050" dirty="0"/>
           </a:p>
           <a:p>
             <a:pPr marL="152400" indent="-152400">
@@ -2950,7 +2814,7 @@
               <a:buChar char="•"/>
             </a:pPr>
             <a:r>
-              <a:rPr lang="en-US" sz="1100" dirty="0">
+              <a:rPr lang="en-US" sz="1050" dirty="0">
                 <a:solidFill>
                   <a:srgbClr val="1B2733"/>
                 </a:solidFill>
@@ -2958,90 +2822,9 @@
                 <a:ea typeface="Calibri" pitchFamily="34" charset="-122"/>
                 <a:cs typeface="Calibri" pitchFamily="34" charset="-120"/>
               </a:rPr>
-              <a:t>Cartera TC y reserva de saneamiento</a:t>
-            </a:r>
-            <a:endParaRPr lang="en-US" sz="1100" dirty="0"/>
-          </a:p>
-          <a:p>
-            <a:pPr marL="152400" indent="-152400">
-              <a:spcAft>
-                <a:spcPts val="200"/>
-              </a:spcAft>
-              <a:buSzPct val="100000"/>
-              <a:buChar char="•"/>
-            </a:pPr>
-            <a:r>
-              <a:rPr lang="en-US" sz="1100" dirty="0">
-                <a:solidFill>
-                  <a:srgbClr val="1B2733"/>
-                </a:solidFill>
-                <a:latin typeface="Calibri" pitchFamily="34" charset="0"/>
-                <a:ea typeface="Calibri" pitchFamily="34" charset="-122"/>
-                <a:cs typeface="Calibri" pitchFamily="34" charset="-120"/>
-              </a:rPr>
-              <a:t>Traslados de deuda y segmentación de productos</a:t>
-            </a:r>
-            <a:endParaRPr lang="en-US" sz="1100" dirty="0"/>
-          </a:p>
-          <a:p>
-            <a:pPr marL="152400" indent="-152400">
-              <a:spcAft>
-                <a:spcPts val="200"/>
-              </a:spcAft>
-              <a:buSzPct val="100000"/>
-              <a:buChar char="•"/>
-            </a:pPr>
-            <a:r>
-              <a:rPr lang="en-US" sz="1100" dirty="0">
-                <a:solidFill>
-                  <a:srgbClr val="1B2733"/>
-                </a:solidFill>
-                <a:latin typeface="Calibri" pitchFamily="34" charset="0"/>
-                <a:ea typeface="Calibri" pitchFamily="34" charset="-122"/>
-                <a:cs typeface="Calibri" pitchFamily="34" charset="-120"/>
-              </a:rPr>
-              <a:t>Sistema de créditos NRP-41 y TC de alto riesgo</a:t>
-            </a:r>
-            <a:endParaRPr lang="en-US" sz="1100" dirty="0"/>
-          </a:p>
-        </p:txBody>
-      </p:sp>
-      <p:sp>
-        <p:nvSpPr>
-          <p:cNvPr id="44" name="Text 38"/>
-          <p:cNvSpPr txBox="1"/>
-          <p:nvPr/>
-        </p:nvSpPr>
-        <p:spPr>
-          <a:xfrm>
-            <a:off x="457200" y="6519672"/>
-            <a:ext cx="11274552" cy="219456"/>
-          </a:xfrm>
-          <a:prstGeom prst="rect">
-            <a:avLst/>
-          </a:prstGeom>
-          <a:noFill/>
-          <a:ln/>
-        </p:spPr>
-        <p:txBody>
-          <a:bodyPr wrap="square" lIns="0" tIns="0" rIns="0" bIns="0" rtlCol="0" anchor="ctr"/>
-          <a:lstStyle/>
-          <a:p>
-            <a:pPr indent="0" marL="0">
-              <a:buNone/>
-            </a:pPr>
-            <a:r>
-              <a:rPr lang="en-US" sz="900" dirty="0">
-                <a:solidFill>
-                  <a:srgbClr val="4A5A6A"/>
-                </a:solidFill>
-                <a:latin typeface="Calibri" pitchFamily="34" charset="0"/>
-                <a:ea typeface="Calibri" pitchFamily="34" charset="-122"/>
-                <a:cs typeface="Calibri" pitchFamily="34" charset="-120"/>
-              </a:rPr>
-              <a:t>«En seguimiento»: asuntos del informe anterior que siguen vigentes. «Actividades de la semana»: documento de actividades semanales.</a:t>
-            </a:r>
-            <a:endParaRPr lang="en-US" sz="900" dirty="0"/>
+              <a:t>Registro permanente de los traslados de deuda</a:t>
+            </a:r>
+            <a:endParaRPr lang="en-US" sz="1050" dirty="0"/>
           </a:p>
         </p:txBody>
       </p:sp>
@@ -4588,8 +4371,8 @@
         </p:nvSpPr>
         <p:spPr>
           <a:xfrm>
-            <a:off x="5995851" y="3410712"/>
-            <a:ext cx="1645920" cy="201168"/>
+            <a:off x="457200" y="3657600"/>
+            <a:ext cx="5486400" cy="329184"/>
           </a:xfrm>
           <a:prstGeom prst="rect">
             <a:avLst/>
@@ -4601,66 +4384,27 @@
           <a:bodyPr wrap="square" lIns="0" tIns="0" rIns="0" bIns="0" rtlCol="0" anchor="ctr"/>
           <a:lstStyle/>
           <a:p>
-            <a:pPr algn="ctr" indent="0" marL="0">
-              <a:buNone/>
-            </a:pPr>
-            <a:r>
-              <a:rPr lang="en-US" sz="950" b="1" dirty="0">
-                <a:solidFill>
-                  <a:srgbClr val="B86E00"/>
-                </a:solidFill>
-                <a:latin typeface="Calibri" pitchFamily="34" charset="0"/>
-                <a:ea typeface="Calibri" pitchFamily="34" charset="-122"/>
-                <a:cs typeface="Calibri" pitchFamily="34" charset="-120"/>
-              </a:rPr>
-              <a:t>Día 24 de 42 del calendario</a:t>
-            </a:r>
-            <a:endParaRPr lang="en-US" sz="950" dirty="0"/>
+            <a:pPr indent="0" marL="0">
+              <a:buNone/>
+            </a:pPr>
+            <a:r>
+              <a:rPr lang="en-US" sz="1600" b="1" dirty="0">
+                <a:solidFill>
+                  <a:srgbClr val="0B2545"/>
+                </a:solidFill>
+                <a:latin typeface="Calibri" pitchFamily="34" charset="0"/>
+                <a:ea typeface="Calibri" pitchFamily="34" charset="-122"/>
+                <a:cs typeface="Calibri" pitchFamily="34" charset="-120"/>
+              </a:rPr>
+              <a:t>Próximos vencimientos</a:t>
+            </a:r>
+            <a:endParaRPr lang="en-US" sz="1600" dirty="0"/>
           </a:p>
         </p:txBody>
       </p:sp>
       <p:sp>
         <p:nvSpPr>
-          <p:cNvPr id="45" name="Text 38"/>
-          <p:cNvSpPr txBox="1"/>
-          <p:nvPr/>
-        </p:nvSpPr>
-        <p:spPr>
-          <a:xfrm>
-            <a:off x="457200" y="3657600"/>
-            <a:ext cx="5486400" cy="329184"/>
-          </a:xfrm>
-          <a:prstGeom prst="rect">
-            <a:avLst/>
-          </a:prstGeom>
-          <a:noFill/>
-          <a:ln/>
-        </p:spPr>
-        <p:txBody>
-          <a:bodyPr wrap="square" lIns="0" tIns="0" rIns="0" bIns="0" rtlCol="0" anchor="ctr"/>
-          <a:lstStyle/>
-          <a:p>
-            <a:pPr indent="0" marL="0">
-              <a:buNone/>
-            </a:pPr>
-            <a:r>
-              <a:rPr lang="en-US" sz="1600" b="1" dirty="0">
-                <a:solidFill>
-                  <a:srgbClr val="0B2545"/>
-                </a:solidFill>
-                <a:latin typeface="Calibri" pitchFamily="34" charset="0"/>
-                <a:ea typeface="Calibri" pitchFamily="34" charset="-122"/>
-                <a:cs typeface="Calibri" pitchFamily="34" charset="-120"/>
-              </a:rPr>
-              <a:t>Próximos vencimientos</a:t>
-            </a:r>
-            <a:endParaRPr lang="en-US" sz="1600" dirty="0"/>
-          </a:p>
-        </p:txBody>
-      </p:sp>
-      <p:sp>
-        <p:nvSpPr>
-          <p:cNvPr id="46" name="Shape 39"/>
+          <p:cNvPr id="45" name="Shape 38"/>
           <p:cNvSpPr/>
           <p:nvPr/>
         </p:nvSpPr>
@@ -4687,7 +4431,7 @@
       </p:sp>
       <p:sp>
         <p:nvSpPr>
-          <p:cNvPr id="47" name="Text 40"/>
+          <p:cNvPr id="46" name="Text 39"/>
           <p:cNvSpPr txBox="1"/>
           <p:nvPr/>
         </p:nvSpPr>
@@ -4726,7 +4470,7 @@
       </p:sp>
       <p:sp>
         <p:nvSpPr>
-          <p:cNvPr id="48" name="Text 41"/>
+          <p:cNvPr id="47" name="Text 40"/>
           <p:cNvSpPr txBox="1"/>
           <p:nvPr/>
         </p:nvSpPr>
@@ -4784,31 +4528,11 @@
             </a:r>
             <a:endParaRPr lang="en-US" sz="1150" dirty="0"/>
           </a:p>
-          <a:p>
-            <a:pPr indent="0" marL="0">
-              <a:spcAft>
-                <a:spcPts val="300"/>
-              </a:spcAft>
-              <a:buNone/>
-            </a:pPr>
-            <a:r>
-              <a:rPr lang="en-US" sz="1000" i="1" dirty="0">
-                <a:solidFill>
-                  <a:srgbClr val="DCE6F0"/>
-                </a:solidFill>
-                <a:latin typeface="Calibri" pitchFamily="34" charset="0"/>
-                <a:ea typeface="Calibri" pitchFamily="34" charset="-122"/>
-                <a:cs typeface="Calibri" pitchFamily="34" charset="-120"/>
-              </a:rPr>
-              <a:t>Semana: seguimiento al envío de pruebas de descargo</a:t>
-            </a:r>
-            <a:endParaRPr lang="en-US" sz="1150" dirty="0"/>
-          </a:p>
         </p:txBody>
       </p:sp>
       <p:sp>
         <p:nvSpPr>
-          <p:cNvPr id="49" name="Shape 42"/>
+          <p:cNvPr id="48" name="Shape 41"/>
           <p:cNvSpPr/>
           <p:nvPr/>
         </p:nvSpPr>
@@ -4835,7 +4559,7 @@
       </p:sp>
       <p:sp>
         <p:nvSpPr>
-          <p:cNvPr id="50" name="Text 43"/>
+          <p:cNvPr id="49" name="Text 42"/>
           <p:cNvSpPr txBox="1"/>
           <p:nvPr/>
         </p:nvSpPr>
@@ -4888,7 +4612,7 @@
       </p:sp>
       <p:sp>
         <p:nvSpPr>
-          <p:cNvPr id="51" name="Text 44"/>
+          <p:cNvPr id="50" name="Text 43"/>
           <p:cNvSpPr txBox="1"/>
           <p:nvPr/>
         </p:nvSpPr>
@@ -4966,31 +4690,11 @@
             </a:r>
             <a:endParaRPr lang="en-US" sz="1300" dirty="0"/>
           </a:p>
-          <a:p>
-            <a:pPr indent="0" marL="0">
-              <a:spcAft>
-                <a:spcPts val="300"/>
-              </a:spcAft>
-              <a:buNone/>
-            </a:pPr>
-            <a:r>
-              <a:rPr lang="en-US" sz="1000" i="1" dirty="0">
-                <a:solidFill>
-                  <a:srgbClr val="3E4F60"/>
-                </a:solidFill>
-                <a:latin typeface="Calibri" pitchFamily="34" charset="0"/>
-                <a:ea typeface="Calibri" pitchFamily="34" charset="-122"/>
-                <a:cs typeface="Calibri" pitchFamily="34" charset="-120"/>
-              </a:rPr>
-              <a:t>Semana: matriz y requerimiento enviado a las áreas</a:t>
-            </a:r>
-            <a:endParaRPr lang="en-US" sz="1300" dirty="0"/>
-          </a:p>
         </p:txBody>
       </p:sp>
       <p:sp>
         <p:nvSpPr>
-          <p:cNvPr id="52" name="Shape 45"/>
+          <p:cNvPr id="51" name="Shape 44"/>
           <p:cNvSpPr/>
           <p:nvPr/>
         </p:nvSpPr>
@@ -5017,7 +4721,7 @@
       </p:sp>
       <p:sp>
         <p:nvSpPr>
-          <p:cNvPr id="53" name="Text 46"/>
+          <p:cNvPr id="52" name="Text 45"/>
           <p:cNvSpPr txBox="1"/>
           <p:nvPr/>
         </p:nvSpPr>
@@ -5070,7 +4774,7 @@
       </p:sp>
       <p:sp>
         <p:nvSpPr>
-          <p:cNvPr id="54" name="Text 47"/>
+          <p:cNvPr id="53" name="Text 46"/>
           <p:cNvSpPr txBox="1"/>
           <p:nvPr/>
         </p:nvSpPr>
@@ -5148,31 +4852,11 @@
             </a:r>
             <a:endParaRPr lang="en-US" sz="1300" dirty="0"/>
           </a:p>
-          <a:p>
-            <a:pPr indent="0" marL="0">
-              <a:spcAft>
-                <a:spcPts val="300"/>
-              </a:spcAft>
-              <a:buNone/>
-            </a:pPr>
-            <a:r>
-              <a:rPr lang="en-US" sz="1000" i="1" dirty="0">
-                <a:solidFill>
-                  <a:srgbClr val="3E4F60"/>
-                </a:solidFill>
-                <a:latin typeface="Calibri" pitchFamily="34" charset="0"/>
-                <a:ea typeface="Calibri" pitchFamily="34" charset="-122"/>
-                <a:cs typeface="Calibri" pitchFamily="34" charset="-120"/>
-              </a:rPr>
-              <a:t>Semana: plan de solución de visitas anteriores</a:t>
-            </a:r>
-            <a:endParaRPr lang="en-US" sz="1300" dirty="0"/>
-          </a:p>
         </p:txBody>
       </p:sp>
       <p:sp>
         <p:nvSpPr>
-          <p:cNvPr id="55" name="Shape 48"/>
+          <p:cNvPr id="54" name="Shape 47"/>
           <p:cNvSpPr/>
           <p:nvPr/>
         </p:nvSpPr>
@@ -5199,7 +4883,7 @@
       </p:sp>
       <p:sp>
         <p:nvSpPr>
-          <p:cNvPr id="56" name="Text 49"/>
+          <p:cNvPr id="55" name="Text 48"/>
           <p:cNvSpPr txBox="1"/>
           <p:nvPr/>
         </p:nvSpPr>
@@ -5252,7 +4936,7 @@
       </p:sp>
       <p:sp>
         <p:nvSpPr>
-          <p:cNvPr id="57" name="Text 50"/>
+          <p:cNvPr id="56" name="Text 49"/>
           <p:cNvSpPr txBox="1"/>
           <p:nvPr/>
         </p:nvSpPr>
@@ -5334,7 +5018,7 @@
       </p:sp>
       <p:sp>
         <p:nvSpPr>
-          <p:cNvPr id="58" name="Text 51"/>
+          <p:cNvPr id="57" name="Text 50"/>
           <p:cNvSpPr txBox="1"/>
           <p:nvPr/>
         </p:nvSpPr>
@@ -5365,7 +5049,7 @@
                 <a:ea typeface="Calibri" pitchFamily="34" charset="-122"/>
                 <a:cs typeface="Calibri" pitchFamily="34" charset="-120"/>
               </a:rPr>
-              <a:t>Riesgos Específicos (Circ. 22742): visita iniciada el 09/10/2026, sin plazo de respuesta documentado. El estado de envío de cada requerimiento está por confirmar.</a:t>
+              <a:t>Riesgos Específicos (Circ. 22742): inicio de visita 09/10/2026.</a:t>
             </a:r>
             <a:endParaRPr lang="en-US" sz="900" dirty="0"/>
           </a:p>

</xml_diff>

<commit_message>
Slide 2: write Gobierno Corporativo and Circular in full
Co-Authored-By: Claude Opus 5.5 <noreply@anthropic.com>
Claude-Session: https://claude.ai/code/session_01QGTe9h3kfUS6BTZosfrxzF
</commit_message>
<xml_diff>
--- a/resumen-ejecutivo-semanal/Resumen_Ejecutivo_Riesgos_COMEDICA_2_Slides.pptx
+++ b/resumen-ejecutivo-semanal/Resumen_Ejecutivo_Riesgos_COMEDICA_2_Slides.pptx
@@ -591,7 +591,7 @@
           <a:p>
             <a:r>
               <a:rPr lang="en-US" dirty="0"/>
-              <a:t>Corte 16/10. Plazo de respuesta PLD/FT: 16/10 (Circ. 23486). Siguen Gobierno Corporativo el 23/10 y 30/10 (Circ. 22741) y el Plan de Recuperación el 03/11 (Circ. 22737).</a:t>
+              <a:t>Corte 16/10. Plazo de respuesta PLD/FT: 16/10 (Circular 23486). Siguen Gobierno Corporativo el 23/10 y 30/10 (Circular 22741) y el Plan de Recuperación el 03/11 (Circular 22737).</a:t>
             </a:r>
             <a:endParaRPr lang="en-US" dirty="0"/>
           </a:p>
@@ -3349,7 +3349,7 @@
                 <a:ea typeface="Calibri" pitchFamily="34" charset="-122"/>
                 <a:cs typeface="Calibri" pitchFamily="34" charset="-120"/>
               </a:rPr>
-              <a:t>Circ. 22737</a:t>
+              <a:t>Circular 22737</a:t>
             </a:r>
             <a:endParaRPr lang="en-US" sz="1300" dirty="0"/>
           </a:p>
@@ -3494,7 +3494,7 @@
                 <a:ea typeface="Calibri" pitchFamily="34" charset="-122"/>
                 <a:cs typeface="Calibri" pitchFamily="34" charset="-120"/>
               </a:rPr>
-              <a:t>Circ. 22742</a:t>
+              <a:t>Circular 22742</a:t>
             </a:r>
             <a:endParaRPr lang="en-US" sz="1300" dirty="0"/>
           </a:p>
@@ -3639,7 +3639,7 @@
                 <a:ea typeface="Calibri" pitchFamily="34" charset="-122"/>
                 <a:cs typeface="Calibri" pitchFamily="34" charset="-120"/>
               </a:rPr>
-              <a:t>Circ. 23486</a:t>
+              <a:t>Circular 23486</a:t>
             </a:r>
             <a:endParaRPr lang="en-US" sz="1300" dirty="0"/>
           </a:p>
@@ -3767,7 +3767,7 @@
                 <a:ea typeface="Calibri" pitchFamily="34" charset="-122"/>
                 <a:cs typeface="Calibri" pitchFamily="34" charset="-120"/>
               </a:rPr>
-              <a:t>Inicio visita Riesgos Específicos · Resultados Gob. Corporativo</a:t>
+              <a:t>Inicio visita Riesgos Específicos · Resultados Gobierno Corporativo</a:t>
             </a:r>
             <a:endParaRPr lang="en-US" sz="1300" dirty="0"/>
           </a:p>
@@ -3784,7 +3784,7 @@
                 <a:ea typeface="Calibri" pitchFamily="34" charset="-122"/>
                 <a:cs typeface="Calibri" pitchFamily="34" charset="-120"/>
               </a:rPr>
-              <a:t>Circ. 22742 · 22741</a:t>
+              <a:t>Circular 22742 · 22741</a:t>
             </a:r>
             <a:endParaRPr lang="en-US" sz="1300" dirty="0"/>
           </a:p>
@@ -3905,7 +3905,7 @@
                 <a:ea typeface="Calibri" pitchFamily="34" charset="-122"/>
                 <a:cs typeface="Calibri" pitchFamily="34" charset="-120"/>
               </a:rPr>
-              <a:t>Circ. 23486</a:t>
+              <a:t>Circular 23486</a:t>
             </a:r>
             <a:endParaRPr lang="en-US" sz="1300" dirty="0"/>
           </a:p>
@@ -4009,7 +4009,7 @@
                 <a:ea typeface="Calibri" pitchFamily="34" charset="-122"/>
                 <a:cs typeface="Calibri" pitchFamily="34" charset="-120"/>
               </a:rPr>
-              <a:t>Nuevas observaciones Gob. Corporativo</a:t>
+              <a:t>Nuevas observaciones Gobierno Corporativo</a:t>
             </a:r>
             <a:endParaRPr lang="en-US" sz="1300" dirty="0"/>
           </a:p>
@@ -4026,7 +4026,7 @@
                 <a:ea typeface="Calibri" pitchFamily="34" charset="-122"/>
                 <a:cs typeface="Calibri" pitchFamily="34" charset="-120"/>
               </a:rPr>
-              <a:t>Circ. 22741</a:t>
+              <a:t>Circular 22741</a:t>
             </a:r>
             <a:endParaRPr lang="en-US" sz="1300" dirty="0"/>
           </a:p>
@@ -4130,7 +4130,7 @@
                 <a:ea typeface="Calibri" pitchFamily="34" charset="-122"/>
                 <a:cs typeface="Calibri" pitchFamily="34" charset="-120"/>
               </a:rPr>
-              <a:t>Seguimiento de observaciones Gob. Corporativo</a:t>
+              <a:t>Seguimiento de observaciones Gobierno Corporativo</a:t>
             </a:r>
             <a:endParaRPr lang="en-US" sz="1300" dirty="0"/>
           </a:p>
@@ -4147,7 +4147,7 @@
                 <a:ea typeface="Calibri" pitchFamily="34" charset="-122"/>
                 <a:cs typeface="Calibri" pitchFamily="34" charset="-120"/>
               </a:rPr>
-              <a:t>Circ. 22741</a:t>
+              <a:t>Circular 22741</a:t>
             </a:r>
             <a:endParaRPr lang="en-US" sz="1300" dirty="0"/>
           </a:p>
@@ -4268,7 +4268,7 @@
                 <a:ea typeface="Calibri" pitchFamily="34" charset="-122"/>
                 <a:cs typeface="Calibri" pitchFamily="34" charset="-120"/>
               </a:rPr>
-              <a:t>Circ. 22737</a:t>
+              <a:t>Circular 22737</a:t>
             </a:r>
             <a:endParaRPr lang="en-US" sz="1300" dirty="0"/>
           </a:p>
@@ -5049,7 +5049,7 @@
                 <a:ea typeface="Calibri" pitchFamily="34" charset="-122"/>
                 <a:cs typeface="Calibri" pitchFamily="34" charset="-120"/>
               </a:rPr>
-              <a:t>Riesgos Específicos (Circ. 22742): inicio de visita 09/10/2026.</a:t>
+              <a:t>Riesgos Específicos (Circular 22742): inicio de visita 09/10/2026.</a:t>
             </a:r>
             <a:endParaRPr lang="en-US" sz="900" dirty="0"/>
           </a:p>

</xml_diff>

<commit_message>
Slide 2: replace amber/gold with institutional blue for SSF deadlines
Co-Authored-By: Claude Opus 5.5 <noreply@anthropic.com>
Claude-Session: https://claude.ai/code/session_01QGTe9h3kfUS6BTZosfrxzF
</commit_message>
<xml_diff>
--- a/resumen-ejecutivo-semanal/Resumen_Ejecutivo_Riesgos_COMEDICA_2_Slides.pptx
+++ b/resumen-ejecutivo-semanal/Resumen_Ejecutivo_Riesgos_COMEDICA_2_Slides.pptx
@@ -3041,11 +3041,11 @@
             <a:avLst/>
           </a:prstGeom>
           <a:solidFill>
-            <a:srgbClr val="B86E00"/>
+            <a:srgbClr val="1F6FB2"/>
           </a:solidFill>
           <a:ln w="12700">
             <a:solidFill>
-              <a:srgbClr val="B86E00"/>
+              <a:srgbClr val="1F6FB2"/>
             </a:solidFill>
             <a:prstDash val="solid"/>
           </a:ln>
@@ -3807,7 +3807,7 @@
           <a:noFill/>
           <a:ln w="12700">
             <a:solidFill>
-              <a:srgbClr val="B86E00"/>
+              <a:srgbClr val="1F6FB2"/>
             </a:solidFill>
             <a:prstDash val="solid"/>
           </a:ln>
@@ -3828,11 +3828,11 @@
             <a:avLst/>
           </a:prstGeom>
           <a:solidFill>
-            <a:srgbClr val="B86E00"/>
+            <a:srgbClr val="1F6FB2"/>
           </a:solidFill>
           <a:ln w="12700">
             <a:solidFill>
-              <a:srgbClr val="B86E00"/>
+              <a:srgbClr val="1F6FB2"/>
             </a:solidFill>
             <a:prstDash val="solid"/>
           </a:ln>
@@ -3865,7 +3865,7 @@
             <a:r>
               <a:rPr lang="en-US" sz="1300" b="1" dirty="0">
                 <a:solidFill>
-                  <a:srgbClr val="B86E00"/>
+                  <a:srgbClr val="1F6FB2"/>
                 </a:solidFill>
                 <a:latin typeface="Calibri" pitchFamily="34" charset="0"/>
                 <a:ea typeface="Calibri" pitchFamily="34" charset="-122"/>
@@ -3928,7 +3928,7 @@
           <a:noFill/>
           <a:ln w="12700">
             <a:solidFill>
-              <a:srgbClr val="B86E00"/>
+              <a:srgbClr val="1F6FB2"/>
             </a:solidFill>
             <a:prstDash val="solid"/>
           </a:ln>
@@ -3949,11 +3949,11 @@
             <a:avLst/>
           </a:prstGeom>
           <a:solidFill>
-            <a:srgbClr val="B86E00"/>
+            <a:srgbClr val="1F6FB2"/>
           </a:solidFill>
           <a:ln w="12700">
             <a:solidFill>
-              <a:srgbClr val="B86E00"/>
+              <a:srgbClr val="1F6FB2"/>
             </a:solidFill>
             <a:prstDash val="solid"/>
           </a:ln>
@@ -3986,7 +3986,7 @@
             <a:r>
               <a:rPr lang="en-US" sz="1300" b="1" dirty="0">
                 <a:solidFill>
-                  <a:srgbClr val="B86E00"/>
+                  <a:srgbClr val="1F6FB2"/>
                 </a:solidFill>
                 <a:latin typeface="Calibri" pitchFamily="34" charset="0"/>
                 <a:ea typeface="Calibri" pitchFamily="34" charset="-122"/>
@@ -4049,7 +4049,7 @@
           <a:noFill/>
           <a:ln w="12700">
             <a:solidFill>
-              <a:srgbClr val="B86E00"/>
+              <a:srgbClr val="1F6FB2"/>
             </a:solidFill>
             <a:prstDash val="solid"/>
           </a:ln>
@@ -4070,11 +4070,11 @@
             <a:avLst/>
           </a:prstGeom>
           <a:solidFill>
-            <a:srgbClr val="B86E00"/>
+            <a:srgbClr val="1F6FB2"/>
           </a:solidFill>
           <a:ln w="12700">
             <a:solidFill>
-              <a:srgbClr val="B86E00"/>
+              <a:srgbClr val="1F6FB2"/>
             </a:solidFill>
             <a:prstDash val="solid"/>
           </a:ln>
@@ -4107,7 +4107,7 @@
             <a:r>
               <a:rPr lang="en-US" sz="1300" b="1" dirty="0">
                 <a:solidFill>
-                  <a:srgbClr val="B86E00"/>
+                  <a:srgbClr val="1F6FB2"/>
                 </a:solidFill>
                 <a:latin typeface="Calibri" pitchFamily="34" charset="0"/>
                 <a:ea typeface="Calibri" pitchFamily="34" charset="-122"/>
@@ -4170,7 +4170,7 @@
           <a:noFill/>
           <a:ln w="12700">
             <a:solidFill>
-              <a:srgbClr val="B86E00"/>
+              <a:srgbClr val="1F6FB2"/>
             </a:solidFill>
             <a:prstDash val="solid"/>
           </a:ln>
@@ -4191,11 +4191,11 @@
             <a:avLst/>
           </a:prstGeom>
           <a:solidFill>
-            <a:srgbClr val="B86E00"/>
+            <a:srgbClr val="1F6FB2"/>
           </a:solidFill>
           <a:ln w="12700">
             <a:solidFill>
-              <a:srgbClr val="B86E00"/>
+              <a:srgbClr val="1F6FB2"/>
             </a:solidFill>
             <a:prstDash val="solid"/>
           </a:ln>
@@ -4228,7 +4228,7 @@
             <a:r>
               <a:rPr lang="en-US" sz="1300" b="1" dirty="0">
                 <a:solidFill>
-                  <a:srgbClr val="B86E00"/>
+                  <a:srgbClr val="1F6FB2"/>
                 </a:solidFill>
                 <a:latin typeface="Calibri" pitchFamily="34" charset="0"/>
                 <a:ea typeface="Calibri" pitchFamily="34" charset="-122"/>
@@ -4291,7 +4291,7 @@
           <a:noFill/>
           <a:ln w="19050">
             <a:solidFill>
-              <a:srgbClr val="B86E00"/>
+              <a:srgbClr val="1F6FB2"/>
             </a:solidFill>
             <a:prstDash val="dash"/>
           </a:ln>
@@ -4314,11 +4314,11 @@
             </a:avLst>
           </a:prstGeom>
           <a:solidFill>
-            <a:srgbClr val="B86E00"/>
+            <a:srgbClr val="1F6FB2"/>
           </a:solidFill>
           <a:ln w="12700">
             <a:solidFill>
-              <a:srgbClr val="B86E00"/>
+              <a:srgbClr val="1F6FB2"/>
             </a:solidFill>
             <a:prstDash val="solid"/>
           </a:ln>
@@ -4456,7 +4456,7 @@
             <a:r>
               <a:rPr lang="en-US" sz="4000" b="1" dirty="0">
                 <a:solidFill>
-                  <a:srgbClr val="F6C26B"/>
+                  <a:srgbClr val="9CCBF2"/>
                 </a:solidFill>
                 <a:latin typeface="Calibri" pitchFamily="34" charset="0"/>
                 <a:ea typeface="Calibri" pitchFamily="34" charset="-122"/>
@@ -4584,7 +4584,7 @@
             <a:r>
               <a:rPr lang="en-US" sz="4000" b="1" dirty="0">
                 <a:solidFill>
-                  <a:srgbClr val="B86E00"/>
+                  <a:srgbClr val="1F6FB2"/>
                 </a:solidFill>
                 <a:latin typeface="Calibri" pitchFamily="34" charset="0"/>
                 <a:ea typeface="Calibri" pitchFamily="34" charset="-122"/>
@@ -4746,7 +4746,7 @@
             <a:r>
               <a:rPr lang="en-US" sz="4000" b="1" dirty="0">
                 <a:solidFill>
-                  <a:srgbClr val="B86E00"/>
+                  <a:srgbClr val="1F6FB2"/>
                 </a:solidFill>
                 <a:latin typeface="Calibri" pitchFamily="34" charset="0"/>
                 <a:ea typeface="Calibri" pitchFamily="34" charset="-122"/>
@@ -4908,7 +4908,7 @@
             <a:r>
               <a:rPr lang="en-US" sz="4000" b="1" dirty="0">
                 <a:solidFill>
-                  <a:srgbClr val="B86E00"/>
+                  <a:srgbClr val="1F6FB2"/>
                 </a:solidFill>
                 <a:latin typeface="Calibri" pitchFamily="34" charset="0"/>
                 <a:ea typeface="Calibri" pitchFamily="34" charset="-122"/>

</xml_diff>

<commit_message>
Slide 1: GIR exam at 93%, blue progress bar
Co-Authored-By: Claude Opus 5.5 <noreply@anthropic.com>
Claude-Session: https://claude.ai/code/session_01QGTe9h3kfUS6BTZosfrxzF
</commit_message>
<xml_diff>
--- a/resumen-ejecutivo-semanal/Resumen_Ejecutivo_Riesgos_COMEDICA_2_Slides.pptx
+++ b/resumen-ejecutivo-semanal/Resumen_Ejecutivo_Riesgos_COMEDICA_2_Slides.pptx
@@ -503,7 +503,7 @@
           <a:p>
             <a:r>
               <a:rPr lang="en-US" dirty="0"/>
-              <a:t>Matriz por frente. Columna izquierda: asuntos del informe anterior que siguen vigentes (plazos SSF). Columna derecha: actividades de la semana según el documento de actividades. Examen GIR 2026: avance 90%.</a:t>
+              <a:t>Matriz por frente. Columna izquierda: asuntos del informe anterior que siguen vigentes (plazos SSF). Columna derecha: actividades de la semana según el documento de actividades. Examen GIR 2026: avance 93%.</a:t>
             </a:r>
             <a:endParaRPr lang="en-US" dirty="0"/>
           </a:p>
@@ -1848,7 +1848,7 @@
         <p:spPr>
           <a:xfrm>
             <a:off x="621792" y="3995928"/>
-            <a:ext cx="1645920" cy="100584"/>
+            <a:ext cx="1700784" cy="100584"/>
           </a:xfrm>
           <a:prstGeom prst="roundRect">
             <a:avLst>
@@ -1856,11 +1856,11 @@
             </a:avLst>
           </a:prstGeom>
           <a:solidFill>
-            <a:srgbClr val="F2B544"/>
+            <a:srgbClr val="5FB3E8"/>
           </a:solidFill>
           <a:ln w="12700">
             <a:solidFill>
-              <a:srgbClr val="F2B544"/>
+              <a:srgbClr val="5FB3E8"/>
             </a:solidFill>
             <a:prstDash val="solid"/>
           </a:ln>
@@ -1899,7 +1899,7 @@
                 <a:ea typeface="Calibri" pitchFamily="34" charset="-122"/>
                 <a:cs typeface="Calibri" pitchFamily="34" charset="-120"/>
               </a:rPr>
-              <a:t>90%</a:t>
+              <a:t>93%</a:t>
             </a:r>
             <a:endParaRPr lang="en-US" sz="1400" dirty="0"/>
           </a:p>

</xml_diff>

<commit_message>
Slide 1: add policy updates to Riesgo Normativo
Co-Authored-By: Claude Opus 5.5 <noreply@anthropic.com>
Claude-Session: https://claude.ai/code/session_01QGTe9h3kfUS6BTZosfrxzF
</commit_message>
<xml_diff>
--- a/resumen-ejecutivo-semanal/Resumen_Ejecutivo_Riesgos_COMEDICA_2_Slides.pptx
+++ b/resumen-ejecutivo-semanal/Resumen_Ejecutivo_Riesgos_COMEDICA_2_Slides.pptx
@@ -1183,11 +1183,11 @@
         <p:spPr>
           <a:xfrm>
             <a:off x="457200" y="1627632"/>
-            <a:ext cx="2697480" cy="1417320"/>
+            <a:ext cx="2697480" cy="1371600"/>
           </a:xfrm>
           <a:prstGeom prst="roundRect">
             <a:avLst>
-              <a:gd name="adj" fmla="val 6452"/>
+              <a:gd name="adj" fmla="val 6667"/>
             </a:avLst>
           </a:prstGeom>
           <a:solidFill>
@@ -1209,7 +1209,7 @@
         </p:nvSpPr>
         <p:spPr>
           <a:xfrm>
-            <a:off x="621792" y="2153412"/>
+            <a:off x="621792" y="2130552"/>
             <a:ext cx="384048" cy="384048"/>
           </a:xfrm>
           <a:prstGeom prst="ellipse">
@@ -1242,7 +1242,7 @@
         </p:blipFill>
         <p:spPr>
           <a:xfrm>
-            <a:off x="722376" y="2253996"/>
+            <a:off x="722376" y="2231136"/>
             <a:ext cx="182880" cy="182880"/>
           </a:xfrm>
           <a:prstGeom prst="rect">
@@ -1258,7 +1258,7 @@
         </p:nvSpPr>
         <p:spPr>
           <a:xfrm>
-            <a:off x="1143000" y="2061972"/>
+            <a:off x="1143000" y="2039112"/>
             <a:ext cx="1920240" cy="566928"/>
           </a:xfrm>
           <a:prstGeom prst="rect">
@@ -1315,11 +1315,11 @@
         <p:spPr>
           <a:xfrm>
             <a:off x="3291840" y="1627632"/>
-            <a:ext cx="4151376" cy="1417320"/>
+            <a:ext cx="4151376" cy="1371600"/>
           </a:xfrm>
           <a:prstGeom prst="roundRect">
             <a:avLst>
-              <a:gd name="adj" fmla="val 6452"/>
+              <a:gd name="adj" fmla="val 6667"/>
             </a:avLst>
           </a:prstGeom>
           <a:solidFill>
@@ -1342,7 +1342,7 @@
         <p:spPr>
           <a:xfrm>
             <a:off x="3456432" y="1700784"/>
-            <a:ext cx="3858768" cy="1271016"/>
+            <a:ext cx="3858768" cy="1225296"/>
           </a:xfrm>
           <a:prstGeom prst="rect">
             <a:avLst/>
@@ -1534,11 +1534,11 @@
         <p:spPr>
           <a:xfrm>
             <a:off x="7580376" y="1627632"/>
-            <a:ext cx="4151376" cy="1417320"/>
+            <a:ext cx="4151376" cy="1371600"/>
           </a:xfrm>
           <a:prstGeom prst="roundRect">
             <a:avLst>
-              <a:gd name="adj" fmla="val 6452"/>
+              <a:gd name="adj" fmla="val 6667"/>
             </a:avLst>
           </a:prstGeom>
           <a:solidFill>
@@ -1561,7 +1561,7 @@
         <p:spPr>
           <a:xfrm>
             <a:off x="7744968" y="1700784"/>
-            <a:ext cx="3858768" cy="1271016"/>
+            <a:ext cx="3858768" cy="1225296"/>
           </a:xfrm>
           <a:prstGeom prst="rect">
             <a:avLst/>
@@ -1666,12 +1666,12 @@
         </p:nvSpPr>
         <p:spPr>
           <a:xfrm>
-            <a:off x="457200" y="3127248"/>
-            <a:ext cx="2697480" cy="1188720"/>
+            <a:off x="457200" y="3081528"/>
+            <a:ext cx="2697480" cy="1152144"/>
           </a:xfrm>
           <a:prstGeom prst="roundRect">
             <a:avLst>
-              <a:gd name="adj" fmla="val 7692"/>
+              <a:gd name="adj" fmla="val 7937"/>
             </a:avLst>
           </a:prstGeom>
           <a:solidFill>
@@ -1693,7 +1693,7 @@
         </p:nvSpPr>
         <p:spPr>
           <a:xfrm>
-            <a:off x="621792" y="3337560"/>
+            <a:off x="621792" y="3273552"/>
             <a:ext cx="384048" cy="384048"/>
           </a:xfrm>
           <a:prstGeom prst="ellipse">
@@ -1726,7 +1726,7 @@
         </p:blipFill>
         <p:spPr>
           <a:xfrm>
-            <a:off x="722376" y="3438144"/>
+            <a:off x="722376" y="3374136"/>
             <a:ext cx="182880" cy="182880"/>
           </a:xfrm>
           <a:prstGeom prst="rect">
@@ -1742,7 +1742,7 @@
         </p:nvSpPr>
         <p:spPr>
           <a:xfrm>
-            <a:off x="1143000" y="3246120"/>
+            <a:off x="1143000" y="3182112"/>
             <a:ext cx="1920240" cy="566928"/>
           </a:xfrm>
           <a:prstGeom prst="rect">
@@ -1781,7 +1781,7 @@
         </p:nvSpPr>
         <p:spPr>
           <a:xfrm>
-            <a:off x="621792" y="3776472"/>
+            <a:off x="621792" y="3712464"/>
             <a:ext cx="2103120" cy="182880"/>
           </a:xfrm>
           <a:prstGeom prst="rect">
@@ -1820,7 +1820,7 @@
         </p:nvSpPr>
         <p:spPr>
           <a:xfrm>
-            <a:off x="621792" y="3995928"/>
+            <a:off x="621792" y="3931920"/>
             <a:ext cx="1828800" cy="100584"/>
           </a:xfrm>
           <a:prstGeom prst="roundRect">
@@ -1847,7 +1847,7 @@
         </p:nvSpPr>
         <p:spPr>
           <a:xfrm>
-            <a:off x="621792" y="3995928"/>
+            <a:off x="621792" y="3931920"/>
             <a:ext cx="1700784" cy="100584"/>
           </a:xfrm>
           <a:prstGeom prst="roundRect">
@@ -1874,7 +1874,7 @@
         </p:nvSpPr>
         <p:spPr>
           <a:xfrm>
-            <a:off x="2496312" y="3886200"/>
+            <a:off x="2496312" y="3822192"/>
             <a:ext cx="548640" cy="310896"/>
           </a:xfrm>
           <a:prstGeom prst="rect">
@@ -1913,12 +1913,12 @@
         </p:nvSpPr>
         <p:spPr>
           <a:xfrm>
-            <a:off x="3291840" y="3127248"/>
-            <a:ext cx="4151376" cy="1188720"/>
+            <a:off x="3291840" y="3081528"/>
+            <a:ext cx="4151376" cy="1152144"/>
           </a:xfrm>
           <a:prstGeom prst="roundRect">
             <a:avLst>
-              <a:gd name="adj" fmla="val 7692"/>
+              <a:gd name="adj" fmla="val 7937"/>
             </a:avLst>
           </a:prstGeom>
           <a:solidFill>
@@ -1940,8 +1940,8 @@
         </p:nvSpPr>
         <p:spPr>
           <a:xfrm>
-            <a:off x="3456432" y="3200400"/>
-            <a:ext cx="3858768" cy="1042416"/>
+            <a:off x="3456432" y="3154680"/>
+            <a:ext cx="3858768" cy="1005840"/>
           </a:xfrm>
           <a:prstGeom prst="rect">
             <a:avLst/>
@@ -2025,12 +2025,12 @@
         </p:nvSpPr>
         <p:spPr>
           <a:xfrm>
-            <a:off x="7580376" y="3127248"/>
-            <a:ext cx="4151376" cy="1188720"/>
+            <a:off x="7580376" y="3081528"/>
+            <a:ext cx="4151376" cy="1152144"/>
           </a:xfrm>
           <a:prstGeom prst="roundRect">
             <a:avLst>
-              <a:gd name="adj" fmla="val 7692"/>
+              <a:gd name="adj" fmla="val 7937"/>
             </a:avLst>
           </a:prstGeom>
           <a:solidFill>
@@ -2052,8 +2052,8 @@
         </p:nvSpPr>
         <p:spPr>
           <a:xfrm>
-            <a:off x="7744968" y="3200400"/>
-            <a:ext cx="3858768" cy="1042416"/>
+            <a:off x="7744968" y="3154680"/>
+            <a:ext cx="3858768" cy="1005840"/>
           </a:xfrm>
           <a:prstGeom prst="rect">
             <a:avLst/>
@@ -2158,12 +2158,12 @@
         </p:nvSpPr>
         <p:spPr>
           <a:xfrm>
-            <a:off x="457200" y="4398264"/>
-            <a:ext cx="2697480" cy="987552"/>
+            <a:off x="457200" y="4315968"/>
+            <a:ext cx="2697480" cy="1188720"/>
           </a:xfrm>
           <a:prstGeom prst="roundRect">
             <a:avLst>
-              <a:gd name="adj" fmla="val 9259"/>
+              <a:gd name="adj" fmla="val 7692"/>
             </a:avLst>
           </a:prstGeom>
           <a:solidFill>
@@ -2185,7 +2185,7 @@
         </p:nvSpPr>
         <p:spPr>
           <a:xfrm>
-            <a:off x="621792" y="4709160"/>
+            <a:off x="621792" y="4727448"/>
             <a:ext cx="384048" cy="384048"/>
           </a:xfrm>
           <a:prstGeom prst="ellipse">
@@ -2218,7 +2218,7 @@
         </p:blipFill>
         <p:spPr>
           <a:xfrm>
-            <a:off x="722376" y="4809744"/>
+            <a:off x="722376" y="4828032"/>
             <a:ext cx="182880" cy="182880"/>
           </a:xfrm>
           <a:prstGeom prst="rect">
@@ -2234,7 +2234,7 @@
         </p:nvSpPr>
         <p:spPr>
           <a:xfrm>
-            <a:off x="1143000" y="4617720"/>
+            <a:off x="1143000" y="4636008"/>
             <a:ext cx="1920240" cy="566928"/>
           </a:xfrm>
           <a:prstGeom prst="rect">
@@ -2273,12 +2273,12 @@
         </p:nvSpPr>
         <p:spPr>
           <a:xfrm>
-            <a:off x="3291840" y="4398264"/>
-            <a:ext cx="4151376" cy="987552"/>
+            <a:off x="3291840" y="4315968"/>
+            <a:ext cx="4151376" cy="1188720"/>
           </a:xfrm>
           <a:prstGeom prst="roundRect">
             <a:avLst>
-              <a:gd name="adj" fmla="val 9259"/>
+              <a:gd name="adj" fmla="val 7692"/>
             </a:avLst>
           </a:prstGeom>
           <a:solidFill>
@@ -2300,8 +2300,8 @@
         </p:nvSpPr>
         <p:spPr>
           <a:xfrm>
-            <a:off x="3456432" y="4471416"/>
-            <a:ext cx="3858768" cy="841248"/>
+            <a:off x="3456432" y="4389120"/>
+            <a:ext cx="3858768" cy="1042416"/>
           </a:xfrm>
           <a:prstGeom prst="rect">
             <a:avLst/>
@@ -2385,12 +2385,12 @@
         </p:nvSpPr>
         <p:spPr>
           <a:xfrm>
-            <a:off x="7580376" y="4398264"/>
-            <a:ext cx="4151376" cy="987552"/>
+            <a:off x="7580376" y="4315968"/>
+            <a:ext cx="4151376" cy="1188720"/>
           </a:xfrm>
           <a:prstGeom prst="roundRect">
             <a:avLst>
-              <a:gd name="adj" fmla="val 9259"/>
+              <a:gd name="adj" fmla="val 7692"/>
             </a:avLst>
           </a:prstGeom>
           <a:solidFill>
@@ -2412,8 +2412,8 @@
         </p:nvSpPr>
         <p:spPr>
           <a:xfrm>
-            <a:off x="7744968" y="4471416"/>
-            <a:ext cx="3858768" cy="841248"/>
+            <a:off x="7744968" y="4389120"/>
+            <a:ext cx="3858768" cy="1042416"/>
           </a:xfrm>
           <a:prstGeom prst="rect">
             <a:avLst/>
@@ -2487,6 +2487,48 @@
             </a:r>
             <a:endParaRPr lang="en-US" sz="1050" dirty="0"/>
           </a:p>
+          <a:p>
+            <a:pPr marL="152400" indent="-152400">
+              <a:spcAft>
+                <a:spcPts val="200"/>
+              </a:spcAft>
+              <a:buSzPct val="100000"/>
+              <a:buChar char="•"/>
+            </a:pPr>
+            <a:r>
+              <a:rPr lang="en-US" sz="1050" dirty="0">
+                <a:solidFill>
+                  <a:srgbClr val="1B2733"/>
+                </a:solidFill>
+                <a:latin typeface="Calibri" pitchFamily="34" charset="0"/>
+                <a:ea typeface="Calibri" pitchFamily="34" charset="-122"/>
+                <a:cs typeface="Calibri" pitchFamily="34" charset="-120"/>
+              </a:rPr>
+              <a:t>Actualización de política de servicios tercerizados</a:t>
+            </a:r>
+            <a:endParaRPr lang="en-US" sz="1050" dirty="0"/>
+          </a:p>
+          <a:p>
+            <a:pPr marL="152400" indent="-152400">
+              <a:spcAft>
+                <a:spcPts val="200"/>
+              </a:spcAft>
+              <a:buSzPct val="100000"/>
+              <a:buChar char="•"/>
+            </a:pPr>
+            <a:r>
+              <a:rPr lang="en-US" sz="1050" dirty="0">
+                <a:solidFill>
+                  <a:srgbClr val="1B2733"/>
+                </a:solidFill>
+                <a:latin typeface="Calibri" pitchFamily="34" charset="0"/>
+                <a:ea typeface="Calibri" pitchFamily="34" charset="-122"/>
+                <a:cs typeface="Calibri" pitchFamily="34" charset="-120"/>
+              </a:rPr>
+              <a:t>Actualización de política de gobierno corporativo</a:t>
+            </a:r>
+            <a:endParaRPr lang="en-US" sz="1050" dirty="0"/>
+          </a:p>
         </p:txBody>
       </p:sp>
       <p:sp>
@@ -2497,12 +2539,12 @@
         </p:nvSpPr>
         <p:spPr>
           <a:xfrm>
-            <a:off x="457200" y="5468112"/>
-            <a:ext cx="2697480" cy="987552"/>
+            <a:off x="457200" y="5586984"/>
+            <a:ext cx="2697480" cy="896112"/>
           </a:xfrm>
           <a:prstGeom prst="roundRect">
             <a:avLst>
-              <a:gd name="adj" fmla="val 9259"/>
+              <a:gd name="adj" fmla="val 10204"/>
             </a:avLst>
           </a:prstGeom>
           <a:solidFill>
@@ -2524,7 +2566,7 @@
         </p:nvSpPr>
         <p:spPr>
           <a:xfrm>
-            <a:off x="621792" y="5779008"/>
+            <a:off x="621792" y="5852160"/>
             <a:ext cx="384048" cy="384048"/>
           </a:xfrm>
           <a:prstGeom prst="ellipse">
@@ -2557,7 +2599,7 @@
         </p:blipFill>
         <p:spPr>
           <a:xfrm>
-            <a:off x="722376" y="5879592"/>
+            <a:off x="722376" y="5952744"/>
             <a:ext cx="182880" cy="182880"/>
           </a:xfrm>
           <a:prstGeom prst="rect">
@@ -2573,7 +2615,7 @@
         </p:nvSpPr>
         <p:spPr>
           <a:xfrm>
-            <a:off x="1143000" y="5687568"/>
+            <a:off x="1143000" y="5760720"/>
             <a:ext cx="1920240" cy="566928"/>
           </a:xfrm>
           <a:prstGeom prst="rect">
@@ -2612,12 +2654,12 @@
         </p:nvSpPr>
         <p:spPr>
           <a:xfrm>
-            <a:off x="3291840" y="5468112"/>
-            <a:ext cx="4151376" cy="987552"/>
+            <a:off x="3291840" y="5586984"/>
+            <a:ext cx="4151376" cy="896112"/>
           </a:xfrm>
           <a:prstGeom prst="roundRect">
             <a:avLst>
-              <a:gd name="adj" fmla="val 9259"/>
+              <a:gd name="adj" fmla="val 10204"/>
             </a:avLst>
           </a:prstGeom>
           <a:solidFill>
@@ -2639,8 +2681,8 @@
         </p:nvSpPr>
         <p:spPr>
           <a:xfrm>
-            <a:off x="3456432" y="5541264"/>
-            <a:ext cx="3858768" cy="841248"/>
+            <a:off x="3456432" y="5660136"/>
+            <a:ext cx="3858768" cy="749808"/>
           </a:xfrm>
           <a:prstGeom prst="rect">
             <a:avLst/>
@@ -2724,12 +2766,12 @@
         </p:nvSpPr>
         <p:spPr>
           <a:xfrm>
-            <a:off x="7580376" y="5468112"/>
-            <a:ext cx="4151376" cy="987552"/>
+            <a:off x="7580376" y="5586984"/>
+            <a:ext cx="4151376" cy="896112"/>
           </a:xfrm>
           <a:prstGeom prst="roundRect">
             <a:avLst>
-              <a:gd name="adj" fmla="val 9259"/>
+              <a:gd name="adj" fmla="val 10204"/>
             </a:avLst>
           </a:prstGeom>
           <a:solidFill>
@@ -2751,8 +2793,8 @@
         </p:nvSpPr>
         <p:spPr>
           <a:xfrm>
-            <a:off x="7744968" y="5541264"/>
-            <a:ext cx="3858768" cy="841248"/>
+            <a:off x="7744968" y="5660136"/>
+            <a:ext cx="3858768" cy="749808"/>
           </a:xfrm>
           <a:prstGeom prst="rect">
             <a:avLst/>

</xml_diff>